<commit_message>
feat: sync the latest Codex journal club workflow
</commit_message>
<xml_diff>
--- a/assets/k105-blue/starter.pptx
+++ b/assets/k105-blue/starter.pptx
@@ -2,21 +2,23 @@
 <file path=ppt/presentation.xml><?xml version="1.0" encoding="utf-8"?>
 <p:presentation xmlns:p="http://schemas.openxmlformats.org/presentationml/2006/main">
   <p:sldMasterIdLst>
-    <p:sldMasterId xmlns:r="http://schemas.openxmlformats.org/officeDocument/2006/relationships" id="2147483648" r:id="R6c1fda1ac22440b5"/>
+    <p:sldMasterId xmlns:r="http://schemas.openxmlformats.org/officeDocument/2006/relationships" id="2147483648" r:id="R677e180bdaa84ecd"/>
   </p:sldMasterIdLst>
   <p:notesMasterIdLst>
-    <p:notesMasterId xmlns:r="http://schemas.openxmlformats.org/officeDocument/2006/relationships" r:id="R0975751ede074613"/>
+    <p:notesMasterId xmlns:r="http://schemas.openxmlformats.org/officeDocument/2006/relationships" r:id="Rbff4535b567040b6"/>
   </p:notesMasterIdLst>
   <p:sldIdLst>
-    <p:sldId xmlns:r="http://schemas.openxmlformats.org/officeDocument/2006/relationships" id="256" r:id="R248045a2010f4cb4"/>
-    <p:sldId xmlns:r="http://schemas.openxmlformats.org/officeDocument/2006/relationships" id="257" r:id="Rf22d5972ae24412b"/>
-    <p:sldId xmlns:r="http://schemas.openxmlformats.org/officeDocument/2006/relationships" id="258" r:id="R0c741b8d92a64157"/>
-    <p:sldId xmlns:r="http://schemas.openxmlformats.org/officeDocument/2006/relationships" id="259" r:id="R76a630c1aa334e5d"/>
-    <p:sldId xmlns:r="http://schemas.openxmlformats.org/officeDocument/2006/relationships" id="260" r:id="R545c9e08ea094991"/>
-    <p:sldId xmlns:r="http://schemas.openxmlformats.org/officeDocument/2006/relationships" id="261" r:id="Ra62fde6ecebe47ab"/>
-    <p:sldId xmlns:r="http://schemas.openxmlformats.org/officeDocument/2006/relationships" id="262" r:id="R80da06fa02584cec"/>
-    <p:sldId xmlns:r="http://schemas.openxmlformats.org/officeDocument/2006/relationships" id="263" r:id="Ra98191c4b08943c4"/>
-    <p:sldId xmlns:r="http://schemas.openxmlformats.org/officeDocument/2006/relationships" id="264" r:id="Rdd713250db1c4e75"/>
+    <p:sldId xmlns:r="http://schemas.openxmlformats.org/officeDocument/2006/relationships" id="256" r:id="R66f76b3b981941ad"/>
+    <p:sldId xmlns:r="http://schemas.openxmlformats.org/officeDocument/2006/relationships" id="257" r:id="R0154c92990ee414b"/>
+    <p:sldId xmlns:r="http://schemas.openxmlformats.org/officeDocument/2006/relationships" id="258" r:id="Racfacc888410412f"/>
+    <p:sldId xmlns:r="http://schemas.openxmlformats.org/officeDocument/2006/relationships" id="259" r:id="Re3a6f6ce89584c5f"/>
+    <p:sldId xmlns:r="http://schemas.openxmlformats.org/officeDocument/2006/relationships" id="260" r:id="R2dfc3375341b4975"/>
+    <p:sldId xmlns:r="http://schemas.openxmlformats.org/officeDocument/2006/relationships" id="261" r:id="Rb8a80f5147354ab2"/>
+    <p:sldId xmlns:r="http://schemas.openxmlformats.org/officeDocument/2006/relationships" id="262" r:id="R49a9e4dfe454434d"/>
+    <p:sldId xmlns:r="http://schemas.openxmlformats.org/officeDocument/2006/relationships" id="263" r:id="R161d215a7ec44ed8"/>
+    <p:sldId xmlns:r="http://schemas.openxmlformats.org/officeDocument/2006/relationships" id="264" r:id="Rb6c161b49f604dec"/>
+    <p:sldId xmlns:r="http://schemas.openxmlformats.org/officeDocument/2006/relationships" id="265" r:id="R0752380716f24582"/>
+    <p:sldId xmlns:r="http://schemas.openxmlformats.org/officeDocument/2006/relationships" id="266" r:id="R96f5f5395e744eb7"/>
   </p:sldIdLst>
   <p:sldSz cx="12192000" cy="6858000"/>
   <p:notesSz cx="6858000" cy="9144000"/>
@@ -480,6 +482,146 @@
 </p:notes>
 </file>
 
+<file path=ppt/notesSlides/notesSlide10.xml><?xml version="1.0" encoding="utf-8"?>
+<p:notes xmlns:p="http://schemas.openxmlformats.org/presentationml/2006/main">
+  <p:cSld>
+    <p:spTree>
+      <p:nvGrpSpPr>
+        <p:cNvPr id="1" name=""/>
+        <p:cNvGrpSpPr/>
+        <p:nvPr/>
+      </p:nvGrpSpPr>
+      <p:grpSpPr>
+        <a:xfrm xmlns:a="http://schemas.openxmlformats.org/drawingml/2006/main"/>
+      </p:grpSpPr>
+      <p:sp>
+        <p:nvSpPr>
+          <p:cNvPr id="2" name="Slide Image Placeholder 1"/>
+          <p:cNvSpPr>
+            <a:spLocks xmlns:a="http://schemas.openxmlformats.org/drawingml/2006/main" noGrp="1"/>
+          </p:cNvSpPr>
+          <p:nvPr>
+            <p:ph type="sldImg" idx="0"/>
+          </p:nvPr>
+        </p:nvSpPr>
+        <p:spPr/>
+      </p:sp>
+      <p:sp>
+        <p:nvSpPr>
+          <p:cNvPr id="3" name="Notes Placeholder 2"/>
+          <p:cNvSpPr>
+            <a:spLocks xmlns:a="http://schemas.openxmlformats.org/drawingml/2006/main" noGrp="1"/>
+          </p:cNvSpPr>
+          <p:nvPr>
+            <p:ph type="body" idx="1"/>
+          </p:nvPr>
+        </p:nvSpPr>
+        <p:spPr/>
+        <p:txBody>
+          <a:bodyPr xmlns:a="http://schemas.openxmlformats.org/drawingml/2006/main"/>
+          <a:lstStyle xmlns:a="http://schemas.openxmlformats.org/drawingml/2006/main"/>
+          <a:p xmlns:a="http://schemas.openxmlformats.org/drawingml/2006/main">
+            <a:r>
+              <a:t>K105干净版式示意，仅含编辑标签，无示例论文或演示数据。普通任务通过同源组件创建已填充页面，不将这些标签带入成品。</a:t>
+            </a:r>
+          </a:p>
+        </p:txBody>
+      </p:sp>
+      <p:sp>
+        <p:nvSpPr>
+          <p:cNvPr id="4" name="Slide Number Placeholder 3"/>
+          <p:cNvSpPr>
+            <a:spLocks xmlns:a="http://schemas.openxmlformats.org/drawingml/2006/main" noGrp="1"/>
+          </p:cNvSpPr>
+          <p:nvPr>
+            <p:ph type="sldNum" idx="5"/>
+          </p:nvPr>
+        </p:nvSpPr>
+        <p:spPr/>
+        <p:txBody>
+          <a:bodyPr xmlns:a="http://schemas.openxmlformats.org/drawingml/2006/main"/>
+          <a:lstStyle xmlns:a="http://schemas.openxmlformats.org/drawingml/2006/main"/>
+          <a:p xmlns:a="http://schemas.openxmlformats.org/drawingml/2006/main"/>
+        </p:txBody>
+      </p:sp>
+    </p:spTree>
+  </p:cSld>
+  <p:clrMapOvr>
+    <a:masterClrMapping xmlns:a="http://schemas.openxmlformats.org/drawingml/2006/main"/>
+  </p:clrMapOvr>
+</p:notes>
+</file>
+
+<file path=ppt/notesSlides/notesSlide11.xml><?xml version="1.0" encoding="utf-8"?>
+<p:notes xmlns:p="http://schemas.openxmlformats.org/presentationml/2006/main">
+  <p:cSld>
+    <p:spTree>
+      <p:nvGrpSpPr>
+        <p:cNvPr id="1" name=""/>
+        <p:cNvGrpSpPr/>
+        <p:nvPr/>
+      </p:nvGrpSpPr>
+      <p:grpSpPr>
+        <a:xfrm xmlns:a="http://schemas.openxmlformats.org/drawingml/2006/main"/>
+      </p:grpSpPr>
+      <p:sp>
+        <p:nvSpPr>
+          <p:cNvPr id="2" name="Slide Image Placeholder 1"/>
+          <p:cNvSpPr>
+            <a:spLocks xmlns:a="http://schemas.openxmlformats.org/drawingml/2006/main" noGrp="1"/>
+          </p:cNvSpPr>
+          <p:nvPr>
+            <p:ph type="sldImg" idx="0"/>
+          </p:nvPr>
+        </p:nvSpPr>
+        <p:spPr/>
+      </p:sp>
+      <p:sp>
+        <p:nvSpPr>
+          <p:cNvPr id="3" name="Notes Placeholder 2"/>
+          <p:cNvSpPr>
+            <a:spLocks xmlns:a="http://schemas.openxmlformats.org/drawingml/2006/main" noGrp="1"/>
+          </p:cNvSpPr>
+          <p:nvPr>
+            <p:ph type="body" idx="1"/>
+          </p:nvPr>
+        </p:nvSpPr>
+        <p:spPr/>
+        <p:txBody>
+          <a:bodyPr xmlns:a="http://schemas.openxmlformats.org/drawingml/2006/main"/>
+          <a:lstStyle xmlns:a="http://schemas.openxmlformats.org/drawingml/2006/main"/>
+          <a:p xmlns:a="http://schemas.openxmlformats.org/drawingml/2006/main">
+            <a:r>
+              <a:t>K105干净版式示意，仅含编辑标签，无示例论文或演示数据。普通任务通过同源组件创建已填充页面，不将这些标签带入成品。</a:t>
+            </a:r>
+          </a:p>
+        </p:txBody>
+      </p:sp>
+      <p:sp>
+        <p:nvSpPr>
+          <p:cNvPr id="4" name="Slide Number Placeholder 3"/>
+          <p:cNvSpPr>
+            <a:spLocks xmlns:a="http://schemas.openxmlformats.org/drawingml/2006/main" noGrp="1"/>
+          </p:cNvSpPr>
+          <p:nvPr>
+            <p:ph type="sldNum" idx="5"/>
+          </p:nvPr>
+        </p:nvSpPr>
+        <p:spPr/>
+        <p:txBody>
+          <a:bodyPr xmlns:a="http://schemas.openxmlformats.org/drawingml/2006/main"/>
+          <a:lstStyle xmlns:a="http://schemas.openxmlformats.org/drawingml/2006/main"/>
+          <a:p xmlns:a="http://schemas.openxmlformats.org/drawingml/2006/main"/>
+        </p:txBody>
+      </p:sp>
+    </p:spTree>
+  </p:cSld>
+  <p:clrMapOvr>
+    <a:masterClrMapping xmlns:a="http://schemas.openxmlformats.org/drawingml/2006/main"/>
+  </p:clrMapOvr>
+</p:notes>
+</file>
+
 <file path=ppt/notesSlides/notesSlide2.xml><?xml version="1.0" encoding="utf-8"?>
 <p:notes xmlns:p="http://schemas.openxmlformats.org/presentationml/2006/main">
   <p:cSld>
@@ -1078,7 +1220,7 @@
   </p:cSld>
   <p:clrMap bg1="lt1" tx1="dk1" bg2="lt2" tx2="dk2" accent1="accent1" accent2="accent2" accent3="accent3" accent4="accent4" accent5="accent5" accent6="accent6" hlink="hlink" folHlink="folHlink"/>
   <p:sldLayoutIdLst>
-    <p:sldLayoutId xmlns:r="http://schemas.openxmlformats.org/officeDocument/2006/relationships" id="2147483649" r:id="R12ebe07e3e394740"/>
+    <p:sldLayoutId xmlns:r="http://schemas.openxmlformats.org/officeDocument/2006/relationships" id="2147483649" r:id="R683ef74864ec4db0"/>
   </p:sldLayoutIdLst>
   <p:txStyles>
     <p:titleStyle>
@@ -1626,22 +1768,22 @@
       </p:grpSpPr>
       <p:sp>
         <p:nvSpPr>
-          <p:cNvPr id="11" name="">
-            <a:extLst xmlns:a="http://schemas.openxmlformats.org/drawingml/2006/main">
-              <a:ext uri="{FF2B5EF4-FFF2-40B4-BE49-F238E27FC236}">
-                <a16:creationId xmlns:a16="http://schemas.microsoft.com/office/drawing/2014/main" id="{0BD2110D-C4AE-4E40-9337-4A213A671509}"/>
-              </a:ext>
-            </a:extLst>
-          </p:cNvPr>
-          <p:cNvSpPr>
-            <a:spLocks xmlns:a="http://schemas.openxmlformats.org/drawingml/2006/main" noGrp="1"/>
-          </p:cNvSpPr>
-          <p:nvPr/>
-        </p:nvSpPr>
-        <p:spPr>
-          <a:xfrm xmlns:a="http://schemas.openxmlformats.org/drawingml/2006/main">
-            <a:off x="0" y="2013775"/>
-            <a:ext cx="12192000" cy="2493454"/>
+          <p:cNvPr id="13" name="">
+            <a:extLst xmlns:a="http://schemas.openxmlformats.org/drawingml/2006/main">
+              <a:ext uri="{FF2B5EF4-FFF2-40B4-BE49-F238E27FC236}">
+                <a16:creationId xmlns:a16="http://schemas.microsoft.com/office/drawing/2014/main" id="{17ADCACB-C64F-4A5D-B97B-1E8E28F7E436}"/>
+              </a:ext>
+            </a:extLst>
+          </p:cNvPr>
+          <p:cNvSpPr>
+            <a:spLocks xmlns:a="http://schemas.openxmlformats.org/drawingml/2006/main" noGrp="1"/>
+          </p:cNvSpPr>
+          <p:nvPr/>
+        </p:nvSpPr>
+        <p:spPr>
+          <a:xfrm xmlns:a="http://schemas.openxmlformats.org/drawingml/2006/main">
+            <a:off x="0" y="2013742"/>
+            <a:ext cx="12192000" cy="2493433"/>
           </a:xfrm>
           <a:prstGeom xmlns:a="http://schemas.openxmlformats.org/drawingml/2006/main" prst="rect">
             <a:avLst/>
@@ -1659,7 +1801,7 @@
           <p:cNvPr id="2" name="">
             <a:extLst xmlns:a="http://schemas.openxmlformats.org/drawingml/2006/main">
               <a:ext uri="{FF2B5EF4-FFF2-40B4-BE49-F238E27FC236}">
-                <a16:creationId xmlns:a16="http://schemas.microsoft.com/office/drawing/2014/main" id="{2A42B41E-7C62-4A08-8E08-F1C745712E4C}"/>
+                <a16:creationId xmlns:a16="http://schemas.microsoft.com/office/drawing/2014/main" id="{D6F0AFBC-C22C-40DD-8197-4909458AB077}"/>
               </a:ext>
             </a:extLst>
           </p:cNvPr>
@@ -1691,7 +1833,7 @@
           <p:cNvPr id="3" name="">
             <a:extLst xmlns:a="http://schemas.openxmlformats.org/drawingml/2006/main">
               <a:ext uri="{FF2B5EF4-FFF2-40B4-BE49-F238E27FC236}">
-                <a16:creationId xmlns:a16="http://schemas.microsoft.com/office/drawing/2014/main" id="{1A9AF3DE-411E-4B82-AAEC-119C40AF74B6}"/>
+                <a16:creationId xmlns:a16="http://schemas.microsoft.com/office/drawing/2014/main" id="{96CE0632-A06C-4EFA-8B86-F7A9C739EC36}"/>
               </a:ext>
             </a:extLst>
           </p:cNvPr>
@@ -1723,7 +1865,7 @@
           <p:cNvPr id="4" name="">
             <a:extLst xmlns:a="http://schemas.openxmlformats.org/drawingml/2006/main">
               <a:ext uri="{FF2B5EF4-FFF2-40B4-BE49-F238E27FC236}">
-                <a16:creationId xmlns:a16="http://schemas.microsoft.com/office/drawing/2014/main" id="{F471D043-24C5-4D46-AB6B-C30E75311DBD}"/>
+                <a16:creationId xmlns:a16="http://schemas.microsoft.com/office/drawing/2014/main" id="{E6F77DE7-F195-4D09-84F3-55EFEFBC163F}"/>
               </a:ext>
             </a:extLst>
           </p:cNvPr>
@@ -1755,7 +1897,7 @@
           <p:cNvPr id="5" name="">
             <a:extLst xmlns:a="http://schemas.openxmlformats.org/drawingml/2006/main">
               <a:ext uri="{FF2B5EF4-FFF2-40B4-BE49-F238E27FC236}">
-                <a16:creationId xmlns:a16="http://schemas.microsoft.com/office/drawing/2014/main" id="{34CE2BD2-0A97-49D5-8B2C-15EC4B16F995}"/>
+                <a16:creationId xmlns:a16="http://schemas.microsoft.com/office/drawing/2014/main" id="{519819BF-9EFF-46DD-BB53-A0CD2646849B}"/>
               </a:ext>
             </a:extLst>
           </p:cNvPr>
@@ -1787,7 +1929,7 @@
           <p:cNvPr id="6" name="">
             <a:extLst xmlns:a="http://schemas.openxmlformats.org/drawingml/2006/main">
               <a:ext uri="{FF2B5EF4-FFF2-40B4-BE49-F238E27FC236}">
-                <a16:creationId xmlns:a16="http://schemas.microsoft.com/office/drawing/2014/main" id="{496438FF-CDD1-48BF-BE02-BAB1D3F30996}"/>
+                <a16:creationId xmlns:a16="http://schemas.microsoft.com/office/drawing/2014/main" id="{812F2D24-E6E1-44A7-A1FC-08206FCDEDE8}"/>
               </a:ext>
             </a:extLst>
           </p:cNvPr>
@@ -1819,7 +1961,7 @@
           <p:cNvPr id="7" name="">
             <a:extLst xmlns:a="http://schemas.openxmlformats.org/drawingml/2006/main">
               <a:ext uri="{FF2B5EF4-FFF2-40B4-BE49-F238E27FC236}">
-                <a16:creationId xmlns:a16="http://schemas.microsoft.com/office/drawing/2014/main" id="{498172C8-BE1B-41B6-B533-5621A5A45FD9}"/>
+                <a16:creationId xmlns:a16="http://schemas.microsoft.com/office/drawing/2014/main" id="{CD0FFB70-E648-490F-BF18-76DF1698A74B}"/>
               </a:ext>
             </a:extLst>
           </p:cNvPr>
@@ -1851,19 +1993,19 @@
           <p:cNvPr id="8" name="">
             <a:extLst xmlns:a="http://schemas.openxmlformats.org/drawingml/2006/main">
               <a:ext uri="{FF2B5EF4-FFF2-40B4-BE49-F238E27FC236}">
-                <a16:creationId xmlns:a16="http://schemas.microsoft.com/office/drawing/2014/main" id="{D1A1CA2E-4988-4E94-9979-D23220D73BA4}"/>
-              </a:ext>
-            </a:extLst>
-          </p:cNvPr>
-          <p:cNvSpPr>
-            <a:spLocks xmlns:a="http://schemas.openxmlformats.org/drawingml/2006/main" noGrp="1"/>
-          </p:cNvSpPr>
-          <p:nvPr/>
-        </p:nvSpPr>
-        <p:spPr>
-          <a:xfrm xmlns:a="http://schemas.openxmlformats.org/drawingml/2006/main">
-            <a:off x="1000125" y="2324100"/>
-            <a:ext cx="10191750" cy="1238250"/>
+                <a16:creationId xmlns:a16="http://schemas.microsoft.com/office/drawing/2014/main" id="{07B61820-1126-4C07-973F-AE7693954581}"/>
+              </a:ext>
+            </a:extLst>
+          </p:cNvPr>
+          <p:cNvSpPr>
+            <a:spLocks xmlns:a="http://schemas.openxmlformats.org/drawingml/2006/main" noGrp="1"/>
+          </p:cNvSpPr>
+          <p:nvPr/>
+        </p:nvSpPr>
+        <p:spPr>
+          <a:xfrm xmlns:a="http://schemas.openxmlformats.org/drawingml/2006/main">
+            <a:off x="1714500" y="2657475"/>
+            <a:ext cx="8763000" cy="1209675"/>
           </a:xfrm>
           <a:prstGeom xmlns:a="http://schemas.openxmlformats.org/drawingml/2006/main" prst="rect">
             <a:avLst/>
@@ -1880,7 +2022,7 @@
           <a:lstStyle xmlns:a="http://schemas.openxmlformats.org/drawingml/2006/main"/>
           <a:p xmlns:a="http://schemas.openxmlformats.org/drawingml/2006/main">
             <a:pPr algn="ctr">
-              <a:defRPr sz="3600" b="1">
+              <a:defRPr sz="6600" b="1">
                 <a:solidFill>
                   <a:srgbClr val="FFFFFF"/>
                 </a:solidFill>
@@ -1890,7 +2032,7 @@
               </a:defRPr>
             </a:pPr>
             <a:r>
-              <a:rPr sz="3600" b="1">
+              <a:rPr sz="6600" b="1">
                 <a:solidFill>
                   <a:srgbClr val="FFFFFF"/>
                 </a:solidFill>
@@ -1898,29 +2040,57 @@
                 <a:ea typeface="Source Han Sans CN"/>
                 <a:cs typeface="Source Han Sans CN"/>
               </a:rPr>
-              <a:t>论文题名</a:t>
+              <a:t>组会汇报</a:t>
             </a:r>
           </a:p>
         </p:txBody>
       </p:sp>
-      <p:sp>
-        <p:nvSpPr>
-          <p:cNvPr id="9" name="">
-            <a:extLst xmlns:a="http://schemas.openxmlformats.org/drawingml/2006/main">
-              <a:ext uri="{FF2B5EF4-FFF2-40B4-BE49-F238E27FC236}">
-                <a16:creationId xmlns:a16="http://schemas.microsoft.com/office/drawing/2014/main" id="{D027FBA9-CA44-4A85-A4F2-2054FC79F8C1}"/>
-              </a:ext>
-            </a:extLst>
-          </p:cNvPr>
-          <p:cNvSpPr>
-            <a:spLocks xmlns:a="http://schemas.openxmlformats.org/drawingml/2006/main" noGrp="1"/>
-          </p:cNvSpPr>
-          <p:nvPr/>
-        </p:nvSpPr>
-        <p:spPr>
-          <a:xfrm xmlns:a="http://schemas.openxmlformats.org/drawingml/2006/main">
-            <a:off x="1238250" y="3686175"/>
-            <a:ext cx="9715500" cy="571500"/>
+      <p:pic>
+        <p:nvPicPr>
+          <p:cNvPr id="21" name=""/>
+          <p:cNvPicPr>
+            <a:picLocks xmlns:a="http://schemas.openxmlformats.org/drawingml/2006/main" noChangeAspect="1"/>
+          </p:cNvPicPr>
+          <p:nvPr/>
+        </p:nvPicPr>
+        <p:blipFill>
+          <a:blip xmlns:r="http://schemas.openxmlformats.org/officeDocument/2006/relationships" xmlns:a="http://schemas.openxmlformats.org/drawingml/2006/main" r:embed="Rfdc9aae806bd4fe3">
+            <a:extLst>
+              <a:ext uri="{96DAC541-7B7A-43D3-8B79-37D633B846F1}">
+                <asvg:svgBlip xmlns:asvg="http://schemas.microsoft.com/office/drawing/2016/SVG/main" r:embed="Rddad0cdc9b094aec"/>
+              </a:ext>
+            </a:extLst>
+          </a:blip>
+          <a:stretch xmlns:a="http://schemas.openxmlformats.org/drawingml/2006/main"/>
+        </p:blipFill>
+        <p:spPr>
+          <a:xfrm xmlns:a="http://schemas.openxmlformats.org/drawingml/2006/main">
+            <a:off x="2646836" y="5214471"/>
+            <a:ext cx="261537" cy="229276"/>
+          </a:xfrm>
+          <a:prstGeom xmlns:a="http://schemas.openxmlformats.org/drawingml/2006/main" prst="rect">
+            <a:avLst/>
+          </a:prstGeom>
+        </p:spPr>
+      </p:pic>
+      <p:sp>
+        <p:nvSpPr>
+          <p:cNvPr id="10" name="">
+            <a:extLst xmlns:a="http://schemas.openxmlformats.org/drawingml/2006/main">
+              <a:ext uri="{FF2B5EF4-FFF2-40B4-BE49-F238E27FC236}">
+                <a16:creationId xmlns:a16="http://schemas.microsoft.com/office/drawing/2014/main" id="{C4FF6878-A9A4-4A03-9E1D-4C10FC31C25B}"/>
+              </a:ext>
+            </a:extLst>
+          </p:cNvPr>
+          <p:cNvSpPr>
+            <a:spLocks xmlns:a="http://schemas.openxmlformats.org/drawingml/2006/main" noGrp="1"/>
+          </p:cNvSpPr>
+          <p:nvPr/>
+        </p:nvSpPr>
+        <p:spPr>
+          <a:xfrm xmlns:a="http://schemas.openxmlformats.org/drawingml/2006/main">
+            <a:off x="3000375" y="5181600"/>
+            <a:ext cx="3381375" cy="714375"/>
           </a:xfrm>
           <a:prstGeom xmlns:a="http://schemas.openxmlformats.org/drawingml/2006/main" prst="rect">
             <a:avLst/>
@@ -1936,10 +2106,10 @@
           </a:bodyPr>
           <a:lstStyle xmlns:a="http://schemas.openxmlformats.org/drawingml/2006/main"/>
           <a:p xmlns:a="http://schemas.openxmlformats.org/drawingml/2006/main">
-            <a:pPr algn="ctr">
-              <a:defRPr sz="2250" b="0">
-                <a:solidFill>
-                  <a:srgbClr val="FFFFFF"/>
+            <a:pPr algn="l">
+              <a:defRPr sz="2000" b="0">
+                <a:solidFill>
+                  <a:srgbClr val="000000"/>
                 </a:solidFill>
                 <a:latin typeface="Source Han Sans CN"/>
                 <a:ea typeface="Source Han Sans CN"/>
@@ -1947,37 +2117,65 @@
               </a:defRPr>
             </a:pPr>
             <a:r>
-              <a:rPr sz="2250" b="0">
-                <a:solidFill>
-                  <a:srgbClr val="FFFFFF"/>
+              <a:rPr sz="2000" b="0">
+                <a:solidFill>
+                  <a:srgbClr val="000000"/>
                 </a:solidFill>
                 <a:latin typeface="Source Han Sans CN"/>
                 <a:ea typeface="Source Han Sans CN"/>
                 <a:cs typeface="Source Han Sans CN"/>
               </a:rPr>
-              <a:t>研究主题</a:t>
+              <a:t>汇报人：汇报人姓名</a:t>
             </a:r>
           </a:p>
         </p:txBody>
       </p:sp>
-      <p:sp>
-        <p:nvSpPr>
-          <p:cNvPr id="10" name="">
-            <a:extLst xmlns:a="http://schemas.openxmlformats.org/drawingml/2006/main">
-              <a:ext uri="{FF2B5EF4-FFF2-40B4-BE49-F238E27FC236}">
-                <a16:creationId xmlns:a16="http://schemas.microsoft.com/office/drawing/2014/main" id="{C34B72E2-566C-4219-A68D-93B7C49C4A1F}"/>
-              </a:ext>
-            </a:extLst>
-          </p:cNvPr>
-          <p:cNvSpPr>
-            <a:spLocks xmlns:a="http://schemas.openxmlformats.org/drawingml/2006/main" noGrp="1"/>
-          </p:cNvSpPr>
-          <p:nvPr/>
-        </p:nvSpPr>
-        <p:spPr>
-          <a:xfrm xmlns:a="http://schemas.openxmlformats.org/drawingml/2006/main">
-            <a:off x="1238250" y="4867275"/>
-            <a:ext cx="9715500" cy="1304925"/>
+      <p:pic>
+        <p:nvPicPr>
+          <p:cNvPr id="23" name=""/>
+          <p:cNvPicPr>
+            <a:picLocks xmlns:a="http://schemas.openxmlformats.org/drawingml/2006/main" noChangeAspect="1"/>
+          </p:cNvPicPr>
+          <p:nvPr/>
+        </p:nvPicPr>
+        <p:blipFill>
+          <a:blip xmlns:r="http://schemas.openxmlformats.org/officeDocument/2006/relationships" xmlns:a="http://schemas.openxmlformats.org/drawingml/2006/main" r:embed="R5ca6705bbcc54b2b">
+            <a:extLst>
+              <a:ext uri="{96DAC541-7B7A-43D3-8B79-37D633B846F1}">
+                <asvg:svgBlip xmlns:asvg="http://schemas.microsoft.com/office/drawing/2016/SVG/main" r:embed="R4dacd9282b4740ea"/>
+              </a:ext>
+            </a:extLst>
+          </a:blip>
+          <a:stretch xmlns:a="http://schemas.openxmlformats.org/drawingml/2006/main"/>
+        </p:blipFill>
+        <p:spPr>
+          <a:xfrm xmlns:a="http://schemas.openxmlformats.org/drawingml/2006/main">
+            <a:off x="6644069" y="5210251"/>
+            <a:ext cx="246917" cy="254879"/>
+          </a:xfrm>
+          <a:prstGeom xmlns:a="http://schemas.openxmlformats.org/drawingml/2006/main" prst="rect">
+            <a:avLst/>
+          </a:prstGeom>
+        </p:spPr>
+      </p:pic>
+      <p:sp>
+        <p:nvSpPr>
+          <p:cNvPr id="12" name="">
+            <a:extLst xmlns:a="http://schemas.openxmlformats.org/drawingml/2006/main">
+              <a:ext uri="{FF2B5EF4-FFF2-40B4-BE49-F238E27FC236}">
+                <a16:creationId xmlns:a16="http://schemas.microsoft.com/office/drawing/2014/main" id="{9983BA6D-FE4C-4CB2-820F-B99C0571F58E}"/>
+              </a:ext>
+            </a:extLst>
+          </p:cNvPr>
+          <p:cNvSpPr>
+            <a:spLocks xmlns:a="http://schemas.openxmlformats.org/drawingml/2006/main" noGrp="1"/>
+          </p:cNvSpPr>
+          <p:nvPr/>
+        </p:nvSpPr>
+        <p:spPr>
+          <a:xfrm xmlns:a="http://schemas.openxmlformats.org/drawingml/2006/main">
+            <a:off x="7000875" y="5181600"/>
+            <a:ext cx="3524250" cy="400050"/>
           </a:xfrm>
           <a:prstGeom xmlns:a="http://schemas.openxmlformats.org/drawingml/2006/main" prst="rect">
             <a:avLst/>
@@ -1993,10 +2191,10 @@
           </a:bodyPr>
           <a:lstStyle xmlns:a="http://schemas.openxmlformats.org/drawingml/2006/main"/>
           <a:p xmlns:a="http://schemas.openxmlformats.org/drawingml/2006/main">
-            <a:pPr algn="ctr">
-              <a:defRPr sz="1650" b="0">
-                <a:solidFill>
-                  <a:srgbClr val="252B35"/>
+            <a:pPr algn="l">
+              <a:defRPr sz="2000" b="0">
+                <a:solidFill>
+                  <a:srgbClr val="000000"/>
                 </a:solidFill>
                 <a:latin typeface="Source Han Sans CN"/>
                 <a:ea typeface="Source Han Sans CN"/>
@@ -2004,15 +2202,15 @@
               </a:defRPr>
             </a:pPr>
             <a:r>
-              <a:rPr sz="1650" b="0">
-                <a:solidFill>
-                  <a:srgbClr val="252B35"/>
+              <a:rPr sz="2000" b="0">
+                <a:solidFill>
+                  <a:srgbClr val="000000"/>
                 </a:solidFill>
                 <a:latin typeface="Source Han Sans CN"/>
                 <a:ea typeface="Source Han Sans CN"/>
                 <a:cs typeface="Source Han Sans CN"/>
               </a:rPr>
-              <a:t>论文出处</a:t>
+              <a:t>汇报日期：2026.09.07</a:t>
             </a:r>
           </a:p>
         </p:txBody>
@@ -2020,7 +2218,1120 @@
     </p:spTree>
     <p:extLst>
       <p:ext uri="{BB962C8B-B14F-4D97-AF65-F5344CB8AC3E}">
-        <p14:creationId xmlns:p14="http://schemas.microsoft.com/office/powerpoint/2010/main" val="1402679127"/>
+        <p14:creationId xmlns:p14="http://schemas.microsoft.com/office/powerpoint/2010/main" val="1546865354"/>
+      </p:ext>
+    </p:extLst>
+  </p:cSld>
+</p:sld>
+</file>
+
+<file path=ppt/slides/slide10.xml><?xml version="1.0" encoding="utf-8"?>
+<p:sld xmlns:p="http://schemas.openxmlformats.org/presentationml/2006/main">
+  <p:cSld>
+    <p:bg>
+      <p:bgPr>
+        <a:solidFill xmlns:a="http://schemas.openxmlformats.org/drawingml/2006/main">
+          <a:srgbClr val="FFFFFF"/>
+        </a:solidFill>
+      </p:bgPr>
+    </p:bg>
+    <p:spTree>
+      <p:nvGrpSpPr>
+        <p:cNvPr id="1" name=""/>
+        <p:cNvGrpSpPr/>
+        <p:nvPr/>
+      </p:nvGrpSpPr>
+      <p:grpSpPr>
+        <a:xfrm xmlns:a="http://schemas.openxmlformats.org/drawingml/2006/main"/>
+      </p:grpSpPr>
+      <p:sp>
+        <p:nvSpPr>
+          <p:cNvPr id="14" name="">
+            <a:extLst xmlns:a="http://schemas.openxmlformats.org/drawingml/2006/main">
+              <a:ext uri="{FF2B5EF4-FFF2-40B4-BE49-F238E27FC236}">
+                <a16:creationId xmlns:a16="http://schemas.microsoft.com/office/drawing/2014/main" id="{9D17FDE0-DE93-4B38-B1DD-1438F47F9CEC}"/>
+              </a:ext>
+            </a:extLst>
+          </p:cNvPr>
+          <p:cNvSpPr>
+            <a:spLocks xmlns:a="http://schemas.openxmlformats.org/drawingml/2006/main" noGrp="1"/>
+          </p:cNvSpPr>
+          <p:nvPr/>
+        </p:nvSpPr>
+        <p:spPr>
+          <a:xfrm xmlns:a="http://schemas.openxmlformats.org/drawingml/2006/main">
+            <a:off x="160979" y="161266"/>
+            <a:ext cx="11870042" cy="6535469"/>
+          </a:xfrm>
+          <a:prstGeom xmlns:a="http://schemas.openxmlformats.org/drawingml/2006/main" prst="rect">
+            <a:avLst/>
+          </a:prstGeom>
+          <a:noFill xmlns:a="http://schemas.openxmlformats.org/drawingml/2006/main"/>
+          <a:ln xmlns:a="http://schemas.openxmlformats.org/drawingml/2006/main" w="19050">
+            <a:solidFill>
+              <a:srgbClr val="32497B"/>
+            </a:solidFill>
+          </a:ln>
+        </p:spPr>
+      </p:sp>
+      <p:sp>
+        <p:nvSpPr>
+          <p:cNvPr id="2" name="">
+            <a:extLst xmlns:a="http://schemas.openxmlformats.org/drawingml/2006/main">
+              <a:ext uri="{FF2B5EF4-FFF2-40B4-BE49-F238E27FC236}">
+                <a16:creationId xmlns:a16="http://schemas.microsoft.com/office/drawing/2014/main" id="{1DB7CFE1-9420-4AAA-8B6C-314AAEDD222D}"/>
+              </a:ext>
+            </a:extLst>
+          </p:cNvPr>
+          <p:cNvSpPr>
+            <a:spLocks xmlns:a="http://schemas.openxmlformats.org/drawingml/2006/main" noGrp="1"/>
+          </p:cNvSpPr>
+          <p:nvPr/>
+        </p:nvSpPr>
+        <p:spPr>
+          <a:xfrm xmlns:a="http://schemas.openxmlformats.org/drawingml/2006/main">
+            <a:off x="4792835" y="161266"/>
+            <a:ext cx="2606331" cy="1524340"/>
+          </a:xfrm>
+          <a:prstGeom xmlns:a="http://schemas.openxmlformats.org/drawingml/2006/main" prst="rect">
+            <a:avLst/>
+          </a:prstGeom>
+          <a:solidFill xmlns:a="http://schemas.openxmlformats.org/drawingml/2006/main">
+            <a:srgbClr val="32497B"/>
+          </a:solidFill>
+          <a:ln xmlns:a="http://schemas.openxmlformats.org/drawingml/2006/main" w="0">
+            <a:noFill/>
+          </a:ln>
+        </p:spPr>
+      </p:sp>
+      <p:sp>
+        <p:nvSpPr>
+          <p:cNvPr id="3" name="">
+            <a:extLst xmlns:a="http://schemas.openxmlformats.org/drawingml/2006/main">
+              <a:ext uri="{FF2B5EF4-FFF2-40B4-BE49-F238E27FC236}">
+                <a16:creationId xmlns:a16="http://schemas.microsoft.com/office/drawing/2014/main" id="{AC41EE28-ED68-4685-A6DA-E2D885C44B8D}"/>
+              </a:ext>
+            </a:extLst>
+          </p:cNvPr>
+          <p:cNvSpPr>
+            <a:spLocks xmlns:a="http://schemas.openxmlformats.org/drawingml/2006/main" noGrp="1"/>
+          </p:cNvSpPr>
+          <p:nvPr/>
+        </p:nvSpPr>
+        <p:spPr>
+          <a:xfrm xmlns:a="http://schemas.openxmlformats.org/drawingml/2006/main">
+            <a:off x="5334000" y="337552"/>
+            <a:ext cx="1524000" cy="923330"/>
+          </a:xfrm>
+          <a:prstGeom xmlns:a="http://schemas.openxmlformats.org/drawingml/2006/main" prst="rect">
+            <a:avLst/>
+          </a:prstGeom>
+          <a:noFill xmlns:a="http://schemas.openxmlformats.org/drawingml/2006/main"/>
+          <a:ln xmlns:a="http://schemas.openxmlformats.org/drawingml/2006/main" w="0">
+            <a:noFill/>
+          </a:ln>
+        </p:spPr>
+        <p:txBody>
+          <a:bodyPr xmlns:a="http://schemas.openxmlformats.org/drawingml/2006/main" wrap="square" lIns="0" tIns="0" rIns="0" bIns="0" anchor="t">
+            <a:noAutofit/>
+          </a:bodyPr>
+          <a:lstStyle xmlns:a="http://schemas.openxmlformats.org/drawingml/2006/main"/>
+          <a:p xmlns:a="http://schemas.openxmlformats.org/drawingml/2006/main">
+            <a:pPr algn="ctr">
+              <a:defRPr sz="5400" b="1">
+                <a:solidFill>
+                  <a:srgbClr val="FFFFFF"/>
+                </a:solidFill>
+                <a:latin typeface="Source Han Sans CN"/>
+                <a:ea typeface="Source Han Sans CN"/>
+                <a:cs typeface="Source Han Sans CN"/>
+              </a:defRPr>
+            </a:pPr>
+            <a:r>
+              <a:rPr sz="5400" b="1">
+                <a:solidFill>
+                  <a:srgbClr val="FFFFFF"/>
+                </a:solidFill>
+                <a:latin typeface="Source Han Sans CN"/>
+                <a:ea typeface="Source Han Sans CN"/>
+                <a:cs typeface="Source Han Sans CN"/>
+              </a:rPr>
+              <a:t>01</a:t>
+            </a:r>
+          </a:p>
+        </p:txBody>
+      </p:sp>
+      <p:sp>
+        <p:nvSpPr>
+          <p:cNvPr id="4" name="">
+            <a:extLst xmlns:a="http://schemas.openxmlformats.org/drawingml/2006/main">
+              <a:ext uri="{FF2B5EF4-FFF2-40B4-BE49-F238E27FC236}">
+                <a16:creationId xmlns:a16="http://schemas.microsoft.com/office/drawing/2014/main" id="{5934E892-828D-4889-ABA6-0EBBD475FCEF}"/>
+              </a:ext>
+            </a:extLst>
+          </p:cNvPr>
+          <p:cNvSpPr>
+            <a:spLocks xmlns:a="http://schemas.openxmlformats.org/drawingml/2006/main" noGrp="1"/>
+          </p:cNvSpPr>
+          <p:nvPr/>
+        </p:nvSpPr>
+        <p:spPr>
+          <a:xfrm xmlns:a="http://schemas.openxmlformats.org/drawingml/2006/main">
+            <a:off x="5095875" y="1133475"/>
+            <a:ext cx="2000250" cy="371475"/>
+          </a:xfrm>
+          <a:prstGeom xmlns:a="http://schemas.openxmlformats.org/drawingml/2006/main" prst="rect">
+            <a:avLst/>
+          </a:prstGeom>
+          <a:noFill xmlns:a="http://schemas.openxmlformats.org/drawingml/2006/main"/>
+          <a:ln xmlns:a="http://schemas.openxmlformats.org/drawingml/2006/main" w="0">
+            <a:noFill/>
+          </a:ln>
+        </p:spPr>
+        <p:txBody>
+          <a:bodyPr xmlns:a="http://schemas.openxmlformats.org/drawingml/2006/main" wrap="square" lIns="0" tIns="0" rIns="0" bIns="0" anchor="t">
+            <a:noAutofit/>
+          </a:bodyPr>
+          <a:lstStyle xmlns:a="http://schemas.openxmlformats.org/drawingml/2006/main"/>
+          <a:p xmlns:a="http://schemas.openxmlformats.org/drawingml/2006/main">
+            <a:pPr algn="ctr">
+              <a:defRPr sz="2000" b="1">
+                <a:solidFill>
+                  <a:srgbClr val="D6DBE5"/>
+                </a:solidFill>
+                <a:latin typeface="Source Han Sans CN"/>
+                <a:ea typeface="Source Han Sans CN"/>
+                <a:cs typeface="Source Han Sans CN"/>
+              </a:defRPr>
+            </a:pPr>
+            <a:r>
+              <a:rPr sz="2000" b="1">
+                <a:solidFill>
+                  <a:srgbClr val="D6DBE5"/>
+                </a:solidFill>
+                <a:latin typeface="Source Han Sans CN"/>
+                <a:ea typeface="Source Han Sans CN"/>
+                <a:cs typeface="Source Han Sans CN"/>
+              </a:rPr>
+              <a:t>PART ONE</a:t>
+            </a:r>
+          </a:p>
+        </p:txBody>
+      </p:sp>
+      <p:sp>
+        <p:nvSpPr>
+          <p:cNvPr id="5" name="">
+            <a:extLst xmlns:a="http://schemas.openxmlformats.org/drawingml/2006/main">
+              <a:ext uri="{FF2B5EF4-FFF2-40B4-BE49-F238E27FC236}">
+                <a16:creationId xmlns:a16="http://schemas.microsoft.com/office/drawing/2014/main" id="{89C5C6E0-4AB8-49DA-95A6-6C6BEA247BFB}"/>
+              </a:ext>
+            </a:extLst>
+          </p:cNvPr>
+          <p:cNvSpPr>
+            <a:spLocks xmlns:a="http://schemas.openxmlformats.org/drawingml/2006/main" noGrp="1"/>
+          </p:cNvSpPr>
+          <p:nvPr/>
+        </p:nvSpPr>
+        <p:spPr>
+          <a:xfrm xmlns:a="http://schemas.openxmlformats.org/drawingml/2006/main">
+            <a:off x="722337" y="2164867"/>
+            <a:ext cx="668497" cy="636717"/>
+          </a:xfrm>
+          <a:prstGeom xmlns:a="http://schemas.openxmlformats.org/drawingml/2006/main" prst="rect">
+            <a:avLst/>
+          </a:prstGeom>
+          <a:solidFill xmlns:a="http://schemas.openxmlformats.org/drawingml/2006/main">
+            <a:srgbClr val="32497B"/>
+          </a:solidFill>
+          <a:ln xmlns:a="http://schemas.openxmlformats.org/drawingml/2006/main" w="0">
+            <a:noFill/>
+          </a:ln>
+        </p:spPr>
+      </p:sp>
+      <p:sp>
+        <p:nvSpPr>
+          <p:cNvPr id="6" name="">
+            <a:extLst xmlns:a="http://schemas.openxmlformats.org/drawingml/2006/main">
+              <a:ext uri="{FF2B5EF4-FFF2-40B4-BE49-F238E27FC236}">
+                <a16:creationId xmlns:a16="http://schemas.microsoft.com/office/drawing/2014/main" id="{5067A5BA-2C74-4489-85C1-CEB8443A2059}"/>
+              </a:ext>
+            </a:extLst>
+          </p:cNvPr>
+          <p:cNvSpPr>
+            <a:spLocks xmlns:a="http://schemas.openxmlformats.org/drawingml/2006/main" noGrp="1"/>
+          </p:cNvSpPr>
+          <p:nvPr/>
+        </p:nvSpPr>
+        <p:spPr>
+          <a:xfrm xmlns:a="http://schemas.openxmlformats.org/drawingml/2006/main">
+            <a:off x="762000" y="2249863"/>
+            <a:ext cx="581025" cy="466725"/>
+          </a:xfrm>
+          <a:prstGeom xmlns:a="http://schemas.openxmlformats.org/drawingml/2006/main" prst="rect">
+            <a:avLst/>
+          </a:prstGeom>
+          <a:noFill xmlns:a="http://schemas.openxmlformats.org/drawingml/2006/main"/>
+          <a:ln xmlns:a="http://schemas.openxmlformats.org/drawingml/2006/main" w="0">
+            <a:noFill/>
+          </a:ln>
+        </p:spPr>
+        <p:txBody>
+          <a:bodyPr xmlns:a="http://schemas.openxmlformats.org/drawingml/2006/main" wrap="square" lIns="0" tIns="0" rIns="0" bIns="0" anchor="t">
+            <a:noAutofit/>
+          </a:bodyPr>
+          <a:lstStyle xmlns:a="http://schemas.openxmlformats.org/drawingml/2006/main"/>
+          <a:p xmlns:a="http://schemas.openxmlformats.org/drawingml/2006/main">
+            <a:pPr algn="ctr">
+              <a:defRPr sz="2800" b="1">
+                <a:solidFill>
+                  <a:srgbClr val="FFFFFF"/>
+                </a:solidFill>
+                <a:latin typeface="Source Han Sans CN"/>
+                <a:ea typeface="Source Han Sans CN"/>
+                <a:cs typeface="Source Han Sans CN"/>
+              </a:defRPr>
+            </a:pPr>
+            <a:r>
+              <a:rPr sz="2800" b="1">
+                <a:solidFill>
+                  <a:srgbClr val="FFFFFF"/>
+                </a:solidFill>
+                <a:latin typeface="Source Han Sans CN"/>
+                <a:ea typeface="Source Han Sans CN"/>
+                <a:cs typeface="Source Han Sans CN"/>
+              </a:rPr>
+              <a:t>01</a:t>
+            </a:r>
+          </a:p>
+        </p:txBody>
+      </p:sp>
+      <p:sp>
+        <p:nvSpPr>
+          <p:cNvPr id="7" name="">
+            <a:extLst xmlns:a="http://schemas.openxmlformats.org/drawingml/2006/main">
+              <a:ext uri="{FF2B5EF4-FFF2-40B4-BE49-F238E27FC236}">
+                <a16:creationId xmlns:a16="http://schemas.microsoft.com/office/drawing/2014/main" id="{0B97E78B-831A-4D94-952C-2234D8B3D4BF}"/>
+              </a:ext>
+            </a:extLst>
+          </p:cNvPr>
+          <p:cNvSpPr>
+            <a:spLocks xmlns:a="http://schemas.openxmlformats.org/drawingml/2006/main" noGrp="1"/>
+          </p:cNvSpPr>
+          <p:nvPr/>
+        </p:nvSpPr>
+        <p:spPr>
+          <a:xfrm xmlns:a="http://schemas.openxmlformats.org/drawingml/2006/main">
+            <a:off x="1556727" y="2283170"/>
+            <a:ext cx="9906000" cy="400110"/>
+          </a:xfrm>
+          <a:prstGeom xmlns:a="http://schemas.openxmlformats.org/drawingml/2006/main" prst="rect">
+            <a:avLst/>
+          </a:prstGeom>
+          <a:noFill xmlns:a="http://schemas.openxmlformats.org/drawingml/2006/main"/>
+          <a:ln xmlns:a="http://schemas.openxmlformats.org/drawingml/2006/main" w="0">
+            <a:noFill/>
+          </a:ln>
+        </p:spPr>
+        <p:txBody>
+          <a:bodyPr xmlns:a="http://schemas.openxmlformats.org/drawingml/2006/main" wrap="square" lIns="0" tIns="0" rIns="0" bIns="0" anchor="t">
+            <a:noAutofit/>
+          </a:bodyPr>
+          <a:lstStyle xmlns:a="http://schemas.openxmlformats.org/drawingml/2006/main"/>
+          <a:p xmlns:a="http://schemas.openxmlformats.org/drawingml/2006/main">
+            <a:pPr algn="l">
+              <a:defRPr sz="2000" b="1">
+                <a:solidFill>
+                  <a:srgbClr val="000000"/>
+                </a:solidFill>
+                <a:latin typeface="Source Han Sans CN"/>
+                <a:ea typeface="Source Han Sans CN"/>
+                <a:cs typeface="Source Han Sans CN"/>
+              </a:defRPr>
+            </a:pPr>
+            <a:r>
+              <a:rPr sz="2000" b="1">
+                <a:solidFill>
+                  <a:srgbClr val="000000"/>
+                </a:solidFill>
+                <a:latin typeface="Source Han Sans CN"/>
+                <a:ea typeface="Source Han Sans CN"/>
+                <a:cs typeface="Source Han Sans CN"/>
+              </a:rPr>
+              <a:t>第一篇论文的短题名</a:t>
+            </a:r>
+          </a:p>
+        </p:txBody>
+      </p:sp>
+      <p:sp>
+        <p:nvSpPr>
+          <p:cNvPr id="8" name="">
+            <a:extLst xmlns:a="http://schemas.openxmlformats.org/drawingml/2006/main">
+              <a:ext uri="{FF2B5EF4-FFF2-40B4-BE49-F238E27FC236}">
+                <a16:creationId xmlns:a16="http://schemas.microsoft.com/office/drawing/2014/main" id="{150F5ADE-C44F-44FE-AC51-499A0BD5C798}"/>
+              </a:ext>
+            </a:extLst>
+          </p:cNvPr>
+          <p:cNvSpPr>
+            <a:spLocks xmlns:a="http://schemas.openxmlformats.org/drawingml/2006/main" noGrp="1"/>
+          </p:cNvSpPr>
+          <p:nvPr/>
+        </p:nvSpPr>
+        <p:spPr>
+          <a:xfrm xmlns:a="http://schemas.openxmlformats.org/drawingml/2006/main">
+            <a:off x="722337" y="3122516"/>
+            <a:ext cx="668497" cy="636717"/>
+          </a:xfrm>
+          <a:prstGeom xmlns:a="http://schemas.openxmlformats.org/drawingml/2006/main" prst="rect">
+            <a:avLst/>
+          </a:prstGeom>
+          <a:solidFill xmlns:a="http://schemas.openxmlformats.org/drawingml/2006/main">
+            <a:srgbClr val="BFC4D0"/>
+          </a:solidFill>
+          <a:ln xmlns:a="http://schemas.openxmlformats.org/drawingml/2006/main" w="0">
+            <a:noFill/>
+          </a:ln>
+        </p:spPr>
+      </p:sp>
+      <p:sp>
+        <p:nvSpPr>
+          <p:cNvPr id="9" name="">
+            <a:extLst xmlns:a="http://schemas.openxmlformats.org/drawingml/2006/main">
+              <a:ext uri="{FF2B5EF4-FFF2-40B4-BE49-F238E27FC236}">
+                <a16:creationId xmlns:a16="http://schemas.microsoft.com/office/drawing/2014/main" id="{20745556-7260-44FA-9E0F-A0175E394708}"/>
+              </a:ext>
+            </a:extLst>
+          </p:cNvPr>
+          <p:cNvSpPr>
+            <a:spLocks xmlns:a="http://schemas.openxmlformats.org/drawingml/2006/main" noGrp="1"/>
+          </p:cNvSpPr>
+          <p:nvPr/>
+        </p:nvSpPr>
+        <p:spPr>
+          <a:xfrm xmlns:a="http://schemas.openxmlformats.org/drawingml/2006/main">
+            <a:off x="762000" y="3207512"/>
+            <a:ext cx="581025" cy="466725"/>
+          </a:xfrm>
+          <a:prstGeom xmlns:a="http://schemas.openxmlformats.org/drawingml/2006/main" prst="rect">
+            <a:avLst/>
+          </a:prstGeom>
+          <a:noFill xmlns:a="http://schemas.openxmlformats.org/drawingml/2006/main"/>
+          <a:ln xmlns:a="http://schemas.openxmlformats.org/drawingml/2006/main" w="0">
+            <a:noFill/>
+          </a:ln>
+        </p:spPr>
+        <p:txBody>
+          <a:bodyPr xmlns:a="http://schemas.openxmlformats.org/drawingml/2006/main" wrap="square" lIns="0" tIns="0" rIns="0" bIns="0" anchor="t">
+            <a:noAutofit/>
+          </a:bodyPr>
+          <a:lstStyle xmlns:a="http://schemas.openxmlformats.org/drawingml/2006/main"/>
+          <a:p xmlns:a="http://schemas.openxmlformats.org/drawingml/2006/main">
+            <a:pPr algn="ctr">
+              <a:defRPr sz="2800" b="1">
+                <a:solidFill>
+                  <a:srgbClr val="FFFFFF"/>
+                </a:solidFill>
+                <a:latin typeface="Source Han Sans CN"/>
+                <a:ea typeface="Source Han Sans CN"/>
+                <a:cs typeface="Source Han Sans CN"/>
+              </a:defRPr>
+            </a:pPr>
+            <a:r>
+              <a:rPr sz="2800" b="1">
+                <a:solidFill>
+                  <a:srgbClr val="FFFFFF"/>
+                </a:solidFill>
+                <a:latin typeface="Source Han Sans CN"/>
+                <a:ea typeface="Source Han Sans CN"/>
+                <a:cs typeface="Source Han Sans CN"/>
+              </a:rPr>
+              <a:t>02</a:t>
+            </a:r>
+          </a:p>
+        </p:txBody>
+      </p:sp>
+      <p:sp>
+        <p:nvSpPr>
+          <p:cNvPr id="10" name="">
+            <a:extLst xmlns:a="http://schemas.openxmlformats.org/drawingml/2006/main">
+              <a:ext uri="{FF2B5EF4-FFF2-40B4-BE49-F238E27FC236}">
+                <a16:creationId xmlns:a16="http://schemas.microsoft.com/office/drawing/2014/main" id="{DA919A34-9F5E-4BB7-AF68-0FB8AC370F74}"/>
+              </a:ext>
+            </a:extLst>
+          </p:cNvPr>
+          <p:cNvSpPr>
+            <a:spLocks xmlns:a="http://schemas.openxmlformats.org/drawingml/2006/main" noGrp="1"/>
+          </p:cNvSpPr>
+          <p:nvPr/>
+        </p:nvSpPr>
+        <p:spPr>
+          <a:xfrm xmlns:a="http://schemas.openxmlformats.org/drawingml/2006/main">
+            <a:off x="1556727" y="3240820"/>
+            <a:ext cx="9906000" cy="400110"/>
+          </a:xfrm>
+          <a:prstGeom xmlns:a="http://schemas.openxmlformats.org/drawingml/2006/main" prst="rect">
+            <a:avLst/>
+          </a:prstGeom>
+          <a:noFill xmlns:a="http://schemas.openxmlformats.org/drawingml/2006/main"/>
+          <a:ln xmlns:a="http://schemas.openxmlformats.org/drawingml/2006/main" w="0">
+            <a:noFill/>
+          </a:ln>
+        </p:spPr>
+        <p:txBody>
+          <a:bodyPr xmlns:a="http://schemas.openxmlformats.org/drawingml/2006/main" wrap="square" lIns="0" tIns="0" rIns="0" bIns="0" anchor="t">
+            <a:noAutofit/>
+          </a:bodyPr>
+          <a:lstStyle xmlns:a="http://schemas.openxmlformats.org/drawingml/2006/main"/>
+          <a:p xmlns:a="http://schemas.openxmlformats.org/drawingml/2006/main">
+            <a:pPr algn="l">
+              <a:defRPr sz="2000" b="1">
+                <a:solidFill>
+                  <a:srgbClr val="B9BCC3"/>
+                </a:solidFill>
+                <a:latin typeface="Source Han Sans CN"/>
+                <a:ea typeface="Source Han Sans CN"/>
+                <a:cs typeface="Source Han Sans CN"/>
+              </a:defRPr>
+            </a:pPr>
+            <a:r>
+              <a:rPr sz="2000" b="1">
+                <a:solidFill>
+                  <a:srgbClr val="B9BCC3"/>
+                </a:solidFill>
+                <a:latin typeface="Source Han Sans CN"/>
+                <a:ea typeface="Source Han Sans CN"/>
+                <a:cs typeface="Source Han Sans CN"/>
+              </a:rPr>
+              <a:t>第二篇论文的短题名</a:t>
+            </a:r>
+          </a:p>
+        </p:txBody>
+      </p:sp>
+      <p:sp>
+        <p:nvSpPr>
+          <p:cNvPr id="11" name="">
+            <a:extLst xmlns:a="http://schemas.openxmlformats.org/drawingml/2006/main">
+              <a:ext uri="{FF2B5EF4-FFF2-40B4-BE49-F238E27FC236}">
+                <a16:creationId xmlns:a16="http://schemas.microsoft.com/office/drawing/2014/main" id="{30857C27-8A6F-4F81-8DB5-F96E6A317200}"/>
+              </a:ext>
+            </a:extLst>
+          </p:cNvPr>
+          <p:cNvSpPr>
+            <a:spLocks xmlns:a="http://schemas.openxmlformats.org/drawingml/2006/main" noGrp="1"/>
+          </p:cNvSpPr>
+          <p:nvPr/>
+        </p:nvSpPr>
+        <p:spPr>
+          <a:xfrm xmlns:a="http://schemas.openxmlformats.org/drawingml/2006/main">
+            <a:off x="722337" y="4080165"/>
+            <a:ext cx="668497" cy="636717"/>
+          </a:xfrm>
+          <a:prstGeom xmlns:a="http://schemas.openxmlformats.org/drawingml/2006/main" prst="rect">
+            <a:avLst/>
+          </a:prstGeom>
+          <a:solidFill xmlns:a="http://schemas.openxmlformats.org/drawingml/2006/main">
+            <a:srgbClr val="BFC4D0"/>
+          </a:solidFill>
+          <a:ln xmlns:a="http://schemas.openxmlformats.org/drawingml/2006/main" w="0">
+            <a:noFill/>
+          </a:ln>
+        </p:spPr>
+      </p:sp>
+      <p:sp>
+        <p:nvSpPr>
+          <p:cNvPr id="12" name="">
+            <a:extLst xmlns:a="http://schemas.openxmlformats.org/drawingml/2006/main">
+              <a:ext uri="{FF2B5EF4-FFF2-40B4-BE49-F238E27FC236}">
+                <a16:creationId xmlns:a16="http://schemas.microsoft.com/office/drawing/2014/main" id="{7336E57D-F7A2-49E9-8E8C-7EC2AE51C6B8}"/>
+              </a:ext>
+            </a:extLst>
+          </p:cNvPr>
+          <p:cNvSpPr>
+            <a:spLocks xmlns:a="http://schemas.openxmlformats.org/drawingml/2006/main" noGrp="1"/>
+          </p:cNvSpPr>
+          <p:nvPr/>
+        </p:nvSpPr>
+        <p:spPr>
+          <a:xfrm xmlns:a="http://schemas.openxmlformats.org/drawingml/2006/main">
+            <a:off x="762000" y="4165161"/>
+            <a:ext cx="581025" cy="466725"/>
+          </a:xfrm>
+          <a:prstGeom xmlns:a="http://schemas.openxmlformats.org/drawingml/2006/main" prst="rect">
+            <a:avLst/>
+          </a:prstGeom>
+          <a:noFill xmlns:a="http://schemas.openxmlformats.org/drawingml/2006/main"/>
+          <a:ln xmlns:a="http://schemas.openxmlformats.org/drawingml/2006/main" w="0">
+            <a:noFill/>
+          </a:ln>
+        </p:spPr>
+        <p:txBody>
+          <a:bodyPr xmlns:a="http://schemas.openxmlformats.org/drawingml/2006/main" wrap="square" lIns="0" tIns="0" rIns="0" bIns="0" anchor="t">
+            <a:noAutofit/>
+          </a:bodyPr>
+          <a:lstStyle xmlns:a="http://schemas.openxmlformats.org/drawingml/2006/main"/>
+          <a:p xmlns:a="http://schemas.openxmlformats.org/drawingml/2006/main">
+            <a:pPr algn="ctr">
+              <a:defRPr sz="2800" b="1">
+                <a:solidFill>
+                  <a:srgbClr val="FFFFFF"/>
+                </a:solidFill>
+                <a:latin typeface="Source Han Sans CN"/>
+                <a:ea typeface="Source Han Sans CN"/>
+                <a:cs typeface="Source Han Sans CN"/>
+              </a:defRPr>
+            </a:pPr>
+            <a:r>
+              <a:rPr sz="2800" b="1">
+                <a:solidFill>
+                  <a:srgbClr val="FFFFFF"/>
+                </a:solidFill>
+                <a:latin typeface="Source Han Sans CN"/>
+                <a:ea typeface="Source Han Sans CN"/>
+                <a:cs typeface="Source Han Sans CN"/>
+              </a:rPr>
+              <a:t>03</a:t>
+            </a:r>
+          </a:p>
+        </p:txBody>
+      </p:sp>
+      <p:sp>
+        <p:nvSpPr>
+          <p:cNvPr id="13" name="">
+            <a:extLst xmlns:a="http://schemas.openxmlformats.org/drawingml/2006/main">
+              <a:ext uri="{FF2B5EF4-FFF2-40B4-BE49-F238E27FC236}">
+                <a16:creationId xmlns:a16="http://schemas.microsoft.com/office/drawing/2014/main" id="{E5D2ED97-7855-4F77-9401-891C939910FF}"/>
+              </a:ext>
+            </a:extLst>
+          </p:cNvPr>
+          <p:cNvSpPr>
+            <a:spLocks xmlns:a="http://schemas.openxmlformats.org/drawingml/2006/main" noGrp="1"/>
+          </p:cNvSpPr>
+          <p:nvPr/>
+        </p:nvSpPr>
+        <p:spPr>
+          <a:xfrm xmlns:a="http://schemas.openxmlformats.org/drawingml/2006/main">
+            <a:off x="1556727" y="4198469"/>
+            <a:ext cx="9906000" cy="400110"/>
+          </a:xfrm>
+          <a:prstGeom xmlns:a="http://schemas.openxmlformats.org/drawingml/2006/main" prst="rect">
+            <a:avLst/>
+          </a:prstGeom>
+          <a:noFill xmlns:a="http://schemas.openxmlformats.org/drawingml/2006/main"/>
+          <a:ln xmlns:a="http://schemas.openxmlformats.org/drawingml/2006/main" w="0">
+            <a:noFill/>
+          </a:ln>
+        </p:spPr>
+        <p:txBody>
+          <a:bodyPr xmlns:a="http://schemas.openxmlformats.org/drawingml/2006/main" wrap="square" lIns="0" tIns="0" rIns="0" bIns="0" anchor="t">
+            <a:noAutofit/>
+          </a:bodyPr>
+          <a:lstStyle xmlns:a="http://schemas.openxmlformats.org/drawingml/2006/main"/>
+          <a:p xmlns:a="http://schemas.openxmlformats.org/drawingml/2006/main">
+            <a:pPr algn="l">
+              <a:defRPr sz="2000" b="1">
+                <a:solidFill>
+                  <a:srgbClr val="B9BCC3"/>
+                </a:solidFill>
+                <a:latin typeface="Source Han Sans CN"/>
+                <a:ea typeface="Source Han Sans CN"/>
+                <a:cs typeface="Source Han Sans CN"/>
+              </a:defRPr>
+            </a:pPr>
+            <a:r>
+              <a:rPr sz="2000" b="1">
+                <a:solidFill>
+                  <a:srgbClr val="B9BCC3"/>
+                </a:solidFill>
+                <a:latin typeface="Source Han Sans CN"/>
+                <a:ea typeface="Source Han Sans CN"/>
+                <a:cs typeface="Source Han Sans CN"/>
+              </a:rPr>
+              <a:t>文献阅读总结与思考</a:t>
+            </a:r>
+          </a:p>
+        </p:txBody>
+      </p:sp>
+    </p:spTree>
+    <p:extLst>
+      <p:ext uri="{BB962C8B-B14F-4D97-AF65-F5344CB8AC3E}">
+        <p14:creationId xmlns:p14="http://schemas.microsoft.com/office/powerpoint/2010/main" val="1448974078"/>
+      </p:ext>
+    </p:extLst>
+  </p:cSld>
+</p:sld>
+</file>
+
+<file path=ppt/slides/slide11.xml><?xml version="1.0" encoding="utf-8"?>
+<p:sld xmlns:p="http://schemas.openxmlformats.org/presentationml/2006/main">
+  <p:cSld>
+    <p:bg>
+      <p:bgPr>
+        <a:solidFill xmlns:a="http://schemas.openxmlformats.org/drawingml/2006/main">
+          <a:srgbClr val="FFFFFF"/>
+        </a:solidFill>
+      </p:bgPr>
+    </p:bg>
+    <p:spTree>
+      <p:nvGrpSpPr>
+        <p:cNvPr id="1" name=""/>
+        <p:cNvGrpSpPr/>
+        <p:nvPr/>
+      </p:nvGrpSpPr>
+      <p:grpSpPr>
+        <a:xfrm xmlns:a="http://schemas.openxmlformats.org/drawingml/2006/main"/>
+      </p:grpSpPr>
+      <p:sp>
+        <p:nvSpPr>
+          <p:cNvPr id="13" name="">
+            <a:extLst xmlns:a="http://schemas.openxmlformats.org/drawingml/2006/main">
+              <a:ext uri="{FF2B5EF4-FFF2-40B4-BE49-F238E27FC236}">
+                <a16:creationId xmlns:a16="http://schemas.microsoft.com/office/drawing/2014/main" id="{994D5E81-C0DE-4027-82D2-EE5450D82620}"/>
+              </a:ext>
+            </a:extLst>
+          </p:cNvPr>
+          <p:cNvSpPr>
+            <a:spLocks xmlns:a="http://schemas.openxmlformats.org/drawingml/2006/main" noGrp="1"/>
+          </p:cNvSpPr>
+          <p:nvPr/>
+        </p:nvSpPr>
+        <p:spPr>
+          <a:xfrm xmlns:a="http://schemas.openxmlformats.org/drawingml/2006/main">
+            <a:off x="0" y="2013742"/>
+            <a:ext cx="12192000" cy="2493433"/>
+          </a:xfrm>
+          <a:prstGeom xmlns:a="http://schemas.openxmlformats.org/drawingml/2006/main" prst="rect">
+            <a:avLst/>
+          </a:prstGeom>
+          <a:solidFill xmlns:a="http://schemas.openxmlformats.org/drawingml/2006/main">
+            <a:srgbClr val="32497B"/>
+          </a:solidFill>
+          <a:ln xmlns:a="http://schemas.openxmlformats.org/drawingml/2006/main" w="0">
+            <a:noFill/>
+          </a:ln>
+        </p:spPr>
+      </p:sp>
+      <p:sp>
+        <p:nvSpPr>
+          <p:cNvPr id="2" name="">
+            <a:extLst xmlns:a="http://schemas.openxmlformats.org/drawingml/2006/main">
+              <a:ext uri="{FF2B5EF4-FFF2-40B4-BE49-F238E27FC236}">
+                <a16:creationId xmlns:a16="http://schemas.microsoft.com/office/drawing/2014/main" id="{D937CD2A-6A5C-4AF4-86BE-357C36879D85}"/>
+              </a:ext>
+            </a:extLst>
+          </p:cNvPr>
+          <p:cNvSpPr>
+            <a:spLocks xmlns:a="http://schemas.openxmlformats.org/drawingml/2006/main" noGrp="1"/>
+          </p:cNvSpPr>
+          <p:nvPr/>
+        </p:nvSpPr>
+        <p:spPr>
+          <a:xfrm xmlns:a="http://schemas.openxmlformats.org/drawingml/2006/main">
+            <a:off x="346377" y="262633"/>
+            <a:ext cx="596598" cy="60922"/>
+          </a:xfrm>
+          <a:prstGeom xmlns:a="http://schemas.openxmlformats.org/drawingml/2006/main" prst="roundRect">
+            <a:avLst>
+              <a:gd name="adj" fmla="val 50000"/>
+            </a:avLst>
+          </a:prstGeom>
+          <a:solidFill xmlns:a="http://schemas.openxmlformats.org/drawingml/2006/main">
+            <a:srgbClr val="32497B"/>
+          </a:solidFill>
+          <a:ln xmlns:a="http://schemas.openxmlformats.org/drawingml/2006/main" w="0">
+            <a:noFill/>
+          </a:ln>
+        </p:spPr>
+      </p:sp>
+      <p:sp>
+        <p:nvSpPr>
+          <p:cNvPr id="3" name="">
+            <a:extLst xmlns:a="http://schemas.openxmlformats.org/drawingml/2006/main">
+              <a:ext uri="{FF2B5EF4-FFF2-40B4-BE49-F238E27FC236}">
+                <a16:creationId xmlns:a16="http://schemas.microsoft.com/office/drawing/2014/main" id="{F484B090-EC82-4E34-824B-6FF099DA40EB}"/>
+              </a:ext>
+            </a:extLst>
+          </p:cNvPr>
+          <p:cNvSpPr>
+            <a:spLocks xmlns:a="http://schemas.openxmlformats.org/drawingml/2006/main" noGrp="1"/>
+          </p:cNvSpPr>
+          <p:nvPr/>
+        </p:nvSpPr>
+        <p:spPr>
+          <a:xfrm xmlns:a="http://schemas.openxmlformats.org/drawingml/2006/main">
+            <a:off x="346377" y="363645"/>
+            <a:ext cx="432806" cy="60922"/>
+          </a:xfrm>
+          <a:prstGeom xmlns:a="http://schemas.openxmlformats.org/drawingml/2006/main" prst="roundRect">
+            <a:avLst>
+              <a:gd name="adj" fmla="val 50000"/>
+            </a:avLst>
+          </a:prstGeom>
+          <a:solidFill xmlns:a="http://schemas.openxmlformats.org/drawingml/2006/main">
+            <a:srgbClr val="32497B"/>
+          </a:solidFill>
+          <a:ln xmlns:a="http://schemas.openxmlformats.org/drawingml/2006/main" w="0">
+            <a:noFill/>
+          </a:ln>
+        </p:spPr>
+      </p:sp>
+      <p:sp>
+        <p:nvSpPr>
+          <p:cNvPr id="4" name="">
+            <a:extLst xmlns:a="http://schemas.openxmlformats.org/drawingml/2006/main">
+              <a:ext uri="{FF2B5EF4-FFF2-40B4-BE49-F238E27FC236}">
+                <a16:creationId xmlns:a16="http://schemas.microsoft.com/office/drawing/2014/main" id="{67530C3E-C18A-4DF2-946C-F6860C9E6E72}"/>
+              </a:ext>
+            </a:extLst>
+          </p:cNvPr>
+          <p:cNvSpPr>
+            <a:spLocks xmlns:a="http://schemas.openxmlformats.org/drawingml/2006/main" noGrp="1"/>
+          </p:cNvSpPr>
+          <p:nvPr/>
+        </p:nvSpPr>
+        <p:spPr>
+          <a:xfrm xmlns:a="http://schemas.openxmlformats.org/drawingml/2006/main">
+            <a:off x="346377" y="464668"/>
+            <a:ext cx="291503" cy="60922"/>
+          </a:xfrm>
+          <a:prstGeom xmlns:a="http://schemas.openxmlformats.org/drawingml/2006/main" prst="roundRect">
+            <a:avLst>
+              <a:gd name="adj" fmla="val 50000"/>
+            </a:avLst>
+          </a:prstGeom>
+          <a:solidFill xmlns:a="http://schemas.openxmlformats.org/drawingml/2006/main">
+            <a:srgbClr val="32497B"/>
+          </a:solidFill>
+          <a:ln xmlns:a="http://schemas.openxmlformats.org/drawingml/2006/main" w="0">
+            <a:noFill/>
+          </a:ln>
+        </p:spPr>
+      </p:sp>
+      <p:sp>
+        <p:nvSpPr>
+          <p:cNvPr id="5" name="">
+            <a:extLst xmlns:a="http://schemas.openxmlformats.org/drawingml/2006/main">
+              <a:ext uri="{FF2B5EF4-FFF2-40B4-BE49-F238E27FC236}">
+                <a16:creationId xmlns:a16="http://schemas.microsoft.com/office/drawing/2014/main" id="{2916447C-ADED-4D78-8A10-FE10B9A87DAF}"/>
+              </a:ext>
+            </a:extLst>
+          </p:cNvPr>
+          <p:cNvSpPr>
+            <a:spLocks xmlns:a="http://schemas.openxmlformats.org/drawingml/2006/main" noGrp="1"/>
+          </p:cNvSpPr>
+          <p:nvPr/>
+        </p:nvSpPr>
+        <p:spPr>
+          <a:xfrm xmlns:a="http://schemas.openxmlformats.org/drawingml/2006/main">
+            <a:off x="11249025" y="6537646"/>
+            <a:ext cx="596598" cy="60922"/>
+          </a:xfrm>
+          <a:prstGeom xmlns:a="http://schemas.openxmlformats.org/drawingml/2006/main" prst="roundRect">
+            <a:avLst>
+              <a:gd name="adj" fmla="val 50000"/>
+            </a:avLst>
+          </a:prstGeom>
+          <a:solidFill xmlns:a="http://schemas.openxmlformats.org/drawingml/2006/main">
+            <a:srgbClr val="32497B"/>
+          </a:solidFill>
+          <a:ln xmlns:a="http://schemas.openxmlformats.org/drawingml/2006/main" w="0">
+            <a:noFill/>
+          </a:ln>
+        </p:spPr>
+      </p:sp>
+      <p:sp>
+        <p:nvSpPr>
+          <p:cNvPr id="6" name="">
+            <a:extLst xmlns:a="http://schemas.openxmlformats.org/drawingml/2006/main">
+              <a:ext uri="{FF2B5EF4-FFF2-40B4-BE49-F238E27FC236}">
+                <a16:creationId xmlns:a16="http://schemas.microsoft.com/office/drawing/2014/main" id="{EEEAFC96-98DB-40B4-8600-84FEBFB4F50D}"/>
+              </a:ext>
+            </a:extLst>
+          </p:cNvPr>
+          <p:cNvSpPr>
+            <a:spLocks xmlns:a="http://schemas.openxmlformats.org/drawingml/2006/main" noGrp="1"/>
+          </p:cNvSpPr>
+          <p:nvPr/>
+        </p:nvSpPr>
+        <p:spPr>
+          <a:xfrm xmlns:a="http://schemas.openxmlformats.org/drawingml/2006/main">
+            <a:off x="11412817" y="6436624"/>
+            <a:ext cx="432806" cy="60922"/>
+          </a:xfrm>
+          <a:prstGeom xmlns:a="http://schemas.openxmlformats.org/drawingml/2006/main" prst="roundRect">
+            <a:avLst>
+              <a:gd name="adj" fmla="val 50000"/>
+            </a:avLst>
+          </a:prstGeom>
+          <a:solidFill xmlns:a="http://schemas.openxmlformats.org/drawingml/2006/main">
+            <a:srgbClr val="32497B"/>
+          </a:solidFill>
+          <a:ln xmlns:a="http://schemas.openxmlformats.org/drawingml/2006/main" w="0">
+            <a:noFill/>
+          </a:ln>
+        </p:spPr>
+      </p:sp>
+      <p:sp>
+        <p:nvSpPr>
+          <p:cNvPr id="7" name="">
+            <a:extLst xmlns:a="http://schemas.openxmlformats.org/drawingml/2006/main">
+              <a:ext uri="{FF2B5EF4-FFF2-40B4-BE49-F238E27FC236}">
+                <a16:creationId xmlns:a16="http://schemas.microsoft.com/office/drawing/2014/main" id="{E314FD08-E4FC-4A12-A3C2-171DE145E04B}"/>
+              </a:ext>
+            </a:extLst>
+          </p:cNvPr>
+          <p:cNvSpPr>
+            <a:spLocks xmlns:a="http://schemas.openxmlformats.org/drawingml/2006/main" noGrp="1"/>
+          </p:cNvSpPr>
+          <p:nvPr/>
+        </p:nvSpPr>
+        <p:spPr>
+          <a:xfrm xmlns:a="http://schemas.openxmlformats.org/drawingml/2006/main">
+            <a:off x="11554111" y="6335611"/>
+            <a:ext cx="291503" cy="60922"/>
+          </a:xfrm>
+          <a:prstGeom xmlns:a="http://schemas.openxmlformats.org/drawingml/2006/main" prst="roundRect">
+            <a:avLst>
+              <a:gd name="adj" fmla="val 50000"/>
+            </a:avLst>
+          </a:prstGeom>
+          <a:solidFill xmlns:a="http://schemas.openxmlformats.org/drawingml/2006/main">
+            <a:srgbClr val="32497B"/>
+          </a:solidFill>
+          <a:ln xmlns:a="http://schemas.openxmlformats.org/drawingml/2006/main" w="0">
+            <a:noFill/>
+          </a:ln>
+        </p:spPr>
+      </p:sp>
+      <p:sp>
+        <p:nvSpPr>
+          <p:cNvPr id="8" name="">
+            <a:extLst xmlns:a="http://schemas.openxmlformats.org/drawingml/2006/main">
+              <a:ext uri="{FF2B5EF4-FFF2-40B4-BE49-F238E27FC236}">
+                <a16:creationId xmlns:a16="http://schemas.microsoft.com/office/drawing/2014/main" id="{5FDF7C22-E335-423D-AA87-22B63BC73792}"/>
+              </a:ext>
+            </a:extLst>
+          </p:cNvPr>
+          <p:cNvSpPr>
+            <a:spLocks xmlns:a="http://schemas.openxmlformats.org/drawingml/2006/main" noGrp="1"/>
+          </p:cNvSpPr>
+          <p:nvPr/>
+        </p:nvSpPr>
+        <p:spPr>
+          <a:xfrm xmlns:a="http://schemas.openxmlformats.org/drawingml/2006/main">
+            <a:off x="1284426" y="2875738"/>
+            <a:ext cx="9623148" cy="769441"/>
+          </a:xfrm>
+          <a:prstGeom xmlns:a="http://schemas.openxmlformats.org/drawingml/2006/main" prst="rect">
+            <a:avLst/>
+          </a:prstGeom>
+          <a:noFill xmlns:a="http://schemas.openxmlformats.org/drawingml/2006/main"/>
+          <a:ln xmlns:a="http://schemas.openxmlformats.org/drawingml/2006/main" w="0">
+            <a:noFill/>
+          </a:ln>
+        </p:spPr>
+        <p:txBody>
+          <a:bodyPr xmlns:a="http://schemas.openxmlformats.org/drawingml/2006/main" wrap="square" lIns="0" tIns="0" rIns="0" bIns="0" anchor="t">
+            <a:noAutofit/>
+          </a:bodyPr>
+          <a:lstStyle xmlns:a="http://schemas.openxmlformats.org/drawingml/2006/main"/>
+          <a:p xmlns:a="http://schemas.openxmlformats.org/drawingml/2006/main">
+            <a:pPr algn="ctr">
+              <a:defRPr sz="4400" b="1">
+                <a:solidFill>
+                  <a:srgbClr val="FFFFFF"/>
+                </a:solidFill>
+                <a:latin typeface="Source Han Sans CN"/>
+                <a:ea typeface="Source Han Sans CN"/>
+                <a:cs typeface="Source Han Sans CN"/>
+              </a:defRPr>
+            </a:pPr>
+            <a:r>
+              <a:rPr sz="4400" b="1">
+                <a:solidFill>
+                  <a:srgbClr val="FFFFFF"/>
+                </a:solidFill>
+                <a:latin typeface="Source Han Sans CN"/>
+                <a:ea typeface="Source Han Sans CN"/>
+                <a:cs typeface="Source Han Sans CN"/>
+              </a:rPr>
+              <a:t>汇报完毕，敬请老师同学批评指正！</a:t>
+            </a:r>
+          </a:p>
+        </p:txBody>
+      </p:sp>
+      <p:pic>
+        <p:nvPicPr>
+          <p:cNvPr id="21" name=""/>
+          <p:cNvPicPr>
+            <a:picLocks xmlns:a="http://schemas.openxmlformats.org/drawingml/2006/main" noChangeAspect="1"/>
+          </p:cNvPicPr>
+          <p:nvPr/>
+        </p:nvPicPr>
+        <p:blipFill>
+          <a:blip xmlns:r="http://schemas.openxmlformats.org/officeDocument/2006/relationships" xmlns:a="http://schemas.openxmlformats.org/drawingml/2006/main" r:embed="R9ee00347852749d1">
+            <a:extLst>
+              <a:ext uri="{96DAC541-7B7A-43D3-8B79-37D633B846F1}">
+                <asvg:svgBlip xmlns:asvg="http://schemas.microsoft.com/office/drawing/2016/SVG/main" r:embed="R29d12d91d3c64edc"/>
+              </a:ext>
+            </a:extLst>
+          </a:blip>
+          <a:stretch xmlns:a="http://schemas.openxmlformats.org/drawingml/2006/main"/>
+        </p:blipFill>
+        <p:spPr>
+          <a:xfrm xmlns:a="http://schemas.openxmlformats.org/drawingml/2006/main">
+            <a:off x="2646836" y="5214471"/>
+            <a:ext cx="261537" cy="229276"/>
+          </a:xfrm>
+          <a:prstGeom xmlns:a="http://schemas.openxmlformats.org/drawingml/2006/main" prst="rect">
+            <a:avLst/>
+          </a:prstGeom>
+        </p:spPr>
+      </p:pic>
+      <p:sp>
+        <p:nvSpPr>
+          <p:cNvPr id="10" name="">
+            <a:extLst xmlns:a="http://schemas.openxmlformats.org/drawingml/2006/main">
+              <a:ext uri="{FF2B5EF4-FFF2-40B4-BE49-F238E27FC236}">
+                <a16:creationId xmlns:a16="http://schemas.microsoft.com/office/drawing/2014/main" id="{A35A2715-E84F-42AD-A2BF-68E66FC5C6B9}"/>
+              </a:ext>
+            </a:extLst>
+          </p:cNvPr>
+          <p:cNvSpPr>
+            <a:spLocks xmlns:a="http://schemas.openxmlformats.org/drawingml/2006/main" noGrp="1"/>
+          </p:cNvSpPr>
+          <p:nvPr/>
+        </p:nvSpPr>
+        <p:spPr>
+          <a:xfrm xmlns:a="http://schemas.openxmlformats.org/drawingml/2006/main">
+            <a:off x="3000375" y="5181600"/>
+            <a:ext cx="3381375" cy="714375"/>
+          </a:xfrm>
+          <a:prstGeom xmlns:a="http://schemas.openxmlformats.org/drawingml/2006/main" prst="rect">
+            <a:avLst/>
+          </a:prstGeom>
+          <a:noFill xmlns:a="http://schemas.openxmlformats.org/drawingml/2006/main"/>
+          <a:ln xmlns:a="http://schemas.openxmlformats.org/drawingml/2006/main" w="0">
+            <a:noFill/>
+          </a:ln>
+        </p:spPr>
+        <p:txBody>
+          <a:bodyPr xmlns:a="http://schemas.openxmlformats.org/drawingml/2006/main" wrap="square" lIns="0" tIns="0" rIns="0" bIns="0" anchor="t">
+            <a:noAutofit/>
+          </a:bodyPr>
+          <a:lstStyle xmlns:a="http://schemas.openxmlformats.org/drawingml/2006/main"/>
+          <a:p xmlns:a="http://schemas.openxmlformats.org/drawingml/2006/main">
+            <a:pPr algn="l">
+              <a:defRPr sz="2000" b="0">
+                <a:solidFill>
+                  <a:srgbClr val="000000"/>
+                </a:solidFill>
+                <a:latin typeface="Source Han Sans CN"/>
+                <a:ea typeface="Source Han Sans CN"/>
+                <a:cs typeface="Source Han Sans CN"/>
+              </a:defRPr>
+            </a:pPr>
+            <a:r>
+              <a:rPr sz="2000" b="0">
+                <a:solidFill>
+                  <a:srgbClr val="000000"/>
+                </a:solidFill>
+                <a:latin typeface="Source Han Sans CN"/>
+                <a:ea typeface="Source Han Sans CN"/>
+                <a:cs typeface="Source Han Sans CN"/>
+              </a:rPr>
+              <a:t>汇报人：汇报人姓名</a:t>
+            </a:r>
+          </a:p>
+        </p:txBody>
+      </p:sp>
+      <p:pic>
+        <p:nvPicPr>
+          <p:cNvPr id="23" name=""/>
+          <p:cNvPicPr>
+            <a:picLocks xmlns:a="http://schemas.openxmlformats.org/drawingml/2006/main" noChangeAspect="1"/>
+          </p:cNvPicPr>
+          <p:nvPr/>
+        </p:nvPicPr>
+        <p:blipFill>
+          <a:blip xmlns:r="http://schemas.openxmlformats.org/officeDocument/2006/relationships" xmlns:a="http://schemas.openxmlformats.org/drawingml/2006/main" r:embed="R5c2601538f4942be">
+            <a:extLst>
+              <a:ext uri="{96DAC541-7B7A-43D3-8B79-37D633B846F1}">
+                <asvg:svgBlip xmlns:asvg="http://schemas.microsoft.com/office/drawing/2016/SVG/main" r:embed="R9474024c5fa046e8"/>
+              </a:ext>
+            </a:extLst>
+          </a:blip>
+          <a:stretch xmlns:a="http://schemas.openxmlformats.org/drawingml/2006/main"/>
+        </p:blipFill>
+        <p:spPr>
+          <a:xfrm xmlns:a="http://schemas.openxmlformats.org/drawingml/2006/main">
+            <a:off x="6644069" y="5210251"/>
+            <a:ext cx="246917" cy="254879"/>
+          </a:xfrm>
+          <a:prstGeom xmlns:a="http://schemas.openxmlformats.org/drawingml/2006/main" prst="rect">
+            <a:avLst/>
+          </a:prstGeom>
+        </p:spPr>
+      </p:pic>
+      <p:sp>
+        <p:nvSpPr>
+          <p:cNvPr id="12" name="">
+            <a:extLst xmlns:a="http://schemas.openxmlformats.org/drawingml/2006/main">
+              <a:ext uri="{FF2B5EF4-FFF2-40B4-BE49-F238E27FC236}">
+                <a16:creationId xmlns:a16="http://schemas.microsoft.com/office/drawing/2014/main" id="{346BD9D8-5C66-4C4D-A998-7701DDCDA05B}"/>
+              </a:ext>
+            </a:extLst>
+          </p:cNvPr>
+          <p:cNvSpPr>
+            <a:spLocks xmlns:a="http://schemas.openxmlformats.org/drawingml/2006/main" noGrp="1"/>
+          </p:cNvSpPr>
+          <p:nvPr/>
+        </p:nvSpPr>
+        <p:spPr>
+          <a:xfrm xmlns:a="http://schemas.openxmlformats.org/drawingml/2006/main">
+            <a:off x="7000875" y="5181600"/>
+            <a:ext cx="3524250" cy="400050"/>
+          </a:xfrm>
+          <a:prstGeom xmlns:a="http://schemas.openxmlformats.org/drawingml/2006/main" prst="rect">
+            <a:avLst/>
+          </a:prstGeom>
+          <a:noFill xmlns:a="http://schemas.openxmlformats.org/drawingml/2006/main"/>
+          <a:ln xmlns:a="http://schemas.openxmlformats.org/drawingml/2006/main" w="0">
+            <a:noFill/>
+          </a:ln>
+        </p:spPr>
+        <p:txBody>
+          <a:bodyPr xmlns:a="http://schemas.openxmlformats.org/drawingml/2006/main" wrap="square" lIns="0" tIns="0" rIns="0" bIns="0" anchor="t">
+            <a:noAutofit/>
+          </a:bodyPr>
+          <a:lstStyle xmlns:a="http://schemas.openxmlformats.org/drawingml/2006/main"/>
+          <a:p xmlns:a="http://schemas.openxmlformats.org/drawingml/2006/main">
+            <a:pPr algn="l">
+              <a:defRPr sz="2000" b="0">
+                <a:solidFill>
+                  <a:srgbClr val="000000"/>
+                </a:solidFill>
+                <a:latin typeface="Source Han Sans CN"/>
+                <a:ea typeface="Source Han Sans CN"/>
+                <a:cs typeface="Source Han Sans CN"/>
+              </a:defRPr>
+            </a:pPr>
+            <a:r>
+              <a:rPr sz="2000" b="0">
+                <a:solidFill>
+                  <a:srgbClr val="000000"/>
+                </a:solidFill>
+                <a:latin typeface="Source Han Sans CN"/>
+                <a:ea typeface="Source Han Sans CN"/>
+                <a:cs typeface="Source Han Sans CN"/>
+              </a:rPr>
+              <a:t>汇报日期：2026.09.07</a:t>
+            </a:r>
+          </a:p>
+        </p:txBody>
+      </p:sp>
+    </p:spTree>
+    <p:extLst>
+      <p:ext uri="{BB962C8B-B14F-4D97-AF65-F5344CB8AC3E}">
+        <p14:creationId xmlns:p14="http://schemas.microsoft.com/office/powerpoint/2010/main" val="184421856"/>
       </p:ext>
     </p:extLst>
   </p:cSld>
@@ -2051,7 +3362,7 @@
           <p:cNvPr id="12" name="">
             <a:extLst xmlns:a="http://schemas.openxmlformats.org/drawingml/2006/main">
               <a:ext uri="{FF2B5EF4-FFF2-40B4-BE49-F238E27FC236}">
-                <a16:creationId xmlns:a16="http://schemas.microsoft.com/office/drawing/2014/main" id="{2578EA3D-E539-414F-97AF-4227F7588DC5}"/>
+                <a16:creationId xmlns:a16="http://schemas.microsoft.com/office/drawing/2014/main" id="{AA7EF225-F3C0-4F07-A74D-586E165B96B5}"/>
               </a:ext>
             </a:extLst>
           </p:cNvPr>
@@ -2081,7 +3392,7 @@
           <p:cNvPr id="2" name="">
             <a:extLst xmlns:a="http://schemas.openxmlformats.org/drawingml/2006/main">
               <a:ext uri="{FF2B5EF4-FFF2-40B4-BE49-F238E27FC236}">
-                <a16:creationId xmlns:a16="http://schemas.microsoft.com/office/drawing/2014/main" id="{6443D59B-18EA-43EC-99D7-F5212B740422}"/>
+                <a16:creationId xmlns:a16="http://schemas.microsoft.com/office/drawing/2014/main" id="{25FAA2EF-643A-4FF4-82DA-3C715E1FA13E}"/>
               </a:ext>
             </a:extLst>
           </p:cNvPr>
@@ -2138,7 +3449,7 @@
           <p:cNvPr id="3" name="">
             <a:extLst xmlns:a="http://schemas.openxmlformats.org/drawingml/2006/main">
               <a:ext uri="{FF2B5EF4-FFF2-40B4-BE49-F238E27FC236}">
-                <a16:creationId xmlns:a16="http://schemas.microsoft.com/office/drawing/2014/main" id="{6988FD1C-40B4-46DD-9047-F7F707DB643B}"/>
+                <a16:creationId xmlns:a16="http://schemas.microsoft.com/office/drawing/2014/main" id="{C2BABE0F-B79C-4F02-AA6D-0104CADAD362}"/>
               </a:ext>
             </a:extLst>
           </p:cNvPr>
@@ -2168,7 +3479,7 @@
           <p:cNvPr id="4" name="">
             <a:extLst xmlns:a="http://schemas.openxmlformats.org/drawingml/2006/main">
               <a:ext uri="{FF2B5EF4-FFF2-40B4-BE49-F238E27FC236}">
-                <a16:creationId xmlns:a16="http://schemas.microsoft.com/office/drawing/2014/main" id="{F4D8790E-51E3-4CFA-8BD1-24C4D890F81E}"/>
+                <a16:creationId xmlns:a16="http://schemas.microsoft.com/office/drawing/2014/main" id="{16B45270-405D-4BE5-B540-E05860119904}"/>
               </a:ext>
             </a:extLst>
           </p:cNvPr>
@@ -2198,7 +3509,7 @@
           <p:cNvPr id="5" name="">
             <a:extLst xmlns:a="http://schemas.openxmlformats.org/drawingml/2006/main">
               <a:ext uri="{FF2B5EF4-FFF2-40B4-BE49-F238E27FC236}">
-                <a16:creationId xmlns:a16="http://schemas.microsoft.com/office/drawing/2014/main" id="{AD882F5C-2E14-4B4C-9890-1AD7257716A4}"/>
+                <a16:creationId xmlns:a16="http://schemas.microsoft.com/office/drawing/2014/main" id="{F08D2999-EFD5-429D-8EA3-CC8F42A5E089}"/>
               </a:ext>
             </a:extLst>
           </p:cNvPr>
@@ -2255,7 +3566,7 @@
           <p:cNvPr id="6" name="">
             <a:extLst xmlns:a="http://schemas.openxmlformats.org/drawingml/2006/main">
               <a:ext uri="{FF2B5EF4-FFF2-40B4-BE49-F238E27FC236}">
-                <a16:creationId xmlns:a16="http://schemas.microsoft.com/office/drawing/2014/main" id="{B80BEC4A-36C0-4869-9CAB-B60EC6C6C842}"/>
+                <a16:creationId xmlns:a16="http://schemas.microsoft.com/office/drawing/2014/main" id="{CA020110-ECCD-4E51-87AC-A141AAB30468}"/>
               </a:ext>
             </a:extLst>
           </p:cNvPr>
@@ -2312,7 +3623,7 @@
           <p:cNvPr id="7" name="">
             <a:extLst xmlns:a="http://schemas.openxmlformats.org/drawingml/2006/main">
               <a:ext uri="{FF2B5EF4-FFF2-40B4-BE49-F238E27FC236}">
-                <a16:creationId xmlns:a16="http://schemas.microsoft.com/office/drawing/2014/main" id="{88AD2945-2B8D-4393-B429-2B7341537BC0}"/>
+                <a16:creationId xmlns:a16="http://schemas.microsoft.com/office/drawing/2014/main" id="{C671558C-3A3A-48AE-A292-0A5073247F52}"/>
               </a:ext>
             </a:extLst>
           </p:cNvPr>
@@ -2369,7 +3680,7 @@
           <p:cNvPr id="8" name="">
             <a:extLst xmlns:a="http://schemas.openxmlformats.org/drawingml/2006/main">
               <a:ext uri="{FF2B5EF4-FFF2-40B4-BE49-F238E27FC236}">
-                <a16:creationId xmlns:a16="http://schemas.microsoft.com/office/drawing/2014/main" id="{8D4C541D-BB38-42CC-A533-6C3D21F564BA}"/>
+                <a16:creationId xmlns:a16="http://schemas.microsoft.com/office/drawing/2014/main" id="{8EF6658B-54B2-4C77-A4DB-98A0B4B4C32F}"/>
               </a:ext>
             </a:extLst>
           </p:cNvPr>
@@ -2426,7 +3737,7 @@
           <p:cNvPr id="9" name="">
             <a:extLst xmlns:a="http://schemas.openxmlformats.org/drawingml/2006/main">
               <a:ext uri="{FF2B5EF4-FFF2-40B4-BE49-F238E27FC236}">
-                <a16:creationId xmlns:a16="http://schemas.microsoft.com/office/drawing/2014/main" id="{EDE9B659-DDFF-4790-847C-938079685CF9}"/>
+                <a16:creationId xmlns:a16="http://schemas.microsoft.com/office/drawing/2014/main" id="{ACE8D104-ABE9-4FF4-B2A7-8C789E96E561}"/>
               </a:ext>
             </a:extLst>
           </p:cNvPr>
@@ -2456,7 +3767,7 @@
           <p:cNvPr id="10" name="">
             <a:extLst xmlns:a="http://schemas.openxmlformats.org/drawingml/2006/main">
               <a:ext uri="{FF2B5EF4-FFF2-40B4-BE49-F238E27FC236}">
-                <a16:creationId xmlns:a16="http://schemas.microsoft.com/office/drawing/2014/main" id="{EDC93C91-24BD-4CF7-9406-99A48EFFD7C1}"/>
+                <a16:creationId xmlns:a16="http://schemas.microsoft.com/office/drawing/2014/main" id="{8097D2FF-5758-4608-A8DC-6D5E3A8C04A3}"/>
               </a:ext>
             </a:extLst>
           </p:cNvPr>
@@ -2513,7 +3824,7 @@
           <p:cNvPr id="11" name="">
             <a:extLst xmlns:a="http://schemas.openxmlformats.org/drawingml/2006/main">
               <a:ext uri="{FF2B5EF4-FFF2-40B4-BE49-F238E27FC236}">
-                <a16:creationId xmlns:a16="http://schemas.microsoft.com/office/drawing/2014/main" id="{5E1AE565-D1B6-469C-8AEF-BF0B91D76463}"/>
+                <a16:creationId xmlns:a16="http://schemas.microsoft.com/office/drawing/2014/main" id="{5B15479E-A96E-4B9D-88F8-B4310F32C301}"/>
               </a:ext>
             </a:extLst>
           </p:cNvPr>
@@ -2568,7 +3879,7 @@
     </p:spTree>
     <p:extLst>
       <p:ext uri="{BB962C8B-B14F-4D97-AF65-F5344CB8AC3E}">
-        <p14:creationId xmlns:p14="http://schemas.microsoft.com/office/powerpoint/2010/main" val="1033750648"/>
+        <p14:creationId xmlns:p14="http://schemas.microsoft.com/office/powerpoint/2010/main" val="1888624232"/>
       </p:ext>
     </p:extLst>
   </p:cSld>
@@ -2599,7 +3910,7 @@
           <p:cNvPr id="14" name="">
             <a:extLst xmlns:a="http://schemas.openxmlformats.org/drawingml/2006/main">
               <a:ext uri="{FF2B5EF4-FFF2-40B4-BE49-F238E27FC236}">
-                <a16:creationId xmlns:a16="http://schemas.microsoft.com/office/drawing/2014/main" id="{2C0CD629-C914-4309-A6DB-686FEDA82164}"/>
+                <a16:creationId xmlns:a16="http://schemas.microsoft.com/office/drawing/2014/main" id="{8FFC9BE1-FCE7-490A-A7FA-7C48BE85E104}"/>
               </a:ext>
             </a:extLst>
           </p:cNvPr>
@@ -2629,7 +3940,7 @@
           <p:cNvPr id="2" name="">
             <a:extLst xmlns:a="http://schemas.openxmlformats.org/drawingml/2006/main">
               <a:ext uri="{FF2B5EF4-FFF2-40B4-BE49-F238E27FC236}">
-                <a16:creationId xmlns:a16="http://schemas.microsoft.com/office/drawing/2014/main" id="{A49BA684-D3F6-434A-BAD9-95D642E697A3}"/>
+                <a16:creationId xmlns:a16="http://schemas.microsoft.com/office/drawing/2014/main" id="{3DF4E84F-2802-4949-8D05-07548DCA7773}"/>
               </a:ext>
             </a:extLst>
           </p:cNvPr>
@@ -2686,7 +3997,7 @@
           <p:cNvPr id="3" name="">
             <a:extLst xmlns:a="http://schemas.openxmlformats.org/drawingml/2006/main">
               <a:ext uri="{FF2B5EF4-FFF2-40B4-BE49-F238E27FC236}">
-                <a16:creationId xmlns:a16="http://schemas.microsoft.com/office/drawing/2014/main" id="{F7FBF162-CB38-409A-9FDA-1CAC5FDDD45B}"/>
+                <a16:creationId xmlns:a16="http://schemas.microsoft.com/office/drawing/2014/main" id="{F3EEADC2-4813-4468-86CD-18AA9E2AC67F}"/>
               </a:ext>
             </a:extLst>
           </p:cNvPr>
@@ -2716,7 +4027,7 @@
           <p:cNvPr id="4" name="">
             <a:extLst xmlns:a="http://schemas.openxmlformats.org/drawingml/2006/main">
               <a:ext uri="{FF2B5EF4-FFF2-40B4-BE49-F238E27FC236}">
-                <a16:creationId xmlns:a16="http://schemas.microsoft.com/office/drawing/2014/main" id="{E9CF333F-CA06-4B14-97B5-85147D8CF02D}"/>
+                <a16:creationId xmlns:a16="http://schemas.microsoft.com/office/drawing/2014/main" id="{9486458A-A60C-489F-B928-6C4F81D3DDAE}"/>
               </a:ext>
             </a:extLst>
           </p:cNvPr>
@@ -2746,7 +4057,7 @@
           <p:cNvPr id="5" name="">
             <a:extLst xmlns:a="http://schemas.openxmlformats.org/drawingml/2006/main">
               <a:ext uri="{FF2B5EF4-FFF2-40B4-BE49-F238E27FC236}">
-                <a16:creationId xmlns:a16="http://schemas.microsoft.com/office/drawing/2014/main" id="{9A31AFBD-3AB0-4FBB-AA08-97D8499484C7}"/>
+                <a16:creationId xmlns:a16="http://schemas.microsoft.com/office/drawing/2014/main" id="{48D0B65E-B09F-45D5-B040-30A3E3FEEF80}"/>
               </a:ext>
             </a:extLst>
           </p:cNvPr>
@@ -2803,7 +4114,7 @@
           <p:cNvPr id="6" name="">
             <a:extLst xmlns:a="http://schemas.openxmlformats.org/drawingml/2006/main">
               <a:ext uri="{FF2B5EF4-FFF2-40B4-BE49-F238E27FC236}">
-                <a16:creationId xmlns:a16="http://schemas.microsoft.com/office/drawing/2014/main" id="{296A1868-E314-4276-9A01-0D091BCFFD42}"/>
+                <a16:creationId xmlns:a16="http://schemas.microsoft.com/office/drawing/2014/main" id="{4CE0719B-8133-44F2-B852-F928C1C81A3C}"/>
               </a:ext>
             </a:extLst>
           </p:cNvPr>
@@ -2835,7 +4146,7 @@
           <p:cNvPr id="7" name="">
             <a:extLst xmlns:a="http://schemas.openxmlformats.org/drawingml/2006/main">
               <a:ext uri="{FF2B5EF4-FFF2-40B4-BE49-F238E27FC236}">
-                <a16:creationId xmlns:a16="http://schemas.microsoft.com/office/drawing/2014/main" id="{C8762CB1-862F-4289-9F05-6F2B1AE62A3E}"/>
+                <a16:creationId xmlns:a16="http://schemas.microsoft.com/office/drawing/2014/main" id="{2430DF6C-6DE5-4A97-B347-BC76129F133C}"/>
               </a:ext>
             </a:extLst>
           </p:cNvPr>
@@ -2892,7 +4203,7 @@
           <p:cNvPr id="8" name="">
             <a:extLst xmlns:a="http://schemas.openxmlformats.org/drawingml/2006/main">
               <a:ext uri="{FF2B5EF4-FFF2-40B4-BE49-F238E27FC236}">
-                <a16:creationId xmlns:a16="http://schemas.microsoft.com/office/drawing/2014/main" id="{A750D00F-E916-4A1D-9AD3-44FCB07CE353}"/>
+                <a16:creationId xmlns:a16="http://schemas.microsoft.com/office/drawing/2014/main" id="{34FD10DA-73F8-46F7-A38F-A8F75D931D89}"/>
               </a:ext>
             </a:extLst>
           </p:cNvPr>
@@ -2949,7 +4260,7 @@
           <p:cNvPr id="9" name="">
             <a:extLst xmlns:a="http://schemas.openxmlformats.org/drawingml/2006/main">
               <a:ext uri="{FF2B5EF4-FFF2-40B4-BE49-F238E27FC236}">
-                <a16:creationId xmlns:a16="http://schemas.microsoft.com/office/drawing/2014/main" id="{F1B67DB6-52B8-46CD-ACF6-BBF3ADB37BFB}"/>
+                <a16:creationId xmlns:a16="http://schemas.microsoft.com/office/drawing/2014/main" id="{2796583A-A6FD-469B-B60E-8A3E7D9F9241}"/>
               </a:ext>
             </a:extLst>
           </p:cNvPr>
@@ -3006,7 +4317,7 @@
           <p:cNvPr id="10" name="">
             <a:extLst xmlns:a="http://schemas.openxmlformats.org/drawingml/2006/main">
               <a:ext uri="{FF2B5EF4-FFF2-40B4-BE49-F238E27FC236}">
-                <a16:creationId xmlns:a16="http://schemas.microsoft.com/office/drawing/2014/main" id="{2A79DD4F-CF10-40DC-BC34-7366220CA2B8}"/>
+                <a16:creationId xmlns:a16="http://schemas.microsoft.com/office/drawing/2014/main" id="{28A2D5A9-3027-4670-BB90-79698F9EC7A7}"/>
               </a:ext>
             </a:extLst>
           </p:cNvPr>
@@ -3063,7 +4374,7 @@
           <p:cNvPr id="11" name="">
             <a:extLst xmlns:a="http://schemas.openxmlformats.org/drawingml/2006/main">
               <a:ext uri="{FF2B5EF4-FFF2-40B4-BE49-F238E27FC236}">
-                <a16:creationId xmlns:a16="http://schemas.microsoft.com/office/drawing/2014/main" id="{E729AF48-8194-4739-A8D2-61B1DCAD1A54}"/>
+                <a16:creationId xmlns:a16="http://schemas.microsoft.com/office/drawing/2014/main" id="{76643914-BF3C-4F9B-B5B8-D09D6AA70FC5}"/>
               </a:ext>
             </a:extLst>
           </p:cNvPr>
@@ -3093,7 +4404,7 @@
           <p:cNvPr id="12" name="">
             <a:extLst xmlns:a="http://schemas.openxmlformats.org/drawingml/2006/main">
               <a:ext uri="{FF2B5EF4-FFF2-40B4-BE49-F238E27FC236}">
-                <a16:creationId xmlns:a16="http://schemas.microsoft.com/office/drawing/2014/main" id="{C53F8DFD-98BF-4E4D-9ED3-6B0612893D23}"/>
+                <a16:creationId xmlns:a16="http://schemas.microsoft.com/office/drawing/2014/main" id="{08936366-A58C-4855-853A-20E84C06859A}"/>
               </a:ext>
             </a:extLst>
           </p:cNvPr>
@@ -3150,7 +4461,7 @@
           <p:cNvPr id="13" name="">
             <a:extLst xmlns:a="http://schemas.openxmlformats.org/drawingml/2006/main">
               <a:ext uri="{FF2B5EF4-FFF2-40B4-BE49-F238E27FC236}">
-                <a16:creationId xmlns:a16="http://schemas.microsoft.com/office/drawing/2014/main" id="{FC231A9A-954E-40E5-BDEB-B9478F7C2C8B}"/>
+                <a16:creationId xmlns:a16="http://schemas.microsoft.com/office/drawing/2014/main" id="{33D85E1F-3D4B-45EA-9D69-8DB0829BDFF2}"/>
               </a:ext>
             </a:extLst>
           </p:cNvPr>
@@ -3205,7 +4516,7 @@
     </p:spTree>
     <p:extLst>
       <p:ext uri="{BB962C8B-B14F-4D97-AF65-F5344CB8AC3E}">
-        <p14:creationId xmlns:p14="http://schemas.microsoft.com/office/powerpoint/2010/main" val="1083876956"/>
+        <p14:creationId xmlns:p14="http://schemas.microsoft.com/office/powerpoint/2010/main" val="177693260"/>
       </p:ext>
     </p:extLst>
   </p:cSld>
@@ -3236,7 +4547,7 @@
           <p:cNvPr id="15" name="">
             <a:extLst xmlns:a="http://schemas.openxmlformats.org/drawingml/2006/main">
               <a:ext uri="{FF2B5EF4-FFF2-40B4-BE49-F238E27FC236}">
-                <a16:creationId xmlns:a16="http://schemas.microsoft.com/office/drawing/2014/main" id="{17220E88-F7FD-4DED-B7D6-05C1BD9A2C8C}"/>
+                <a16:creationId xmlns:a16="http://schemas.microsoft.com/office/drawing/2014/main" id="{567898E2-47CD-4CA4-90B7-637F1ED1D5B5}"/>
               </a:ext>
             </a:extLst>
           </p:cNvPr>
@@ -3266,7 +4577,7 @@
           <p:cNvPr id="2" name="">
             <a:extLst xmlns:a="http://schemas.openxmlformats.org/drawingml/2006/main">
               <a:ext uri="{FF2B5EF4-FFF2-40B4-BE49-F238E27FC236}">
-                <a16:creationId xmlns:a16="http://schemas.microsoft.com/office/drawing/2014/main" id="{4CE2D626-7E02-4ED4-BFB1-EC4B9F42416E}"/>
+                <a16:creationId xmlns:a16="http://schemas.microsoft.com/office/drawing/2014/main" id="{6D099AD1-F6C8-4287-B36F-1EC3029118C2}"/>
               </a:ext>
             </a:extLst>
           </p:cNvPr>
@@ -3323,7 +4634,7 @@
           <p:cNvPr id="3" name="">
             <a:extLst xmlns:a="http://schemas.openxmlformats.org/drawingml/2006/main">
               <a:ext uri="{FF2B5EF4-FFF2-40B4-BE49-F238E27FC236}">
-                <a16:creationId xmlns:a16="http://schemas.microsoft.com/office/drawing/2014/main" id="{5F11E295-D4A9-43CE-BDA0-21D8963F4120}"/>
+                <a16:creationId xmlns:a16="http://schemas.microsoft.com/office/drawing/2014/main" id="{928A9C81-D4E9-402C-A16F-7930D70380C9}"/>
               </a:ext>
             </a:extLst>
           </p:cNvPr>
@@ -3353,7 +4664,7 @@
           <p:cNvPr id="4" name="">
             <a:extLst xmlns:a="http://schemas.openxmlformats.org/drawingml/2006/main">
               <a:ext uri="{FF2B5EF4-FFF2-40B4-BE49-F238E27FC236}">
-                <a16:creationId xmlns:a16="http://schemas.microsoft.com/office/drawing/2014/main" id="{07CB5DD1-6142-4E8F-8458-93E49447642D}"/>
+                <a16:creationId xmlns:a16="http://schemas.microsoft.com/office/drawing/2014/main" id="{0D0D7504-4B55-43C9-B9E1-A4CC89DAF716}"/>
               </a:ext>
             </a:extLst>
           </p:cNvPr>
@@ -3383,7 +4694,7 @@
           <p:cNvPr id="5" name="">
             <a:extLst xmlns:a="http://schemas.openxmlformats.org/drawingml/2006/main">
               <a:ext uri="{FF2B5EF4-FFF2-40B4-BE49-F238E27FC236}">
-                <a16:creationId xmlns:a16="http://schemas.microsoft.com/office/drawing/2014/main" id="{13A3C9BD-16E0-44D1-86FC-2EE479D10C73}"/>
+                <a16:creationId xmlns:a16="http://schemas.microsoft.com/office/drawing/2014/main" id="{62EA545B-1936-44EE-89F3-E1AB2C597D0B}"/>
               </a:ext>
             </a:extLst>
           </p:cNvPr>
@@ -3440,7 +4751,7 @@
           <p:cNvPr id="6" name="">
             <a:extLst xmlns:a="http://schemas.openxmlformats.org/drawingml/2006/main">
               <a:ext uri="{FF2B5EF4-FFF2-40B4-BE49-F238E27FC236}">
-                <a16:creationId xmlns:a16="http://schemas.microsoft.com/office/drawing/2014/main" id="{FBFDAD13-A1C9-4F8F-B786-EC07C4112C19}"/>
+                <a16:creationId xmlns:a16="http://schemas.microsoft.com/office/drawing/2014/main" id="{0DD1FBD5-A169-4F35-A0A9-8333DC367DAE}"/>
               </a:ext>
             </a:extLst>
           </p:cNvPr>
@@ -3472,7 +4783,7 @@
           <p:cNvPr id="7" name="">
             <a:extLst xmlns:a="http://schemas.openxmlformats.org/drawingml/2006/main">
               <a:ext uri="{FF2B5EF4-FFF2-40B4-BE49-F238E27FC236}">
-                <a16:creationId xmlns:a16="http://schemas.microsoft.com/office/drawing/2014/main" id="{59BB043C-6241-4D03-B598-44492B9B4E27}"/>
+                <a16:creationId xmlns:a16="http://schemas.microsoft.com/office/drawing/2014/main" id="{6DD8DD0B-67F4-4AD5-BE54-A67B8BB541DC}"/>
               </a:ext>
             </a:extLst>
           </p:cNvPr>
@@ -3529,7 +4840,7 @@
           <p:cNvPr id="8" name="">
             <a:extLst xmlns:a="http://schemas.openxmlformats.org/drawingml/2006/main">
               <a:ext uri="{FF2B5EF4-FFF2-40B4-BE49-F238E27FC236}">
-                <a16:creationId xmlns:a16="http://schemas.microsoft.com/office/drawing/2014/main" id="{620DAFFE-B8A6-43A2-BEE8-875D4D9F7B56}"/>
+                <a16:creationId xmlns:a16="http://schemas.microsoft.com/office/drawing/2014/main" id="{79B4DD37-A073-41F7-A629-F7223B7F44EE}"/>
               </a:ext>
             </a:extLst>
           </p:cNvPr>
@@ -3561,7 +4872,7 @@
           <p:cNvPr id="9" name="">
             <a:extLst xmlns:a="http://schemas.openxmlformats.org/drawingml/2006/main">
               <a:ext uri="{FF2B5EF4-FFF2-40B4-BE49-F238E27FC236}">
-                <a16:creationId xmlns:a16="http://schemas.microsoft.com/office/drawing/2014/main" id="{A5FFC126-0426-4939-A4FC-32BCECF05136}"/>
+                <a16:creationId xmlns:a16="http://schemas.microsoft.com/office/drawing/2014/main" id="{596DB2F7-DB69-4D26-8E48-6ABF4BA517D9}"/>
               </a:ext>
             </a:extLst>
           </p:cNvPr>
@@ -3618,7 +4929,7 @@
           <p:cNvPr id="10" name="">
             <a:extLst xmlns:a="http://schemas.openxmlformats.org/drawingml/2006/main">
               <a:ext uri="{FF2B5EF4-FFF2-40B4-BE49-F238E27FC236}">
-                <a16:creationId xmlns:a16="http://schemas.microsoft.com/office/drawing/2014/main" id="{434612B9-7D72-4FB1-A00E-1D3B11683CE5}"/>
+                <a16:creationId xmlns:a16="http://schemas.microsoft.com/office/drawing/2014/main" id="{C8A07254-A4B8-4D16-B570-74399EF117E7}"/>
               </a:ext>
             </a:extLst>
           </p:cNvPr>
@@ -3675,7 +4986,7 @@
           <p:cNvPr id="11" name="">
             <a:extLst xmlns:a="http://schemas.openxmlformats.org/drawingml/2006/main">
               <a:ext uri="{FF2B5EF4-FFF2-40B4-BE49-F238E27FC236}">
-                <a16:creationId xmlns:a16="http://schemas.microsoft.com/office/drawing/2014/main" id="{57CD6ECC-1ADA-4D41-86FF-18258014749A}"/>
+                <a16:creationId xmlns:a16="http://schemas.microsoft.com/office/drawing/2014/main" id="{60A366FF-7F45-4874-B4E3-30402E1F1E80}"/>
               </a:ext>
             </a:extLst>
           </p:cNvPr>
@@ -3732,7 +5043,7 @@
           <p:cNvPr id="12" name="">
             <a:extLst xmlns:a="http://schemas.openxmlformats.org/drawingml/2006/main">
               <a:ext uri="{FF2B5EF4-FFF2-40B4-BE49-F238E27FC236}">
-                <a16:creationId xmlns:a16="http://schemas.microsoft.com/office/drawing/2014/main" id="{131E84D3-D728-46A2-B61C-1DA132E6AE90}"/>
+                <a16:creationId xmlns:a16="http://schemas.microsoft.com/office/drawing/2014/main" id="{74A404AF-F199-4B3E-A801-3F489C85B49C}"/>
               </a:ext>
             </a:extLst>
           </p:cNvPr>
@@ -3762,7 +5073,7 @@
           <p:cNvPr id="13" name="">
             <a:extLst xmlns:a="http://schemas.openxmlformats.org/drawingml/2006/main">
               <a:ext uri="{FF2B5EF4-FFF2-40B4-BE49-F238E27FC236}">
-                <a16:creationId xmlns:a16="http://schemas.microsoft.com/office/drawing/2014/main" id="{EF83946C-71AD-4F02-BA87-13451405FA01}"/>
+                <a16:creationId xmlns:a16="http://schemas.microsoft.com/office/drawing/2014/main" id="{C66BE2FD-D409-4D30-AB23-0285A187A40A}"/>
               </a:ext>
             </a:extLst>
           </p:cNvPr>
@@ -3819,7 +5130,7 @@
           <p:cNvPr id="14" name="">
             <a:extLst xmlns:a="http://schemas.openxmlformats.org/drawingml/2006/main">
               <a:ext uri="{FF2B5EF4-FFF2-40B4-BE49-F238E27FC236}">
-                <a16:creationId xmlns:a16="http://schemas.microsoft.com/office/drawing/2014/main" id="{0D9DCA65-8042-4F50-8303-8CAC70FC2DA9}"/>
+                <a16:creationId xmlns:a16="http://schemas.microsoft.com/office/drawing/2014/main" id="{6C09471C-E704-4CC7-9346-25BA3B81AE50}"/>
               </a:ext>
             </a:extLst>
           </p:cNvPr>
@@ -3874,7 +5185,7 @@
     </p:spTree>
     <p:extLst>
       <p:ext uri="{BB962C8B-B14F-4D97-AF65-F5344CB8AC3E}">
-        <p14:creationId xmlns:p14="http://schemas.microsoft.com/office/powerpoint/2010/main" val="91985904"/>
+        <p14:creationId xmlns:p14="http://schemas.microsoft.com/office/powerpoint/2010/main" val="277050836"/>
       </p:ext>
     </p:extLst>
   </p:cSld>
@@ -3905,7 +5216,7 @@
           <p:cNvPr id="10" name="">
             <a:extLst xmlns:a="http://schemas.openxmlformats.org/drawingml/2006/main">
               <a:ext uri="{FF2B5EF4-FFF2-40B4-BE49-F238E27FC236}">
-                <a16:creationId xmlns:a16="http://schemas.microsoft.com/office/drawing/2014/main" id="{43BE8D43-7838-41AF-A3FD-AD2206DF21E9}"/>
+                <a16:creationId xmlns:a16="http://schemas.microsoft.com/office/drawing/2014/main" id="{FB79D7B7-F9D6-491E-B6C0-729200146E0C}"/>
               </a:ext>
             </a:extLst>
           </p:cNvPr>
@@ -3935,7 +5246,7 @@
           <p:cNvPr id="2" name="">
             <a:extLst xmlns:a="http://schemas.openxmlformats.org/drawingml/2006/main">
               <a:ext uri="{FF2B5EF4-FFF2-40B4-BE49-F238E27FC236}">
-                <a16:creationId xmlns:a16="http://schemas.microsoft.com/office/drawing/2014/main" id="{5381E0B3-139F-4B9C-8739-C4E313CBDC39}"/>
+                <a16:creationId xmlns:a16="http://schemas.microsoft.com/office/drawing/2014/main" id="{A60A89A9-1527-438D-855B-FF7319C621A6}"/>
               </a:ext>
             </a:extLst>
           </p:cNvPr>
@@ -3992,7 +5303,7 @@
           <p:cNvPr id="3" name="">
             <a:extLst xmlns:a="http://schemas.openxmlformats.org/drawingml/2006/main">
               <a:ext uri="{FF2B5EF4-FFF2-40B4-BE49-F238E27FC236}">
-                <a16:creationId xmlns:a16="http://schemas.microsoft.com/office/drawing/2014/main" id="{B7DB6FAC-D346-46FA-B4F9-43C9223E3DA8}"/>
+                <a16:creationId xmlns:a16="http://schemas.microsoft.com/office/drawing/2014/main" id="{C31C53F3-1431-4CE0-9DE0-40306D088105}"/>
               </a:ext>
             </a:extLst>
           </p:cNvPr>
@@ -4022,7 +5333,7 @@
           <p:cNvPr id="4" name="">
             <a:extLst xmlns:a="http://schemas.openxmlformats.org/drawingml/2006/main">
               <a:ext uri="{FF2B5EF4-FFF2-40B4-BE49-F238E27FC236}">
-                <a16:creationId xmlns:a16="http://schemas.microsoft.com/office/drawing/2014/main" id="{F350DBA9-B5B7-48E0-A8D9-D402605FC08D}"/>
+                <a16:creationId xmlns:a16="http://schemas.microsoft.com/office/drawing/2014/main" id="{7B04F532-FA4E-4B9A-B466-4F786287891F}"/>
               </a:ext>
             </a:extLst>
           </p:cNvPr>
@@ -4052,7 +5363,7 @@
           <p:cNvPr id="5" name="">
             <a:extLst xmlns:a="http://schemas.openxmlformats.org/drawingml/2006/main">
               <a:ext uri="{FF2B5EF4-FFF2-40B4-BE49-F238E27FC236}">
-                <a16:creationId xmlns:a16="http://schemas.microsoft.com/office/drawing/2014/main" id="{66788D85-BBCE-4EC1-9F01-67BEADF30D69}"/>
+                <a16:creationId xmlns:a16="http://schemas.microsoft.com/office/drawing/2014/main" id="{6F6AAB8B-2F44-447D-9E91-79A937F94D31}"/>
               </a:ext>
             </a:extLst>
           </p:cNvPr>
@@ -4428,7 +5739,7 @@
           <p:cNvPr id="7" name="">
             <a:extLst xmlns:a="http://schemas.openxmlformats.org/drawingml/2006/main">
               <a:ext uri="{FF2B5EF4-FFF2-40B4-BE49-F238E27FC236}">
-                <a16:creationId xmlns:a16="http://schemas.microsoft.com/office/drawing/2014/main" id="{E41DBB0C-4272-4A01-A189-73D3A0BC43BD}"/>
+                <a16:creationId xmlns:a16="http://schemas.microsoft.com/office/drawing/2014/main" id="{96CA9C4C-D951-42F7-953E-7EFE934B5445}"/>
               </a:ext>
             </a:extLst>
           </p:cNvPr>
@@ -4458,7 +5769,7 @@
           <p:cNvPr id="8" name="">
             <a:extLst xmlns:a="http://schemas.openxmlformats.org/drawingml/2006/main">
               <a:ext uri="{FF2B5EF4-FFF2-40B4-BE49-F238E27FC236}">
-                <a16:creationId xmlns:a16="http://schemas.microsoft.com/office/drawing/2014/main" id="{07888276-FA18-410E-A734-6AE8EF22211A}"/>
+                <a16:creationId xmlns:a16="http://schemas.microsoft.com/office/drawing/2014/main" id="{AA0A5610-12BC-4865-B60E-47A4A8B1FC23}"/>
               </a:ext>
             </a:extLst>
           </p:cNvPr>
@@ -4515,7 +5826,7 @@
           <p:cNvPr id="9" name="">
             <a:extLst xmlns:a="http://schemas.openxmlformats.org/drawingml/2006/main">
               <a:ext uri="{FF2B5EF4-FFF2-40B4-BE49-F238E27FC236}">
-                <a16:creationId xmlns:a16="http://schemas.microsoft.com/office/drawing/2014/main" id="{C2975BD3-1742-4168-B897-7223910CEDFD}"/>
+                <a16:creationId xmlns:a16="http://schemas.microsoft.com/office/drawing/2014/main" id="{693297D0-93C1-4E2A-B8B8-3052697E5D96}"/>
               </a:ext>
             </a:extLst>
           </p:cNvPr>
@@ -4570,7 +5881,7 @@
     </p:spTree>
     <p:extLst>
       <p:ext uri="{BB962C8B-B14F-4D97-AF65-F5344CB8AC3E}">
-        <p14:creationId xmlns:p14="http://schemas.microsoft.com/office/powerpoint/2010/main" val="230205328"/>
+        <p14:creationId xmlns:p14="http://schemas.microsoft.com/office/powerpoint/2010/main" val="1276044715"/>
       </p:ext>
     </p:extLst>
   </p:cSld>
@@ -4601,7 +5912,7 @@
           <p:cNvPr id="27" name="">
             <a:extLst xmlns:a="http://schemas.openxmlformats.org/drawingml/2006/main">
               <a:ext uri="{FF2B5EF4-FFF2-40B4-BE49-F238E27FC236}">
-                <a16:creationId xmlns:a16="http://schemas.microsoft.com/office/drawing/2014/main" id="{7873F9D1-96BB-407B-9042-B8D292A08A9D}"/>
+                <a16:creationId xmlns:a16="http://schemas.microsoft.com/office/drawing/2014/main" id="{741E3778-7369-4CE4-A805-3521D0BA5CE0}"/>
               </a:ext>
             </a:extLst>
           </p:cNvPr>
@@ -4631,7 +5942,7 @@
           <p:cNvPr id="2" name="">
             <a:extLst xmlns:a="http://schemas.openxmlformats.org/drawingml/2006/main">
               <a:ext uri="{FF2B5EF4-FFF2-40B4-BE49-F238E27FC236}">
-                <a16:creationId xmlns:a16="http://schemas.microsoft.com/office/drawing/2014/main" id="{F0EFC1C9-03A2-4766-9F19-6A8FE617E476}"/>
+                <a16:creationId xmlns:a16="http://schemas.microsoft.com/office/drawing/2014/main" id="{EB9E95B9-024D-4B0D-BAC9-A66EBF0972C5}"/>
               </a:ext>
             </a:extLst>
           </p:cNvPr>
@@ -4688,7 +5999,7 @@
           <p:cNvPr id="3" name="">
             <a:extLst xmlns:a="http://schemas.openxmlformats.org/drawingml/2006/main">
               <a:ext uri="{FF2B5EF4-FFF2-40B4-BE49-F238E27FC236}">
-                <a16:creationId xmlns:a16="http://schemas.microsoft.com/office/drawing/2014/main" id="{08DB21DD-AA2B-44BA-9FFF-0B22A49236FA}"/>
+                <a16:creationId xmlns:a16="http://schemas.microsoft.com/office/drawing/2014/main" id="{68435D1F-E34D-4F01-97A4-45A13A17AC1B}"/>
               </a:ext>
             </a:extLst>
           </p:cNvPr>
@@ -4718,7 +6029,7 @@
           <p:cNvPr id="4" name="">
             <a:extLst xmlns:a="http://schemas.openxmlformats.org/drawingml/2006/main">
               <a:ext uri="{FF2B5EF4-FFF2-40B4-BE49-F238E27FC236}">
-                <a16:creationId xmlns:a16="http://schemas.microsoft.com/office/drawing/2014/main" id="{DBB50891-E283-4CC1-A43F-8E8769752CFA}"/>
+                <a16:creationId xmlns:a16="http://schemas.microsoft.com/office/drawing/2014/main" id="{AAC8CAD1-75D3-4383-939C-870E7EEE1587}"/>
               </a:ext>
             </a:extLst>
           </p:cNvPr>
@@ -4748,7 +6059,7 @@
           <p:cNvPr id="5" name="">
             <a:extLst xmlns:a="http://schemas.openxmlformats.org/drawingml/2006/main">
               <a:ext uri="{FF2B5EF4-FFF2-40B4-BE49-F238E27FC236}">
-                <a16:creationId xmlns:a16="http://schemas.microsoft.com/office/drawing/2014/main" id="{955BA85C-E16E-4A54-A1F7-18A126F9FFD2}"/>
+                <a16:creationId xmlns:a16="http://schemas.microsoft.com/office/drawing/2014/main" id="{566F4BA7-EAED-4A72-AB14-2621A86CC012}"/>
               </a:ext>
             </a:extLst>
           </p:cNvPr>
@@ -4805,7 +6116,7 @@
           <p:cNvPr id="6" name="">
             <a:extLst xmlns:a="http://schemas.openxmlformats.org/drawingml/2006/main">
               <a:ext uri="{FF2B5EF4-FFF2-40B4-BE49-F238E27FC236}">
-                <a16:creationId xmlns:a16="http://schemas.microsoft.com/office/drawing/2014/main" id="{FD34482A-9E2C-4C94-8EF9-847515DE82E0}"/>
+                <a16:creationId xmlns:a16="http://schemas.microsoft.com/office/drawing/2014/main" id="{C66BA6E0-2579-4CC9-8F6D-8CA359FE780E}"/>
               </a:ext>
             </a:extLst>
           </p:cNvPr>
@@ -4862,7 +6173,7 @@
           <p:cNvPr id="7" name="">
             <a:extLst xmlns:a="http://schemas.openxmlformats.org/drawingml/2006/main">
               <a:ext uri="{FF2B5EF4-FFF2-40B4-BE49-F238E27FC236}">
-                <a16:creationId xmlns:a16="http://schemas.microsoft.com/office/drawing/2014/main" id="{7E21752E-68D8-4650-AFAD-42302574C480}"/>
+                <a16:creationId xmlns:a16="http://schemas.microsoft.com/office/drawing/2014/main" id="{2F2393A3-BD66-46F0-BD08-5F6B9CBDDF01}"/>
               </a:ext>
             </a:extLst>
           </p:cNvPr>
@@ -4894,7 +6205,7 @@
           <p:cNvPr id="8" name="">
             <a:extLst xmlns:a="http://schemas.openxmlformats.org/drawingml/2006/main">
               <a:ext uri="{FF2B5EF4-FFF2-40B4-BE49-F238E27FC236}">
-                <a16:creationId xmlns:a16="http://schemas.microsoft.com/office/drawing/2014/main" id="{0F431CDE-B8E3-4216-A0F1-D2FD47B6CC06}"/>
+                <a16:creationId xmlns:a16="http://schemas.microsoft.com/office/drawing/2014/main" id="{E9477291-921D-45CA-8D40-A790B8F4CDF3}"/>
               </a:ext>
             </a:extLst>
           </p:cNvPr>
@@ -4951,7 +6262,7 @@
           <p:cNvPr id="9" name="">
             <a:extLst xmlns:a="http://schemas.openxmlformats.org/drawingml/2006/main">
               <a:ext uri="{FF2B5EF4-FFF2-40B4-BE49-F238E27FC236}">
-                <a16:creationId xmlns:a16="http://schemas.microsoft.com/office/drawing/2014/main" id="{54F8A0C4-E9F3-4BB5-80F3-65BE45CABAC4}"/>
+                <a16:creationId xmlns:a16="http://schemas.microsoft.com/office/drawing/2014/main" id="{E47F9AE4-B44A-429A-984A-0AEFD051A836}"/>
               </a:ext>
             </a:extLst>
           </p:cNvPr>
@@ -5008,7 +6319,7 @@
           <p:cNvPr id="10" name="">
             <a:extLst xmlns:a="http://schemas.openxmlformats.org/drawingml/2006/main">
               <a:ext uri="{FF2B5EF4-FFF2-40B4-BE49-F238E27FC236}">
-                <a16:creationId xmlns:a16="http://schemas.microsoft.com/office/drawing/2014/main" id="{8FF90738-3F59-469E-877A-258758F4428E}"/>
+                <a16:creationId xmlns:a16="http://schemas.microsoft.com/office/drawing/2014/main" id="{8C127795-165D-4CDE-826B-672B6809FCE3}"/>
               </a:ext>
             </a:extLst>
           </p:cNvPr>
@@ -5040,7 +6351,7 @@
           <p:cNvPr id="11" name="">
             <a:extLst xmlns:a="http://schemas.openxmlformats.org/drawingml/2006/main">
               <a:ext uri="{FF2B5EF4-FFF2-40B4-BE49-F238E27FC236}">
-                <a16:creationId xmlns:a16="http://schemas.microsoft.com/office/drawing/2014/main" id="{3B23CFAB-9568-4992-AEE0-8EC57ADADE39}"/>
+                <a16:creationId xmlns:a16="http://schemas.microsoft.com/office/drawing/2014/main" id="{341AABF1-66A7-4258-BAF6-B93F15007A97}"/>
               </a:ext>
             </a:extLst>
           </p:cNvPr>
@@ -5097,7 +6408,7 @@
           <p:cNvPr id="12" name="">
             <a:extLst xmlns:a="http://schemas.openxmlformats.org/drawingml/2006/main">
               <a:ext uri="{FF2B5EF4-FFF2-40B4-BE49-F238E27FC236}">
-                <a16:creationId xmlns:a16="http://schemas.microsoft.com/office/drawing/2014/main" id="{76B19A96-30E4-45CE-A137-6E7E3D1DD98B}"/>
+                <a16:creationId xmlns:a16="http://schemas.microsoft.com/office/drawing/2014/main" id="{64F40134-33DA-4BFA-A4F3-D85F990B7E10}"/>
               </a:ext>
             </a:extLst>
           </p:cNvPr>
@@ -5154,7 +6465,7 @@
           <p:cNvPr id="13" name="">
             <a:extLst xmlns:a="http://schemas.openxmlformats.org/drawingml/2006/main">
               <a:ext uri="{FF2B5EF4-FFF2-40B4-BE49-F238E27FC236}">
-                <a16:creationId xmlns:a16="http://schemas.microsoft.com/office/drawing/2014/main" id="{B4A8F6EF-895E-41B2-B7CE-319DD1BD84DC}"/>
+                <a16:creationId xmlns:a16="http://schemas.microsoft.com/office/drawing/2014/main" id="{3B536103-B520-462D-9979-3297EA68BE31}"/>
               </a:ext>
             </a:extLst>
           </p:cNvPr>
@@ -5186,7 +6497,7 @@
           <p:cNvPr id="14" name="">
             <a:extLst xmlns:a="http://schemas.openxmlformats.org/drawingml/2006/main">
               <a:ext uri="{FF2B5EF4-FFF2-40B4-BE49-F238E27FC236}">
-                <a16:creationId xmlns:a16="http://schemas.microsoft.com/office/drawing/2014/main" id="{AE85E288-C1C1-4C51-AF38-A813F0A2E9DF}"/>
+                <a16:creationId xmlns:a16="http://schemas.microsoft.com/office/drawing/2014/main" id="{BFE1BF96-2DAF-4A1A-A8C1-F02BF33B1CCA}"/>
               </a:ext>
             </a:extLst>
           </p:cNvPr>
@@ -5243,7 +6554,7 @@
           <p:cNvPr id="15" name="">
             <a:extLst xmlns:a="http://schemas.openxmlformats.org/drawingml/2006/main">
               <a:ext uri="{FF2B5EF4-FFF2-40B4-BE49-F238E27FC236}">
-                <a16:creationId xmlns:a16="http://schemas.microsoft.com/office/drawing/2014/main" id="{9D21E9BE-2963-4279-99E3-F16158F3EADC}"/>
+                <a16:creationId xmlns:a16="http://schemas.microsoft.com/office/drawing/2014/main" id="{98048CD5-DE87-4121-8117-9B5BB13690CD}"/>
               </a:ext>
             </a:extLst>
           </p:cNvPr>
@@ -5300,7 +6611,7 @@
           <p:cNvPr id="16" name="">
             <a:extLst xmlns:a="http://schemas.openxmlformats.org/drawingml/2006/main">
               <a:ext uri="{FF2B5EF4-FFF2-40B4-BE49-F238E27FC236}">
-                <a16:creationId xmlns:a16="http://schemas.microsoft.com/office/drawing/2014/main" id="{49952331-DF3F-4111-9B86-E7F2E3EE73A9}"/>
+                <a16:creationId xmlns:a16="http://schemas.microsoft.com/office/drawing/2014/main" id="{6426508E-8B41-422E-AF12-9F9EC27E1E71}"/>
               </a:ext>
             </a:extLst>
           </p:cNvPr>
@@ -5332,7 +6643,7 @@
           <p:cNvPr id="17" name="">
             <a:extLst xmlns:a="http://schemas.openxmlformats.org/drawingml/2006/main">
               <a:ext uri="{FF2B5EF4-FFF2-40B4-BE49-F238E27FC236}">
-                <a16:creationId xmlns:a16="http://schemas.microsoft.com/office/drawing/2014/main" id="{3A17A2E4-CDE7-461F-8B68-4B5D534A1EF5}"/>
+                <a16:creationId xmlns:a16="http://schemas.microsoft.com/office/drawing/2014/main" id="{86B6DA4D-2623-4F02-9A44-8E7AEB4DBBAC}"/>
               </a:ext>
             </a:extLst>
           </p:cNvPr>
@@ -5389,7 +6700,7 @@
           <p:cNvPr id="18" name="">
             <a:extLst xmlns:a="http://schemas.openxmlformats.org/drawingml/2006/main">
               <a:ext uri="{FF2B5EF4-FFF2-40B4-BE49-F238E27FC236}">
-                <a16:creationId xmlns:a16="http://schemas.microsoft.com/office/drawing/2014/main" id="{47154013-EA4E-43C6-A441-2D7BA2CBB55E}"/>
+                <a16:creationId xmlns:a16="http://schemas.microsoft.com/office/drawing/2014/main" id="{30C2319C-1B90-4229-B87D-B92B26017CD4}"/>
               </a:ext>
             </a:extLst>
           </p:cNvPr>
@@ -5521,7 +6832,7 @@
           <p:cNvPr id="22" name="">
             <a:extLst xmlns:a="http://schemas.openxmlformats.org/drawingml/2006/main">
               <a:ext uri="{FF2B5EF4-FFF2-40B4-BE49-F238E27FC236}">
-                <a16:creationId xmlns:a16="http://schemas.microsoft.com/office/drawing/2014/main" id="{83F03A0B-3D32-4FB6-B4C0-BBAD7173C7F8}"/>
+                <a16:creationId xmlns:a16="http://schemas.microsoft.com/office/drawing/2014/main" id="{30F92B52-F097-41E7-8370-FE0314CB2278}"/>
               </a:ext>
             </a:extLst>
           </p:cNvPr>
@@ -5551,7 +6862,7 @@
           <p:cNvPr id="23" name="">
             <a:extLst xmlns:a="http://schemas.openxmlformats.org/drawingml/2006/main">
               <a:ext uri="{FF2B5EF4-FFF2-40B4-BE49-F238E27FC236}">
-                <a16:creationId xmlns:a16="http://schemas.microsoft.com/office/drawing/2014/main" id="{80C386F7-866F-44CC-A28D-F81E6384C1B1}"/>
+                <a16:creationId xmlns:a16="http://schemas.microsoft.com/office/drawing/2014/main" id="{93723859-4B21-440A-9854-261F8AFC90F3}"/>
               </a:ext>
             </a:extLst>
           </p:cNvPr>
@@ -5608,7 +6919,7 @@
           <p:cNvPr id="24" name="">
             <a:extLst xmlns:a="http://schemas.openxmlformats.org/drawingml/2006/main">
               <a:ext uri="{FF2B5EF4-FFF2-40B4-BE49-F238E27FC236}">
-                <a16:creationId xmlns:a16="http://schemas.microsoft.com/office/drawing/2014/main" id="{98B76FBF-1869-4AB7-BAE8-E36648AD7F61}"/>
+                <a16:creationId xmlns:a16="http://schemas.microsoft.com/office/drawing/2014/main" id="{928123A1-701A-48B2-8502-6DCE391D795E}"/>
               </a:ext>
             </a:extLst>
           </p:cNvPr>
@@ -5638,7 +6949,7 @@
           <p:cNvPr id="25" name="">
             <a:extLst xmlns:a="http://schemas.openxmlformats.org/drawingml/2006/main">
               <a:ext uri="{FF2B5EF4-FFF2-40B4-BE49-F238E27FC236}">
-                <a16:creationId xmlns:a16="http://schemas.microsoft.com/office/drawing/2014/main" id="{37585902-F88B-4E4F-AC75-40ADBF704F4C}"/>
+                <a16:creationId xmlns:a16="http://schemas.microsoft.com/office/drawing/2014/main" id="{84E93326-29C1-42E3-AF11-C8E2869A38C9}"/>
               </a:ext>
             </a:extLst>
           </p:cNvPr>
@@ -5695,7 +7006,7 @@
           <p:cNvPr id="26" name="">
             <a:extLst xmlns:a="http://schemas.openxmlformats.org/drawingml/2006/main">
               <a:ext uri="{FF2B5EF4-FFF2-40B4-BE49-F238E27FC236}">
-                <a16:creationId xmlns:a16="http://schemas.microsoft.com/office/drawing/2014/main" id="{3A1F38C1-8DE8-49F6-B41E-9298A62C220C}"/>
+                <a16:creationId xmlns:a16="http://schemas.microsoft.com/office/drawing/2014/main" id="{D54896B1-1AC6-47B1-AC6D-463408728837}"/>
               </a:ext>
             </a:extLst>
           </p:cNvPr>
@@ -5750,7 +7061,7 @@
     </p:spTree>
     <p:extLst>
       <p:ext uri="{BB962C8B-B14F-4D97-AF65-F5344CB8AC3E}">
-        <p14:creationId xmlns:p14="http://schemas.microsoft.com/office/powerpoint/2010/main" val="1652487124"/>
+        <p14:creationId xmlns:p14="http://schemas.microsoft.com/office/powerpoint/2010/main" val="1776583273"/>
       </p:ext>
     </p:extLst>
   </p:cSld>
@@ -5781,7 +7092,7 @@
           <p:cNvPr id="12" name="">
             <a:extLst xmlns:a="http://schemas.openxmlformats.org/drawingml/2006/main">
               <a:ext uri="{FF2B5EF4-FFF2-40B4-BE49-F238E27FC236}">
-                <a16:creationId xmlns:a16="http://schemas.microsoft.com/office/drawing/2014/main" id="{73B6D62C-7354-452B-8E8E-8510BCAD9763}"/>
+                <a16:creationId xmlns:a16="http://schemas.microsoft.com/office/drawing/2014/main" id="{A03187BF-FF09-44F0-A8EE-A66166C2A50D}"/>
               </a:ext>
             </a:extLst>
           </p:cNvPr>
@@ -5811,7 +7122,7 @@
           <p:cNvPr id="2" name="">
             <a:extLst xmlns:a="http://schemas.openxmlformats.org/drawingml/2006/main">
               <a:ext uri="{FF2B5EF4-FFF2-40B4-BE49-F238E27FC236}">
-                <a16:creationId xmlns:a16="http://schemas.microsoft.com/office/drawing/2014/main" id="{13C669AC-D404-45C2-8B2F-D50B2436FD17}"/>
+                <a16:creationId xmlns:a16="http://schemas.microsoft.com/office/drawing/2014/main" id="{1A482E36-C4A7-48B8-9FF3-AA412A695098}"/>
               </a:ext>
             </a:extLst>
           </p:cNvPr>
@@ -5868,7 +7179,7 @@
           <p:cNvPr id="3" name="">
             <a:extLst xmlns:a="http://schemas.openxmlformats.org/drawingml/2006/main">
               <a:ext uri="{FF2B5EF4-FFF2-40B4-BE49-F238E27FC236}">
-                <a16:creationId xmlns:a16="http://schemas.microsoft.com/office/drawing/2014/main" id="{52ED01DF-3526-4550-9F66-89649956642D}"/>
+                <a16:creationId xmlns:a16="http://schemas.microsoft.com/office/drawing/2014/main" id="{A420DFB9-DFD9-4AF5-803A-492436BBF0B4}"/>
               </a:ext>
             </a:extLst>
           </p:cNvPr>
@@ -5898,7 +7209,7 @@
           <p:cNvPr id="4" name="">
             <a:extLst xmlns:a="http://schemas.openxmlformats.org/drawingml/2006/main">
               <a:ext uri="{FF2B5EF4-FFF2-40B4-BE49-F238E27FC236}">
-                <a16:creationId xmlns:a16="http://schemas.microsoft.com/office/drawing/2014/main" id="{E88D43FA-E9C8-474D-A65D-29EFC002FE2F}"/>
+                <a16:creationId xmlns:a16="http://schemas.microsoft.com/office/drawing/2014/main" id="{0D93870D-19EA-465E-A0FE-5D0D6B920F57}"/>
               </a:ext>
             </a:extLst>
           </p:cNvPr>
@@ -5928,7 +7239,7 @@
           <p:cNvPr id="5" name="">
             <a:extLst xmlns:a="http://schemas.openxmlformats.org/drawingml/2006/main">
               <a:ext uri="{FF2B5EF4-FFF2-40B4-BE49-F238E27FC236}">
-                <a16:creationId xmlns:a16="http://schemas.microsoft.com/office/drawing/2014/main" id="{B645AAB9-D477-4500-A78D-141185E86A08}"/>
+                <a16:creationId xmlns:a16="http://schemas.microsoft.com/office/drawing/2014/main" id="{317F6DD3-A873-4649-B5C6-A09A93E03EB2}"/>
               </a:ext>
             </a:extLst>
           </p:cNvPr>
@@ -5985,7 +7296,7 @@
           <p:cNvPr id="6" name="">
             <a:extLst xmlns:a="http://schemas.openxmlformats.org/drawingml/2006/main">
               <a:ext uri="{FF2B5EF4-FFF2-40B4-BE49-F238E27FC236}">
-                <a16:creationId xmlns:a16="http://schemas.microsoft.com/office/drawing/2014/main" id="{ECF58414-D4B8-43C1-BCBA-876800CFD24C}"/>
+                <a16:creationId xmlns:a16="http://schemas.microsoft.com/office/drawing/2014/main" id="{9F1ED9D9-2C4F-472D-9BE9-039BDC77DC47}"/>
               </a:ext>
             </a:extLst>
           </p:cNvPr>
@@ -6042,7 +7353,7 @@
           <p:cNvPr id="7" name="">
             <a:extLst xmlns:a="http://schemas.openxmlformats.org/drawingml/2006/main">
               <a:ext uri="{FF2B5EF4-FFF2-40B4-BE49-F238E27FC236}">
-                <a16:creationId xmlns:a16="http://schemas.microsoft.com/office/drawing/2014/main" id="{32B509E1-E8B4-4BFE-AE77-4C309CE8C719}"/>
+                <a16:creationId xmlns:a16="http://schemas.microsoft.com/office/drawing/2014/main" id="{2B8E9FAB-DFE7-4C4F-85C3-FC6744192CCE}"/>
               </a:ext>
             </a:extLst>
           </p:cNvPr>
@@ -6099,7 +7410,7 @@
           <p:cNvPr id="8" name="">
             <a:extLst xmlns:a="http://schemas.openxmlformats.org/drawingml/2006/main">
               <a:ext uri="{FF2B5EF4-FFF2-40B4-BE49-F238E27FC236}">
-                <a16:creationId xmlns:a16="http://schemas.microsoft.com/office/drawing/2014/main" id="{30B62326-CA42-4967-8DD6-816014D226E0}"/>
+                <a16:creationId xmlns:a16="http://schemas.microsoft.com/office/drawing/2014/main" id="{917C7478-C287-4601-9847-EEDA99960686}"/>
               </a:ext>
             </a:extLst>
           </p:cNvPr>
@@ -6156,7 +7467,7 @@
           <p:cNvPr id="9" name="">
             <a:extLst xmlns:a="http://schemas.openxmlformats.org/drawingml/2006/main">
               <a:ext uri="{FF2B5EF4-FFF2-40B4-BE49-F238E27FC236}">
-                <a16:creationId xmlns:a16="http://schemas.microsoft.com/office/drawing/2014/main" id="{CD3601CE-4BCE-43DA-90E2-DBB418F0633D}"/>
+                <a16:creationId xmlns:a16="http://schemas.microsoft.com/office/drawing/2014/main" id="{8968EAEA-49C6-44A0-AB85-82EBF219549C}"/>
               </a:ext>
             </a:extLst>
           </p:cNvPr>
@@ -6186,7 +7497,7 @@
           <p:cNvPr id="10" name="">
             <a:extLst xmlns:a="http://schemas.openxmlformats.org/drawingml/2006/main">
               <a:ext uri="{FF2B5EF4-FFF2-40B4-BE49-F238E27FC236}">
-                <a16:creationId xmlns:a16="http://schemas.microsoft.com/office/drawing/2014/main" id="{D72FEDC3-B929-43B8-8FBB-E8E91D742DF1}"/>
+                <a16:creationId xmlns:a16="http://schemas.microsoft.com/office/drawing/2014/main" id="{854677D4-88D7-4A6B-AFBD-29A04095B871}"/>
               </a:ext>
             </a:extLst>
           </p:cNvPr>
@@ -6243,7 +7554,7 @@
           <p:cNvPr id="11" name="">
             <a:extLst xmlns:a="http://schemas.openxmlformats.org/drawingml/2006/main">
               <a:ext uri="{FF2B5EF4-FFF2-40B4-BE49-F238E27FC236}">
-                <a16:creationId xmlns:a16="http://schemas.microsoft.com/office/drawing/2014/main" id="{54F5F320-8D2B-4EEC-B573-4D5022A386BF}"/>
+                <a16:creationId xmlns:a16="http://schemas.microsoft.com/office/drawing/2014/main" id="{90E2C2B9-EA45-43A7-909B-D0763FFF939E}"/>
               </a:ext>
             </a:extLst>
           </p:cNvPr>
@@ -6298,7 +7609,7 @@
     </p:spTree>
     <p:extLst>
       <p:ext uri="{BB962C8B-B14F-4D97-AF65-F5344CB8AC3E}">
-        <p14:creationId xmlns:p14="http://schemas.microsoft.com/office/powerpoint/2010/main" val="1287790917"/>
+        <p14:creationId xmlns:p14="http://schemas.microsoft.com/office/powerpoint/2010/main" val="498371696"/>
       </p:ext>
     </p:extLst>
   </p:cSld>
@@ -6329,7 +7640,7 @@
           <p:cNvPr id="17" name="">
             <a:extLst xmlns:a="http://schemas.openxmlformats.org/drawingml/2006/main">
               <a:ext uri="{FF2B5EF4-FFF2-40B4-BE49-F238E27FC236}">
-                <a16:creationId xmlns:a16="http://schemas.microsoft.com/office/drawing/2014/main" id="{69E40640-6882-4D7B-AE87-BB166CB6660A}"/>
+                <a16:creationId xmlns:a16="http://schemas.microsoft.com/office/drawing/2014/main" id="{81BEFAEA-9AF1-4099-9A1F-68358D4D8B76}"/>
               </a:ext>
             </a:extLst>
           </p:cNvPr>
@@ -6359,7 +7670,7 @@
           <p:cNvPr id="2" name="">
             <a:extLst xmlns:a="http://schemas.openxmlformats.org/drawingml/2006/main">
               <a:ext uri="{FF2B5EF4-FFF2-40B4-BE49-F238E27FC236}">
-                <a16:creationId xmlns:a16="http://schemas.microsoft.com/office/drawing/2014/main" id="{01C4CC48-699B-46BD-A722-BD45529AD7CC}"/>
+                <a16:creationId xmlns:a16="http://schemas.microsoft.com/office/drawing/2014/main" id="{883169EA-3E27-4B35-AF1A-23BA2F37974E}"/>
               </a:ext>
             </a:extLst>
           </p:cNvPr>
@@ -6389,7 +7700,7 @@
           <p:cNvPr id="3" name="">
             <a:extLst xmlns:a="http://schemas.openxmlformats.org/drawingml/2006/main">
               <a:ext uri="{FF2B5EF4-FFF2-40B4-BE49-F238E27FC236}">
-                <a16:creationId xmlns:a16="http://schemas.microsoft.com/office/drawing/2014/main" id="{4209F21C-18DA-4F43-A04A-CF2E643747E2}"/>
+                <a16:creationId xmlns:a16="http://schemas.microsoft.com/office/drawing/2014/main" id="{83F2DE6E-32BD-4310-872D-1BCA9A5DE4D8}"/>
               </a:ext>
             </a:extLst>
           </p:cNvPr>
@@ -6446,7 +7757,7 @@
           <p:cNvPr id="4" name="">
             <a:extLst xmlns:a="http://schemas.openxmlformats.org/drawingml/2006/main">
               <a:ext uri="{FF2B5EF4-FFF2-40B4-BE49-F238E27FC236}">
-                <a16:creationId xmlns:a16="http://schemas.microsoft.com/office/drawing/2014/main" id="{44B6A2A5-1A83-40E4-BF1A-42B1AFC79F35}"/>
+                <a16:creationId xmlns:a16="http://schemas.microsoft.com/office/drawing/2014/main" id="{A3DAE35C-5335-40EB-9BDD-CB60A8C45B49}"/>
               </a:ext>
             </a:extLst>
           </p:cNvPr>
@@ -6503,7 +7814,7 @@
           <p:cNvPr id="5" name="">
             <a:extLst xmlns:a="http://schemas.openxmlformats.org/drawingml/2006/main">
               <a:ext uri="{FF2B5EF4-FFF2-40B4-BE49-F238E27FC236}">
-                <a16:creationId xmlns:a16="http://schemas.microsoft.com/office/drawing/2014/main" id="{80AFE693-D4DD-45FF-8A73-DBEFD69E62F6}"/>
+                <a16:creationId xmlns:a16="http://schemas.microsoft.com/office/drawing/2014/main" id="{C3CC11A4-5012-45C4-8E41-F4AFA6946623}"/>
               </a:ext>
             </a:extLst>
           </p:cNvPr>
@@ -6533,7 +7844,7 @@
           <p:cNvPr id="6" name="">
             <a:extLst xmlns:a="http://schemas.openxmlformats.org/drawingml/2006/main">
               <a:ext uri="{FF2B5EF4-FFF2-40B4-BE49-F238E27FC236}">
-                <a16:creationId xmlns:a16="http://schemas.microsoft.com/office/drawing/2014/main" id="{D280778B-4E17-410D-B611-D17E57F3A2F7}"/>
+                <a16:creationId xmlns:a16="http://schemas.microsoft.com/office/drawing/2014/main" id="{29B158C3-91E4-49DD-9AB5-4BF081DC70B2}"/>
               </a:ext>
             </a:extLst>
           </p:cNvPr>
@@ -6590,7 +7901,7 @@
           <p:cNvPr id="7" name="">
             <a:extLst xmlns:a="http://schemas.openxmlformats.org/drawingml/2006/main">
               <a:ext uri="{FF2B5EF4-FFF2-40B4-BE49-F238E27FC236}">
-                <a16:creationId xmlns:a16="http://schemas.microsoft.com/office/drawing/2014/main" id="{17ED39FA-7CE8-4C86-BB0F-2FD64C373732}"/>
+                <a16:creationId xmlns:a16="http://schemas.microsoft.com/office/drawing/2014/main" id="{55A7771D-4B08-4595-8FD9-1AB743DAF14C}"/>
               </a:ext>
             </a:extLst>
           </p:cNvPr>
@@ -6647,7 +7958,7 @@
           <p:cNvPr id="8" name="">
             <a:extLst xmlns:a="http://schemas.openxmlformats.org/drawingml/2006/main">
               <a:ext uri="{FF2B5EF4-FFF2-40B4-BE49-F238E27FC236}">
-                <a16:creationId xmlns:a16="http://schemas.microsoft.com/office/drawing/2014/main" id="{A76F33ED-77AC-4E80-9E63-1022BC4B1061}"/>
+                <a16:creationId xmlns:a16="http://schemas.microsoft.com/office/drawing/2014/main" id="{663B018B-4323-43C3-8103-2CDEB471034A}"/>
               </a:ext>
             </a:extLst>
           </p:cNvPr>
@@ -6704,7 +8015,7 @@
           <p:cNvPr id="9" name="">
             <a:extLst xmlns:a="http://schemas.openxmlformats.org/drawingml/2006/main">
               <a:ext uri="{FF2B5EF4-FFF2-40B4-BE49-F238E27FC236}">
-                <a16:creationId xmlns:a16="http://schemas.microsoft.com/office/drawing/2014/main" id="{1D1E06C1-03CB-4B37-9F2F-5CAA95830850}"/>
+                <a16:creationId xmlns:a16="http://schemas.microsoft.com/office/drawing/2014/main" id="{7126C302-E5C8-45DC-8AA5-B774202D5DD1}"/>
               </a:ext>
             </a:extLst>
           </p:cNvPr>
@@ -6734,7 +8045,7 @@
           <p:cNvPr id="10" name="">
             <a:extLst xmlns:a="http://schemas.openxmlformats.org/drawingml/2006/main">
               <a:ext uri="{FF2B5EF4-FFF2-40B4-BE49-F238E27FC236}">
-                <a16:creationId xmlns:a16="http://schemas.microsoft.com/office/drawing/2014/main" id="{849D457E-EFA9-4130-948D-3085C9097232}"/>
+                <a16:creationId xmlns:a16="http://schemas.microsoft.com/office/drawing/2014/main" id="{B3E7E6A8-10F9-4402-A837-9C1C9285E442}"/>
               </a:ext>
             </a:extLst>
           </p:cNvPr>
@@ -6791,7 +8102,7 @@
           <p:cNvPr id="11" name="">
             <a:extLst xmlns:a="http://schemas.openxmlformats.org/drawingml/2006/main">
               <a:ext uri="{FF2B5EF4-FFF2-40B4-BE49-F238E27FC236}">
-                <a16:creationId xmlns:a16="http://schemas.microsoft.com/office/drawing/2014/main" id="{A3A9FEE6-0E91-47A7-814F-90EC93EC0BBA}"/>
+                <a16:creationId xmlns:a16="http://schemas.microsoft.com/office/drawing/2014/main" id="{99A822AA-EE4C-4B40-8065-48D6A4A57AE6}"/>
               </a:ext>
             </a:extLst>
           </p:cNvPr>
@@ -6848,7 +8159,7 @@
           <p:cNvPr id="12" name="">
             <a:extLst xmlns:a="http://schemas.openxmlformats.org/drawingml/2006/main">
               <a:ext uri="{FF2B5EF4-FFF2-40B4-BE49-F238E27FC236}">
-                <a16:creationId xmlns:a16="http://schemas.microsoft.com/office/drawing/2014/main" id="{4753562B-A03A-46E9-B923-337042AF737C}"/>
+                <a16:creationId xmlns:a16="http://schemas.microsoft.com/office/drawing/2014/main" id="{7ED77B2A-2B2A-4A92-AFF5-87325044B29B}"/>
               </a:ext>
             </a:extLst>
           </p:cNvPr>
@@ -6905,7 +8216,7 @@
           <p:cNvPr id="13" name="">
             <a:extLst xmlns:a="http://schemas.openxmlformats.org/drawingml/2006/main">
               <a:ext uri="{FF2B5EF4-FFF2-40B4-BE49-F238E27FC236}">
-                <a16:creationId xmlns:a16="http://schemas.microsoft.com/office/drawing/2014/main" id="{18A1057A-5B14-4498-814D-2F8857CDD9C3}"/>
+                <a16:creationId xmlns:a16="http://schemas.microsoft.com/office/drawing/2014/main" id="{D843BF82-9BAD-469F-A89C-9DD782C27F77}"/>
               </a:ext>
             </a:extLst>
           </p:cNvPr>
@@ -6935,7 +8246,7 @@
           <p:cNvPr id="14" name="">
             <a:extLst xmlns:a="http://schemas.openxmlformats.org/drawingml/2006/main">
               <a:ext uri="{FF2B5EF4-FFF2-40B4-BE49-F238E27FC236}">
-                <a16:creationId xmlns:a16="http://schemas.microsoft.com/office/drawing/2014/main" id="{A714A577-9894-4CE2-8DA0-8CE2F7CEC1C8}"/>
+                <a16:creationId xmlns:a16="http://schemas.microsoft.com/office/drawing/2014/main" id="{042620F2-275A-4E0E-9220-CAFA26CE8CB8}"/>
               </a:ext>
             </a:extLst>
           </p:cNvPr>
@@ -6992,7 +8303,7 @@
           <p:cNvPr id="15" name="">
             <a:extLst xmlns:a="http://schemas.openxmlformats.org/drawingml/2006/main">
               <a:ext uri="{FF2B5EF4-FFF2-40B4-BE49-F238E27FC236}">
-                <a16:creationId xmlns:a16="http://schemas.microsoft.com/office/drawing/2014/main" id="{A2A4FDFA-FA4E-4167-A6B0-B68EB3573BF3}"/>
+                <a16:creationId xmlns:a16="http://schemas.microsoft.com/office/drawing/2014/main" id="{8267C48D-0DAE-4C16-B2DF-5864E3CD9479}"/>
               </a:ext>
             </a:extLst>
           </p:cNvPr>
@@ -7049,7 +8360,7 @@
           <p:cNvPr id="16" name="">
             <a:extLst xmlns:a="http://schemas.openxmlformats.org/drawingml/2006/main">
               <a:ext uri="{FF2B5EF4-FFF2-40B4-BE49-F238E27FC236}">
-                <a16:creationId xmlns:a16="http://schemas.microsoft.com/office/drawing/2014/main" id="{E74636DE-B885-4C72-94E2-F1A3DB929588}"/>
+                <a16:creationId xmlns:a16="http://schemas.microsoft.com/office/drawing/2014/main" id="{227756CE-95EE-4948-BD50-D48AE1E54335}"/>
               </a:ext>
             </a:extLst>
           </p:cNvPr>
@@ -7104,7 +8415,7 @@
     </p:spTree>
     <p:extLst>
       <p:ext uri="{BB962C8B-B14F-4D97-AF65-F5344CB8AC3E}">
-        <p14:creationId xmlns:p14="http://schemas.microsoft.com/office/powerpoint/2010/main" val="104133457"/>
+        <p14:creationId xmlns:p14="http://schemas.microsoft.com/office/powerpoint/2010/main" val="89558498"/>
       </p:ext>
     </p:extLst>
   </p:cSld>
@@ -7132,24 +8443,24 @@
       </p:grpSpPr>
       <p:sp>
         <p:nvSpPr>
-          <p:cNvPr id="9" name="">
-            <a:extLst xmlns:a="http://schemas.openxmlformats.org/drawingml/2006/main">
-              <a:ext uri="{FF2B5EF4-FFF2-40B4-BE49-F238E27FC236}">
-                <a16:creationId xmlns:a16="http://schemas.microsoft.com/office/drawing/2014/main" id="{E079267D-53A2-47DF-9FCC-D6547C496553}"/>
-              </a:ext>
-            </a:extLst>
-          </p:cNvPr>
-          <p:cNvSpPr>
-            <a:spLocks xmlns:a="http://schemas.openxmlformats.org/drawingml/2006/main" noGrp="1"/>
-          </p:cNvSpPr>
-          <p:nvPr/>
-        </p:nvSpPr>
-        <p:spPr>
-          <a:xfrm xmlns:a="http://schemas.openxmlformats.org/drawingml/2006/main">
-            <a:off x="0" y="2013742"/>
-            <a:ext cx="12192000" cy="2493433"/>
-          </a:xfrm>
-          <a:prstGeom xmlns:a="http://schemas.openxmlformats.org/drawingml/2006/main" prst="rect">
+          <p:cNvPr id="17" name="">
+            <a:extLst xmlns:a="http://schemas.openxmlformats.org/drawingml/2006/main">
+              <a:ext uri="{FF2B5EF4-FFF2-40B4-BE49-F238E27FC236}">
+                <a16:creationId xmlns:a16="http://schemas.microsoft.com/office/drawing/2014/main" id="{611AC960-EB2C-4647-852D-BA7F471D37C1}"/>
+              </a:ext>
+            </a:extLst>
+          </p:cNvPr>
+          <p:cNvSpPr>
+            <a:spLocks xmlns:a="http://schemas.openxmlformats.org/drawingml/2006/main" noGrp="1"/>
+          </p:cNvSpPr>
+          <p:nvPr/>
+        </p:nvSpPr>
+        <p:spPr>
+          <a:xfrm xmlns:a="http://schemas.openxmlformats.org/drawingml/2006/main" rot="5400000">
+            <a:off x="533400" y="295275"/>
+            <a:ext cx="228600" cy="209550"/>
+          </a:xfrm>
+          <a:prstGeom xmlns:a="http://schemas.openxmlformats.org/drawingml/2006/main" prst="triangle">
             <a:avLst/>
           </a:prstGeom>
           <a:solidFill xmlns:a="http://schemas.openxmlformats.org/drawingml/2006/main">
@@ -7165,24 +8476,79 @@
           <p:cNvPr id="2" name="">
             <a:extLst xmlns:a="http://schemas.openxmlformats.org/drawingml/2006/main">
               <a:ext uri="{FF2B5EF4-FFF2-40B4-BE49-F238E27FC236}">
-                <a16:creationId xmlns:a16="http://schemas.microsoft.com/office/drawing/2014/main" id="{0AE22C66-0F1C-4C0F-815C-CA8C98CF04AA}"/>
-              </a:ext>
-            </a:extLst>
-          </p:cNvPr>
-          <p:cNvSpPr>
-            <a:spLocks xmlns:a="http://schemas.openxmlformats.org/drawingml/2006/main" noGrp="1"/>
-          </p:cNvSpPr>
-          <p:nvPr/>
-        </p:nvSpPr>
-        <p:spPr>
-          <a:xfrm xmlns:a="http://schemas.openxmlformats.org/drawingml/2006/main">
-            <a:off x="346377" y="262633"/>
-            <a:ext cx="596598" cy="60922"/>
-          </a:xfrm>
-          <a:prstGeom xmlns:a="http://schemas.openxmlformats.org/drawingml/2006/main" prst="roundRect">
-            <a:avLst>
-              <a:gd name="adj" fmla="val 50000"/>
-            </a:avLst>
+                <a16:creationId xmlns:a16="http://schemas.microsoft.com/office/drawing/2014/main" id="{35372B5C-8A4D-4E33-AE57-94ADB0AEAE1D}"/>
+              </a:ext>
+            </a:extLst>
+          </p:cNvPr>
+          <p:cNvSpPr>
+            <a:spLocks xmlns:a="http://schemas.openxmlformats.org/drawingml/2006/main" noGrp="1"/>
+          </p:cNvSpPr>
+          <p:nvPr/>
+        </p:nvSpPr>
+        <p:spPr>
+          <a:xfrm xmlns:a="http://schemas.openxmlformats.org/drawingml/2006/main">
+            <a:off x="857250" y="219075"/>
+            <a:ext cx="10715625" cy="409575"/>
+          </a:xfrm>
+          <a:prstGeom xmlns:a="http://schemas.openxmlformats.org/drawingml/2006/main" prst="rect">
+            <a:avLst/>
+          </a:prstGeom>
+          <a:noFill xmlns:a="http://schemas.openxmlformats.org/drawingml/2006/main"/>
+          <a:ln xmlns:a="http://schemas.openxmlformats.org/drawingml/2006/main" w="0">
+            <a:noFill/>
+          </a:ln>
+        </p:spPr>
+        <p:txBody>
+          <a:bodyPr xmlns:a="http://schemas.openxmlformats.org/drawingml/2006/main" wrap="square" lIns="0" tIns="0" rIns="0" bIns="0" anchor="t">
+            <a:noAutofit/>
+          </a:bodyPr>
+          <a:lstStyle xmlns:a="http://schemas.openxmlformats.org/drawingml/2006/main"/>
+          <a:p xmlns:a="http://schemas.openxmlformats.org/drawingml/2006/main">
+            <a:pPr algn="l">
+              <a:defRPr sz="2400" b="1">
+                <a:solidFill>
+                  <a:srgbClr val="32497B"/>
+                </a:solidFill>
+                <a:latin typeface="Source Han Sans CN"/>
+                <a:ea typeface="Source Han Sans CN"/>
+                <a:cs typeface="Source Han Sans CN"/>
+              </a:defRPr>
+            </a:pPr>
+            <a:r>
+              <a:rPr sz="2400" b="1">
+                <a:solidFill>
+                  <a:srgbClr val="32497B"/>
+                </a:solidFill>
+                <a:latin typeface="Source Han Sans CN"/>
+                <a:ea typeface="Source Han Sans CN"/>
+                <a:cs typeface="Source Han Sans CN"/>
+              </a:rPr>
+              <a:t>1.1 文献基本信息</a:t>
+            </a:r>
+          </a:p>
+        </p:txBody>
+      </p:sp>
+      <p:sp>
+        <p:nvSpPr>
+          <p:cNvPr id="3" name="">
+            <a:extLst xmlns:a="http://schemas.openxmlformats.org/drawingml/2006/main">
+              <a:ext uri="{FF2B5EF4-FFF2-40B4-BE49-F238E27FC236}">
+                <a16:creationId xmlns:a16="http://schemas.microsoft.com/office/drawing/2014/main" id="{9C55435A-A7CF-4D22-A3B9-06FBB8B31BEF}"/>
+              </a:ext>
+            </a:extLst>
+          </p:cNvPr>
+          <p:cNvSpPr>
+            <a:spLocks xmlns:a="http://schemas.openxmlformats.org/drawingml/2006/main" noGrp="1"/>
+          </p:cNvSpPr>
+          <p:nvPr/>
+        </p:nvSpPr>
+        <p:spPr>
+          <a:xfrm xmlns:a="http://schemas.openxmlformats.org/drawingml/2006/main">
+            <a:off x="533400" y="638175"/>
+            <a:ext cx="11125200" cy="9525"/>
+          </a:xfrm>
+          <a:prstGeom xmlns:a="http://schemas.openxmlformats.org/drawingml/2006/main" prst="rect">
+            <a:avLst/>
           </a:prstGeom>
           <a:solidFill xmlns:a="http://schemas.openxmlformats.org/drawingml/2006/main">
             <a:srgbClr val="32497B"/>
@@ -7194,27 +8560,25 @@
       </p:sp>
       <p:sp>
         <p:nvSpPr>
-          <p:cNvPr id="3" name="">
-            <a:extLst xmlns:a="http://schemas.openxmlformats.org/drawingml/2006/main">
-              <a:ext uri="{FF2B5EF4-FFF2-40B4-BE49-F238E27FC236}">
-                <a16:creationId xmlns:a16="http://schemas.microsoft.com/office/drawing/2014/main" id="{ABDC2C01-4214-49CD-8FDF-359D6B75E38C}"/>
-              </a:ext>
-            </a:extLst>
-          </p:cNvPr>
-          <p:cNvSpPr>
-            <a:spLocks xmlns:a="http://schemas.openxmlformats.org/drawingml/2006/main" noGrp="1"/>
-          </p:cNvSpPr>
-          <p:nvPr/>
-        </p:nvSpPr>
-        <p:spPr>
-          <a:xfrm xmlns:a="http://schemas.openxmlformats.org/drawingml/2006/main">
-            <a:off x="346377" y="363645"/>
-            <a:ext cx="432806" cy="60922"/>
-          </a:xfrm>
-          <a:prstGeom xmlns:a="http://schemas.openxmlformats.org/drawingml/2006/main" prst="roundRect">
-            <a:avLst>
-              <a:gd name="adj" fmla="val 50000"/>
-            </a:avLst>
+          <p:cNvPr id="4" name="">
+            <a:extLst xmlns:a="http://schemas.openxmlformats.org/drawingml/2006/main">
+              <a:ext uri="{FF2B5EF4-FFF2-40B4-BE49-F238E27FC236}">
+                <a16:creationId xmlns:a16="http://schemas.microsoft.com/office/drawing/2014/main" id="{7573A5C9-40AB-4483-B093-687AF54A9E75}"/>
+              </a:ext>
+            </a:extLst>
+          </p:cNvPr>
+          <p:cNvSpPr>
+            <a:spLocks xmlns:a="http://schemas.openxmlformats.org/drawingml/2006/main" noGrp="1"/>
+          </p:cNvSpPr>
+          <p:nvPr/>
+        </p:nvSpPr>
+        <p:spPr>
+          <a:xfrm xmlns:a="http://schemas.openxmlformats.org/drawingml/2006/main">
+            <a:off x="11782425" y="6438900"/>
+            <a:ext cx="409575" cy="419100"/>
+          </a:xfrm>
+          <a:prstGeom xmlns:a="http://schemas.openxmlformats.org/drawingml/2006/main" prst="rect">
+            <a:avLst/>
           </a:prstGeom>
           <a:solidFill xmlns:a="http://schemas.openxmlformats.org/drawingml/2006/main">
             <a:srgbClr val="32497B"/>
@@ -7226,150 +8590,22 @@
       </p:sp>
       <p:sp>
         <p:nvSpPr>
-          <p:cNvPr id="4" name="">
-            <a:extLst xmlns:a="http://schemas.openxmlformats.org/drawingml/2006/main">
-              <a:ext uri="{FF2B5EF4-FFF2-40B4-BE49-F238E27FC236}">
-                <a16:creationId xmlns:a16="http://schemas.microsoft.com/office/drawing/2014/main" id="{647550E2-52AF-4999-9CE8-03C6AB5417DB}"/>
-              </a:ext>
-            </a:extLst>
-          </p:cNvPr>
-          <p:cNvSpPr>
-            <a:spLocks xmlns:a="http://schemas.openxmlformats.org/drawingml/2006/main" noGrp="1"/>
-          </p:cNvSpPr>
-          <p:nvPr/>
-        </p:nvSpPr>
-        <p:spPr>
-          <a:xfrm xmlns:a="http://schemas.openxmlformats.org/drawingml/2006/main">
-            <a:off x="346377" y="464668"/>
-            <a:ext cx="291503" cy="60922"/>
-          </a:xfrm>
-          <a:prstGeom xmlns:a="http://schemas.openxmlformats.org/drawingml/2006/main" prst="roundRect">
-            <a:avLst>
-              <a:gd name="adj" fmla="val 50000"/>
-            </a:avLst>
-          </a:prstGeom>
-          <a:solidFill xmlns:a="http://schemas.openxmlformats.org/drawingml/2006/main">
-            <a:srgbClr val="32497B"/>
-          </a:solidFill>
-          <a:ln xmlns:a="http://schemas.openxmlformats.org/drawingml/2006/main" w="0">
-            <a:noFill/>
-          </a:ln>
-        </p:spPr>
-      </p:sp>
-      <p:sp>
-        <p:nvSpPr>
           <p:cNvPr id="5" name="">
             <a:extLst xmlns:a="http://schemas.openxmlformats.org/drawingml/2006/main">
               <a:ext uri="{FF2B5EF4-FFF2-40B4-BE49-F238E27FC236}">
-                <a16:creationId xmlns:a16="http://schemas.microsoft.com/office/drawing/2014/main" id="{8F477473-EF82-4DD0-85E8-C778CD3C67AA}"/>
-              </a:ext>
-            </a:extLst>
-          </p:cNvPr>
-          <p:cNvSpPr>
-            <a:spLocks xmlns:a="http://schemas.openxmlformats.org/drawingml/2006/main" noGrp="1"/>
-          </p:cNvSpPr>
-          <p:nvPr/>
-        </p:nvSpPr>
-        <p:spPr>
-          <a:xfrm xmlns:a="http://schemas.openxmlformats.org/drawingml/2006/main">
-            <a:off x="11249025" y="6537646"/>
-            <a:ext cx="596598" cy="60922"/>
-          </a:xfrm>
-          <a:prstGeom xmlns:a="http://schemas.openxmlformats.org/drawingml/2006/main" prst="roundRect">
-            <a:avLst>
-              <a:gd name="adj" fmla="val 50000"/>
-            </a:avLst>
-          </a:prstGeom>
-          <a:solidFill xmlns:a="http://schemas.openxmlformats.org/drawingml/2006/main">
-            <a:srgbClr val="32497B"/>
-          </a:solidFill>
-          <a:ln xmlns:a="http://schemas.openxmlformats.org/drawingml/2006/main" w="0">
-            <a:noFill/>
-          </a:ln>
-        </p:spPr>
-      </p:sp>
-      <p:sp>
-        <p:nvSpPr>
-          <p:cNvPr id="6" name="">
-            <a:extLst xmlns:a="http://schemas.openxmlformats.org/drawingml/2006/main">
-              <a:ext uri="{FF2B5EF4-FFF2-40B4-BE49-F238E27FC236}">
-                <a16:creationId xmlns:a16="http://schemas.microsoft.com/office/drawing/2014/main" id="{84386FD7-45C9-4374-BE3F-7F3D41C1E644}"/>
-              </a:ext>
-            </a:extLst>
-          </p:cNvPr>
-          <p:cNvSpPr>
-            <a:spLocks xmlns:a="http://schemas.openxmlformats.org/drawingml/2006/main" noGrp="1"/>
-          </p:cNvSpPr>
-          <p:nvPr/>
-        </p:nvSpPr>
-        <p:spPr>
-          <a:xfrm xmlns:a="http://schemas.openxmlformats.org/drawingml/2006/main">
-            <a:off x="11412817" y="6436624"/>
-            <a:ext cx="432806" cy="60922"/>
-          </a:xfrm>
-          <a:prstGeom xmlns:a="http://schemas.openxmlformats.org/drawingml/2006/main" prst="roundRect">
-            <a:avLst>
-              <a:gd name="adj" fmla="val 50000"/>
-            </a:avLst>
-          </a:prstGeom>
-          <a:solidFill xmlns:a="http://schemas.openxmlformats.org/drawingml/2006/main">
-            <a:srgbClr val="32497B"/>
-          </a:solidFill>
-          <a:ln xmlns:a="http://schemas.openxmlformats.org/drawingml/2006/main" w="0">
-            <a:noFill/>
-          </a:ln>
-        </p:spPr>
-      </p:sp>
-      <p:sp>
-        <p:nvSpPr>
-          <p:cNvPr id="7" name="">
-            <a:extLst xmlns:a="http://schemas.openxmlformats.org/drawingml/2006/main">
-              <a:ext uri="{FF2B5EF4-FFF2-40B4-BE49-F238E27FC236}">
-                <a16:creationId xmlns:a16="http://schemas.microsoft.com/office/drawing/2014/main" id="{DA1C7B65-F12F-4165-B104-4B4D6626D7FB}"/>
-              </a:ext>
-            </a:extLst>
-          </p:cNvPr>
-          <p:cNvSpPr>
-            <a:spLocks xmlns:a="http://schemas.openxmlformats.org/drawingml/2006/main" noGrp="1"/>
-          </p:cNvSpPr>
-          <p:nvPr/>
-        </p:nvSpPr>
-        <p:spPr>
-          <a:xfrm xmlns:a="http://schemas.openxmlformats.org/drawingml/2006/main">
-            <a:off x="11554111" y="6335611"/>
-            <a:ext cx="291503" cy="60922"/>
-          </a:xfrm>
-          <a:prstGeom xmlns:a="http://schemas.openxmlformats.org/drawingml/2006/main" prst="roundRect">
-            <a:avLst>
-              <a:gd name="adj" fmla="val 50000"/>
-            </a:avLst>
-          </a:prstGeom>
-          <a:solidFill xmlns:a="http://schemas.openxmlformats.org/drawingml/2006/main">
-            <a:srgbClr val="32497B"/>
-          </a:solidFill>
-          <a:ln xmlns:a="http://schemas.openxmlformats.org/drawingml/2006/main" w="0">
-            <a:noFill/>
-          </a:ln>
-        </p:spPr>
-      </p:sp>
-      <p:sp>
-        <p:nvSpPr>
-          <p:cNvPr id="8" name="">
-            <a:extLst xmlns:a="http://schemas.openxmlformats.org/drawingml/2006/main">
-              <a:ext uri="{FF2B5EF4-FFF2-40B4-BE49-F238E27FC236}">
-                <a16:creationId xmlns:a16="http://schemas.microsoft.com/office/drawing/2014/main" id="{1FE08006-E90D-45D5-A226-E931CF4F348A}"/>
-              </a:ext>
-            </a:extLst>
-          </p:cNvPr>
-          <p:cNvSpPr>
-            <a:spLocks xmlns:a="http://schemas.openxmlformats.org/drawingml/2006/main" noGrp="1"/>
-          </p:cNvSpPr>
-          <p:nvPr/>
-        </p:nvSpPr>
-        <p:spPr>
-          <a:xfrm xmlns:a="http://schemas.openxmlformats.org/drawingml/2006/main">
-            <a:off x="1284426" y="2875738"/>
-            <a:ext cx="9623148" cy="769441"/>
+                <a16:creationId xmlns:a16="http://schemas.microsoft.com/office/drawing/2014/main" id="{059086AA-16C3-441E-9E00-23EA052FEC9F}"/>
+              </a:ext>
+            </a:extLst>
+          </p:cNvPr>
+          <p:cNvSpPr>
+            <a:spLocks xmlns:a="http://schemas.openxmlformats.org/drawingml/2006/main" noGrp="1"/>
+          </p:cNvSpPr>
+          <p:nvPr/>
+        </p:nvSpPr>
+        <p:spPr>
+          <a:xfrm xmlns:a="http://schemas.openxmlformats.org/drawingml/2006/main">
+            <a:off x="11811000" y="6505575"/>
+            <a:ext cx="333375" cy="257175"/>
           </a:xfrm>
           <a:prstGeom xmlns:a="http://schemas.openxmlformats.org/drawingml/2006/main" prst="rect">
             <a:avLst/>
@@ -7386,7 +8622,7 @@
           <a:lstStyle xmlns:a="http://schemas.openxmlformats.org/drawingml/2006/main"/>
           <a:p xmlns:a="http://schemas.openxmlformats.org/drawingml/2006/main">
             <a:pPr algn="ctr">
-              <a:defRPr sz="4400" b="1">
+              <a:defRPr sz="1350" b="0">
                 <a:solidFill>
                   <a:srgbClr val="FFFFFF"/>
                 </a:solidFill>
@@ -7396,7 +8632,7 @@
               </a:defRPr>
             </a:pPr>
             <a:r>
-              <a:rPr sz="4400" b="1">
+              <a:rPr sz="1350" b="0">
                 <a:solidFill>
                   <a:srgbClr val="FFFFFF"/>
                 </a:solidFill>
@@ -7404,7 +8640,607 @@
                 <a:ea typeface="Source Han Sans CN"/>
                 <a:cs typeface="Source Han Sans CN"/>
               </a:rPr>
-              <a:t>汇报完毕，敬请老师同学批评指正！</a:t>
+              <a:t>9</a:t>
+            </a:r>
+          </a:p>
+        </p:txBody>
+      </p:sp>
+      <p:sp>
+        <p:nvSpPr>
+          <p:cNvPr id="6" name="">
+            <a:extLst xmlns:a="http://schemas.openxmlformats.org/drawingml/2006/main">
+              <a:ext uri="{FF2B5EF4-FFF2-40B4-BE49-F238E27FC236}">
+                <a16:creationId xmlns:a16="http://schemas.microsoft.com/office/drawing/2014/main" id="{E50C8990-8093-4FBC-9C78-72F04E88B58C}"/>
+              </a:ext>
+            </a:extLst>
+          </p:cNvPr>
+          <p:cNvSpPr>
+            <a:spLocks xmlns:a="http://schemas.openxmlformats.org/drawingml/2006/main" noGrp="1"/>
+          </p:cNvSpPr>
+          <p:nvPr/>
+        </p:nvSpPr>
+        <p:spPr>
+          <a:xfrm xmlns:a="http://schemas.openxmlformats.org/drawingml/2006/main">
+            <a:off x="609600" y="981075"/>
+            <a:ext cx="10953750" cy="414338"/>
+          </a:xfrm>
+          <a:prstGeom xmlns:a="http://schemas.openxmlformats.org/drawingml/2006/main" prst="rect">
+            <a:avLst/>
+          </a:prstGeom>
+          <a:noFill xmlns:a="http://schemas.openxmlformats.org/drawingml/2006/main"/>
+          <a:ln xmlns:a="http://schemas.openxmlformats.org/drawingml/2006/main" w="0">
+            <a:noFill/>
+          </a:ln>
+        </p:spPr>
+        <p:txBody>
+          <a:bodyPr xmlns:a="http://schemas.openxmlformats.org/drawingml/2006/main" wrap="square" lIns="0" tIns="0" rIns="0" bIns="0" anchor="t">
+            <a:noAutofit/>
+          </a:bodyPr>
+          <a:lstStyle xmlns:a="http://schemas.openxmlformats.org/drawingml/2006/main"/>
+          <a:p xmlns:a="http://schemas.openxmlformats.org/drawingml/2006/main">
+            <a:pPr algn="l">
+              <a:defRPr sz="2250" b="1">
+                <a:solidFill>
+                  <a:srgbClr val="252B35"/>
+                </a:solidFill>
+                <a:latin typeface="Source Han Sans CN"/>
+                <a:ea typeface="Source Han Sans CN"/>
+                <a:cs typeface="Source Han Sans CN"/>
+              </a:defRPr>
+            </a:pPr>
+            <a:r>
+              <a:rPr sz="2250" b="1">
+                <a:solidFill>
+                  <a:srgbClr val="252B35"/>
+                </a:solidFill>
+                <a:latin typeface="Source Han Sans CN"/>
+                <a:ea typeface="Source Han Sans CN"/>
+                <a:cs typeface="Source Han Sans CN"/>
+              </a:rPr>
+              <a:t>论文完整题名</a:t>
+            </a:r>
+          </a:p>
+        </p:txBody>
+      </p:sp>
+      <p:sp>
+        <p:nvSpPr>
+          <p:cNvPr id="7" name="">
+            <a:extLst xmlns:a="http://schemas.openxmlformats.org/drawingml/2006/main">
+              <a:ext uri="{FF2B5EF4-FFF2-40B4-BE49-F238E27FC236}">
+                <a16:creationId xmlns:a16="http://schemas.microsoft.com/office/drawing/2014/main" id="{4D317F96-D3CA-4ED2-A762-8D4823661286}"/>
+              </a:ext>
+            </a:extLst>
+          </p:cNvPr>
+          <p:cNvSpPr>
+            <a:spLocks xmlns:a="http://schemas.openxmlformats.org/drawingml/2006/main" noGrp="1"/>
+          </p:cNvSpPr>
+          <p:nvPr/>
+        </p:nvSpPr>
+        <p:spPr>
+          <a:xfrm xmlns:a="http://schemas.openxmlformats.org/drawingml/2006/main">
+            <a:off x="609600" y="1490663"/>
+            <a:ext cx="10953750" cy="327660"/>
+          </a:xfrm>
+          <a:prstGeom xmlns:a="http://schemas.openxmlformats.org/drawingml/2006/main" prst="rect">
+            <a:avLst/>
+          </a:prstGeom>
+          <a:noFill xmlns:a="http://schemas.openxmlformats.org/drawingml/2006/main"/>
+          <a:ln xmlns:a="http://schemas.openxmlformats.org/drawingml/2006/main" w="0">
+            <a:noFill/>
+          </a:ln>
+        </p:spPr>
+        <p:txBody>
+          <a:bodyPr xmlns:a="http://schemas.openxmlformats.org/drawingml/2006/main" wrap="square" lIns="0" tIns="0" rIns="0" bIns="0" anchor="t">
+            <a:noAutofit/>
+          </a:bodyPr>
+          <a:lstStyle xmlns:a="http://schemas.openxmlformats.org/drawingml/2006/main"/>
+          <a:p xmlns:a="http://schemas.openxmlformats.org/drawingml/2006/main">
+            <a:pPr algn="l">
+              <a:defRPr sz="1800" b="0">
+                <a:solidFill>
+                  <a:srgbClr val="626873"/>
+                </a:solidFill>
+                <a:latin typeface="Source Han Sans CN"/>
+                <a:ea typeface="Source Han Sans CN"/>
+                <a:cs typeface="Source Han Sans CN"/>
+              </a:defRPr>
+            </a:pPr>
+            <a:r>
+              <a:rPr sz="1800" b="0">
+                <a:solidFill>
+                  <a:srgbClr val="626873"/>
+                </a:solidFill>
+                <a:latin typeface="Source Han Sans CN"/>
+                <a:ea typeface="Source Han Sans CN"/>
+                <a:cs typeface="Source Han Sans CN"/>
+              </a:rPr>
+              <a:t>必要时可另列中文译名</a:t>
+            </a:r>
+          </a:p>
+        </p:txBody>
+      </p:sp>
+      <p:sp>
+        <p:nvSpPr>
+          <p:cNvPr id="8" name="">
+            <a:extLst xmlns:a="http://schemas.openxmlformats.org/drawingml/2006/main">
+              <a:ext uri="{FF2B5EF4-FFF2-40B4-BE49-F238E27FC236}">
+                <a16:creationId xmlns:a16="http://schemas.microsoft.com/office/drawing/2014/main" id="{EB7140BD-6313-4A91-86B5-0D94CAE2CC08}"/>
+              </a:ext>
+            </a:extLst>
+          </p:cNvPr>
+          <p:cNvSpPr>
+            <a:spLocks xmlns:a="http://schemas.openxmlformats.org/drawingml/2006/main" noGrp="1"/>
+          </p:cNvSpPr>
+          <p:nvPr/>
+        </p:nvSpPr>
+        <p:spPr>
+          <a:xfrm xmlns:a="http://schemas.openxmlformats.org/drawingml/2006/main">
+            <a:off x="609600" y="1980248"/>
+            <a:ext cx="10953750" cy="9525"/>
+          </a:xfrm>
+          <a:prstGeom xmlns:a="http://schemas.openxmlformats.org/drawingml/2006/main" prst="rect">
+            <a:avLst/>
+          </a:prstGeom>
+          <a:solidFill xmlns:a="http://schemas.openxmlformats.org/drawingml/2006/main">
+            <a:srgbClr val="A9B6D0"/>
+          </a:solidFill>
+          <a:ln xmlns:a="http://schemas.openxmlformats.org/drawingml/2006/main" w="0">
+            <a:noFill/>
+          </a:ln>
+        </p:spPr>
+      </p:sp>
+      <p:sp>
+        <p:nvSpPr>
+          <p:cNvPr id="9" name="">
+            <a:extLst xmlns:a="http://schemas.openxmlformats.org/drawingml/2006/main">
+              <a:ext uri="{FF2B5EF4-FFF2-40B4-BE49-F238E27FC236}">
+                <a16:creationId xmlns:a16="http://schemas.microsoft.com/office/drawing/2014/main" id="{CEEB9371-743E-4F36-AFAE-2B5B1AB68CC7}"/>
+              </a:ext>
+            </a:extLst>
+          </p:cNvPr>
+          <p:cNvSpPr>
+            <a:spLocks xmlns:a="http://schemas.openxmlformats.org/drawingml/2006/main" noGrp="1"/>
+          </p:cNvSpPr>
+          <p:nvPr/>
+        </p:nvSpPr>
+        <p:spPr>
+          <a:xfrm xmlns:a="http://schemas.openxmlformats.org/drawingml/2006/main">
+            <a:off x="609600" y="2208848"/>
+            <a:ext cx="5114925" cy="318135"/>
+          </a:xfrm>
+          <a:prstGeom xmlns:a="http://schemas.openxmlformats.org/drawingml/2006/main" prst="rect">
+            <a:avLst/>
+          </a:prstGeom>
+          <a:noFill xmlns:a="http://schemas.openxmlformats.org/drawingml/2006/main"/>
+          <a:ln xmlns:a="http://schemas.openxmlformats.org/drawingml/2006/main" w="0">
+            <a:noFill/>
+          </a:ln>
+        </p:spPr>
+        <p:txBody>
+          <a:bodyPr xmlns:a="http://schemas.openxmlformats.org/drawingml/2006/main" wrap="square" lIns="0" tIns="0" rIns="0" bIns="0" anchor="t">
+            <a:noAutofit/>
+          </a:bodyPr>
+          <a:lstStyle xmlns:a="http://schemas.openxmlformats.org/drawingml/2006/main"/>
+          <a:p xmlns:a="http://schemas.openxmlformats.org/drawingml/2006/main">
+            <a:pPr algn="l">
+              <a:defRPr sz="1800" b="0">
+                <a:solidFill>
+                  <a:srgbClr val="252B35"/>
+                </a:solidFill>
+                <a:latin typeface="Source Han Sans CN"/>
+                <a:ea typeface="Source Han Sans CN"/>
+                <a:cs typeface="Source Han Sans CN"/>
+              </a:defRPr>
+            </a:pPr>
+            <a:r>
+              <a:rPr sz="1800" b="0">
+                <a:solidFill>
+                  <a:srgbClr val="252B35"/>
+                </a:solidFill>
+                <a:latin typeface="Source Han Sans CN"/>
+                <a:ea typeface="Source Han Sans CN"/>
+                <a:cs typeface="Source Han Sans CN"/>
+              </a:rPr>
+              <a:t>作者：真实作者信息</a:t>
+            </a:r>
+          </a:p>
+        </p:txBody>
+      </p:sp>
+      <p:sp>
+        <p:nvSpPr>
+          <p:cNvPr id="10" name="">
+            <a:extLst xmlns:a="http://schemas.openxmlformats.org/drawingml/2006/main">
+              <a:ext uri="{FF2B5EF4-FFF2-40B4-BE49-F238E27FC236}">
+                <a16:creationId xmlns:a16="http://schemas.microsoft.com/office/drawing/2014/main" id="{F1A6FB9C-1327-43FE-B62D-E74B6E33A775}"/>
+              </a:ext>
+            </a:extLst>
+          </p:cNvPr>
+          <p:cNvSpPr>
+            <a:spLocks xmlns:a="http://schemas.openxmlformats.org/drawingml/2006/main" noGrp="1"/>
+          </p:cNvSpPr>
+          <p:nvPr/>
+        </p:nvSpPr>
+        <p:spPr>
+          <a:xfrm xmlns:a="http://schemas.openxmlformats.org/drawingml/2006/main">
+            <a:off x="609600" y="2669858"/>
+            <a:ext cx="5114925" cy="318135"/>
+          </a:xfrm>
+          <a:prstGeom xmlns:a="http://schemas.openxmlformats.org/drawingml/2006/main" prst="rect">
+            <a:avLst/>
+          </a:prstGeom>
+          <a:noFill xmlns:a="http://schemas.openxmlformats.org/drawingml/2006/main"/>
+          <a:ln xmlns:a="http://schemas.openxmlformats.org/drawingml/2006/main" w="0">
+            <a:noFill/>
+          </a:ln>
+        </p:spPr>
+        <p:txBody>
+          <a:bodyPr xmlns:a="http://schemas.openxmlformats.org/drawingml/2006/main" wrap="square" lIns="0" tIns="0" rIns="0" bIns="0" anchor="t">
+            <a:noAutofit/>
+          </a:bodyPr>
+          <a:lstStyle xmlns:a="http://schemas.openxmlformats.org/drawingml/2006/main"/>
+          <a:p xmlns:a="http://schemas.openxmlformats.org/drawingml/2006/main">
+            <a:pPr algn="l">
+              <a:defRPr sz="1800" b="0">
+                <a:solidFill>
+                  <a:srgbClr val="252B35"/>
+                </a:solidFill>
+                <a:latin typeface="Source Han Sans CN"/>
+                <a:ea typeface="Source Han Sans CN"/>
+                <a:cs typeface="Source Han Sans CN"/>
+              </a:defRPr>
+            </a:pPr>
+            <a:r>
+              <a:rPr sz="1800" b="0">
+                <a:solidFill>
+                  <a:srgbClr val="252B35"/>
+                </a:solidFill>
+                <a:latin typeface="Source Han Sans CN"/>
+                <a:ea typeface="Source Han Sans CN"/>
+                <a:cs typeface="Source Han Sans CN"/>
+              </a:rPr>
+              <a:t>来源：发表载体</a:t>
+            </a:r>
+          </a:p>
+        </p:txBody>
+      </p:sp>
+      <p:sp>
+        <p:nvSpPr>
+          <p:cNvPr id="11" name="">
+            <a:extLst xmlns:a="http://schemas.openxmlformats.org/drawingml/2006/main">
+              <a:ext uri="{FF2B5EF4-FFF2-40B4-BE49-F238E27FC236}">
+                <a16:creationId xmlns:a16="http://schemas.microsoft.com/office/drawing/2014/main" id="{410E746B-A285-4ADD-A5AD-3E0150D6E3BB}"/>
+              </a:ext>
+            </a:extLst>
+          </p:cNvPr>
+          <p:cNvSpPr>
+            <a:spLocks xmlns:a="http://schemas.openxmlformats.org/drawingml/2006/main" noGrp="1"/>
+          </p:cNvSpPr>
+          <p:nvPr/>
+        </p:nvSpPr>
+        <p:spPr>
+          <a:xfrm xmlns:a="http://schemas.openxmlformats.org/drawingml/2006/main">
+            <a:off x="609600" y="3130868"/>
+            <a:ext cx="5114925" cy="318135"/>
+          </a:xfrm>
+          <a:prstGeom xmlns:a="http://schemas.openxmlformats.org/drawingml/2006/main" prst="rect">
+            <a:avLst/>
+          </a:prstGeom>
+          <a:noFill xmlns:a="http://schemas.openxmlformats.org/drawingml/2006/main"/>
+          <a:ln xmlns:a="http://schemas.openxmlformats.org/drawingml/2006/main" w="0">
+            <a:noFill/>
+          </a:ln>
+        </p:spPr>
+        <p:txBody>
+          <a:bodyPr xmlns:a="http://schemas.openxmlformats.org/drawingml/2006/main" wrap="square" lIns="0" tIns="0" rIns="0" bIns="0" anchor="t">
+            <a:noAutofit/>
+          </a:bodyPr>
+          <a:lstStyle xmlns:a="http://schemas.openxmlformats.org/drawingml/2006/main"/>
+          <a:p xmlns:a="http://schemas.openxmlformats.org/drawingml/2006/main">
+            <a:pPr algn="l">
+              <a:defRPr sz="1800" b="0">
+                <a:solidFill>
+                  <a:srgbClr val="252B35"/>
+                </a:solidFill>
+                <a:latin typeface="Source Han Sans CN"/>
+                <a:ea typeface="Source Han Sans CN"/>
+                <a:cs typeface="Source Han Sans CN"/>
+              </a:defRPr>
+            </a:pPr>
+            <a:r>
+              <a:rPr sz="1800" b="0">
+                <a:solidFill>
+                  <a:srgbClr val="252B35"/>
+                </a:solidFill>
+                <a:latin typeface="Source Han Sans CN"/>
+                <a:ea typeface="Source Han Sans CN"/>
+                <a:cs typeface="Source Han Sans CN"/>
+              </a:rPr>
+              <a:t>发表：发表年份</a:t>
+            </a:r>
+          </a:p>
+        </p:txBody>
+      </p:sp>
+      <p:sp>
+        <p:nvSpPr>
+          <p:cNvPr id="12" name="">
+            <a:extLst xmlns:a="http://schemas.openxmlformats.org/drawingml/2006/main">
+              <a:ext uri="{FF2B5EF4-FFF2-40B4-BE49-F238E27FC236}">
+                <a16:creationId xmlns:a16="http://schemas.microsoft.com/office/drawing/2014/main" id="{F1A64F3C-3E29-431E-A1B3-702E4AD18422}"/>
+              </a:ext>
+            </a:extLst>
+          </p:cNvPr>
+          <p:cNvSpPr>
+            <a:spLocks xmlns:a="http://schemas.openxmlformats.org/drawingml/2006/main" noGrp="1"/>
+          </p:cNvSpPr>
+          <p:nvPr/>
+        </p:nvSpPr>
+        <p:spPr>
+          <a:xfrm xmlns:a="http://schemas.openxmlformats.org/drawingml/2006/main">
+            <a:off x="6296025" y="2208848"/>
+            <a:ext cx="5267325" cy="320040"/>
+          </a:xfrm>
+          <a:prstGeom xmlns:a="http://schemas.openxmlformats.org/drawingml/2006/main" prst="rect">
+            <a:avLst/>
+          </a:prstGeom>
+          <a:noFill xmlns:a="http://schemas.openxmlformats.org/drawingml/2006/main"/>
+          <a:ln xmlns:a="http://schemas.openxmlformats.org/drawingml/2006/main" w="0">
+            <a:noFill/>
+          </a:ln>
+        </p:spPr>
+        <p:txBody>
+          <a:bodyPr xmlns:a="http://schemas.openxmlformats.org/drawingml/2006/main" wrap="square" lIns="0" tIns="0" rIns="0" bIns="0" anchor="t">
+            <a:noAutofit/>
+          </a:bodyPr>
+          <a:lstStyle xmlns:a="http://schemas.openxmlformats.org/drawingml/2006/main"/>
+          <a:p xmlns:a="http://schemas.openxmlformats.org/drawingml/2006/main">
+            <a:pPr algn="l">
+              <a:defRPr sz="1800" b="1">
+                <a:solidFill>
+                  <a:srgbClr val="32497B"/>
+                </a:solidFill>
+                <a:latin typeface="Source Han Sans CN"/>
+                <a:ea typeface="Source Han Sans CN"/>
+                <a:cs typeface="Source Han Sans CN"/>
+              </a:defRPr>
+            </a:pPr>
+            <a:r>
+              <a:rPr sz="1800" b="1">
+                <a:solidFill>
+                  <a:srgbClr val="32497B"/>
+                </a:solidFill>
+                <a:latin typeface="Source Han Sans CN"/>
+                <a:ea typeface="Source Han Sans CN"/>
+                <a:cs typeface="Source Han Sans CN"/>
+              </a:rPr>
+              <a:t>主要研究内容</a:t>
+            </a:r>
+          </a:p>
+        </p:txBody>
+      </p:sp>
+      <p:sp>
+        <p:nvSpPr>
+          <p:cNvPr id="13" name="">
+            <a:extLst xmlns:a="http://schemas.openxmlformats.org/drawingml/2006/main">
+              <a:ext uri="{FF2B5EF4-FFF2-40B4-BE49-F238E27FC236}">
+                <a16:creationId xmlns:a16="http://schemas.microsoft.com/office/drawing/2014/main" id="{2C4BFA78-F173-4081-B19A-B138D2AAA3F3}"/>
+              </a:ext>
+            </a:extLst>
+          </p:cNvPr>
+          <p:cNvSpPr>
+            <a:spLocks xmlns:a="http://schemas.openxmlformats.org/drawingml/2006/main" noGrp="1"/>
+          </p:cNvSpPr>
+          <p:nvPr/>
+        </p:nvSpPr>
+        <p:spPr>
+          <a:xfrm xmlns:a="http://schemas.openxmlformats.org/drawingml/2006/main">
+            <a:off x="6296025" y="2608898"/>
+            <a:ext cx="5267325" cy="1022033"/>
+          </a:xfrm>
+          <a:prstGeom xmlns:a="http://schemas.openxmlformats.org/drawingml/2006/main" prst="rect">
+            <a:avLst/>
+          </a:prstGeom>
+          <a:noFill xmlns:a="http://schemas.openxmlformats.org/drawingml/2006/main"/>
+          <a:ln xmlns:a="http://schemas.openxmlformats.org/drawingml/2006/main" w="0">
+            <a:noFill/>
+          </a:ln>
+        </p:spPr>
+        <p:txBody>
+          <a:bodyPr xmlns:a="http://schemas.openxmlformats.org/drawingml/2006/main" wrap="square" lIns="0" tIns="0" rIns="0" bIns="0" anchor="t">
+            <a:noAutofit/>
+          </a:bodyPr>
+          <a:lstStyle xmlns:a="http://schemas.openxmlformats.org/drawingml/2006/main"/>
+          <a:p xmlns:a="http://schemas.openxmlformats.org/drawingml/2006/main">
+            <a:pPr algn="l">
+              <a:defRPr sz="1950" b="0">
+                <a:solidFill>
+                  <a:srgbClr val="252B35"/>
+                </a:solidFill>
+                <a:latin typeface="Source Han Sans CN"/>
+                <a:ea typeface="Source Han Sans CN"/>
+                <a:cs typeface="Source Han Sans CN"/>
+              </a:defRPr>
+            </a:pPr>
+            <a:r>
+              <a:rPr sz="1950" b="0">
+                <a:solidFill>
+                  <a:srgbClr val="252B35"/>
+                </a:solidFill>
+                <a:latin typeface="Source Han Sans CN"/>
+                <a:ea typeface="Source Han Sans CN"/>
+                <a:cs typeface="Source Han Sans CN"/>
+              </a:rPr>
+              <a:t>简要交代文献研究对象、核心问题与主要研究内容。正式汇报中据用户论文填写，不将本页标签作为事实。</a:t>
+            </a:r>
+          </a:p>
+        </p:txBody>
+      </p:sp>
+      <p:sp>
+        <p:nvSpPr>
+          <p:cNvPr id="14" name="">
+            <a:extLst xmlns:a="http://schemas.openxmlformats.org/drawingml/2006/main">
+              <a:ext uri="{FF2B5EF4-FFF2-40B4-BE49-F238E27FC236}">
+                <a16:creationId xmlns:a16="http://schemas.microsoft.com/office/drawing/2014/main" id="{EF9383F8-B4E0-43E0-A2E3-12D8F2559757}"/>
+              </a:ext>
+            </a:extLst>
+          </p:cNvPr>
+          <p:cNvSpPr>
+            <a:spLocks xmlns:a="http://schemas.openxmlformats.org/drawingml/2006/main" noGrp="1"/>
+          </p:cNvSpPr>
+          <p:nvPr/>
+        </p:nvSpPr>
+        <p:spPr>
+          <a:xfrm xmlns:a="http://schemas.openxmlformats.org/drawingml/2006/main">
+            <a:off x="6296025" y="3869055"/>
+            <a:ext cx="5267325" cy="320040"/>
+          </a:xfrm>
+          <a:prstGeom xmlns:a="http://schemas.openxmlformats.org/drawingml/2006/main" prst="rect">
+            <a:avLst/>
+          </a:prstGeom>
+          <a:noFill xmlns:a="http://schemas.openxmlformats.org/drawingml/2006/main"/>
+          <a:ln xmlns:a="http://schemas.openxmlformats.org/drawingml/2006/main" w="0">
+            <a:noFill/>
+          </a:ln>
+        </p:spPr>
+        <p:txBody>
+          <a:bodyPr xmlns:a="http://schemas.openxmlformats.org/drawingml/2006/main" wrap="square" lIns="0" tIns="0" rIns="0" bIns="0" anchor="t">
+            <a:noAutofit/>
+          </a:bodyPr>
+          <a:lstStyle xmlns:a="http://schemas.openxmlformats.org/drawingml/2006/main"/>
+          <a:p xmlns:a="http://schemas.openxmlformats.org/drawingml/2006/main">
+            <a:pPr algn="l">
+              <a:defRPr sz="1800" b="1">
+                <a:solidFill>
+                  <a:srgbClr val="32497B"/>
+                </a:solidFill>
+                <a:latin typeface="Source Han Sans CN"/>
+                <a:ea typeface="Source Han Sans CN"/>
+                <a:cs typeface="Source Han Sans CN"/>
+              </a:defRPr>
+            </a:pPr>
+            <a:r>
+              <a:rPr sz="1800" b="1">
+                <a:solidFill>
+                  <a:srgbClr val="32497B"/>
+                </a:solidFill>
+                <a:latin typeface="Source Han Sans CN"/>
+                <a:ea typeface="Source Han Sans CN"/>
+                <a:cs typeface="Source Han Sans CN"/>
+              </a:rPr>
+              <a:t>关键词</a:t>
+            </a:r>
+          </a:p>
+        </p:txBody>
+      </p:sp>
+      <p:sp>
+        <p:nvSpPr>
+          <p:cNvPr id="15" name="">
+            <a:extLst xmlns:a="http://schemas.openxmlformats.org/drawingml/2006/main">
+              <a:ext uri="{FF2B5EF4-FFF2-40B4-BE49-F238E27FC236}">
+                <a16:creationId xmlns:a16="http://schemas.microsoft.com/office/drawing/2014/main" id="{B2C28D91-A674-4760-8F2B-646FA1FE3732}"/>
+              </a:ext>
+            </a:extLst>
+          </p:cNvPr>
+          <p:cNvSpPr>
+            <a:spLocks xmlns:a="http://schemas.openxmlformats.org/drawingml/2006/main" noGrp="1"/>
+          </p:cNvSpPr>
+          <p:nvPr/>
+        </p:nvSpPr>
+        <p:spPr>
+          <a:xfrm xmlns:a="http://schemas.openxmlformats.org/drawingml/2006/main">
+            <a:off x="6296025" y="4269105"/>
+            <a:ext cx="5267325" cy="327660"/>
+          </a:xfrm>
+          <a:prstGeom xmlns:a="http://schemas.openxmlformats.org/drawingml/2006/main" prst="rect">
+            <a:avLst/>
+          </a:prstGeom>
+          <a:noFill xmlns:a="http://schemas.openxmlformats.org/drawingml/2006/main"/>
+          <a:ln xmlns:a="http://schemas.openxmlformats.org/drawingml/2006/main" w="0">
+            <a:noFill/>
+          </a:ln>
+        </p:spPr>
+        <p:txBody>
+          <a:bodyPr xmlns:a="http://schemas.openxmlformats.org/drawingml/2006/main" wrap="square" lIns="0" tIns="0" rIns="0" bIns="0" anchor="t">
+            <a:noAutofit/>
+          </a:bodyPr>
+          <a:lstStyle xmlns:a="http://schemas.openxmlformats.org/drawingml/2006/main"/>
+          <a:p xmlns:a="http://schemas.openxmlformats.org/drawingml/2006/main">
+            <a:pPr algn="l">
+              <a:defRPr sz="1800" b="0">
+                <a:solidFill>
+                  <a:srgbClr val="252B35"/>
+                </a:solidFill>
+                <a:latin typeface="Source Han Sans CN"/>
+                <a:ea typeface="Source Han Sans CN"/>
+                <a:cs typeface="Source Han Sans CN"/>
+              </a:defRPr>
+            </a:pPr>
+            <a:r>
+              <a:rPr sz="1800" b="0">
+                <a:solidFill>
+                  <a:srgbClr val="252B35"/>
+                </a:solidFill>
+                <a:latin typeface="Source Han Sans CN"/>
+                <a:ea typeface="Source Han Sans CN"/>
+                <a:cs typeface="Source Han Sans CN"/>
+              </a:rPr>
+              <a:t>据原文提炼的关键词</a:t>
+            </a:r>
+          </a:p>
+        </p:txBody>
+      </p:sp>
+      <p:sp>
+        <p:nvSpPr>
+          <p:cNvPr id="16" name="">
+            <a:extLst xmlns:a="http://schemas.openxmlformats.org/drawingml/2006/main">
+              <a:ext uri="{FF2B5EF4-FFF2-40B4-BE49-F238E27FC236}">
+                <a16:creationId xmlns:a16="http://schemas.microsoft.com/office/drawing/2014/main" id="{C77A2327-95E1-4CB9-9853-189ED53CDA6F}"/>
+              </a:ext>
+            </a:extLst>
+          </p:cNvPr>
+          <p:cNvSpPr>
+            <a:spLocks xmlns:a="http://schemas.openxmlformats.org/drawingml/2006/main" noGrp="1"/>
+          </p:cNvSpPr>
+          <p:nvPr/>
+        </p:nvSpPr>
+        <p:spPr>
+          <a:xfrm xmlns:a="http://schemas.openxmlformats.org/drawingml/2006/main">
+            <a:off x="542925" y="6429375"/>
+            <a:ext cx="10972800" cy="352425"/>
+          </a:xfrm>
+          <a:prstGeom xmlns:a="http://schemas.openxmlformats.org/drawingml/2006/main" prst="rect">
+            <a:avLst/>
+          </a:prstGeom>
+          <a:noFill xmlns:a="http://schemas.openxmlformats.org/drawingml/2006/main"/>
+          <a:ln xmlns:a="http://schemas.openxmlformats.org/drawingml/2006/main" w="0">
+            <a:noFill/>
+          </a:ln>
+        </p:spPr>
+        <p:txBody>
+          <a:bodyPr xmlns:a="http://schemas.openxmlformats.org/drawingml/2006/main" wrap="square" lIns="0" tIns="0" rIns="0" bIns="0" anchor="t">
+            <a:noAutofit/>
+          </a:bodyPr>
+          <a:lstStyle xmlns:a="http://schemas.openxmlformats.org/drawingml/2006/main"/>
+          <a:p xmlns:a="http://schemas.openxmlformats.org/drawingml/2006/main">
+            <a:pPr algn="l">
+              <a:defRPr sz="1050" b="0">
+                <a:solidFill>
+                  <a:srgbClr val="626873"/>
+                </a:solidFill>
+                <a:latin typeface="Source Han Sans CN"/>
+                <a:ea typeface="Source Han Sans CN"/>
+                <a:cs typeface="Source Han Sans CN"/>
+              </a:defRPr>
+            </a:pPr>
+            <a:r>
+              <a:rPr sz="1050" b="0">
+                <a:solidFill>
+                  <a:srgbClr val="626873"/>
+                </a:solidFill>
+                <a:latin typeface="Source Han Sans CN"/>
+                <a:ea typeface="Source Han Sans CN"/>
+                <a:cs typeface="Source Han Sans CN"/>
+              </a:rPr>
+              <a:t>论文出处与原文定位</a:t>
             </a:r>
           </a:p>
         </p:txBody>
@@ -7412,7 +9248,7 @@
     </p:spTree>
     <p:extLst>
       <p:ext uri="{BB962C8B-B14F-4D97-AF65-F5344CB8AC3E}">
-        <p14:creationId xmlns:p14="http://schemas.microsoft.com/office/powerpoint/2010/main" val="1332938250"/>
+        <p14:creationId xmlns:p14="http://schemas.microsoft.com/office/powerpoint/2010/main" val="751780968"/>
       </p:ext>
     </p:extLst>
   </p:cSld>

</xml_diff>

<commit_message>
feat: sync the latest Codex journal club workflow (#18)
* feat: sync the latest Codex journal club workflow

* test: validate public SVG icons independently of their source comments
</commit_message>
<xml_diff>
--- a/assets/k105-blue/starter.pptx
+++ b/assets/k105-blue/starter.pptx
@@ -2,21 +2,23 @@
 <file path=ppt/presentation.xml><?xml version="1.0" encoding="utf-8"?>
 <p:presentation xmlns:p="http://schemas.openxmlformats.org/presentationml/2006/main">
   <p:sldMasterIdLst>
-    <p:sldMasterId xmlns:r="http://schemas.openxmlformats.org/officeDocument/2006/relationships" id="2147483648" r:id="R6c1fda1ac22440b5"/>
+    <p:sldMasterId xmlns:r="http://schemas.openxmlformats.org/officeDocument/2006/relationships" id="2147483648" r:id="R677e180bdaa84ecd"/>
   </p:sldMasterIdLst>
   <p:notesMasterIdLst>
-    <p:notesMasterId xmlns:r="http://schemas.openxmlformats.org/officeDocument/2006/relationships" r:id="R0975751ede074613"/>
+    <p:notesMasterId xmlns:r="http://schemas.openxmlformats.org/officeDocument/2006/relationships" r:id="Rbff4535b567040b6"/>
   </p:notesMasterIdLst>
   <p:sldIdLst>
-    <p:sldId xmlns:r="http://schemas.openxmlformats.org/officeDocument/2006/relationships" id="256" r:id="R248045a2010f4cb4"/>
-    <p:sldId xmlns:r="http://schemas.openxmlformats.org/officeDocument/2006/relationships" id="257" r:id="Rf22d5972ae24412b"/>
-    <p:sldId xmlns:r="http://schemas.openxmlformats.org/officeDocument/2006/relationships" id="258" r:id="R0c741b8d92a64157"/>
-    <p:sldId xmlns:r="http://schemas.openxmlformats.org/officeDocument/2006/relationships" id="259" r:id="R76a630c1aa334e5d"/>
-    <p:sldId xmlns:r="http://schemas.openxmlformats.org/officeDocument/2006/relationships" id="260" r:id="R545c9e08ea094991"/>
-    <p:sldId xmlns:r="http://schemas.openxmlformats.org/officeDocument/2006/relationships" id="261" r:id="Ra62fde6ecebe47ab"/>
-    <p:sldId xmlns:r="http://schemas.openxmlformats.org/officeDocument/2006/relationships" id="262" r:id="R80da06fa02584cec"/>
-    <p:sldId xmlns:r="http://schemas.openxmlformats.org/officeDocument/2006/relationships" id="263" r:id="Ra98191c4b08943c4"/>
-    <p:sldId xmlns:r="http://schemas.openxmlformats.org/officeDocument/2006/relationships" id="264" r:id="Rdd713250db1c4e75"/>
+    <p:sldId xmlns:r="http://schemas.openxmlformats.org/officeDocument/2006/relationships" id="256" r:id="R66f76b3b981941ad"/>
+    <p:sldId xmlns:r="http://schemas.openxmlformats.org/officeDocument/2006/relationships" id="257" r:id="R0154c92990ee414b"/>
+    <p:sldId xmlns:r="http://schemas.openxmlformats.org/officeDocument/2006/relationships" id="258" r:id="Racfacc888410412f"/>
+    <p:sldId xmlns:r="http://schemas.openxmlformats.org/officeDocument/2006/relationships" id="259" r:id="Re3a6f6ce89584c5f"/>
+    <p:sldId xmlns:r="http://schemas.openxmlformats.org/officeDocument/2006/relationships" id="260" r:id="R2dfc3375341b4975"/>
+    <p:sldId xmlns:r="http://schemas.openxmlformats.org/officeDocument/2006/relationships" id="261" r:id="Rb8a80f5147354ab2"/>
+    <p:sldId xmlns:r="http://schemas.openxmlformats.org/officeDocument/2006/relationships" id="262" r:id="R49a9e4dfe454434d"/>
+    <p:sldId xmlns:r="http://schemas.openxmlformats.org/officeDocument/2006/relationships" id="263" r:id="R161d215a7ec44ed8"/>
+    <p:sldId xmlns:r="http://schemas.openxmlformats.org/officeDocument/2006/relationships" id="264" r:id="Rb6c161b49f604dec"/>
+    <p:sldId xmlns:r="http://schemas.openxmlformats.org/officeDocument/2006/relationships" id="265" r:id="R0752380716f24582"/>
+    <p:sldId xmlns:r="http://schemas.openxmlformats.org/officeDocument/2006/relationships" id="266" r:id="R96f5f5395e744eb7"/>
   </p:sldIdLst>
   <p:sldSz cx="12192000" cy="6858000"/>
   <p:notesSz cx="6858000" cy="9144000"/>
@@ -480,6 +482,146 @@
 </p:notes>
 </file>
 
+<file path=ppt/notesSlides/notesSlide10.xml><?xml version="1.0" encoding="utf-8"?>
+<p:notes xmlns:p="http://schemas.openxmlformats.org/presentationml/2006/main">
+  <p:cSld>
+    <p:spTree>
+      <p:nvGrpSpPr>
+        <p:cNvPr id="1" name=""/>
+        <p:cNvGrpSpPr/>
+        <p:nvPr/>
+      </p:nvGrpSpPr>
+      <p:grpSpPr>
+        <a:xfrm xmlns:a="http://schemas.openxmlformats.org/drawingml/2006/main"/>
+      </p:grpSpPr>
+      <p:sp>
+        <p:nvSpPr>
+          <p:cNvPr id="2" name="Slide Image Placeholder 1"/>
+          <p:cNvSpPr>
+            <a:spLocks xmlns:a="http://schemas.openxmlformats.org/drawingml/2006/main" noGrp="1"/>
+          </p:cNvSpPr>
+          <p:nvPr>
+            <p:ph type="sldImg" idx="0"/>
+          </p:nvPr>
+        </p:nvSpPr>
+        <p:spPr/>
+      </p:sp>
+      <p:sp>
+        <p:nvSpPr>
+          <p:cNvPr id="3" name="Notes Placeholder 2"/>
+          <p:cNvSpPr>
+            <a:spLocks xmlns:a="http://schemas.openxmlformats.org/drawingml/2006/main" noGrp="1"/>
+          </p:cNvSpPr>
+          <p:nvPr>
+            <p:ph type="body" idx="1"/>
+          </p:nvPr>
+        </p:nvSpPr>
+        <p:spPr/>
+        <p:txBody>
+          <a:bodyPr xmlns:a="http://schemas.openxmlformats.org/drawingml/2006/main"/>
+          <a:lstStyle xmlns:a="http://schemas.openxmlformats.org/drawingml/2006/main"/>
+          <a:p xmlns:a="http://schemas.openxmlformats.org/drawingml/2006/main">
+            <a:r>
+              <a:t>K105干净版式示意，仅含编辑标签，无示例论文或演示数据。普通任务通过同源组件创建已填充页面，不将这些标签带入成品。</a:t>
+            </a:r>
+          </a:p>
+        </p:txBody>
+      </p:sp>
+      <p:sp>
+        <p:nvSpPr>
+          <p:cNvPr id="4" name="Slide Number Placeholder 3"/>
+          <p:cNvSpPr>
+            <a:spLocks xmlns:a="http://schemas.openxmlformats.org/drawingml/2006/main" noGrp="1"/>
+          </p:cNvSpPr>
+          <p:nvPr>
+            <p:ph type="sldNum" idx="5"/>
+          </p:nvPr>
+        </p:nvSpPr>
+        <p:spPr/>
+        <p:txBody>
+          <a:bodyPr xmlns:a="http://schemas.openxmlformats.org/drawingml/2006/main"/>
+          <a:lstStyle xmlns:a="http://schemas.openxmlformats.org/drawingml/2006/main"/>
+          <a:p xmlns:a="http://schemas.openxmlformats.org/drawingml/2006/main"/>
+        </p:txBody>
+      </p:sp>
+    </p:spTree>
+  </p:cSld>
+  <p:clrMapOvr>
+    <a:masterClrMapping xmlns:a="http://schemas.openxmlformats.org/drawingml/2006/main"/>
+  </p:clrMapOvr>
+</p:notes>
+</file>
+
+<file path=ppt/notesSlides/notesSlide11.xml><?xml version="1.0" encoding="utf-8"?>
+<p:notes xmlns:p="http://schemas.openxmlformats.org/presentationml/2006/main">
+  <p:cSld>
+    <p:spTree>
+      <p:nvGrpSpPr>
+        <p:cNvPr id="1" name=""/>
+        <p:cNvGrpSpPr/>
+        <p:nvPr/>
+      </p:nvGrpSpPr>
+      <p:grpSpPr>
+        <a:xfrm xmlns:a="http://schemas.openxmlformats.org/drawingml/2006/main"/>
+      </p:grpSpPr>
+      <p:sp>
+        <p:nvSpPr>
+          <p:cNvPr id="2" name="Slide Image Placeholder 1"/>
+          <p:cNvSpPr>
+            <a:spLocks xmlns:a="http://schemas.openxmlformats.org/drawingml/2006/main" noGrp="1"/>
+          </p:cNvSpPr>
+          <p:nvPr>
+            <p:ph type="sldImg" idx="0"/>
+          </p:nvPr>
+        </p:nvSpPr>
+        <p:spPr/>
+      </p:sp>
+      <p:sp>
+        <p:nvSpPr>
+          <p:cNvPr id="3" name="Notes Placeholder 2"/>
+          <p:cNvSpPr>
+            <a:spLocks xmlns:a="http://schemas.openxmlformats.org/drawingml/2006/main" noGrp="1"/>
+          </p:cNvSpPr>
+          <p:nvPr>
+            <p:ph type="body" idx="1"/>
+          </p:nvPr>
+        </p:nvSpPr>
+        <p:spPr/>
+        <p:txBody>
+          <a:bodyPr xmlns:a="http://schemas.openxmlformats.org/drawingml/2006/main"/>
+          <a:lstStyle xmlns:a="http://schemas.openxmlformats.org/drawingml/2006/main"/>
+          <a:p xmlns:a="http://schemas.openxmlformats.org/drawingml/2006/main">
+            <a:r>
+              <a:t>K105干净版式示意，仅含编辑标签，无示例论文或演示数据。普通任务通过同源组件创建已填充页面，不将这些标签带入成品。</a:t>
+            </a:r>
+          </a:p>
+        </p:txBody>
+      </p:sp>
+      <p:sp>
+        <p:nvSpPr>
+          <p:cNvPr id="4" name="Slide Number Placeholder 3"/>
+          <p:cNvSpPr>
+            <a:spLocks xmlns:a="http://schemas.openxmlformats.org/drawingml/2006/main" noGrp="1"/>
+          </p:cNvSpPr>
+          <p:nvPr>
+            <p:ph type="sldNum" idx="5"/>
+          </p:nvPr>
+        </p:nvSpPr>
+        <p:spPr/>
+        <p:txBody>
+          <a:bodyPr xmlns:a="http://schemas.openxmlformats.org/drawingml/2006/main"/>
+          <a:lstStyle xmlns:a="http://schemas.openxmlformats.org/drawingml/2006/main"/>
+          <a:p xmlns:a="http://schemas.openxmlformats.org/drawingml/2006/main"/>
+        </p:txBody>
+      </p:sp>
+    </p:spTree>
+  </p:cSld>
+  <p:clrMapOvr>
+    <a:masterClrMapping xmlns:a="http://schemas.openxmlformats.org/drawingml/2006/main"/>
+  </p:clrMapOvr>
+</p:notes>
+</file>
+
 <file path=ppt/notesSlides/notesSlide2.xml><?xml version="1.0" encoding="utf-8"?>
 <p:notes xmlns:p="http://schemas.openxmlformats.org/presentationml/2006/main">
   <p:cSld>
@@ -1078,7 +1220,7 @@
   </p:cSld>
   <p:clrMap bg1="lt1" tx1="dk1" bg2="lt2" tx2="dk2" accent1="accent1" accent2="accent2" accent3="accent3" accent4="accent4" accent5="accent5" accent6="accent6" hlink="hlink" folHlink="folHlink"/>
   <p:sldLayoutIdLst>
-    <p:sldLayoutId xmlns:r="http://schemas.openxmlformats.org/officeDocument/2006/relationships" id="2147483649" r:id="R12ebe07e3e394740"/>
+    <p:sldLayoutId xmlns:r="http://schemas.openxmlformats.org/officeDocument/2006/relationships" id="2147483649" r:id="R683ef74864ec4db0"/>
   </p:sldLayoutIdLst>
   <p:txStyles>
     <p:titleStyle>
@@ -1626,22 +1768,22 @@
       </p:grpSpPr>
       <p:sp>
         <p:nvSpPr>
-          <p:cNvPr id="11" name="">
-            <a:extLst xmlns:a="http://schemas.openxmlformats.org/drawingml/2006/main">
-              <a:ext uri="{FF2B5EF4-FFF2-40B4-BE49-F238E27FC236}">
-                <a16:creationId xmlns:a16="http://schemas.microsoft.com/office/drawing/2014/main" id="{0BD2110D-C4AE-4E40-9337-4A213A671509}"/>
-              </a:ext>
-            </a:extLst>
-          </p:cNvPr>
-          <p:cNvSpPr>
-            <a:spLocks xmlns:a="http://schemas.openxmlformats.org/drawingml/2006/main" noGrp="1"/>
-          </p:cNvSpPr>
-          <p:nvPr/>
-        </p:nvSpPr>
-        <p:spPr>
-          <a:xfrm xmlns:a="http://schemas.openxmlformats.org/drawingml/2006/main">
-            <a:off x="0" y="2013775"/>
-            <a:ext cx="12192000" cy="2493454"/>
+          <p:cNvPr id="13" name="">
+            <a:extLst xmlns:a="http://schemas.openxmlformats.org/drawingml/2006/main">
+              <a:ext uri="{FF2B5EF4-FFF2-40B4-BE49-F238E27FC236}">
+                <a16:creationId xmlns:a16="http://schemas.microsoft.com/office/drawing/2014/main" id="{17ADCACB-C64F-4A5D-B97B-1E8E28F7E436}"/>
+              </a:ext>
+            </a:extLst>
+          </p:cNvPr>
+          <p:cNvSpPr>
+            <a:spLocks xmlns:a="http://schemas.openxmlformats.org/drawingml/2006/main" noGrp="1"/>
+          </p:cNvSpPr>
+          <p:nvPr/>
+        </p:nvSpPr>
+        <p:spPr>
+          <a:xfrm xmlns:a="http://schemas.openxmlformats.org/drawingml/2006/main">
+            <a:off x="0" y="2013742"/>
+            <a:ext cx="12192000" cy="2493433"/>
           </a:xfrm>
           <a:prstGeom xmlns:a="http://schemas.openxmlformats.org/drawingml/2006/main" prst="rect">
             <a:avLst/>
@@ -1659,7 +1801,7 @@
           <p:cNvPr id="2" name="">
             <a:extLst xmlns:a="http://schemas.openxmlformats.org/drawingml/2006/main">
               <a:ext uri="{FF2B5EF4-FFF2-40B4-BE49-F238E27FC236}">
-                <a16:creationId xmlns:a16="http://schemas.microsoft.com/office/drawing/2014/main" id="{2A42B41E-7C62-4A08-8E08-F1C745712E4C}"/>
+                <a16:creationId xmlns:a16="http://schemas.microsoft.com/office/drawing/2014/main" id="{D6F0AFBC-C22C-40DD-8197-4909458AB077}"/>
               </a:ext>
             </a:extLst>
           </p:cNvPr>
@@ -1691,7 +1833,7 @@
           <p:cNvPr id="3" name="">
             <a:extLst xmlns:a="http://schemas.openxmlformats.org/drawingml/2006/main">
               <a:ext uri="{FF2B5EF4-FFF2-40B4-BE49-F238E27FC236}">
-                <a16:creationId xmlns:a16="http://schemas.microsoft.com/office/drawing/2014/main" id="{1A9AF3DE-411E-4B82-AAEC-119C40AF74B6}"/>
+                <a16:creationId xmlns:a16="http://schemas.microsoft.com/office/drawing/2014/main" id="{96CE0632-A06C-4EFA-8B86-F7A9C739EC36}"/>
               </a:ext>
             </a:extLst>
           </p:cNvPr>
@@ -1723,7 +1865,7 @@
           <p:cNvPr id="4" name="">
             <a:extLst xmlns:a="http://schemas.openxmlformats.org/drawingml/2006/main">
               <a:ext uri="{FF2B5EF4-FFF2-40B4-BE49-F238E27FC236}">
-                <a16:creationId xmlns:a16="http://schemas.microsoft.com/office/drawing/2014/main" id="{F471D043-24C5-4D46-AB6B-C30E75311DBD}"/>
+                <a16:creationId xmlns:a16="http://schemas.microsoft.com/office/drawing/2014/main" id="{E6F77DE7-F195-4D09-84F3-55EFEFBC163F}"/>
               </a:ext>
             </a:extLst>
           </p:cNvPr>
@@ -1755,7 +1897,7 @@
           <p:cNvPr id="5" name="">
             <a:extLst xmlns:a="http://schemas.openxmlformats.org/drawingml/2006/main">
               <a:ext uri="{FF2B5EF4-FFF2-40B4-BE49-F238E27FC236}">
-                <a16:creationId xmlns:a16="http://schemas.microsoft.com/office/drawing/2014/main" id="{34CE2BD2-0A97-49D5-8B2C-15EC4B16F995}"/>
+                <a16:creationId xmlns:a16="http://schemas.microsoft.com/office/drawing/2014/main" id="{519819BF-9EFF-46DD-BB53-A0CD2646849B}"/>
               </a:ext>
             </a:extLst>
           </p:cNvPr>
@@ -1787,7 +1929,7 @@
           <p:cNvPr id="6" name="">
             <a:extLst xmlns:a="http://schemas.openxmlformats.org/drawingml/2006/main">
               <a:ext uri="{FF2B5EF4-FFF2-40B4-BE49-F238E27FC236}">
-                <a16:creationId xmlns:a16="http://schemas.microsoft.com/office/drawing/2014/main" id="{496438FF-CDD1-48BF-BE02-BAB1D3F30996}"/>
+                <a16:creationId xmlns:a16="http://schemas.microsoft.com/office/drawing/2014/main" id="{812F2D24-E6E1-44A7-A1FC-08206FCDEDE8}"/>
               </a:ext>
             </a:extLst>
           </p:cNvPr>
@@ -1819,7 +1961,7 @@
           <p:cNvPr id="7" name="">
             <a:extLst xmlns:a="http://schemas.openxmlformats.org/drawingml/2006/main">
               <a:ext uri="{FF2B5EF4-FFF2-40B4-BE49-F238E27FC236}">
-                <a16:creationId xmlns:a16="http://schemas.microsoft.com/office/drawing/2014/main" id="{498172C8-BE1B-41B6-B533-5621A5A45FD9}"/>
+                <a16:creationId xmlns:a16="http://schemas.microsoft.com/office/drawing/2014/main" id="{CD0FFB70-E648-490F-BF18-76DF1698A74B}"/>
               </a:ext>
             </a:extLst>
           </p:cNvPr>
@@ -1851,19 +1993,19 @@
           <p:cNvPr id="8" name="">
             <a:extLst xmlns:a="http://schemas.openxmlformats.org/drawingml/2006/main">
               <a:ext uri="{FF2B5EF4-FFF2-40B4-BE49-F238E27FC236}">
-                <a16:creationId xmlns:a16="http://schemas.microsoft.com/office/drawing/2014/main" id="{D1A1CA2E-4988-4E94-9979-D23220D73BA4}"/>
-              </a:ext>
-            </a:extLst>
-          </p:cNvPr>
-          <p:cNvSpPr>
-            <a:spLocks xmlns:a="http://schemas.openxmlformats.org/drawingml/2006/main" noGrp="1"/>
-          </p:cNvSpPr>
-          <p:nvPr/>
-        </p:nvSpPr>
-        <p:spPr>
-          <a:xfrm xmlns:a="http://schemas.openxmlformats.org/drawingml/2006/main">
-            <a:off x="1000125" y="2324100"/>
-            <a:ext cx="10191750" cy="1238250"/>
+                <a16:creationId xmlns:a16="http://schemas.microsoft.com/office/drawing/2014/main" id="{07B61820-1126-4C07-973F-AE7693954581}"/>
+              </a:ext>
+            </a:extLst>
+          </p:cNvPr>
+          <p:cNvSpPr>
+            <a:spLocks xmlns:a="http://schemas.openxmlformats.org/drawingml/2006/main" noGrp="1"/>
+          </p:cNvSpPr>
+          <p:nvPr/>
+        </p:nvSpPr>
+        <p:spPr>
+          <a:xfrm xmlns:a="http://schemas.openxmlformats.org/drawingml/2006/main">
+            <a:off x="1714500" y="2657475"/>
+            <a:ext cx="8763000" cy="1209675"/>
           </a:xfrm>
           <a:prstGeom xmlns:a="http://schemas.openxmlformats.org/drawingml/2006/main" prst="rect">
             <a:avLst/>
@@ -1880,7 +2022,7 @@
           <a:lstStyle xmlns:a="http://schemas.openxmlformats.org/drawingml/2006/main"/>
           <a:p xmlns:a="http://schemas.openxmlformats.org/drawingml/2006/main">
             <a:pPr algn="ctr">
-              <a:defRPr sz="3600" b="1">
+              <a:defRPr sz="6600" b="1">
                 <a:solidFill>
                   <a:srgbClr val="FFFFFF"/>
                 </a:solidFill>
@@ -1890,7 +2032,7 @@
               </a:defRPr>
             </a:pPr>
             <a:r>
-              <a:rPr sz="3600" b="1">
+              <a:rPr sz="6600" b="1">
                 <a:solidFill>
                   <a:srgbClr val="FFFFFF"/>
                 </a:solidFill>
@@ -1898,29 +2040,57 @@
                 <a:ea typeface="Source Han Sans CN"/>
                 <a:cs typeface="Source Han Sans CN"/>
               </a:rPr>
-              <a:t>论文题名</a:t>
+              <a:t>组会汇报</a:t>
             </a:r>
           </a:p>
         </p:txBody>
       </p:sp>
-      <p:sp>
-        <p:nvSpPr>
-          <p:cNvPr id="9" name="">
-            <a:extLst xmlns:a="http://schemas.openxmlformats.org/drawingml/2006/main">
-              <a:ext uri="{FF2B5EF4-FFF2-40B4-BE49-F238E27FC236}">
-                <a16:creationId xmlns:a16="http://schemas.microsoft.com/office/drawing/2014/main" id="{D027FBA9-CA44-4A85-A4F2-2054FC79F8C1}"/>
-              </a:ext>
-            </a:extLst>
-          </p:cNvPr>
-          <p:cNvSpPr>
-            <a:spLocks xmlns:a="http://schemas.openxmlformats.org/drawingml/2006/main" noGrp="1"/>
-          </p:cNvSpPr>
-          <p:nvPr/>
-        </p:nvSpPr>
-        <p:spPr>
-          <a:xfrm xmlns:a="http://schemas.openxmlformats.org/drawingml/2006/main">
-            <a:off x="1238250" y="3686175"/>
-            <a:ext cx="9715500" cy="571500"/>
+      <p:pic>
+        <p:nvPicPr>
+          <p:cNvPr id="21" name=""/>
+          <p:cNvPicPr>
+            <a:picLocks xmlns:a="http://schemas.openxmlformats.org/drawingml/2006/main" noChangeAspect="1"/>
+          </p:cNvPicPr>
+          <p:nvPr/>
+        </p:nvPicPr>
+        <p:blipFill>
+          <a:blip xmlns:r="http://schemas.openxmlformats.org/officeDocument/2006/relationships" xmlns:a="http://schemas.openxmlformats.org/drawingml/2006/main" r:embed="Rfdc9aae806bd4fe3">
+            <a:extLst>
+              <a:ext uri="{96DAC541-7B7A-43D3-8B79-37D633B846F1}">
+                <asvg:svgBlip xmlns:asvg="http://schemas.microsoft.com/office/drawing/2016/SVG/main" r:embed="Rddad0cdc9b094aec"/>
+              </a:ext>
+            </a:extLst>
+          </a:blip>
+          <a:stretch xmlns:a="http://schemas.openxmlformats.org/drawingml/2006/main"/>
+        </p:blipFill>
+        <p:spPr>
+          <a:xfrm xmlns:a="http://schemas.openxmlformats.org/drawingml/2006/main">
+            <a:off x="2646836" y="5214471"/>
+            <a:ext cx="261537" cy="229276"/>
+          </a:xfrm>
+          <a:prstGeom xmlns:a="http://schemas.openxmlformats.org/drawingml/2006/main" prst="rect">
+            <a:avLst/>
+          </a:prstGeom>
+        </p:spPr>
+      </p:pic>
+      <p:sp>
+        <p:nvSpPr>
+          <p:cNvPr id="10" name="">
+            <a:extLst xmlns:a="http://schemas.openxmlformats.org/drawingml/2006/main">
+              <a:ext uri="{FF2B5EF4-FFF2-40B4-BE49-F238E27FC236}">
+                <a16:creationId xmlns:a16="http://schemas.microsoft.com/office/drawing/2014/main" id="{C4FF6878-A9A4-4A03-9E1D-4C10FC31C25B}"/>
+              </a:ext>
+            </a:extLst>
+          </p:cNvPr>
+          <p:cNvSpPr>
+            <a:spLocks xmlns:a="http://schemas.openxmlformats.org/drawingml/2006/main" noGrp="1"/>
+          </p:cNvSpPr>
+          <p:nvPr/>
+        </p:nvSpPr>
+        <p:spPr>
+          <a:xfrm xmlns:a="http://schemas.openxmlformats.org/drawingml/2006/main">
+            <a:off x="3000375" y="5181600"/>
+            <a:ext cx="3381375" cy="714375"/>
           </a:xfrm>
           <a:prstGeom xmlns:a="http://schemas.openxmlformats.org/drawingml/2006/main" prst="rect">
             <a:avLst/>
@@ -1936,10 +2106,10 @@
           </a:bodyPr>
           <a:lstStyle xmlns:a="http://schemas.openxmlformats.org/drawingml/2006/main"/>
           <a:p xmlns:a="http://schemas.openxmlformats.org/drawingml/2006/main">
-            <a:pPr algn="ctr">
-              <a:defRPr sz="2250" b="0">
-                <a:solidFill>
-                  <a:srgbClr val="FFFFFF"/>
+            <a:pPr algn="l">
+              <a:defRPr sz="2000" b="0">
+                <a:solidFill>
+                  <a:srgbClr val="000000"/>
                 </a:solidFill>
                 <a:latin typeface="Source Han Sans CN"/>
                 <a:ea typeface="Source Han Sans CN"/>
@@ -1947,37 +2117,65 @@
               </a:defRPr>
             </a:pPr>
             <a:r>
-              <a:rPr sz="2250" b="0">
-                <a:solidFill>
-                  <a:srgbClr val="FFFFFF"/>
+              <a:rPr sz="2000" b="0">
+                <a:solidFill>
+                  <a:srgbClr val="000000"/>
                 </a:solidFill>
                 <a:latin typeface="Source Han Sans CN"/>
                 <a:ea typeface="Source Han Sans CN"/>
                 <a:cs typeface="Source Han Sans CN"/>
               </a:rPr>
-              <a:t>研究主题</a:t>
+              <a:t>汇报人：汇报人姓名</a:t>
             </a:r>
           </a:p>
         </p:txBody>
       </p:sp>
-      <p:sp>
-        <p:nvSpPr>
-          <p:cNvPr id="10" name="">
-            <a:extLst xmlns:a="http://schemas.openxmlformats.org/drawingml/2006/main">
-              <a:ext uri="{FF2B5EF4-FFF2-40B4-BE49-F238E27FC236}">
-                <a16:creationId xmlns:a16="http://schemas.microsoft.com/office/drawing/2014/main" id="{C34B72E2-566C-4219-A68D-93B7C49C4A1F}"/>
-              </a:ext>
-            </a:extLst>
-          </p:cNvPr>
-          <p:cNvSpPr>
-            <a:spLocks xmlns:a="http://schemas.openxmlformats.org/drawingml/2006/main" noGrp="1"/>
-          </p:cNvSpPr>
-          <p:nvPr/>
-        </p:nvSpPr>
-        <p:spPr>
-          <a:xfrm xmlns:a="http://schemas.openxmlformats.org/drawingml/2006/main">
-            <a:off x="1238250" y="4867275"/>
-            <a:ext cx="9715500" cy="1304925"/>
+      <p:pic>
+        <p:nvPicPr>
+          <p:cNvPr id="23" name=""/>
+          <p:cNvPicPr>
+            <a:picLocks xmlns:a="http://schemas.openxmlformats.org/drawingml/2006/main" noChangeAspect="1"/>
+          </p:cNvPicPr>
+          <p:nvPr/>
+        </p:nvPicPr>
+        <p:blipFill>
+          <a:blip xmlns:r="http://schemas.openxmlformats.org/officeDocument/2006/relationships" xmlns:a="http://schemas.openxmlformats.org/drawingml/2006/main" r:embed="R5ca6705bbcc54b2b">
+            <a:extLst>
+              <a:ext uri="{96DAC541-7B7A-43D3-8B79-37D633B846F1}">
+                <asvg:svgBlip xmlns:asvg="http://schemas.microsoft.com/office/drawing/2016/SVG/main" r:embed="R4dacd9282b4740ea"/>
+              </a:ext>
+            </a:extLst>
+          </a:blip>
+          <a:stretch xmlns:a="http://schemas.openxmlformats.org/drawingml/2006/main"/>
+        </p:blipFill>
+        <p:spPr>
+          <a:xfrm xmlns:a="http://schemas.openxmlformats.org/drawingml/2006/main">
+            <a:off x="6644069" y="5210251"/>
+            <a:ext cx="246917" cy="254879"/>
+          </a:xfrm>
+          <a:prstGeom xmlns:a="http://schemas.openxmlformats.org/drawingml/2006/main" prst="rect">
+            <a:avLst/>
+          </a:prstGeom>
+        </p:spPr>
+      </p:pic>
+      <p:sp>
+        <p:nvSpPr>
+          <p:cNvPr id="12" name="">
+            <a:extLst xmlns:a="http://schemas.openxmlformats.org/drawingml/2006/main">
+              <a:ext uri="{FF2B5EF4-FFF2-40B4-BE49-F238E27FC236}">
+                <a16:creationId xmlns:a16="http://schemas.microsoft.com/office/drawing/2014/main" id="{9983BA6D-FE4C-4CB2-820F-B99C0571F58E}"/>
+              </a:ext>
+            </a:extLst>
+          </p:cNvPr>
+          <p:cNvSpPr>
+            <a:spLocks xmlns:a="http://schemas.openxmlformats.org/drawingml/2006/main" noGrp="1"/>
+          </p:cNvSpPr>
+          <p:nvPr/>
+        </p:nvSpPr>
+        <p:spPr>
+          <a:xfrm xmlns:a="http://schemas.openxmlformats.org/drawingml/2006/main">
+            <a:off x="7000875" y="5181600"/>
+            <a:ext cx="3524250" cy="400050"/>
           </a:xfrm>
           <a:prstGeom xmlns:a="http://schemas.openxmlformats.org/drawingml/2006/main" prst="rect">
             <a:avLst/>
@@ -1993,10 +2191,10 @@
           </a:bodyPr>
           <a:lstStyle xmlns:a="http://schemas.openxmlformats.org/drawingml/2006/main"/>
           <a:p xmlns:a="http://schemas.openxmlformats.org/drawingml/2006/main">
-            <a:pPr algn="ctr">
-              <a:defRPr sz="1650" b="0">
-                <a:solidFill>
-                  <a:srgbClr val="252B35"/>
+            <a:pPr algn="l">
+              <a:defRPr sz="2000" b="0">
+                <a:solidFill>
+                  <a:srgbClr val="000000"/>
                 </a:solidFill>
                 <a:latin typeface="Source Han Sans CN"/>
                 <a:ea typeface="Source Han Sans CN"/>
@@ -2004,15 +2202,15 @@
               </a:defRPr>
             </a:pPr>
             <a:r>
-              <a:rPr sz="1650" b="0">
-                <a:solidFill>
-                  <a:srgbClr val="252B35"/>
+              <a:rPr sz="2000" b="0">
+                <a:solidFill>
+                  <a:srgbClr val="000000"/>
                 </a:solidFill>
                 <a:latin typeface="Source Han Sans CN"/>
                 <a:ea typeface="Source Han Sans CN"/>
                 <a:cs typeface="Source Han Sans CN"/>
               </a:rPr>
-              <a:t>论文出处</a:t>
+              <a:t>汇报日期：2026.09.07</a:t>
             </a:r>
           </a:p>
         </p:txBody>
@@ -2020,7 +2218,1120 @@
     </p:spTree>
     <p:extLst>
       <p:ext uri="{BB962C8B-B14F-4D97-AF65-F5344CB8AC3E}">
-        <p14:creationId xmlns:p14="http://schemas.microsoft.com/office/powerpoint/2010/main" val="1402679127"/>
+        <p14:creationId xmlns:p14="http://schemas.microsoft.com/office/powerpoint/2010/main" val="1546865354"/>
+      </p:ext>
+    </p:extLst>
+  </p:cSld>
+</p:sld>
+</file>
+
+<file path=ppt/slides/slide10.xml><?xml version="1.0" encoding="utf-8"?>
+<p:sld xmlns:p="http://schemas.openxmlformats.org/presentationml/2006/main">
+  <p:cSld>
+    <p:bg>
+      <p:bgPr>
+        <a:solidFill xmlns:a="http://schemas.openxmlformats.org/drawingml/2006/main">
+          <a:srgbClr val="FFFFFF"/>
+        </a:solidFill>
+      </p:bgPr>
+    </p:bg>
+    <p:spTree>
+      <p:nvGrpSpPr>
+        <p:cNvPr id="1" name=""/>
+        <p:cNvGrpSpPr/>
+        <p:nvPr/>
+      </p:nvGrpSpPr>
+      <p:grpSpPr>
+        <a:xfrm xmlns:a="http://schemas.openxmlformats.org/drawingml/2006/main"/>
+      </p:grpSpPr>
+      <p:sp>
+        <p:nvSpPr>
+          <p:cNvPr id="14" name="">
+            <a:extLst xmlns:a="http://schemas.openxmlformats.org/drawingml/2006/main">
+              <a:ext uri="{FF2B5EF4-FFF2-40B4-BE49-F238E27FC236}">
+                <a16:creationId xmlns:a16="http://schemas.microsoft.com/office/drawing/2014/main" id="{9D17FDE0-DE93-4B38-B1DD-1438F47F9CEC}"/>
+              </a:ext>
+            </a:extLst>
+          </p:cNvPr>
+          <p:cNvSpPr>
+            <a:spLocks xmlns:a="http://schemas.openxmlformats.org/drawingml/2006/main" noGrp="1"/>
+          </p:cNvSpPr>
+          <p:nvPr/>
+        </p:nvSpPr>
+        <p:spPr>
+          <a:xfrm xmlns:a="http://schemas.openxmlformats.org/drawingml/2006/main">
+            <a:off x="160979" y="161266"/>
+            <a:ext cx="11870042" cy="6535469"/>
+          </a:xfrm>
+          <a:prstGeom xmlns:a="http://schemas.openxmlformats.org/drawingml/2006/main" prst="rect">
+            <a:avLst/>
+          </a:prstGeom>
+          <a:noFill xmlns:a="http://schemas.openxmlformats.org/drawingml/2006/main"/>
+          <a:ln xmlns:a="http://schemas.openxmlformats.org/drawingml/2006/main" w="19050">
+            <a:solidFill>
+              <a:srgbClr val="32497B"/>
+            </a:solidFill>
+          </a:ln>
+        </p:spPr>
+      </p:sp>
+      <p:sp>
+        <p:nvSpPr>
+          <p:cNvPr id="2" name="">
+            <a:extLst xmlns:a="http://schemas.openxmlformats.org/drawingml/2006/main">
+              <a:ext uri="{FF2B5EF4-FFF2-40B4-BE49-F238E27FC236}">
+                <a16:creationId xmlns:a16="http://schemas.microsoft.com/office/drawing/2014/main" id="{1DB7CFE1-9420-4AAA-8B6C-314AAEDD222D}"/>
+              </a:ext>
+            </a:extLst>
+          </p:cNvPr>
+          <p:cNvSpPr>
+            <a:spLocks xmlns:a="http://schemas.openxmlformats.org/drawingml/2006/main" noGrp="1"/>
+          </p:cNvSpPr>
+          <p:nvPr/>
+        </p:nvSpPr>
+        <p:spPr>
+          <a:xfrm xmlns:a="http://schemas.openxmlformats.org/drawingml/2006/main">
+            <a:off x="4792835" y="161266"/>
+            <a:ext cx="2606331" cy="1524340"/>
+          </a:xfrm>
+          <a:prstGeom xmlns:a="http://schemas.openxmlformats.org/drawingml/2006/main" prst="rect">
+            <a:avLst/>
+          </a:prstGeom>
+          <a:solidFill xmlns:a="http://schemas.openxmlformats.org/drawingml/2006/main">
+            <a:srgbClr val="32497B"/>
+          </a:solidFill>
+          <a:ln xmlns:a="http://schemas.openxmlformats.org/drawingml/2006/main" w="0">
+            <a:noFill/>
+          </a:ln>
+        </p:spPr>
+      </p:sp>
+      <p:sp>
+        <p:nvSpPr>
+          <p:cNvPr id="3" name="">
+            <a:extLst xmlns:a="http://schemas.openxmlformats.org/drawingml/2006/main">
+              <a:ext uri="{FF2B5EF4-FFF2-40B4-BE49-F238E27FC236}">
+                <a16:creationId xmlns:a16="http://schemas.microsoft.com/office/drawing/2014/main" id="{AC41EE28-ED68-4685-A6DA-E2D885C44B8D}"/>
+              </a:ext>
+            </a:extLst>
+          </p:cNvPr>
+          <p:cNvSpPr>
+            <a:spLocks xmlns:a="http://schemas.openxmlformats.org/drawingml/2006/main" noGrp="1"/>
+          </p:cNvSpPr>
+          <p:nvPr/>
+        </p:nvSpPr>
+        <p:spPr>
+          <a:xfrm xmlns:a="http://schemas.openxmlformats.org/drawingml/2006/main">
+            <a:off x="5334000" y="337552"/>
+            <a:ext cx="1524000" cy="923330"/>
+          </a:xfrm>
+          <a:prstGeom xmlns:a="http://schemas.openxmlformats.org/drawingml/2006/main" prst="rect">
+            <a:avLst/>
+          </a:prstGeom>
+          <a:noFill xmlns:a="http://schemas.openxmlformats.org/drawingml/2006/main"/>
+          <a:ln xmlns:a="http://schemas.openxmlformats.org/drawingml/2006/main" w="0">
+            <a:noFill/>
+          </a:ln>
+        </p:spPr>
+        <p:txBody>
+          <a:bodyPr xmlns:a="http://schemas.openxmlformats.org/drawingml/2006/main" wrap="square" lIns="0" tIns="0" rIns="0" bIns="0" anchor="t">
+            <a:noAutofit/>
+          </a:bodyPr>
+          <a:lstStyle xmlns:a="http://schemas.openxmlformats.org/drawingml/2006/main"/>
+          <a:p xmlns:a="http://schemas.openxmlformats.org/drawingml/2006/main">
+            <a:pPr algn="ctr">
+              <a:defRPr sz="5400" b="1">
+                <a:solidFill>
+                  <a:srgbClr val="FFFFFF"/>
+                </a:solidFill>
+                <a:latin typeface="Source Han Sans CN"/>
+                <a:ea typeface="Source Han Sans CN"/>
+                <a:cs typeface="Source Han Sans CN"/>
+              </a:defRPr>
+            </a:pPr>
+            <a:r>
+              <a:rPr sz="5400" b="1">
+                <a:solidFill>
+                  <a:srgbClr val="FFFFFF"/>
+                </a:solidFill>
+                <a:latin typeface="Source Han Sans CN"/>
+                <a:ea typeface="Source Han Sans CN"/>
+                <a:cs typeface="Source Han Sans CN"/>
+              </a:rPr>
+              <a:t>01</a:t>
+            </a:r>
+          </a:p>
+        </p:txBody>
+      </p:sp>
+      <p:sp>
+        <p:nvSpPr>
+          <p:cNvPr id="4" name="">
+            <a:extLst xmlns:a="http://schemas.openxmlformats.org/drawingml/2006/main">
+              <a:ext uri="{FF2B5EF4-FFF2-40B4-BE49-F238E27FC236}">
+                <a16:creationId xmlns:a16="http://schemas.microsoft.com/office/drawing/2014/main" id="{5934E892-828D-4889-ABA6-0EBBD475FCEF}"/>
+              </a:ext>
+            </a:extLst>
+          </p:cNvPr>
+          <p:cNvSpPr>
+            <a:spLocks xmlns:a="http://schemas.openxmlformats.org/drawingml/2006/main" noGrp="1"/>
+          </p:cNvSpPr>
+          <p:nvPr/>
+        </p:nvSpPr>
+        <p:spPr>
+          <a:xfrm xmlns:a="http://schemas.openxmlformats.org/drawingml/2006/main">
+            <a:off x="5095875" y="1133475"/>
+            <a:ext cx="2000250" cy="371475"/>
+          </a:xfrm>
+          <a:prstGeom xmlns:a="http://schemas.openxmlformats.org/drawingml/2006/main" prst="rect">
+            <a:avLst/>
+          </a:prstGeom>
+          <a:noFill xmlns:a="http://schemas.openxmlformats.org/drawingml/2006/main"/>
+          <a:ln xmlns:a="http://schemas.openxmlformats.org/drawingml/2006/main" w="0">
+            <a:noFill/>
+          </a:ln>
+        </p:spPr>
+        <p:txBody>
+          <a:bodyPr xmlns:a="http://schemas.openxmlformats.org/drawingml/2006/main" wrap="square" lIns="0" tIns="0" rIns="0" bIns="0" anchor="t">
+            <a:noAutofit/>
+          </a:bodyPr>
+          <a:lstStyle xmlns:a="http://schemas.openxmlformats.org/drawingml/2006/main"/>
+          <a:p xmlns:a="http://schemas.openxmlformats.org/drawingml/2006/main">
+            <a:pPr algn="ctr">
+              <a:defRPr sz="2000" b="1">
+                <a:solidFill>
+                  <a:srgbClr val="D6DBE5"/>
+                </a:solidFill>
+                <a:latin typeface="Source Han Sans CN"/>
+                <a:ea typeface="Source Han Sans CN"/>
+                <a:cs typeface="Source Han Sans CN"/>
+              </a:defRPr>
+            </a:pPr>
+            <a:r>
+              <a:rPr sz="2000" b="1">
+                <a:solidFill>
+                  <a:srgbClr val="D6DBE5"/>
+                </a:solidFill>
+                <a:latin typeface="Source Han Sans CN"/>
+                <a:ea typeface="Source Han Sans CN"/>
+                <a:cs typeface="Source Han Sans CN"/>
+              </a:rPr>
+              <a:t>PART ONE</a:t>
+            </a:r>
+          </a:p>
+        </p:txBody>
+      </p:sp>
+      <p:sp>
+        <p:nvSpPr>
+          <p:cNvPr id="5" name="">
+            <a:extLst xmlns:a="http://schemas.openxmlformats.org/drawingml/2006/main">
+              <a:ext uri="{FF2B5EF4-FFF2-40B4-BE49-F238E27FC236}">
+                <a16:creationId xmlns:a16="http://schemas.microsoft.com/office/drawing/2014/main" id="{89C5C6E0-4AB8-49DA-95A6-6C6BEA247BFB}"/>
+              </a:ext>
+            </a:extLst>
+          </p:cNvPr>
+          <p:cNvSpPr>
+            <a:spLocks xmlns:a="http://schemas.openxmlformats.org/drawingml/2006/main" noGrp="1"/>
+          </p:cNvSpPr>
+          <p:nvPr/>
+        </p:nvSpPr>
+        <p:spPr>
+          <a:xfrm xmlns:a="http://schemas.openxmlformats.org/drawingml/2006/main">
+            <a:off x="722337" y="2164867"/>
+            <a:ext cx="668497" cy="636717"/>
+          </a:xfrm>
+          <a:prstGeom xmlns:a="http://schemas.openxmlformats.org/drawingml/2006/main" prst="rect">
+            <a:avLst/>
+          </a:prstGeom>
+          <a:solidFill xmlns:a="http://schemas.openxmlformats.org/drawingml/2006/main">
+            <a:srgbClr val="32497B"/>
+          </a:solidFill>
+          <a:ln xmlns:a="http://schemas.openxmlformats.org/drawingml/2006/main" w="0">
+            <a:noFill/>
+          </a:ln>
+        </p:spPr>
+      </p:sp>
+      <p:sp>
+        <p:nvSpPr>
+          <p:cNvPr id="6" name="">
+            <a:extLst xmlns:a="http://schemas.openxmlformats.org/drawingml/2006/main">
+              <a:ext uri="{FF2B5EF4-FFF2-40B4-BE49-F238E27FC236}">
+                <a16:creationId xmlns:a16="http://schemas.microsoft.com/office/drawing/2014/main" id="{5067A5BA-2C74-4489-85C1-CEB8443A2059}"/>
+              </a:ext>
+            </a:extLst>
+          </p:cNvPr>
+          <p:cNvSpPr>
+            <a:spLocks xmlns:a="http://schemas.openxmlformats.org/drawingml/2006/main" noGrp="1"/>
+          </p:cNvSpPr>
+          <p:nvPr/>
+        </p:nvSpPr>
+        <p:spPr>
+          <a:xfrm xmlns:a="http://schemas.openxmlformats.org/drawingml/2006/main">
+            <a:off x="762000" y="2249863"/>
+            <a:ext cx="581025" cy="466725"/>
+          </a:xfrm>
+          <a:prstGeom xmlns:a="http://schemas.openxmlformats.org/drawingml/2006/main" prst="rect">
+            <a:avLst/>
+          </a:prstGeom>
+          <a:noFill xmlns:a="http://schemas.openxmlformats.org/drawingml/2006/main"/>
+          <a:ln xmlns:a="http://schemas.openxmlformats.org/drawingml/2006/main" w="0">
+            <a:noFill/>
+          </a:ln>
+        </p:spPr>
+        <p:txBody>
+          <a:bodyPr xmlns:a="http://schemas.openxmlformats.org/drawingml/2006/main" wrap="square" lIns="0" tIns="0" rIns="0" bIns="0" anchor="t">
+            <a:noAutofit/>
+          </a:bodyPr>
+          <a:lstStyle xmlns:a="http://schemas.openxmlformats.org/drawingml/2006/main"/>
+          <a:p xmlns:a="http://schemas.openxmlformats.org/drawingml/2006/main">
+            <a:pPr algn="ctr">
+              <a:defRPr sz="2800" b="1">
+                <a:solidFill>
+                  <a:srgbClr val="FFFFFF"/>
+                </a:solidFill>
+                <a:latin typeface="Source Han Sans CN"/>
+                <a:ea typeface="Source Han Sans CN"/>
+                <a:cs typeface="Source Han Sans CN"/>
+              </a:defRPr>
+            </a:pPr>
+            <a:r>
+              <a:rPr sz="2800" b="1">
+                <a:solidFill>
+                  <a:srgbClr val="FFFFFF"/>
+                </a:solidFill>
+                <a:latin typeface="Source Han Sans CN"/>
+                <a:ea typeface="Source Han Sans CN"/>
+                <a:cs typeface="Source Han Sans CN"/>
+              </a:rPr>
+              <a:t>01</a:t>
+            </a:r>
+          </a:p>
+        </p:txBody>
+      </p:sp>
+      <p:sp>
+        <p:nvSpPr>
+          <p:cNvPr id="7" name="">
+            <a:extLst xmlns:a="http://schemas.openxmlformats.org/drawingml/2006/main">
+              <a:ext uri="{FF2B5EF4-FFF2-40B4-BE49-F238E27FC236}">
+                <a16:creationId xmlns:a16="http://schemas.microsoft.com/office/drawing/2014/main" id="{0B97E78B-831A-4D94-952C-2234D8B3D4BF}"/>
+              </a:ext>
+            </a:extLst>
+          </p:cNvPr>
+          <p:cNvSpPr>
+            <a:spLocks xmlns:a="http://schemas.openxmlformats.org/drawingml/2006/main" noGrp="1"/>
+          </p:cNvSpPr>
+          <p:nvPr/>
+        </p:nvSpPr>
+        <p:spPr>
+          <a:xfrm xmlns:a="http://schemas.openxmlformats.org/drawingml/2006/main">
+            <a:off x="1556727" y="2283170"/>
+            <a:ext cx="9906000" cy="400110"/>
+          </a:xfrm>
+          <a:prstGeom xmlns:a="http://schemas.openxmlformats.org/drawingml/2006/main" prst="rect">
+            <a:avLst/>
+          </a:prstGeom>
+          <a:noFill xmlns:a="http://schemas.openxmlformats.org/drawingml/2006/main"/>
+          <a:ln xmlns:a="http://schemas.openxmlformats.org/drawingml/2006/main" w="0">
+            <a:noFill/>
+          </a:ln>
+        </p:spPr>
+        <p:txBody>
+          <a:bodyPr xmlns:a="http://schemas.openxmlformats.org/drawingml/2006/main" wrap="square" lIns="0" tIns="0" rIns="0" bIns="0" anchor="t">
+            <a:noAutofit/>
+          </a:bodyPr>
+          <a:lstStyle xmlns:a="http://schemas.openxmlformats.org/drawingml/2006/main"/>
+          <a:p xmlns:a="http://schemas.openxmlformats.org/drawingml/2006/main">
+            <a:pPr algn="l">
+              <a:defRPr sz="2000" b="1">
+                <a:solidFill>
+                  <a:srgbClr val="000000"/>
+                </a:solidFill>
+                <a:latin typeface="Source Han Sans CN"/>
+                <a:ea typeface="Source Han Sans CN"/>
+                <a:cs typeface="Source Han Sans CN"/>
+              </a:defRPr>
+            </a:pPr>
+            <a:r>
+              <a:rPr sz="2000" b="1">
+                <a:solidFill>
+                  <a:srgbClr val="000000"/>
+                </a:solidFill>
+                <a:latin typeface="Source Han Sans CN"/>
+                <a:ea typeface="Source Han Sans CN"/>
+                <a:cs typeface="Source Han Sans CN"/>
+              </a:rPr>
+              <a:t>第一篇论文的短题名</a:t>
+            </a:r>
+          </a:p>
+        </p:txBody>
+      </p:sp>
+      <p:sp>
+        <p:nvSpPr>
+          <p:cNvPr id="8" name="">
+            <a:extLst xmlns:a="http://schemas.openxmlformats.org/drawingml/2006/main">
+              <a:ext uri="{FF2B5EF4-FFF2-40B4-BE49-F238E27FC236}">
+                <a16:creationId xmlns:a16="http://schemas.microsoft.com/office/drawing/2014/main" id="{150F5ADE-C44F-44FE-AC51-499A0BD5C798}"/>
+              </a:ext>
+            </a:extLst>
+          </p:cNvPr>
+          <p:cNvSpPr>
+            <a:spLocks xmlns:a="http://schemas.openxmlformats.org/drawingml/2006/main" noGrp="1"/>
+          </p:cNvSpPr>
+          <p:nvPr/>
+        </p:nvSpPr>
+        <p:spPr>
+          <a:xfrm xmlns:a="http://schemas.openxmlformats.org/drawingml/2006/main">
+            <a:off x="722337" y="3122516"/>
+            <a:ext cx="668497" cy="636717"/>
+          </a:xfrm>
+          <a:prstGeom xmlns:a="http://schemas.openxmlformats.org/drawingml/2006/main" prst="rect">
+            <a:avLst/>
+          </a:prstGeom>
+          <a:solidFill xmlns:a="http://schemas.openxmlformats.org/drawingml/2006/main">
+            <a:srgbClr val="BFC4D0"/>
+          </a:solidFill>
+          <a:ln xmlns:a="http://schemas.openxmlformats.org/drawingml/2006/main" w="0">
+            <a:noFill/>
+          </a:ln>
+        </p:spPr>
+      </p:sp>
+      <p:sp>
+        <p:nvSpPr>
+          <p:cNvPr id="9" name="">
+            <a:extLst xmlns:a="http://schemas.openxmlformats.org/drawingml/2006/main">
+              <a:ext uri="{FF2B5EF4-FFF2-40B4-BE49-F238E27FC236}">
+                <a16:creationId xmlns:a16="http://schemas.microsoft.com/office/drawing/2014/main" id="{20745556-7260-44FA-9E0F-A0175E394708}"/>
+              </a:ext>
+            </a:extLst>
+          </p:cNvPr>
+          <p:cNvSpPr>
+            <a:spLocks xmlns:a="http://schemas.openxmlformats.org/drawingml/2006/main" noGrp="1"/>
+          </p:cNvSpPr>
+          <p:nvPr/>
+        </p:nvSpPr>
+        <p:spPr>
+          <a:xfrm xmlns:a="http://schemas.openxmlformats.org/drawingml/2006/main">
+            <a:off x="762000" y="3207512"/>
+            <a:ext cx="581025" cy="466725"/>
+          </a:xfrm>
+          <a:prstGeom xmlns:a="http://schemas.openxmlformats.org/drawingml/2006/main" prst="rect">
+            <a:avLst/>
+          </a:prstGeom>
+          <a:noFill xmlns:a="http://schemas.openxmlformats.org/drawingml/2006/main"/>
+          <a:ln xmlns:a="http://schemas.openxmlformats.org/drawingml/2006/main" w="0">
+            <a:noFill/>
+          </a:ln>
+        </p:spPr>
+        <p:txBody>
+          <a:bodyPr xmlns:a="http://schemas.openxmlformats.org/drawingml/2006/main" wrap="square" lIns="0" tIns="0" rIns="0" bIns="0" anchor="t">
+            <a:noAutofit/>
+          </a:bodyPr>
+          <a:lstStyle xmlns:a="http://schemas.openxmlformats.org/drawingml/2006/main"/>
+          <a:p xmlns:a="http://schemas.openxmlformats.org/drawingml/2006/main">
+            <a:pPr algn="ctr">
+              <a:defRPr sz="2800" b="1">
+                <a:solidFill>
+                  <a:srgbClr val="FFFFFF"/>
+                </a:solidFill>
+                <a:latin typeface="Source Han Sans CN"/>
+                <a:ea typeface="Source Han Sans CN"/>
+                <a:cs typeface="Source Han Sans CN"/>
+              </a:defRPr>
+            </a:pPr>
+            <a:r>
+              <a:rPr sz="2800" b="1">
+                <a:solidFill>
+                  <a:srgbClr val="FFFFFF"/>
+                </a:solidFill>
+                <a:latin typeface="Source Han Sans CN"/>
+                <a:ea typeface="Source Han Sans CN"/>
+                <a:cs typeface="Source Han Sans CN"/>
+              </a:rPr>
+              <a:t>02</a:t>
+            </a:r>
+          </a:p>
+        </p:txBody>
+      </p:sp>
+      <p:sp>
+        <p:nvSpPr>
+          <p:cNvPr id="10" name="">
+            <a:extLst xmlns:a="http://schemas.openxmlformats.org/drawingml/2006/main">
+              <a:ext uri="{FF2B5EF4-FFF2-40B4-BE49-F238E27FC236}">
+                <a16:creationId xmlns:a16="http://schemas.microsoft.com/office/drawing/2014/main" id="{DA919A34-9F5E-4BB7-AF68-0FB8AC370F74}"/>
+              </a:ext>
+            </a:extLst>
+          </p:cNvPr>
+          <p:cNvSpPr>
+            <a:spLocks xmlns:a="http://schemas.openxmlformats.org/drawingml/2006/main" noGrp="1"/>
+          </p:cNvSpPr>
+          <p:nvPr/>
+        </p:nvSpPr>
+        <p:spPr>
+          <a:xfrm xmlns:a="http://schemas.openxmlformats.org/drawingml/2006/main">
+            <a:off x="1556727" y="3240820"/>
+            <a:ext cx="9906000" cy="400110"/>
+          </a:xfrm>
+          <a:prstGeom xmlns:a="http://schemas.openxmlformats.org/drawingml/2006/main" prst="rect">
+            <a:avLst/>
+          </a:prstGeom>
+          <a:noFill xmlns:a="http://schemas.openxmlformats.org/drawingml/2006/main"/>
+          <a:ln xmlns:a="http://schemas.openxmlformats.org/drawingml/2006/main" w="0">
+            <a:noFill/>
+          </a:ln>
+        </p:spPr>
+        <p:txBody>
+          <a:bodyPr xmlns:a="http://schemas.openxmlformats.org/drawingml/2006/main" wrap="square" lIns="0" tIns="0" rIns="0" bIns="0" anchor="t">
+            <a:noAutofit/>
+          </a:bodyPr>
+          <a:lstStyle xmlns:a="http://schemas.openxmlformats.org/drawingml/2006/main"/>
+          <a:p xmlns:a="http://schemas.openxmlformats.org/drawingml/2006/main">
+            <a:pPr algn="l">
+              <a:defRPr sz="2000" b="1">
+                <a:solidFill>
+                  <a:srgbClr val="B9BCC3"/>
+                </a:solidFill>
+                <a:latin typeface="Source Han Sans CN"/>
+                <a:ea typeface="Source Han Sans CN"/>
+                <a:cs typeface="Source Han Sans CN"/>
+              </a:defRPr>
+            </a:pPr>
+            <a:r>
+              <a:rPr sz="2000" b="1">
+                <a:solidFill>
+                  <a:srgbClr val="B9BCC3"/>
+                </a:solidFill>
+                <a:latin typeface="Source Han Sans CN"/>
+                <a:ea typeface="Source Han Sans CN"/>
+                <a:cs typeface="Source Han Sans CN"/>
+              </a:rPr>
+              <a:t>第二篇论文的短题名</a:t>
+            </a:r>
+          </a:p>
+        </p:txBody>
+      </p:sp>
+      <p:sp>
+        <p:nvSpPr>
+          <p:cNvPr id="11" name="">
+            <a:extLst xmlns:a="http://schemas.openxmlformats.org/drawingml/2006/main">
+              <a:ext uri="{FF2B5EF4-FFF2-40B4-BE49-F238E27FC236}">
+                <a16:creationId xmlns:a16="http://schemas.microsoft.com/office/drawing/2014/main" id="{30857C27-8A6F-4F81-8DB5-F96E6A317200}"/>
+              </a:ext>
+            </a:extLst>
+          </p:cNvPr>
+          <p:cNvSpPr>
+            <a:spLocks xmlns:a="http://schemas.openxmlformats.org/drawingml/2006/main" noGrp="1"/>
+          </p:cNvSpPr>
+          <p:nvPr/>
+        </p:nvSpPr>
+        <p:spPr>
+          <a:xfrm xmlns:a="http://schemas.openxmlformats.org/drawingml/2006/main">
+            <a:off x="722337" y="4080165"/>
+            <a:ext cx="668497" cy="636717"/>
+          </a:xfrm>
+          <a:prstGeom xmlns:a="http://schemas.openxmlformats.org/drawingml/2006/main" prst="rect">
+            <a:avLst/>
+          </a:prstGeom>
+          <a:solidFill xmlns:a="http://schemas.openxmlformats.org/drawingml/2006/main">
+            <a:srgbClr val="BFC4D0"/>
+          </a:solidFill>
+          <a:ln xmlns:a="http://schemas.openxmlformats.org/drawingml/2006/main" w="0">
+            <a:noFill/>
+          </a:ln>
+        </p:spPr>
+      </p:sp>
+      <p:sp>
+        <p:nvSpPr>
+          <p:cNvPr id="12" name="">
+            <a:extLst xmlns:a="http://schemas.openxmlformats.org/drawingml/2006/main">
+              <a:ext uri="{FF2B5EF4-FFF2-40B4-BE49-F238E27FC236}">
+                <a16:creationId xmlns:a16="http://schemas.microsoft.com/office/drawing/2014/main" id="{7336E57D-F7A2-49E9-8E8C-7EC2AE51C6B8}"/>
+              </a:ext>
+            </a:extLst>
+          </p:cNvPr>
+          <p:cNvSpPr>
+            <a:spLocks xmlns:a="http://schemas.openxmlformats.org/drawingml/2006/main" noGrp="1"/>
+          </p:cNvSpPr>
+          <p:nvPr/>
+        </p:nvSpPr>
+        <p:spPr>
+          <a:xfrm xmlns:a="http://schemas.openxmlformats.org/drawingml/2006/main">
+            <a:off x="762000" y="4165161"/>
+            <a:ext cx="581025" cy="466725"/>
+          </a:xfrm>
+          <a:prstGeom xmlns:a="http://schemas.openxmlformats.org/drawingml/2006/main" prst="rect">
+            <a:avLst/>
+          </a:prstGeom>
+          <a:noFill xmlns:a="http://schemas.openxmlformats.org/drawingml/2006/main"/>
+          <a:ln xmlns:a="http://schemas.openxmlformats.org/drawingml/2006/main" w="0">
+            <a:noFill/>
+          </a:ln>
+        </p:spPr>
+        <p:txBody>
+          <a:bodyPr xmlns:a="http://schemas.openxmlformats.org/drawingml/2006/main" wrap="square" lIns="0" tIns="0" rIns="0" bIns="0" anchor="t">
+            <a:noAutofit/>
+          </a:bodyPr>
+          <a:lstStyle xmlns:a="http://schemas.openxmlformats.org/drawingml/2006/main"/>
+          <a:p xmlns:a="http://schemas.openxmlformats.org/drawingml/2006/main">
+            <a:pPr algn="ctr">
+              <a:defRPr sz="2800" b="1">
+                <a:solidFill>
+                  <a:srgbClr val="FFFFFF"/>
+                </a:solidFill>
+                <a:latin typeface="Source Han Sans CN"/>
+                <a:ea typeface="Source Han Sans CN"/>
+                <a:cs typeface="Source Han Sans CN"/>
+              </a:defRPr>
+            </a:pPr>
+            <a:r>
+              <a:rPr sz="2800" b="1">
+                <a:solidFill>
+                  <a:srgbClr val="FFFFFF"/>
+                </a:solidFill>
+                <a:latin typeface="Source Han Sans CN"/>
+                <a:ea typeface="Source Han Sans CN"/>
+                <a:cs typeface="Source Han Sans CN"/>
+              </a:rPr>
+              <a:t>03</a:t>
+            </a:r>
+          </a:p>
+        </p:txBody>
+      </p:sp>
+      <p:sp>
+        <p:nvSpPr>
+          <p:cNvPr id="13" name="">
+            <a:extLst xmlns:a="http://schemas.openxmlformats.org/drawingml/2006/main">
+              <a:ext uri="{FF2B5EF4-FFF2-40B4-BE49-F238E27FC236}">
+                <a16:creationId xmlns:a16="http://schemas.microsoft.com/office/drawing/2014/main" id="{E5D2ED97-7855-4F77-9401-891C939910FF}"/>
+              </a:ext>
+            </a:extLst>
+          </p:cNvPr>
+          <p:cNvSpPr>
+            <a:spLocks xmlns:a="http://schemas.openxmlformats.org/drawingml/2006/main" noGrp="1"/>
+          </p:cNvSpPr>
+          <p:nvPr/>
+        </p:nvSpPr>
+        <p:spPr>
+          <a:xfrm xmlns:a="http://schemas.openxmlformats.org/drawingml/2006/main">
+            <a:off x="1556727" y="4198469"/>
+            <a:ext cx="9906000" cy="400110"/>
+          </a:xfrm>
+          <a:prstGeom xmlns:a="http://schemas.openxmlformats.org/drawingml/2006/main" prst="rect">
+            <a:avLst/>
+          </a:prstGeom>
+          <a:noFill xmlns:a="http://schemas.openxmlformats.org/drawingml/2006/main"/>
+          <a:ln xmlns:a="http://schemas.openxmlformats.org/drawingml/2006/main" w="0">
+            <a:noFill/>
+          </a:ln>
+        </p:spPr>
+        <p:txBody>
+          <a:bodyPr xmlns:a="http://schemas.openxmlformats.org/drawingml/2006/main" wrap="square" lIns="0" tIns="0" rIns="0" bIns="0" anchor="t">
+            <a:noAutofit/>
+          </a:bodyPr>
+          <a:lstStyle xmlns:a="http://schemas.openxmlformats.org/drawingml/2006/main"/>
+          <a:p xmlns:a="http://schemas.openxmlformats.org/drawingml/2006/main">
+            <a:pPr algn="l">
+              <a:defRPr sz="2000" b="1">
+                <a:solidFill>
+                  <a:srgbClr val="B9BCC3"/>
+                </a:solidFill>
+                <a:latin typeface="Source Han Sans CN"/>
+                <a:ea typeface="Source Han Sans CN"/>
+                <a:cs typeface="Source Han Sans CN"/>
+              </a:defRPr>
+            </a:pPr>
+            <a:r>
+              <a:rPr sz="2000" b="1">
+                <a:solidFill>
+                  <a:srgbClr val="B9BCC3"/>
+                </a:solidFill>
+                <a:latin typeface="Source Han Sans CN"/>
+                <a:ea typeface="Source Han Sans CN"/>
+                <a:cs typeface="Source Han Sans CN"/>
+              </a:rPr>
+              <a:t>文献阅读总结与思考</a:t>
+            </a:r>
+          </a:p>
+        </p:txBody>
+      </p:sp>
+    </p:spTree>
+    <p:extLst>
+      <p:ext uri="{BB962C8B-B14F-4D97-AF65-F5344CB8AC3E}">
+        <p14:creationId xmlns:p14="http://schemas.microsoft.com/office/powerpoint/2010/main" val="1448974078"/>
+      </p:ext>
+    </p:extLst>
+  </p:cSld>
+</p:sld>
+</file>
+
+<file path=ppt/slides/slide11.xml><?xml version="1.0" encoding="utf-8"?>
+<p:sld xmlns:p="http://schemas.openxmlformats.org/presentationml/2006/main">
+  <p:cSld>
+    <p:bg>
+      <p:bgPr>
+        <a:solidFill xmlns:a="http://schemas.openxmlformats.org/drawingml/2006/main">
+          <a:srgbClr val="FFFFFF"/>
+        </a:solidFill>
+      </p:bgPr>
+    </p:bg>
+    <p:spTree>
+      <p:nvGrpSpPr>
+        <p:cNvPr id="1" name=""/>
+        <p:cNvGrpSpPr/>
+        <p:nvPr/>
+      </p:nvGrpSpPr>
+      <p:grpSpPr>
+        <a:xfrm xmlns:a="http://schemas.openxmlformats.org/drawingml/2006/main"/>
+      </p:grpSpPr>
+      <p:sp>
+        <p:nvSpPr>
+          <p:cNvPr id="13" name="">
+            <a:extLst xmlns:a="http://schemas.openxmlformats.org/drawingml/2006/main">
+              <a:ext uri="{FF2B5EF4-FFF2-40B4-BE49-F238E27FC236}">
+                <a16:creationId xmlns:a16="http://schemas.microsoft.com/office/drawing/2014/main" id="{994D5E81-C0DE-4027-82D2-EE5450D82620}"/>
+              </a:ext>
+            </a:extLst>
+          </p:cNvPr>
+          <p:cNvSpPr>
+            <a:spLocks xmlns:a="http://schemas.openxmlformats.org/drawingml/2006/main" noGrp="1"/>
+          </p:cNvSpPr>
+          <p:nvPr/>
+        </p:nvSpPr>
+        <p:spPr>
+          <a:xfrm xmlns:a="http://schemas.openxmlformats.org/drawingml/2006/main">
+            <a:off x="0" y="2013742"/>
+            <a:ext cx="12192000" cy="2493433"/>
+          </a:xfrm>
+          <a:prstGeom xmlns:a="http://schemas.openxmlformats.org/drawingml/2006/main" prst="rect">
+            <a:avLst/>
+          </a:prstGeom>
+          <a:solidFill xmlns:a="http://schemas.openxmlformats.org/drawingml/2006/main">
+            <a:srgbClr val="32497B"/>
+          </a:solidFill>
+          <a:ln xmlns:a="http://schemas.openxmlformats.org/drawingml/2006/main" w="0">
+            <a:noFill/>
+          </a:ln>
+        </p:spPr>
+      </p:sp>
+      <p:sp>
+        <p:nvSpPr>
+          <p:cNvPr id="2" name="">
+            <a:extLst xmlns:a="http://schemas.openxmlformats.org/drawingml/2006/main">
+              <a:ext uri="{FF2B5EF4-FFF2-40B4-BE49-F238E27FC236}">
+                <a16:creationId xmlns:a16="http://schemas.microsoft.com/office/drawing/2014/main" id="{D937CD2A-6A5C-4AF4-86BE-357C36879D85}"/>
+              </a:ext>
+            </a:extLst>
+          </p:cNvPr>
+          <p:cNvSpPr>
+            <a:spLocks xmlns:a="http://schemas.openxmlformats.org/drawingml/2006/main" noGrp="1"/>
+          </p:cNvSpPr>
+          <p:nvPr/>
+        </p:nvSpPr>
+        <p:spPr>
+          <a:xfrm xmlns:a="http://schemas.openxmlformats.org/drawingml/2006/main">
+            <a:off x="346377" y="262633"/>
+            <a:ext cx="596598" cy="60922"/>
+          </a:xfrm>
+          <a:prstGeom xmlns:a="http://schemas.openxmlformats.org/drawingml/2006/main" prst="roundRect">
+            <a:avLst>
+              <a:gd name="adj" fmla="val 50000"/>
+            </a:avLst>
+          </a:prstGeom>
+          <a:solidFill xmlns:a="http://schemas.openxmlformats.org/drawingml/2006/main">
+            <a:srgbClr val="32497B"/>
+          </a:solidFill>
+          <a:ln xmlns:a="http://schemas.openxmlformats.org/drawingml/2006/main" w="0">
+            <a:noFill/>
+          </a:ln>
+        </p:spPr>
+      </p:sp>
+      <p:sp>
+        <p:nvSpPr>
+          <p:cNvPr id="3" name="">
+            <a:extLst xmlns:a="http://schemas.openxmlformats.org/drawingml/2006/main">
+              <a:ext uri="{FF2B5EF4-FFF2-40B4-BE49-F238E27FC236}">
+                <a16:creationId xmlns:a16="http://schemas.microsoft.com/office/drawing/2014/main" id="{F484B090-EC82-4E34-824B-6FF099DA40EB}"/>
+              </a:ext>
+            </a:extLst>
+          </p:cNvPr>
+          <p:cNvSpPr>
+            <a:spLocks xmlns:a="http://schemas.openxmlformats.org/drawingml/2006/main" noGrp="1"/>
+          </p:cNvSpPr>
+          <p:nvPr/>
+        </p:nvSpPr>
+        <p:spPr>
+          <a:xfrm xmlns:a="http://schemas.openxmlformats.org/drawingml/2006/main">
+            <a:off x="346377" y="363645"/>
+            <a:ext cx="432806" cy="60922"/>
+          </a:xfrm>
+          <a:prstGeom xmlns:a="http://schemas.openxmlformats.org/drawingml/2006/main" prst="roundRect">
+            <a:avLst>
+              <a:gd name="adj" fmla="val 50000"/>
+            </a:avLst>
+          </a:prstGeom>
+          <a:solidFill xmlns:a="http://schemas.openxmlformats.org/drawingml/2006/main">
+            <a:srgbClr val="32497B"/>
+          </a:solidFill>
+          <a:ln xmlns:a="http://schemas.openxmlformats.org/drawingml/2006/main" w="0">
+            <a:noFill/>
+          </a:ln>
+        </p:spPr>
+      </p:sp>
+      <p:sp>
+        <p:nvSpPr>
+          <p:cNvPr id="4" name="">
+            <a:extLst xmlns:a="http://schemas.openxmlformats.org/drawingml/2006/main">
+              <a:ext uri="{FF2B5EF4-FFF2-40B4-BE49-F238E27FC236}">
+                <a16:creationId xmlns:a16="http://schemas.microsoft.com/office/drawing/2014/main" id="{67530C3E-C18A-4DF2-946C-F6860C9E6E72}"/>
+              </a:ext>
+            </a:extLst>
+          </p:cNvPr>
+          <p:cNvSpPr>
+            <a:spLocks xmlns:a="http://schemas.openxmlformats.org/drawingml/2006/main" noGrp="1"/>
+          </p:cNvSpPr>
+          <p:nvPr/>
+        </p:nvSpPr>
+        <p:spPr>
+          <a:xfrm xmlns:a="http://schemas.openxmlformats.org/drawingml/2006/main">
+            <a:off x="346377" y="464668"/>
+            <a:ext cx="291503" cy="60922"/>
+          </a:xfrm>
+          <a:prstGeom xmlns:a="http://schemas.openxmlformats.org/drawingml/2006/main" prst="roundRect">
+            <a:avLst>
+              <a:gd name="adj" fmla="val 50000"/>
+            </a:avLst>
+          </a:prstGeom>
+          <a:solidFill xmlns:a="http://schemas.openxmlformats.org/drawingml/2006/main">
+            <a:srgbClr val="32497B"/>
+          </a:solidFill>
+          <a:ln xmlns:a="http://schemas.openxmlformats.org/drawingml/2006/main" w="0">
+            <a:noFill/>
+          </a:ln>
+        </p:spPr>
+      </p:sp>
+      <p:sp>
+        <p:nvSpPr>
+          <p:cNvPr id="5" name="">
+            <a:extLst xmlns:a="http://schemas.openxmlformats.org/drawingml/2006/main">
+              <a:ext uri="{FF2B5EF4-FFF2-40B4-BE49-F238E27FC236}">
+                <a16:creationId xmlns:a16="http://schemas.microsoft.com/office/drawing/2014/main" id="{2916447C-ADED-4D78-8A10-FE10B9A87DAF}"/>
+              </a:ext>
+            </a:extLst>
+          </p:cNvPr>
+          <p:cNvSpPr>
+            <a:spLocks xmlns:a="http://schemas.openxmlformats.org/drawingml/2006/main" noGrp="1"/>
+          </p:cNvSpPr>
+          <p:nvPr/>
+        </p:nvSpPr>
+        <p:spPr>
+          <a:xfrm xmlns:a="http://schemas.openxmlformats.org/drawingml/2006/main">
+            <a:off x="11249025" y="6537646"/>
+            <a:ext cx="596598" cy="60922"/>
+          </a:xfrm>
+          <a:prstGeom xmlns:a="http://schemas.openxmlformats.org/drawingml/2006/main" prst="roundRect">
+            <a:avLst>
+              <a:gd name="adj" fmla="val 50000"/>
+            </a:avLst>
+          </a:prstGeom>
+          <a:solidFill xmlns:a="http://schemas.openxmlformats.org/drawingml/2006/main">
+            <a:srgbClr val="32497B"/>
+          </a:solidFill>
+          <a:ln xmlns:a="http://schemas.openxmlformats.org/drawingml/2006/main" w="0">
+            <a:noFill/>
+          </a:ln>
+        </p:spPr>
+      </p:sp>
+      <p:sp>
+        <p:nvSpPr>
+          <p:cNvPr id="6" name="">
+            <a:extLst xmlns:a="http://schemas.openxmlformats.org/drawingml/2006/main">
+              <a:ext uri="{FF2B5EF4-FFF2-40B4-BE49-F238E27FC236}">
+                <a16:creationId xmlns:a16="http://schemas.microsoft.com/office/drawing/2014/main" id="{EEEAFC96-98DB-40B4-8600-84FEBFB4F50D}"/>
+              </a:ext>
+            </a:extLst>
+          </p:cNvPr>
+          <p:cNvSpPr>
+            <a:spLocks xmlns:a="http://schemas.openxmlformats.org/drawingml/2006/main" noGrp="1"/>
+          </p:cNvSpPr>
+          <p:nvPr/>
+        </p:nvSpPr>
+        <p:spPr>
+          <a:xfrm xmlns:a="http://schemas.openxmlformats.org/drawingml/2006/main">
+            <a:off x="11412817" y="6436624"/>
+            <a:ext cx="432806" cy="60922"/>
+          </a:xfrm>
+          <a:prstGeom xmlns:a="http://schemas.openxmlformats.org/drawingml/2006/main" prst="roundRect">
+            <a:avLst>
+              <a:gd name="adj" fmla="val 50000"/>
+            </a:avLst>
+          </a:prstGeom>
+          <a:solidFill xmlns:a="http://schemas.openxmlformats.org/drawingml/2006/main">
+            <a:srgbClr val="32497B"/>
+          </a:solidFill>
+          <a:ln xmlns:a="http://schemas.openxmlformats.org/drawingml/2006/main" w="0">
+            <a:noFill/>
+          </a:ln>
+        </p:spPr>
+      </p:sp>
+      <p:sp>
+        <p:nvSpPr>
+          <p:cNvPr id="7" name="">
+            <a:extLst xmlns:a="http://schemas.openxmlformats.org/drawingml/2006/main">
+              <a:ext uri="{FF2B5EF4-FFF2-40B4-BE49-F238E27FC236}">
+                <a16:creationId xmlns:a16="http://schemas.microsoft.com/office/drawing/2014/main" id="{E314FD08-E4FC-4A12-A3C2-171DE145E04B}"/>
+              </a:ext>
+            </a:extLst>
+          </p:cNvPr>
+          <p:cNvSpPr>
+            <a:spLocks xmlns:a="http://schemas.openxmlformats.org/drawingml/2006/main" noGrp="1"/>
+          </p:cNvSpPr>
+          <p:nvPr/>
+        </p:nvSpPr>
+        <p:spPr>
+          <a:xfrm xmlns:a="http://schemas.openxmlformats.org/drawingml/2006/main">
+            <a:off x="11554111" y="6335611"/>
+            <a:ext cx="291503" cy="60922"/>
+          </a:xfrm>
+          <a:prstGeom xmlns:a="http://schemas.openxmlformats.org/drawingml/2006/main" prst="roundRect">
+            <a:avLst>
+              <a:gd name="adj" fmla="val 50000"/>
+            </a:avLst>
+          </a:prstGeom>
+          <a:solidFill xmlns:a="http://schemas.openxmlformats.org/drawingml/2006/main">
+            <a:srgbClr val="32497B"/>
+          </a:solidFill>
+          <a:ln xmlns:a="http://schemas.openxmlformats.org/drawingml/2006/main" w="0">
+            <a:noFill/>
+          </a:ln>
+        </p:spPr>
+      </p:sp>
+      <p:sp>
+        <p:nvSpPr>
+          <p:cNvPr id="8" name="">
+            <a:extLst xmlns:a="http://schemas.openxmlformats.org/drawingml/2006/main">
+              <a:ext uri="{FF2B5EF4-FFF2-40B4-BE49-F238E27FC236}">
+                <a16:creationId xmlns:a16="http://schemas.microsoft.com/office/drawing/2014/main" id="{5FDF7C22-E335-423D-AA87-22B63BC73792}"/>
+              </a:ext>
+            </a:extLst>
+          </p:cNvPr>
+          <p:cNvSpPr>
+            <a:spLocks xmlns:a="http://schemas.openxmlformats.org/drawingml/2006/main" noGrp="1"/>
+          </p:cNvSpPr>
+          <p:nvPr/>
+        </p:nvSpPr>
+        <p:spPr>
+          <a:xfrm xmlns:a="http://schemas.openxmlformats.org/drawingml/2006/main">
+            <a:off x="1284426" y="2875738"/>
+            <a:ext cx="9623148" cy="769441"/>
+          </a:xfrm>
+          <a:prstGeom xmlns:a="http://schemas.openxmlformats.org/drawingml/2006/main" prst="rect">
+            <a:avLst/>
+          </a:prstGeom>
+          <a:noFill xmlns:a="http://schemas.openxmlformats.org/drawingml/2006/main"/>
+          <a:ln xmlns:a="http://schemas.openxmlformats.org/drawingml/2006/main" w="0">
+            <a:noFill/>
+          </a:ln>
+        </p:spPr>
+        <p:txBody>
+          <a:bodyPr xmlns:a="http://schemas.openxmlformats.org/drawingml/2006/main" wrap="square" lIns="0" tIns="0" rIns="0" bIns="0" anchor="t">
+            <a:noAutofit/>
+          </a:bodyPr>
+          <a:lstStyle xmlns:a="http://schemas.openxmlformats.org/drawingml/2006/main"/>
+          <a:p xmlns:a="http://schemas.openxmlformats.org/drawingml/2006/main">
+            <a:pPr algn="ctr">
+              <a:defRPr sz="4400" b="1">
+                <a:solidFill>
+                  <a:srgbClr val="FFFFFF"/>
+                </a:solidFill>
+                <a:latin typeface="Source Han Sans CN"/>
+                <a:ea typeface="Source Han Sans CN"/>
+                <a:cs typeface="Source Han Sans CN"/>
+              </a:defRPr>
+            </a:pPr>
+            <a:r>
+              <a:rPr sz="4400" b="1">
+                <a:solidFill>
+                  <a:srgbClr val="FFFFFF"/>
+                </a:solidFill>
+                <a:latin typeface="Source Han Sans CN"/>
+                <a:ea typeface="Source Han Sans CN"/>
+                <a:cs typeface="Source Han Sans CN"/>
+              </a:rPr>
+              <a:t>汇报完毕，敬请老师同学批评指正！</a:t>
+            </a:r>
+          </a:p>
+        </p:txBody>
+      </p:sp>
+      <p:pic>
+        <p:nvPicPr>
+          <p:cNvPr id="21" name=""/>
+          <p:cNvPicPr>
+            <a:picLocks xmlns:a="http://schemas.openxmlformats.org/drawingml/2006/main" noChangeAspect="1"/>
+          </p:cNvPicPr>
+          <p:nvPr/>
+        </p:nvPicPr>
+        <p:blipFill>
+          <a:blip xmlns:r="http://schemas.openxmlformats.org/officeDocument/2006/relationships" xmlns:a="http://schemas.openxmlformats.org/drawingml/2006/main" r:embed="R9ee00347852749d1">
+            <a:extLst>
+              <a:ext uri="{96DAC541-7B7A-43D3-8B79-37D633B846F1}">
+                <asvg:svgBlip xmlns:asvg="http://schemas.microsoft.com/office/drawing/2016/SVG/main" r:embed="R29d12d91d3c64edc"/>
+              </a:ext>
+            </a:extLst>
+          </a:blip>
+          <a:stretch xmlns:a="http://schemas.openxmlformats.org/drawingml/2006/main"/>
+        </p:blipFill>
+        <p:spPr>
+          <a:xfrm xmlns:a="http://schemas.openxmlformats.org/drawingml/2006/main">
+            <a:off x="2646836" y="5214471"/>
+            <a:ext cx="261537" cy="229276"/>
+          </a:xfrm>
+          <a:prstGeom xmlns:a="http://schemas.openxmlformats.org/drawingml/2006/main" prst="rect">
+            <a:avLst/>
+          </a:prstGeom>
+        </p:spPr>
+      </p:pic>
+      <p:sp>
+        <p:nvSpPr>
+          <p:cNvPr id="10" name="">
+            <a:extLst xmlns:a="http://schemas.openxmlformats.org/drawingml/2006/main">
+              <a:ext uri="{FF2B5EF4-FFF2-40B4-BE49-F238E27FC236}">
+                <a16:creationId xmlns:a16="http://schemas.microsoft.com/office/drawing/2014/main" id="{A35A2715-E84F-42AD-A2BF-68E66FC5C6B9}"/>
+              </a:ext>
+            </a:extLst>
+          </p:cNvPr>
+          <p:cNvSpPr>
+            <a:spLocks xmlns:a="http://schemas.openxmlformats.org/drawingml/2006/main" noGrp="1"/>
+          </p:cNvSpPr>
+          <p:nvPr/>
+        </p:nvSpPr>
+        <p:spPr>
+          <a:xfrm xmlns:a="http://schemas.openxmlformats.org/drawingml/2006/main">
+            <a:off x="3000375" y="5181600"/>
+            <a:ext cx="3381375" cy="714375"/>
+          </a:xfrm>
+          <a:prstGeom xmlns:a="http://schemas.openxmlformats.org/drawingml/2006/main" prst="rect">
+            <a:avLst/>
+          </a:prstGeom>
+          <a:noFill xmlns:a="http://schemas.openxmlformats.org/drawingml/2006/main"/>
+          <a:ln xmlns:a="http://schemas.openxmlformats.org/drawingml/2006/main" w="0">
+            <a:noFill/>
+          </a:ln>
+        </p:spPr>
+        <p:txBody>
+          <a:bodyPr xmlns:a="http://schemas.openxmlformats.org/drawingml/2006/main" wrap="square" lIns="0" tIns="0" rIns="0" bIns="0" anchor="t">
+            <a:noAutofit/>
+          </a:bodyPr>
+          <a:lstStyle xmlns:a="http://schemas.openxmlformats.org/drawingml/2006/main"/>
+          <a:p xmlns:a="http://schemas.openxmlformats.org/drawingml/2006/main">
+            <a:pPr algn="l">
+              <a:defRPr sz="2000" b="0">
+                <a:solidFill>
+                  <a:srgbClr val="000000"/>
+                </a:solidFill>
+                <a:latin typeface="Source Han Sans CN"/>
+                <a:ea typeface="Source Han Sans CN"/>
+                <a:cs typeface="Source Han Sans CN"/>
+              </a:defRPr>
+            </a:pPr>
+            <a:r>
+              <a:rPr sz="2000" b="0">
+                <a:solidFill>
+                  <a:srgbClr val="000000"/>
+                </a:solidFill>
+                <a:latin typeface="Source Han Sans CN"/>
+                <a:ea typeface="Source Han Sans CN"/>
+                <a:cs typeface="Source Han Sans CN"/>
+              </a:rPr>
+              <a:t>汇报人：汇报人姓名</a:t>
+            </a:r>
+          </a:p>
+        </p:txBody>
+      </p:sp>
+      <p:pic>
+        <p:nvPicPr>
+          <p:cNvPr id="23" name=""/>
+          <p:cNvPicPr>
+            <a:picLocks xmlns:a="http://schemas.openxmlformats.org/drawingml/2006/main" noChangeAspect="1"/>
+          </p:cNvPicPr>
+          <p:nvPr/>
+        </p:nvPicPr>
+        <p:blipFill>
+          <a:blip xmlns:r="http://schemas.openxmlformats.org/officeDocument/2006/relationships" xmlns:a="http://schemas.openxmlformats.org/drawingml/2006/main" r:embed="R5c2601538f4942be">
+            <a:extLst>
+              <a:ext uri="{96DAC541-7B7A-43D3-8B79-37D633B846F1}">
+                <asvg:svgBlip xmlns:asvg="http://schemas.microsoft.com/office/drawing/2016/SVG/main" r:embed="R9474024c5fa046e8"/>
+              </a:ext>
+            </a:extLst>
+          </a:blip>
+          <a:stretch xmlns:a="http://schemas.openxmlformats.org/drawingml/2006/main"/>
+        </p:blipFill>
+        <p:spPr>
+          <a:xfrm xmlns:a="http://schemas.openxmlformats.org/drawingml/2006/main">
+            <a:off x="6644069" y="5210251"/>
+            <a:ext cx="246917" cy="254879"/>
+          </a:xfrm>
+          <a:prstGeom xmlns:a="http://schemas.openxmlformats.org/drawingml/2006/main" prst="rect">
+            <a:avLst/>
+          </a:prstGeom>
+        </p:spPr>
+      </p:pic>
+      <p:sp>
+        <p:nvSpPr>
+          <p:cNvPr id="12" name="">
+            <a:extLst xmlns:a="http://schemas.openxmlformats.org/drawingml/2006/main">
+              <a:ext uri="{FF2B5EF4-FFF2-40B4-BE49-F238E27FC236}">
+                <a16:creationId xmlns:a16="http://schemas.microsoft.com/office/drawing/2014/main" id="{346BD9D8-5C66-4C4D-A998-7701DDCDA05B}"/>
+              </a:ext>
+            </a:extLst>
+          </p:cNvPr>
+          <p:cNvSpPr>
+            <a:spLocks xmlns:a="http://schemas.openxmlformats.org/drawingml/2006/main" noGrp="1"/>
+          </p:cNvSpPr>
+          <p:nvPr/>
+        </p:nvSpPr>
+        <p:spPr>
+          <a:xfrm xmlns:a="http://schemas.openxmlformats.org/drawingml/2006/main">
+            <a:off x="7000875" y="5181600"/>
+            <a:ext cx="3524250" cy="400050"/>
+          </a:xfrm>
+          <a:prstGeom xmlns:a="http://schemas.openxmlformats.org/drawingml/2006/main" prst="rect">
+            <a:avLst/>
+          </a:prstGeom>
+          <a:noFill xmlns:a="http://schemas.openxmlformats.org/drawingml/2006/main"/>
+          <a:ln xmlns:a="http://schemas.openxmlformats.org/drawingml/2006/main" w="0">
+            <a:noFill/>
+          </a:ln>
+        </p:spPr>
+        <p:txBody>
+          <a:bodyPr xmlns:a="http://schemas.openxmlformats.org/drawingml/2006/main" wrap="square" lIns="0" tIns="0" rIns="0" bIns="0" anchor="t">
+            <a:noAutofit/>
+          </a:bodyPr>
+          <a:lstStyle xmlns:a="http://schemas.openxmlformats.org/drawingml/2006/main"/>
+          <a:p xmlns:a="http://schemas.openxmlformats.org/drawingml/2006/main">
+            <a:pPr algn="l">
+              <a:defRPr sz="2000" b="0">
+                <a:solidFill>
+                  <a:srgbClr val="000000"/>
+                </a:solidFill>
+                <a:latin typeface="Source Han Sans CN"/>
+                <a:ea typeface="Source Han Sans CN"/>
+                <a:cs typeface="Source Han Sans CN"/>
+              </a:defRPr>
+            </a:pPr>
+            <a:r>
+              <a:rPr sz="2000" b="0">
+                <a:solidFill>
+                  <a:srgbClr val="000000"/>
+                </a:solidFill>
+                <a:latin typeface="Source Han Sans CN"/>
+                <a:ea typeface="Source Han Sans CN"/>
+                <a:cs typeface="Source Han Sans CN"/>
+              </a:rPr>
+              <a:t>汇报日期：2026.09.07</a:t>
+            </a:r>
+          </a:p>
+        </p:txBody>
+      </p:sp>
+    </p:spTree>
+    <p:extLst>
+      <p:ext uri="{BB962C8B-B14F-4D97-AF65-F5344CB8AC3E}">
+        <p14:creationId xmlns:p14="http://schemas.microsoft.com/office/powerpoint/2010/main" val="184421856"/>
       </p:ext>
     </p:extLst>
   </p:cSld>
@@ -2051,7 +3362,7 @@
           <p:cNvPr id="12" name="">
             <a:extLst xmlns:a="http://schemas.openxmlformats.org/drawingml/2006/main">
               <a:ext uri="{FF2B5EF4-FFF2-40B4-BE49-F238E27FC236}">
-                <a16:creationId xmlns:a16="http://schemas.microsoft.com/office/drawing/2014/main" id="{2578EA3D-E539-414F-97AF-4227F7588DC5}"/>
+                <a16:creationId xmlns:a16="http://schemas.microsoft.com/office/drawing/2014/main" id="{AA7EF225-F3C0-4F07-A74D-586E165B96B5}"/>
               </a:ext>
             </a:extLst>
           </p:cNvPr>
@@ -2081,7 +3392,7 @@
           <p:cNvPr id="2" name="">
             <a:extLst xmlns:a="http://schemas.openxmlformats.org/drawingml/2006/main">
               <a:ext uri="{FF2B5EF4-FFF2-40B4-BE49-F238E27FC236}">
-                <a16:creationId xmlns:a16="http://schemas.microsoft.com/office/drawing/2014/main" id="{6443D59B-18EA-43EC-99D7-F5212B740422}"/>
+                <a16:creationId xmlns:a16="http://schemas.microsoft.com/office/drawing/2014/main" id="{25FAA2EF-643A-4FF4-82DA-3C715E1FA13E}"/>
               </a:ext>
             </a:extLst>
           </p:cNvPr>
@@ -2138,7 +3449,7 @@
           <p:cNvPr id="3" name="">
             <a:extLst xmlns:a="http://schemas.openxmlformats.org/drawingml/2006/main">
               <a:ext uri="{FF2B5EF4-FFF2-40B4-BE49-F238E27FC236}">
-                <a16:creationId xmlns:a16="http://schemas.microsoft.com/office/drawing/2014/main" id="{6988FD1C-40B4-46DD-9047-F7F707DB643B}"/>
+                <a16:creationId xmlns:a16="http://schemas.microsoft.com/office/drawing/2014/main" id="{C2BABE0F-B79C-4F02-AA6D-0104CADAD362}"/>
               </a:ext>
             </a:extLst>
           </p:cNvPr>
@@ -2168,7 +3479,7 @@
           <p:cNvPr id="4" name="">
             <a:extLst xmlns:a="http://schemas.openxmlformats.org/drawingml/2006/main">
               <a:ext uri="{FF2B5EF4-FFF2-40B4-BE49-F238E27FC236}">
-                <a16:creationId xmlns:a16="http://schemas.microsoft.com/office/drawing/2014/main" id="{F4D8790E-51E3-4CFA-8BD1-24C4D890F81E}"/>
+                <a16:creationId xmlns:a16="http://schemas.microsoft.com/office/drawing/2014/main" id="{16B45270-405D-4BE5-B540-E05860119904}"/>
               </a:ext>
             </a:extLst>
           </p:cNvPr>
@@ -2198,7 +3509,7 @@
           <p:cNvPr id="5" name="">
             <a:extLst xmlns:a="http://schemas.openxmlformats.org/drawingml/2006/main">
               <a:ext uri="{FF2B5EF4-FFF2-40B4-BE49-F238E27FC236}">
-                <a16:creationId xmlns:a16="http://schemas.microsoft.com/office/drawing/2014/main" id="{AD882F5C-2E14-4B4C-9890-1AD7257716A4}"/>
+                <a16:creationId xmlns:a16="http://schemas.microsoft.com/office/drawing/2014/main" id="{F08D2999-EFD5-429D-8EA3-CC8F42A5E089}"/>
               </a:ext>
             </a:extLst>
           </p:cNvPr>
@@ -2255,7 +3566,7 @@
           <p:cNvPr id="6" name="">
             <a:extLst xmlns:a="http://schemas.openxmlformats.org/drawingml/2006/main">
               <a:ext uri="{FF2B5EF4-FFF2-40B4-BE49-F238E27FC236}">
-                <a16:creationId xmlns:a16="http://schemas.microsoft.com/office/drawing/2014/main" id="{B80BEC4A-36C0-4869-9CAB-B60EC6C6C842}"/>
+                <a16:creationId xmlns:a16="http://schemas.microsoft.com/office/drawing/2014/main" id="{CA020110-ECCD-4E51-87AC-A141AAB30468}"/>
               </a:ext>
             </a:extLst>
           </p:cNvPr>
@@ -2312,7 +3623,7 @@
           <p:cNvPr id="7" name="">
             <a:extLst xmlns:a="http://schemas.openxmlformats.org/drawingml/2006/main">
               <a:ext uri="{FF2B5EF4-FFF2-40B4-BE49-F238E27FC236}">
-                <a16:creationId xmlns:a16="http://schemas.microsoft.com/office/drawing/2014/main" id="{88AD2945-2B8D-4393-B429-2B7341537BC0}"/>
+                <a16:creationId xmlns:a16="http://schemas.microsoft.com/office/drawing/2014/main" id="{C671558C-3A3A-48AE-A292-0A5073247F52}"/>
               </a:ext>
             </a:extLst>
           </p:cNvPr>
@@ -2369,7 +3680,7 @@
           <p:cNvPr id="8" name="">
             <a:extLst xmlns:a="http://schemas.openxmlformats.org/drawingml/2006/main">
               <a:ext uri="{FF2B5EF4-FFF2-40B4-BE49-F238E27FC236}">
-                <a16:creationId xmlns:a16="http://schemas.microsoft.com/office/drawing/2014/main" id="{8D4C541D-BB38-42CC-A533-6C3D21F564BA}"/>
+                <a16:creationId xmlns:a16="http://schemas.microsoft.com/office/drawing/2014/main" id="{8EF6658B-54B2-4C77-A4DB-98A0B4B4C32F}"/>
               </a:ext>
             </a:extLst>
           </p:cNvPr>
@@ -2426,7 +3737,7 @@
           <p:cNvPr id="9" name="">
             <a:extLst xmlns:a="http://schemas.openxmlformats.org/drawingml/2006/main">
               <a:ext uri="{FF2B5EF4-FFF2-40B4-BE49-F238E27FC236}">
-                <a16:creationId xmlns:a16="http://schemas.microsoft.com/office/drawing/2014/main" id="{EDE9B659-DDFF-4790-847C-938079685CF9}"/>
+                <a16:creationId xmlns:a16="http://schemas.microsoft.com/office/drawing/2014/main" id="{ACE8D104-ABE9-4FF4-B2A7-8C789E96E561}"/>
               </a:ext>
             </a:extLst>
           </p:cNvPr>
@@ -2456,7 +3767,7 @@
           <p:cNvPr id="10" name="">
             <a:extLst xmlns:a="http://schemas.openxmlformats.org/drawingml/2006/main">
               <a:ext uri="{FF2B5EF4-FFF2-40B4-BE49-F238E27FC236}">
-                <a16:creationId xmlns:a16="http://schemas.microsoft.com/office/drawing/2014/main" id="{EDC93C91-24BD-4CF7-9406-99A48EFFD7C1}"/>
+                <a16:creationId xmlns:a16="http://schemas.microsoft.com/office/drawing/2014/main" id="{8097D2FF-5758-4608-A8DC-6D5E3A8C04A3}"/>
               </a:ext>
             </a:extLst>
           </p:cNvPr>
@@ -2513,7 +3824,7 @@
           <p:cNvPr id="11" name="">
             <a:extLst xmlns:a="http://schemas.openxmlformats.org/drawingml/2006/main">
               <a:ext uri="{FF2B5EF4-FFF2-40B4-BE49-F238E27FC236}">
-                <a16:creationId xmlns:a16="http://schemas.microsoft.com/office/drawing/2014/main" id="{5E1AE565-D1B6-469C-8AEF-BF0B91D76463}"/>
+                <a16:creationId xmlns:a16="http://schemas.microsoft.com/office/drawing/2014/main" id="{5B15479E-A96E-4B9D-88F8-B4310F32C301}"/>
               </a:ext>
             </a:extLst>
           </p:cNvPr>
@@ -2568,7 +3879,7 @@
     </p:spTree>
     <p:extLst>
       <p:ext uri="{BB962C8B-B14F-4D97-AF65-F5344CB8AC3E}">
-        <p14:creationId xmlns:p14="http://schemas.microsoft.com/office/powerpoint/2010/main" val="1033750648"/>
+        <p14:creationId xmlns:p14="http://schemas.microsoft.com/office/powerpoint/2010/main" val="1888624232"/>
       </p:ext>
     </p:extLst>
   </p:cSld>
@@ -2599,7 +3910,7 @@
           <p:cNvPr id="14" name="">
             <a:extLst xmlns:a="http://schemas.openxmlformats.org/drawingml/2006/main">
               <a:ext uri="{FF2B5EF4-FFF2-40B4-BE49-F238E27FC236}">
-                <a16:creationId xmlns:a16="http://schemas.microsoft.com/office/drawing/2014/main" id="{2C0CD629-C914-4309-A6DB-686FEDA82164}"/>
+                <a16:creationId xmlns:a16="http://schemas.microsoft.com/office/drawing/2014/main" id="{8FFC9BE1-FCE7-490A-A7FA-7C48BE85E104}"/>
               </a:ext>
             </a:extLst>
           </p:cNvPr>
@@ -2629,7 +3940,7 @@
           <p:cNvPr id="2" name="">
             <a:extLst xmlns:a="http://schemas.openxmlformats.org/drawingml/2006/main">
               <a:ext uri="{FF2B5EF4-FFF2-40B4-BE49-F238E27FC236}">
-                <a16:creationId xmlns:a16="http://schemas.microsoft.com/office/drawing/2014/main" id="{A49BA684-D3F6-434A-BAD9-95D642E697A3}"/>
+                <a16:creationId xmlns:a16="http://schemas.microsoft.com/office/drawing/2014/main" id="{3DF4E84F-2802-4949-8D05-07548DCA7773}"/>
               </a:ext>
             </a:extLst>
           </p:cNvPr>
@@ -2686,7 +3997,7 @@
           <p:cNvPr id="3" name="">
             <a:extLst xmlns:a="http://schemas.openxmlformats.org/drawingml/2006/main">
               <a:ext uri="{FF2B5EF4-FFF2-40B4-BE49-F238E27FC236}">
-                <a16:creationId xmlns:a16="http://schemas.microsoft.com/office/drawing/2014/main" id="{F7FBF162-CB38-409A-9FDA-1CAC5FDDD45B}"/>
+                <a16:creationId xmlns:a16="http://schemas.microsoft.com/office/drawing/2014/main" id="{F3EEADC2-4813-4468-86CD-18AA9E2AC67F}"/>
               </a:ext>
             </a:extLst>
           </p:cNvPr>
@@ -2716,7 +4027,7 @@
           <p:cNvPr id="4" name="">
             <a:extLst xmlns:a="http://schemas.openxmlformats.org/drawingml/2006/main">
               <a:ext uri="{FF2B5EF4-FFF2-40B4-BE49-F238E27FC236}">
-                <a16:creationId xmlns:a16="http://schemas.microsoft.com/office/drawing/2014/main" id="{E9CF333F-CA06-4B14-97B5-85147D8CF02D}"/>
+                <a16:creationId xmlns:a16="http://schemas.microsoft.com/office/drawing/2014/main" id="{9486458A-A60C-489F-B928-6C4F81D3DDAE}"/>
               </a:ext>
             </a:extLst>
           </p:cNvPr>
@@ -2746,7 +4057,7 @@
           <p:cNvPr id="5" name="">
             <a:extLst xmlns:a="http://schemas.openxmlformats.org/drawingml/2006/main">
               <a:ext uri="{FF2B5EF4-FFF2-40B4-BE49-F238E27FC236}">
-                <a16:creationId xmlns:a16="http://schemas.microsoft.com/office/drawing/2014/main" id="{9A31AFBD-3AB0-4FBB-AA08-97D8499484C7}"/>
+                <a16:creationId xmlns:a16="http://schemas.microsoft.com/office/drawing/2014/main" id="{48D0B65E-B09F-45D5-B040-30A3E3FEEF80}"/>
               </a:ext>
             </a:extLst>
           </p:cNvPr>
@@ -2803,7 +4114,7 @@
           <p:cNvPr id="6" name="">
             <a:extLst xmlns:a="http://schemas.openxmlformats.org/drawingml/2006/main">
               <a:ext uri="{FF2B5EF4-FFF2-40B4-BE49-F238E27FC236}">
-                <a16:creationId xmlns:a16="http://schemas.microsoft.com/office/drawing/2014/main" id="{296A1868-E314-4276-9A01-0D091BCFFD42}"/>
+                <a16:creationId xmlns:a16="http://schemas.microsoft.com/office/drawing/2014/main" id="{4CE0719B-8133-44F2-B852-F928C1C81A3C}"/>
               </a:ext>
             </a:extLst>
           </p:cNvPr>
@@ -2835,7 +4146,7 @@
           <p:cNvPr id="7" name="">
             <a:extLst xmlns:a="http://schemas.openxmlformats.org/drawingml/2006/main">
               <a:ext uri="{FF2B5EF4-FFF2-40B4-BE49-F238E27FC236}">
-                <a16:creationId xmlns:a16="http://schemas.microsoft.com/office/drawing/2014/main" id="{C8762CB1-862F-4289-9F05-6F2B1AE62A3E}"/>
+                <a16:creationId xmlns:a16="http://schemas.microsoft.com/office/drawing/2014/main" id="{2430DF6C-6DE5-4A97-B347-BC76129F133C}"/>
               </a:ext>
             </a:extLst>
           </p:cNvPr>
@@ -2892,7 +4203,7 @@
           <p:cNvPr id="8" name="">
             <a:extLst xmlns:a="http://schemas.openxmlformats.org/drawingml/2006/main">
               <a:ext uri="{FF2B5EF4-FFF2-40B4-BE49-F238E27FC236}">
-                <a16:creationId xmlns:a16="http://schemas.microsoft.com/office/drawing/2014/main" id="{A750D00F-E916-4A1D-9AD3-44FCB07CE353}"/>
+                <a16:creationId xmlns:a16="http://schemas.microsoft.com/office/drawing/2014/main" id="{34FD10DA-73F8-46F7-A38F-A8F75D931D89}"/>
               </a:ext>
             </a:extLst>
           </p:cNvPr>
@@ -2949,7 +4260,7 @@
           <p:cNvPr id="9" name="">
             <a:extLst xmlns:a="http://schemas.openxmlformats.org/drawingml/2006/main">
               <a:ext uri="{FF2B5EF4-FFF2-40B4-BE49-F238E27FC236}">
-                <a16:creationId xmlns:a16="http://schemas.microsoft.com/office/drawing/2014/main" id="{F1B67DB6-52B8-46CD-ACF6-BBF3ADB37BFB}"/>
+                <a16:creationId xmlns:a16="http://schemas.microsoft.com/office/drawing/2014/main" id="{2796583A-A6FD-469B-B60E-8A3E7D9F9241}"/>
               </a:ext>
             </a:extLst>
           </p:cNvPr>
@@ -3006,7 +4317,7 @@
           <p:cNvPr id="10" name="">
             <a:extLst xmlns:a="http://schemas.openxmlformats.org/drawingml/2006/main">
               <a:ext uri="{FF2B5EF4-FFF2-40B4-BE49-F238E27FC236}">
-                <a16:creationId xmlns:a16="http://schemas.microsoft.com/office/drawing/2014/main" id="{2A79DD4F-CF10-40DC-BC34-7366220CA2B8}"/>
+                <a16:creationId xmlns:a16="http://schemas.microsoft.com/office/drawing/2014/main" id="{28A2D5A9-3027-4670-BB90-79698F9EC7A7}"/>
               </a:ext>
             </a:extLst>
           </p:cNvPr>
@@ -3063,7 +4374,7 @@
           <p:cNvPr id="11" name="">
             <a:extLst xmlns:a="http://schemas.openxmlformats.org/drawingml/2006/main">
               <a:ext uri="{FF2B5EF4-FFF2-40B4-BE49-F238E27FC236}">
-                <a16:creationId xmlns:a16="http://schemas.microsoft.com/office/drawing/2014/main" id="{E729AF48-8194-4739-A8D2-61B1DCAD1A54}"/>
+                <a16:creationId xmlns:a16="http://schemas.microsoft.com/office/drawing/2014/main" id="{76643914-BF3C-4F9B-B5B8-D09D6AA70FC5}"/>
               </a:ext>
             </a:extLst>
           </p:cNvPr>
@@ -3093,7 +4404,7 @@
           <p:cNvPr id="12" name="">
             <a:extLst xmlns:a="http://schemas.openxmlformats.org/drawingml/2006/main">
               <a:ext uri="{FF2B5EF4-FFF2-40B4-BE49-F238E27FC236}">
-                <a16:creationId xmlns:a16="http://schemas.microsoft.com/office/drawing/2014/main" id="{C53F8DFD-98BF-4E4D-9ED3-6B0612893D23}"/>
+                <a16:creationId xmlns:a16="http://schemas.microsoft.com/office/drawing/2014/main" id="{08936366-A58C-4855-853A-20E84C06859A}"/>
               </a:ext>
             </a:extLst>
           </p:cNvPr>
@@ -3150,7 +4461,7 @@
           <p:cNvPr id="13" name="">
             <a:extLst xmlns:a="http://schemas.openxmlformats.org/drawingml/2006/main">
               <a:ext uri="{FF2B5EF4-FFF2-40B4-BE49-F238E27FC236}">
-                <a16:creationId xmlns:a16="http://schemas.microsoft.com/office/drawing/2014/main" id="{FC231A9A-954E-40E5-BDEB-B9478F7C2C8B}"/>
+                <a16:creationId xmlns:a16="http://schemas.microsoft.com/office/drawing/2014/main" id="{33D85E1F-3D4B-45EA-9D69-8DB0829BDFF2}"/>
               </a:ext>
             </a:extLst>
           </p:cNvPr>
@@ -3205,7 +4516,7 @@
     </p:spTree>
     <p:extLst>
       <p:ext uri="{BB962C8B-B14F-4D97-AF65-F5344CB8AC3E}">
-        <p14:creationId xmlns:p14="http://schemas.microsoft.com/office/powerpoint/2010/main" val="1083876956"/>
+        <p14:creationId xmlns:p14="http://schemas.microsoft.com/office/powerpoint/2010/main" val="177693260"/>
       </p:ext>
     </p:extLst>
   </p:cSld>
@@ -3236,7 +4547,7 @@
           <p:cNvPr id="15" name="">
             <a:extLst xmlns:a="http://schemas.openxmlformats.org/drawingml/2006/main">
               <a:ext uri="{FF2B5EF4-FFF2-40B4-BE49-F238E27FC236}">
-                <a16:creationId xmlns:a16="http://schemas.microsoft.com/office/drawing/2014/main" id="{17220E88-F7FD-4DED-B7D6-05C1BD9A2C8C}"/>
+                <a16:creationId xmlns:a16="http://schemas.microsoft.com/office/drawing/2014/main" id="{567898E2-47CD-4CA4-90B7-637F1ED1D5B5}"/>
               </a:ext>
             </a:extLst>
           </p:cNvPr>
@@ -3266,7 +4577,7 @@
           <p:cNvPr id="2" name="">
             <a:extLst xmlns:a="http://schemas.openxmlformats.org/drawingml/2006/main">
               <a:ext uri="{FF2B5EF4-FFF2-40B4-BE49-F238E27FC236}">
-                <a16:creationId xmlns:a16="http://schemas.microsoft.com/office/drawing/2014/main" id="{4CE2D626-7E02-4ED4-BFB1-EC4B9F42416E}"/>
+                <a16:creationId xmlns:a16="http://schemas.microsoft.com/office/drawing/2014/main" id="{6D099AD1-F6C8-4287-B36F-1EC3029118C2}"/>
               </a:ext>
             </a:extLst>
           </p:cNvPr>
@@ -3323,7 +4634,7 @@
           <p:cNvPr id="3" name="">
             <a:extLst xmlns:a="http://schemas.openxmlformats.org/drawingml/2006/main">
               <a:ext uri="{FF2B5EF4-FFF2-40B4-BE49-F238E27FC236}">
-                <a16:creationId xmlns:a16="http://schemas.microsoft.com/office/drawing/2014/main" id="{5F11E295-D4A9-43CE-BDA0-21D8963F4120}"/>
+                <a16:creationId xmlns:a16="http://schemas.microsoft.com/office/drawing/2014/main" id="{928A9C81-D4E9-402C-A16F-7930D70380C9}"/>
               </a:ext>
             </a:extLst>
           </p:cNvPr>
@@ -3353,7 +4664,7 @@
           <p:cNvPr id="4" name="">
             <a:extLst xmlns:a="http://schemas.openxmlformats.org/drawingml/2006/main">
               <a:ext uri="{FF2B5EF4-FFF2-40B4-BE49-F238E27FC236}">
-                <a16:creationId xmlns:a16="http://schemas.microsoft.com/office/drawing/2014/main" id="{07CB5DD1-6142-4E8F-8458-93E49447642D}"/>
+                <a16:creationId xmlns:a16="http://schemas.microsoft.com/office/drawing/2014/main" id="{0D0D7504-4B55-43C9-B9E1-A4CC89DAF716}"/>
               </a:ext>
             </a:extLst>
           </p:cNvPr>
@@ -3383,7 +4694,7 @@
           <p:cNvPr id="5" name="">
             <a:extLst xmlns:a="http://schemas.openxmlformats.org/drawingml/2006/main">
               <a:ext uri="{FF2B5EF4-FFF2-40B4-BE49-F238E27FC236}">
-                <a16:creationId xmlns:a16="http://schemas.microsoft.com/office/drawing/2014/main" id="{13A3C9BD-16E0-44D1-86FC-2EE479D10C73}"/>
+                <a16:creationId xmlns:a16="http://schemas.microsoft.com/office/drawing/2014/main" id="{62EA545B-1936-44EE-89F3-E1AB2C597D0B}"/>
               </a:ext>
             </a:extLst>
           </p:cNvPr>
@@ -3440,7 +4751,7 @@
           <p:cNvPr id="6" name="">
             <a:extLst xmlns:a="http://schemas.openxmlformats.org/drawingml/2006/main">
               <a:ext uri="{FF2B5EF4-FFF2-40B4-BE49-F238E27FC236}">
-                <a16:creationId xmlns:a16="http://schemas.microsoft.com/office/drawing/2014/main" id="{FBFDAD13-A1C9-4F8F-B786-EC07C4112C19}"/>
+                <a16:creationId xmlns:a16="http://schemas.microsoft.com/office/drawing/2014/main" id="{0DD1FBD5-A169-4F35-A0A9-8333DC367DAE}"/>
               </a:ext>
             </a:extLst>
           </p:cNvPr>
@@ -3472,7 +4783,7 @@
           <p:cNvPr id="7" name="">
             <a:extLst xmlns:a="http://schemas.openxmlformats.org/drawingml/2006/main">
               <a:ext uri="{FF2B5EF4-FFF2-40B4-BE49-F238E27FC236}">
-                <a16:creationId xmlns:a16="http://schemas.microsoft.com/office/drawing/2014/main" id="{59BB043C-6241-4D03-B598-44492B9B4E27}"/>
+                <a16:creationId xmlns:a16="http://schemas.microsoft.com/office/drawing/2014/main" id="{6DD8DD0B-67F4-4AD5-BE54-A67B8BB541DC}"/>
               </a:ext>
             </a:extLst>
           </p:cNvPr>
@@ -3529,7 +4840,7 @@
           <p:cNvPr id="8" name="">
             <a:extLst xmlns:a="http://schemas.openxmlformats.org/drawingml/2006/main">
               <a:ext uri="{FF2B5EF4-FFF2-40B4-BE49-F238E27FC236}">
-                <a16:creationId xmlns:a16="http://schemas.microsoft.com/office/drawing/2014/main" id="{620DAFFE-B8A6-43A2-BEE8-875D4D9F7B56}"/>
+                <a16:creationId xmlns:a16="http://schemas.microsoft.com/office/drawing/2014/main" id="{79B4DD37-A073-41F7-A629-F7223B7F44EE}"/>
               </a:ext>
             </a:extLst>
           </p:cNvPr>
@@ -3561,7 +4872,7 @@
           <p:cNvPr id="9" name="">
             <a:extLst xmlns:a="http://schemas.openxmlformats.org/drawingml/2006/main">
               <a:ext uri="{FF2B5EF4-FFF2-40B4-BE49-F238E27FC236}">
-                <a16:creationId xmlns:a16="http://schemas.microsoft.com/office/drawing/2014/main" id="{A5FFC126-0426-4939-A4FC-32BCECF05136}"/>
+                <a16:creationId xmlns:a16="http://schemas.microsoft.com/office/drawing/2014/main" id="{596DB2F7-DB69-4D26-8E48-6ABF4BA517D9}"/>
               </a:ext>
             </a:extLst>
           </p:cNvPr>
@@ -3618,7 +4929,7 @@
           <p:cNvPr id="10" name="">
             <a:extLst xmlns:a="http://schemas.openxmlformats.org/drawingml/2006/main">
               <a:ext uri="{FF2B5EF4-FFF2-40B4-BE49-F238E27FC236}">
-                <a16:creationId xmlns:a16="http://schemas.microsoft.com/office/drawing/2014/main" id="{434612B9-7D72-4FB1-A00E-1D3B11683CE5}"/>
+                <a16:creationId xmlns:a16="http://schemas.microsoft.com/office/drawing/2014/main" id="{C8A07254-A4B8-4D16-B570-74399EF117E7}"/>
               </a:ext>
             </a:extLst>
           </p:cNvPr>
@@ -3675,7 +4986,7 @@
           <p:cNvPr id="11" name="">
             <a:extLst xmlns:a="http://schemas.openxmlformats.org/drawingml/2006/main">
               <a:ext uri="{FF2B5EF4-FFF2-40B4-BE49-F238E27FC236}">
-                <a16:creationId xmlns:a16="http://schemas.microsoft.com/office/drawing/2014/main" id="{57CD6ECC-1ADA-4D41-86FF-18258014749A}"/>
+                <a16:creationId xmlns:a16="http://schemas.microsoft.com/office/drawing/2014/main" id="{60A366FF-7F45-4874-B4E3-30402E1F1E80}"/>
               </a:ext>
             </a:extLst>
           </p:cNvPr>
@@ -3732,7 +5043,7 @@
           <p:cNvPr id="12" name="">
             <a:extLst xmlns:a="http://schemas.openxmlformats.org/drawingml/2006/main">
               <a:ext uri="{FF2B5EF4-FFF2-40B4-BE49-F238E27FC236}">
-                <a16:creationId xmlns:a16="http://schemas.microsoft.com/office/drawing/2014/main" id="{131E84D3-D728-46A2-B61C-1DA132E6AE90}"/>
+                <a16:creationId xmlns:a16="http://schemas.microsoft.com/office/drawing/2014/main" id="{74A404AF-F199-4B3E-A801-3F489C85B49C}"/>
               </a:ext>
             </a:extLst>
           </p:cNvPr>
@@ -3762,7 +5073,7 @@
           <p:cNvPr id="13" name="">
             <a:extLst xmlns:a="http://schemas.openxmlformats.org/drawingml/2006/main">
               <a:ext uri="{FF2B5EF4-FFF2-40B4-BE49-F238E27FC236}">
-                <a16:creationId xmlns:a16="http://schemas.microsoft.com/office/drawing/2014/main" id="{EF83946C-71AD-4F02-BA87-13451405FA01}"/>
+                <a16:creationId xmlns:a16="http://schemas.microsoft.com/office/drawing/2014/main" id="{C66BE2FD-D409-4D30-AB23-0285A187A40A}"/>
               </a:ext>
             </a:extLst>
           </p:cNvPr>
@@ -3819,7 +5130,7 @@
           <p:cNvPr id="14" name="">
             <a:extLst xmlns:a="http://schemas.openxmlformats.org/drawingml/2006/main">
               <a:ext uri="{FF2B5EF4-FFF2-40B4-BE49-F238E27FC236}">
-                <a16:creationId xmlns:a16="http://schemas.microsoft.com/office/drawing/2014/main" id="{0D9DCA65-8042-4F50-8303-8CAC70FC2DA9}"/>
+                <a16:creationId xmlns:a16="http://schemas.microsoft.com/office/drawing/2014/main" id="{6C09471C-E704-4CC7-9346-25BA3B81AE50}"/>
               </a:ext>
             </a:extLst>
           </p:cNvPr>
@@ -3874,7 +5185,7 @@
     </p:spTree>
     <p:extLst>
       <p:ext uri="{BB962C8B-B14F-4D97-AF65-F5344CB8AC3E}">
-        <p14:creationId xmlns:p14="http://schemas.microsoft.com/office/powerpoint/2010/main" val="91985904"/>
+        <p14:creationId xmlns:p14="http://schemas.microsoft.com/office/powerpoint/2010/main" val="277050836"/>
       </p:ext>
     </p:extLst>
   </p:cSld>
@@ -3905,7 +5216,7 @@
           <p:cNvPr id="10" name="">
             <a:extLst xmlns:a="http://schemas.openxmlformats.org/drawingml/2006/main">
               <a:ext uri="{FF2B5EF4-FFF2-40B4-BE49-F238E27FC236}">
-                <a16:creationId xmlns:a16="http://schemas.microsoft.com/office/drawing/2014/main" id="{43BE8D43-7838-41AF-A3FD-AD2206DF21E9}"/>
+                <a16:creationId xmlns:a16="http://schemas.microsoft.com/office/drawing/2014/main" id="{FB79D7B7-F9D6-491E-B6C0-729200146E0C}"/>
               </a:ext>
             </a:extLst>
           </p:cNvPr>
@@ -3935,7 +5246,7 @@
           <p:cNvPr id="2" name="">
             <a:extLst xmlns:a="http://schemas.openxmlformats.org/drawingml/2006/main">
               <a:ext uri="{FF2B5EF4-FFF2-40B4-BE49-F238E27FC236}">
-                <a16:creationId xmlns:a16="http://schemas.microsoft.com/office/drawing/2014/main" id="{5381E0B3-139F-4B9C-8739-C4E313CBDC39}"/>
+                <a16:creationId xmlns:a16="http://schemas.microsoft.com/office/drawing/2014/main" id="{A60A89A9-1527-438D-855B-FF7319C621A6}"/>
               </a:ext>
             </a:extLst>
           </p:cNvPr>
@@ -3992,7 +5303,7 @@
           <p:cNvPr id="3" name="">
             <a:extLst xmlns:a="http://schemas.openxmlformats.org/drawingml/2006/main">
               <a:ext uri="{FF2B5EF4-FFF2-40B4-BE49-F238E27FC236}">
-                <a16:creationId xmlns:a16="http://schemas.microsoft.com/office/drawing/2014/main" id="{B7DB6FAC-D346-46FA-B4F9-43C9223E3DA8}"/>
+                <a16:creationId xmlns:a16="http://schemas.microsoft.com/office/drawing/2014/main" id="{C31C53F3-1431-4CE0-9DE0-40306D088105}"/>
               </a:ext>
             </a:extLst>
           </p:cNvPr>
@@ -4022,7 +5333,7 @@
           <p:cNvPr id="4" name="">
             <a:extLst xmlns:a="http://schemas.openxmlformats.org/drawingml/2006/main">
               <a:ext uri="{FF2B5EF4-FFF2-40B4-BE49-F238E27FC236}">
-                <a16:creationId xmlns:a16="http://schemas.microsoft.com/office/drawing/2014/main" id="{F350DBA9-B5B7-48E0-A8D9-D402605FC08D}"/>
+                <a16:creationId xmlns:a16="http://schemas.microsoft.com/office/drawing/2014/main" id="{7B04F532-FA4E-4B9A-B466-4F786287891F}"/>
               </a:ext>
             </a:extLst>
           </p:cNvPr>
@@ -4052,7 +5363,7 @@
           <p:cNvPr id="5" name="">
             <a:extLst xmlns:a="http://schemas.openxmlformats.org/drawingml/2006/main">
               <a:ext uri="{FF2B5EF4-FFF2-40B4-BE49-F238E27FC236}">
-                <a16:creationId xmlns:a16="http://schemas.microsoft.com/office/drawing/2014/main" id="{66788D85-BBCE-4EC1-9F01-67BEADF30D69}"/>
+                <a16:creationId xmlns:a16="http://schemas.microsoft.com/office/drawing/2014/main" id="{6F6AAB8B-2F44-447D-9E91-79A937F94D31}"/>
               </a:ext>
             </a:extLst>
           </p:cNvPr>
@@ -4428,7 +5739,7 @@
           <p:cNvPr id="7" name="">
             <a:extLst xmlns:a="http://schemas.openxmlformats.org/drawingml/2006/main">
               <a:ext uri="{FF2B5EF4-FFF2-40B4-BE49-F238E27FC236}">
-                <a16:creationId xmlns:a16="http://schemas.microsoft.com/office/drawing/2014/main" id="{E41DBB0C-4272-4A01-A189-73D3A0BC43BD}"/>
+                <a16:creationId xmlns:a16="http://schemas.microsoft.com/office/drawing/2014/main" id="{96CA9C4C-D951-42F7-953E-7EFE934B5445}"/>
               </a:ext>
             </a:extLst>
           </p:cNvPr>
@@ -4458,7 +5769,7 @@
           <p:cNvPr id="8" name="">
             <a:extLst xmlns:a="http://schemas.openxmlformats.org/drawingml/2006/main">
               <a:ext uri="{FF2B5EF4-FFF2-40B4-BE49-F238E27FC236}">
-                <a16:creationId xmlns:a16="http://schemas.microsoft.com/office/drawing/2014/main" id="{07888276-FA18-410E-A734-6AE8EF22211A}"/>
+                <a16:creationId xmlns:a16="http://schemas.microsoft.com/office/drawing/2014/main" id="{AA0A5610-12BC-4865-B60E-47A4A8B1FC23}"/>
               </a:ext>
             </a:extLst>
           </p:cNvPr>
@@ -4515,7 +5826,7 @@
           <p:cNvPr id="9" name="">
             <a:extLst xmlns:a="http://schemas.openxmlformats.org/drawingml/2006/main">
               <a:ext uri="{FF2B5EF4-FFF2-40B4-BE49-F238E27FC236}">
-                <a16:creationId xmlns:a16="http://schemas.microsoft.com/office/drawing/2014/main" id="{C2975BD3-1742-4168-B897-7223910CEDFD}"/>
+                <a16:creationId xmlns:a16="http://schemas.microsoft.com/office/drawing/2014/main" id="{693297D0-93C1-4E2A-B8B8-3052697E5D96}"/>
               </a:ext>
             </a:extLst>
           </p:cNvPr>
@@ -4570,7 +5881,7 @@
     </p:spTree>
     <p:extLst>
       <p:ext uri="{BB962C8B-B14F-4D97-AF65-F5344CB8AC3E}">
-        <p14:creationId xmlns:p14="http://schemas.microsoft.com/office/powerpoint/2010/main" val="230205328"/>
+        <p14:creationId xmlns:p14="http://schemas.microsoft.com/office/powerpoint/2010/main" val="1276044715"/>
       </p:ext>
     </p:extLst>
   </p:cSld>
@@ -4601,7 +5912,7 @@
           <p:cNvPr id="27" name="">
             <a:extLst xmlns:a="http://schemas.openxmlformats.org/drawingml/2006/main">
               <a:ext uri="{FF2B5EF4-FFF2-40B4-BE49-F238E27FC236}">
-                <a16:creationId xmlns:a16="http://schemas.microsoft.com/office/drawing/2014/main" id="{7873F9D1-96BB-407B-9042-B8D292A08A9D}"/>
+                <a16:creationId xmlns:a16="http://schemas.microsoft.com/office/drawing/2014/main" id="{741E3778-7369-4CE4-A805-3521D0BA5CE0}"/>
               </a:ext>
             </a:extLst>
           </p:cNvPr>
@@ -4631,7 +5942,7 @@
           <p:cNvPr id="2" name="">
             <a:extLst xmlns:a="http://schemas.openxmlformats.org/drawingml/2006/main">
               <a:ext uri="{FF2B5EF4-FFF2-40B4-BE49-F238E27FC236}">
-                <a16:creationId xmlns:a16="http://schemas.microsoft.com/office/drawing/2014/main" id="{F0EFC1C9-03A2-4766-9F19-6A8FE617E476}"/>
+                <a16:creationId xmlns:a16="http://schemas.microsoft.com/office/drawing/2014/main" id="{EB9E95B9-024D-4B0D-BAC9-A66EBF0972C5}"/>
               </a:ext>
             </a:extLst>
           </p:cNvPr>
@@ -4688,7 +5999,7 @@
           <p:cNvPr id="3" name="">
             <a:extLst xmlns:a="http://schemas.openxmlformats.org/drawingml/2006/main">
               <a:ext uri="{FF2B5EF4-FFF2-40B4-BE49-F238E27FC236}">
-                <a16:creationId xmlns:a16="http://schemas.microsoft.com/office/drawing/2014/main" id="{08DB21DD-AA2B-44BA-9FFF-0B22A49236FA}"/>
+                <a16:creationId xmlns:a16="http://schemas.microsoft.com/office/drawing/2014/main" id="{68435D1F-E34D-4F01-97A4-45A13A17AC1B}"/>
               </a:ext>
             </a:extLst>
           </p:cNvPr>
@@ -4718,7 +6029,7 @@
           <p:cNvPr id="4" name="">
             <a:extLst xmlns:a="http://schemas.openxmlformats.org/drawingml/2006/main">
               <a:ext uri="{FF2B5EF4-FFF2-40B4-BE49-F238E27FC236}">
-                <a16:creationId xmlns:a16="http://schemas.microsoft.com/office/drawing/2014/main" id="{DBB50891-E283-4CC1-A43F-8E8769752CFA}"/>
+                <a16:creationId xmlns:a16="http://schemas.microsoft.com/office/drawing/2014/main" id="{AAC8CAD1-75D3-4383-939C-870E7EEE1587}"/>
               </a:ext>
             </a:extLst>
           </p:cNvPr>
@@ -4748,7 +6059,7 @@
           <p:cNvPr id="5" name="">
             <a:extLst xmlns:a="http://schemas.openxmlformats.org/drawingml/2006/main">
               <a:ext uri="{FF2B5EF4-FFF2-40B4-BE49-F238E27FC236}">
-                <a16:creationId xmlns:a16="http://schemas.microsoft.com/office/drawing/2014/main" id="{955BA85C-E16E-4A54-A1F7-18A126F9FFD2}"/>
+                <a16:creationId xmlns:a16="http://schemas.microsoft.com/office/drawing/2014/main" id="{566F4BA7-EAED-4A72-AB14-2621A86CC012}"/>
               </a:ext>
             </a:extLst>
           </p:cNvPr>
@@ -4805,7 +6116,7 @@
           <p:cNvPr id="6" name="">
             <a:extLst xmlns:a="http://schemas.openxmlformats.org/drawingml/2006/main">
               <a:ext uri="{FF2B5EF4-FFF2-40B4-BE49-F238E27FC236}">
-                <a16:creationId xmlns:a16="http://schemas.microsoft.com/office/drawing/2014/main" id="{FD34482A-9E2C-4C94-8EF9-847515DE82E0}"/>
+                <a16:creationId xmlns:a16="http://schemas.microsoft.com/office/drawing/2014/main" id="{C66BA6E0-2579-4CC9-8F6D-8CA359FE780E}"/>
               </a:ext>
             </a:extLst>
           </p:cNvPr>
@@ -4862,7 +6173,7 @@
           <p:cNvPr id="7" name="">
             <a:extLst xmlns:a="http://schemas.openxmlformats.org/drawingml/2006/main">
               <a:ext uri="{FF2B5EF4-FFF2-40B4-BE49-F238E27FC236}">
-                <a16:creationId xmlns:a16="http://schemas.microsoft.com/office/drawing/2014/main" id="{7E21752E-68D8-4650-AFAD-42302574C480}"/>
+                <a16:creationId xmlns:a16="http://schemas.microsoft.com/office/drawing/2014/main" id="{2F2393A3-BD66-46F0-BD08-5F6B9CBDDF01}"/>
               </a:ext>
             </a:extLst>
           </p:cNvPr>
@@ -4894,7 +6205,7 @@
           <p:cNvPr id="8" name="">
             <a:extLst xmlns:a="http://schemas.openxmlformats.org/drawingml/2006/main">
               <a:ext uri="{FF2B5EF4-FFF2-40B4-BE49-F238E27FC236}">
-                <a16:creationId xmlns:a16="http://schemas.microsoft.com/office/drawing/2014/main" id="{0F431CDE-B8E3-4216-A0F1-D2FD47B6CC06}"/>
+                <a16:creationId xmlns:a16="http://schemas.microsoft.com/office/drawing/2014/main" id="{E9477291-921D-45CA-8D40-A790B8F4CDF3}"/>
               </a:ext>
             </a:extLst>
           </p:cNvPr>
@@ -4951,7 +6262,7 @@
           <p:cNvPr id="9" name="">
             <a:extLst xmlns:a="http://schemas.openxmlformats.org/drawingml/2006/main">
               <a:ext uri="{FF2B5EF4-FFF2-40B4-BE49-F238E27FC236}">
-                <a16:creationId xmlns:a16="http://schemas.microsoft.com/office/drawing/2014/main" id="{54F8A0C4-E9F3-4BB5-80F3-65BE45CABAC4}"/>
+                <a16:creationId xmlns:a16="http://schemas.microsoft.com/office/drawing/2014/main" id="{E47F9AE4-B44A-429A-984A-0AEFD051A836}"/>
               </a:ext>
             </a:extLst>
           </p:cNvPr>
@@ -5008,7 +6319,7 @@
           <p:cNvPr id="10" name="">
             <a:extLst xmlns:a="http://schemas.openxmlformats.org/drawingml/2006/main">
               <a:ext uri="{FF2B5EF4-FFF2-40B4-BE49-F238E27FC236}">
-                <a16:creationId xmlns:a16="http://schemas.microsoft.com/office/drawing/2014/main" id="{8FF90738-3F59-469E-877A-258758F4428E}"/>
+                <a16:creationId xmlns:a16="http://schemas.microsoft.com/office/drawing/2014/main" id="{8C127795-165D-4CDE-826B-672B6809FCE3}"/>
               </a:ext>
             </a:extLst>
           </p:cNvPr>
@@ -5040,7 +6351,7 @@
           <p:cNvPr id="11" name="">
             <a:extLst xmlns:a="http://schemas.openxmlformats.org/drawingml/2006/main">
               <a:ext uri="{FF2B5EF4-FFF2-40B4-BE49-F238E27FC236}">
-                <a16:creationId xmlns:a16="http://schemas.microsoft.com/office/drawing/2014/main" id="{3B23CFAB-9568-4992-AEE0-8EC57ADADE39}"/>
+                <a16:creationId xmlns:a16="http://schemas.microsoft.com/office/drawing/2014/main" id="{341AABF1-66A7-4258-BAF6-B93F15007A97}"/>
               </a:ext>
             </a:extLst>
           </p:cNvPr>
@@ -5097,7 +6408,7 @@
           <p:cNvPr id="12" name="">
             <a:extLst xmlns:a="http://schemas.openxmlformats.org/drawingml/2006/main">
               <a:ext uri="{FF2B5EF4-FFF2-40B4-BE49-F238E27FC236}">
-                <a16:creationId xmlns:a16="http://schemas.microsoft.com/office/drawing/2014/main" id="{76B19A96-30E4-45CE-A137-6E7E3D1DD98B}"/>
+                <a16:creationId xmlns:a16="http://schemas.microsoft.com/office/drawing/2014/main" id="{64F40134-33DA-4BFA-A4F3-D85F990B7E10}"/>
               </a:ext>
             </a:extLst>
           </p:cNvPr>
@@ -5154,7 +6465,7 @@
           <p:cNvPr id="13" name="">
             <a:extLst xmlns:a="http://schemas.openxmlformats.org/drawingml/2006/main">
               <a:ext uri="{FF2B5EF4-FFF2-40B4-BE49-F238E27FC236}">
-                <a16:creationId xmlns:a16="http://schemas.microsoft.com/office/drawing/2014/main" id="{B4A8F6EF-895E-41B2-B7CE-319DD1BD84DC}"/>
+                <a16:creationId xmlns:a16="http://schemas.microsoft.com/office/drawing/2014/main" id="{3B536103-B520-462D-9979-3297EA68BE31}"/>
               </a:ext>
             </a:extLst>
           </p:cNvPr>
@@ -5186,7 +6497,7 @@
           <p:cNvPr id="14" name="">
             <a:extLst xmlns:a="http://schemas.openxmlformats.org/drawingml/2006/main">
               <a:ext uri="{FF2B5EF4-FFF2-40B4-BE49-F238E27FC236}">
-                <a16:creationId xmlns:a16="http://schemas.microsoft.com/office/drawing/2014/main" id="{AE85E288-C1C1-4C51-AF38-A813F0A2E9DF}"/>
+                <a16:creationId xmlns:a16="http://schemas.microsoft.com/office/drawing/2014/main" id="{BFE1BF96-2DAF-4A1A-A8C1-F02BF33B1CCA}"/>
               </a:ext>
             </a:extLst>
           </p:cNvPr>
@@ -5243,7 +6554,7 @@
           <p:cNvPr id="15" name="">
             <a:extLst xmlns:a="http://schemas.openxmlformats.org/drawingml/2006/main">
               <a:ext uri="{FF2B5EF4-FFF2-40B4-BE49-F238E27FC236}">
-                <a16:creationId xmlns:a16="http://schemas.microsoft.com/office/drawing/2014/main" id="{9D21E9BE-2963-4279-99E3-F16158F3EADC}"/>
+                <a16:creationId xmlns:a16="http://schemas.microsoft.com/office/drawing/2014/main" id="{98048CD5-DE87-4121-8117-9B5BB13690CD}"/>
               </a:ext>
             </a:extLst>
           </p:cNvPr>
@@ -5300,7 +6611,7 @@
           <p:cNvPr id="16" name="">
             <a:extLst xmlns:a="http://schemas.openxmlformats.org/drawingml/2006/main">
               <a:ext uri="{FF2B5EF4-FFF2-40B4-BE49-F238E27FC236}">
-                <a16:creationId xmlns:a16="http://schemas.microsoft.com/office/drawing/2014/main" id="{49952331-DF3F-4111-9B86-E7F2E3EE73A9}"/>
+                <a16:creationId xmlns:a16="http://schemas.microsoft.com/office/drawing/2014/main" id="{6426508E-8B41-422E-AF12-9F9EC27E1E71}"/>
               </a:ext>
             </a:extLst>
           </p:cNvPr>
@@ -5332,7 +6643,7 @@
           <p:cNvPr id="17" name="">
             <a:extLst xmlns:a="http://schemas.openxmlformats.org/drawingml/2006/main">
               <a:ext uri="{FF2B5EF4-FFF2-40B4-BE49-F238E27FC236}">
-                <a16:creationId xmlns:a16="http://schemas.microsoft.com/office/drawing/2014/main" id="{3A17A2E4-CDE7-461F-8B68-4B5D534A1EF5}"/>
+                <a16:creationId xmlns:a16="http://schemas.microsoft.com/office/drawing/2014/main" id="{86B6DA4D-2623-4F02-9A44-8E7AEB4DBBAC}"/>
               </a:ext>
             </a:extLst>
           </p:cNvPr>
@@ -5389,7 +6700,7 @@
           <p:cNvPr id="18" name="">
             <a:extLst xmlns:a="http://schemas.openxmlformats.org/drawingml/2006/main">
               <a:ext uri="{FF2B5EF4-FFF2-40B4-BE49-F238E27FC236}">
-                <a16:creationId xmlns:a16="http://schemas.microsoft.com/office/drawing/2014/main" id="{47154013-EA4E-43C6-A441-2D7BA2CBB55E}"/>
+                <a16:creationId xmlns:a16="http://schemas.microsoft.com/office/drawing/2014/main" id="{30C2319C-1B90-4229-B87D-B92B26017CD4}"/>
               </a:ext>
             </a:extLst>
           </p:cNvPr>
@@ -5521,7 +6832,7 @@
           <p:cNvPr id="22" name="">
             <a:extLst xmlns:a="http://schemas.openxmlformats.org/drawingml/2006/main">
               <a:ext uri="{FF2B5EF4-FFF2-40B4-BE49-F238E27FC236}">
-                <a16:creationId xmlns:a16="http://schemas.microsoft.com/office/drawing/2014/main" id="{83F03A0B-3D32-4FB6-B4C0-BBAD7173C7F8}"/>
+                <a16:creationId xmlns:a16="http://schemas.microsoft.com/office/drawing/2014/main" id="{30F92B52-F097-41E7-8370-FE0314CB2278}"/>
               </a:ext>
             </a:extLst>
           </p:cNvPr>
@@ -5551,7 +6862,7 @@
           <p:cNvPr id="23" name="">
             <a:extLst xmlns:a="http://schemas.openxmlformats.org/drawingml/2006/main">
               <a:ext uri="{FF2B5EF4-FFF2-40B4-BE49-F238E27FC236}">
-                <a16:creationId xmlns:a16="http://schemas.microsoft.com/office/drawing/2014/main" id="{80C386F7-866F-44CC-A28D-F81E6384C1B1}"/>
+                <a16:creationId xmlns:a16="http://schemas.microsoft.com/office/drawing/2014/main" id="{93723859-4B21-440A-9854-261F8AFC90F3}"/>
               </a:ext>
             </a:extLst>
           </p:cNvPr>
@@ -5608,7 +6919,7 @@
           <p:cNvPr id="24" name="">
             <a:extLst xmlns:a="http://schemas.openxmlformats.org/drawingml/2006/main">
               <a:ext uri="{FF2B5EF4-FFF2-40B4-BE49-F238E27FC236}">
-                <a16:creationId xmlns:a16="http://schemas.microsoft.com/office/drawing/2014/main" id="{98B76FBF-1869-4AB7-BAE8-E36648AD7F61}"/>
+                <a16:creationId xmlns:a16="http://schemas.microsoft.com/office/drawing/2014/main" id="{928123A1-701A-48B2-8502-6DCE391D795E}"/>
               </a:ext>
             </a:extLst>
           </p:cNvPr>
@@ -5638,7 +6949,7 @@
           <p:cNvPr id="25" name="">
             <a:extLst xmlns:a="http://schemas.openxmlformats.org/drawingml/2006/main">
               <a:ext uri="{FF2B5EF4-FFF2-40B4-BE49-F238E27FC236}">
-                <a16:creationId xmlns:a16="http://schemas.microsoft.com/office/drawing/2014/main" id="{37585902-F88B-4E4F-AC75-40ADBF704F4C}"/>
+                <a16:creationId xmlns:a16="http://schemas.microsoft.com/office/drawing/2014/main" id="{84E93326-29C1-42E3-AF11-C8E2869A38C9}"/>
               </a:ext>
             </a:extLst>
           </p:cNvPr>
@@ -5695,7 +7006,7 @@
           <p:cNvPr id="26" name="">
             <a:extLst xmlns:a="http://schemas.openxmlformats.org/drawingml/2006/main">
               <a:ext uri="{FF2B5EF4-FFF2-40B4-BE49-F238E27FC236}">
-                <a16:creationId xmlns:a16="http://schemas.microsoft.com/office/drawing/2014/main" id="{3A1F38C1-8DE8-49F6-B41E-9298A62C220C}"/>
+                <a16:creationId xmlns:a16="http://schemas.microsoft.com/office/drawing/2014/main" id="{D54896B1-1AC6-47B1-AC6D-463408728837}"/>
               </a:ext>
             </a:extLst>
           </p:cNvPr>
@@ -5750,7 +7061,7 @@
     </p:spTree>
     <p:extLst>
       <p:ext uri="{BB962C8B-B14F-4D97-AF65-F5344CB8AC3E}">
-        <p14:creationId xmlns:p14="http://schemas.microsoft.com/office/powerpoint/2010/main" val="1652487124"/>
+        <p14:creationId xmlns:p14="http://schemas.microsoft.com/office/powerpoint/2010/main" val="1776583273"/>
       </p:ext>
     </p:extLst>
   </p:cSld>
@@ -5781,7 +7092,7 @@
           <p:cNvPr id="12" name="">
             <a:extLst xmlns:a="http://schemas.openxmlformats.org/drawingml/2006/main">
               <a:ext uri="{FF2B5EF4-FFF2-40B4-BE49-F238E27FC236}">
-                <a16:creationId xmlns:a16="http://schemas.microsoft.com/office/drawing/2014/main" id="{73B6D62C-7354-452B-8E8E-8510BCAD9763}"/>
+                <a16:creationId xmlns:a16="http://schemas.microsoft.com/office/drawing/2014/main" id="{A03187BF-FF09-44F0-A8EE-A66166C2A50D}"/>
               </a:ext>
             </a:extLst>
           </p:cNvPr>
@@ -5811,7 +7122,7 @@
           <p:cNvPr id="2" name="">
             <a:extLst xmlns:a="http://schemas.openxmlformats.org/drawingml/2006/main">
               <a:ext uri="{FF2B5EF4-FFF2-40B4-BE49-F238E27FC236}">
-                <a16:creationId xmlns:a16="http://schemas.microsoft.com/office/drawing/2014/main" id="{13C669AC-D404-45C2-8B2F-D50B2436FD17}"/>
+                <a16:creationId xmlns:a16="http://schemas.microsoft.com/office/drawing/2014/main" id="{1A482E36-C4A7-48B8-9FF3-AA412A695098}"/>
               </a:ext>
             </a:extLst>
           </p:cNvPr>
@@ -5868,7 +7179,7 @@
           <p:cNvPr id="3" name="">
             <a:extLst xmlns:a="http://schemas.openxmlformats.org/drawingml/2006/main">
               <a:ext uri="{FF2B5EF4-FFF2-40B4-BE49-F238E27FC236}">
-                <a16:creationId xmlns:a16="http://schemas.microsoft.com/office/drawing/2014/main" id="{52ED01DF-3526-4550-9F66-89649956642D}"/>
+                <a16:creationId xmlns:a16="http://schemas.microsoft.com/office/drawing/2014/main" id="{A420DFB9-DFD9-4AF5-803A-492436BBF0B4}"/>
               </a:ext>
             </a:extLst>
           </p:cNvPr>
@@ -5898,7 +7209,7 @@
           <p:cNvPr id="4" name="">
             <a:extLst xmlns:a="http://schemas.openxmlformats.org/drawingml/2006/main">
               <a:ext uri="{FF2B5EF4-FFF2-40B4-BE49-F238E27FC236}">
-                <a16:creationId xmlns:a16="http://schemas.microsoft.com/office/drawing/2014/main" id="{E88D43FA-E9C8-474D-A65D-29EFC002FE2F}"/>
+                <a16:creationId xmlns:a16="http://schemas.microsoft.com/office/drawing/2014/main" id="{0D93870D-19EA-465E-A0FE-5D0D6B920F57}"/>
               </a:ext>
             </a:extLst>
           </p:cNvPr>
@@ -5928,7 +7239,7 @@
           <p:cNvPr id="5" name="">
             <a:extLst xmlns:a="http://schemas.openxmlformats.org/drawingml/2006/main">
               <a:ext uri="{FF2B5EF4-FFF2-40B4-BE49-F238E27FC236}">
-                <a16:creationId xmlns:a16="http://schemas.microsoft.com/office/drawing/2014/main" id="{B645AAB9-D477-4500-A78D-141185E86A08}"/>
+                <a16:creationId xmlns:a16="http://schemas.microsoft.com/office/drawing/2014/main" id="{317F6DD3-A873-4649-B5C6-A09A93E03EB2}"/>
               </a:ext>
             </a:extLst>
           </p:cNvPr>
@@ -5985,7 +7296,7 @@
           <p:cNvPr id="6" name="">
             <a:extLst xmlns:a="http://schemas.openxmlformats.org/drawingml/2006/main">
               <a:ext uri="{FF2B5EF4-FFF2-40B4-BE49-F238E27FC236}">
-                <a16:creationId xmlns:a16="http://schemas.microsoft.com/office/drawing/2014/main" id="{ECF58414-D4B8-43C1-BCBA-876800CFD24C}"/>
+                <a16:creationId xmlns:a16="http://schemas.microsoft.com/office/drawing/2014/main" id="{9F1ED9D9-2C4F-472D-9BE9-039BDC77DC47}"/>
               </a:ext>
             </a:extLst>
           </p:cNvPr>
@@ -6042,7 +7353,7 @@
           <p:cNvPr id="7" name="">
             <a:extLst xmlns:a="http://schemas.openxmlformats.org/drawingml/2006/main">
               <a:ext uri="{FF2B5EF4-FFF2-40B4-BE49-F238E27FC236}">
-                <a16:creationId xmlns:a16="http://schemas.microsoft.com/office/drawing/2014/main" id="{32B509E1-E8B4-4BFE-AE77-4C309CE8C719}"/>
+                <a16:creationId xmlns:a16="http://schemas.microsoft.com/office/drawing/2014/main" id="{2B8E9FAB-DFE7-4C4F-85C3-FC6744192CCE}"/>
               </a:ext>
             </a:extLst>
           </p:cNvPr>
@@ -6099,7 +7410,7 @@
           <p:cNvPr id="8" name="">
             <a:extLst xmlns:a="http://schemas.openxmlformats.org/drawingml/2006/main">
               <a:ext uri="{FF2B5EF4-FFF2-40B4-BE49-F238E27FC236}">
-                <a16:creationId xmlns:a16="http://schemas.microsoft.com/office/drawing/2014/main" id="{30B62326-CA42-4967-8DD6-816014D226E0}"/>
+                <a16:creationId xmlns:a16="http://schemas.microsoft.com/office/drawing/2014/main" id="{917C7478-C287-4601-9847-EEDA99960686}"/>
               </a:ext>
             </a:extLst>
           </p:cNvPr>
@@ -6156,7 +7467,7 @@
           <p:cNvPr id="9" name="">
             <a:extLst xmlns:a="http://schemas.openxmlformats.org/drawingml/2006/main">
               <a:ext uri="{FF2B5EF4-FFF2-40B4-BE49-F238E27FC236}">
-                <a16:creationId xmlns:a16="http://schemas.microsoft.com/office/drawing/2014/main" id="{CD3601CE-4BCE-43DA-90E2-DBB418F0633D}"/>
+                <a16:creationId xmlns:a16="http://schemas.microsoft.com/office/drawing/2014/main" id="{8968EAEA-49C6-44A0-AB85-82EBF219549C}"/>
               </a:ext>
             </a:extLst>
           </p:cNvPr>
@@ -6186,7 +7497,7 @@
           <p:cNvPr id="10" name="">
             <a:extLst xmlns:a="http://schemas.openxmlformats.org/drawingml/2006/main">
               <a:ext uri="{FF2B5EF4-FFF2-40B4-BE49-F238E27FC236}">
-                <a16:creationId xmlns:a16="http://schemas.microsoft.com/office/drawing/2014/main" id="{D72FEDC3-B929-43B8-8FBB-E8E91D742DF1}"/>
+                <a16:creationId xmlns:a16="http://schemas.microsoft.com/office/drawing/2014/main" id="{854677D4-88D7-4A6B-AFBD-29A04095B871}"/>
               </a:ext>
             </a:extLst>
           </p:cNvPr>
@@ -6243,7 +7554,7 @@
           <p:cNvPr id="11" name="">
             <a:extLst xmlns:a="http://schemas.openxmlformats.org/drawingml/2006/main">
               <a:ext uri="{FF2B5EF4-FFF2-40B4-BE49-F238E27FC236}">
-                <a16:creationId xmlns:a16="http://schemas.microsoft.com/office/drawing/2014/main" id="{54F5F320-8D2B-4EEC-B573-4D5022A386BF}"/>
+                <a16:creationId xmlns:a16="http://schemas.microsoft.com/office/drawing/2014/main" id="{90E2C2B9-EA45-43A7-909B-D0763FFF939E}"/>
               </a:ext>
             </a:extLst>
           </p:cNvPr>
@@ -6298,7 +7609,7 @@
     </p:spTree>
     <p:extLst>
       <p:ext uri="{BB962C8B-B14F-4D97-AF65-F5344CB8AC3E}">
-        <p14:creationId xmlns:p14="http://schemas.microsoft.com/office/powerpoint/2010/main" val="1287790917"/>
+        <p14:creationId xmlns:p14="http://schemas.microsoft.com/office/powerpoint/2010/main" val="498371696"/>
       </p:ext>
     </p:extLst>
   </p:cSld>
@@ -6329,7 +7640,7 @@
           <p:cNvPr id="17" name="">
             <a:extLst xmlns:a="http://schemas.openxmlformats.org/drawingml/2006/main">
               <a:ext uri="{FF2B5EF4-FFF2-40B4-BE49-F238E27FC236}">
-                <a16:creationId xmlns:a16="http://schemas.microsoft.com/office/drawing/2014/main" id="{69E40640-6882-4D7B-AE87-BB166CB6660A}"/>
+                <a16:creationId xmlns:a16="http://schemas.microsoft.com/office/drawing/2014/main" id="{81BEFAEA-9AF1-4099-9A1F-68358D4D8B76}"/>
               </a:ext>
             </a:extLst>
           </p:cNvPr>
@@ -6359,7 +7670,7 @@
           <p:cNvPr id="2" name="">
             <a:extLst xmlns:a="http://schemas.openxmlformats.org/drawingml/2006/main">
               <a:ext uri="{FF2B5EF4-FFF2-40B4-BE49-F238E27FC236}">
-                <a16:creationId xmlns:a16="http://schemas.microsoft.com/office/drawing/2014/main" id="{01C4CC48-699B-46BD-A722-BD45529AD7CC}"/>
+                <a16:creationId xmlns:a16="http://schemas.microsoft.com/office/drawing/2014/main" id="{883169EA-3E27-4B35-AF1A-23BA2F37974E}"/>
               </a:ext>
             </a:extLst>
           </p:cNvPr>
@@ -6389,7 +7700,7 @@
           <p:cNvPr id="3" name="">
             <a:extLst xmlns:a="http://schemas.openxmlformats.org/drawingml/2006/main">
               <a:ext uri="{FF2B5EF4-FFF2-40B4-BE49-F238E27FC236}">
-                <a16:creationId xmlns:a16="http://schemas.microsoft.com/office/drawing/2014/main" id="{4209F21C-18DA-4F43-A04A-CF2E643747E2}"/>
+                <a16:creationId xmlns:a16="http://schemas.microsoft.com/office/drawing/2014/main" id="{83F2DE6E-32BD-4310-872D-1BCA9A5DE4D8}"/>
               </a:ext>
             </a:extLst>
           </p:cNvPr>
@@ -6446,7 +7757,7 @@
           <p:cNvPr id="4" name="">
             <a:extLst xmlns:a="http://schemas.openxmlformats.org/drawingml/2006/main">
               <a:ext uri="{FF2B5EF4-FFF2-40B4-BE49-F238E27FC236}">
-                <a16:creationId xmlns:a16="http://schemas.microsoft.com/office/drawing/2014/main" id="{44B6A2A5-1A83-40E4-BF1A-42B1AFC79F35}"/>
+                <a16:creationId xmlns:a16="http://schemas.microsoft.com/office/drawing/2014/main" id="{A3DAE35C-5335-40EB-9BDD-CB60A8C45B49}"/>
               </a:ext>
             </a:extLst>
           </p:cNvPr>
@@ -6503,7 +7814,7 @@
           <p:cNvPr id="5" name="">
             <a:extLst xmlns:a="http://schemas.openxmlformats.org/drawingml/2006/main">
               <a:ext uri="{FF2B5EF4-FFF2-40B4-BE49-F238E27FC236}">
-                <a16:creationId xmlns:a16="http://schemas.microsoft.com/office/drawing/2014/main" id="{80AFE693-D4DD-45FF-8A73-DBEFD69E62F6}"/>
+                <a16:creationId xmlns:a16="http://schemas.microsoft.com/office/drawing/2014/main" id="{C3CC11A4-5012-45C4-8E41-F4AFA6946623}"/>
               </a:ext>
             </a:extLst>
           </p:cNvPr>
@@ -6533,7 +7844,7 @@
           <p:cNvPr id="6" name="">
             <a:extLst xmlns:a="http://schemas.openxmlformats.org/drawingml/2006/main">
               <a:ext uri="{FF2B5EF4-FFF2-40B4-BE49-F238E27FC236}">
-                <a16:creationId xmlns:a16="http://schemas.microsoft.com/office/drawing/2014/main" id="{D280778B-4E17-410D-B611-D17E57F3A2F7}"/>
+                <a16:creationId xmlns:a16="http://schemas.microsoft.com/office/drawing/2014/main" id="{29B158C3-91E4-49DD-9AB5-4BF081DC70B2}"/>
               </a:ext>
             </a:extLst>
           </p:cNvPr>
@@ -6590,7 +7901,7 @@
           <p:cNvPr id="7" name="">
             <a:extLst xmlns:a="http://schemas.openxmlformats.org/drawingml/2006/main">
               <a:ext uri="{FF2B5EF4-FFF2-40B4-BE49-F238E27FC236}">
-                <a16:creationId xmlns:a16="http://schemas.microsoft.com/office/drawing/2014/main" id="{17ED39FA-7CE8-4C86-BB0F-2FD64C373732}"/>
+                <a16:creationId xmlns:a16="http://schemas.microsoft.com/office/drawing/2014/main" id="{55A7771D-4B08-4595-8FD9-1AB743DAF14C}"/>
               </a:ext>
             </a:extLst>
           </p:cNvPr>
@@ -6647,7 +7958,7 @@
           <p:cNvPr id="8" name="">
             <a:extLst xmlns:a="http://schemas.openxmlformats.org/drawingml/2006/main">
               <a:ext uri="{FF2B5EF4-FFF2-40B4-BE49-F238E27FC236}">
-                <a16:creationId xmlns:a16="http://schemas.microsoft.com/office/drawing/2014/main" id="{A76F33ED-77AC-4E80-9E63-1022BC4B1061}"/>
+                <a16:creationId xmlns:a16="http://schemas.microsoft.com/office/drawing/2014/main" id="{663B018B-4323-43C3-8103-2CDEB471034A}"/>
               </a:ext>
             </a:extLst>
           </p:cNvPr>
@@ -6704,7 +8015,7 @@
           <p:cNvPr id="9" name="">
             <a:extLst xmlns:a="http://schemas.openxmlformats.org/drawingml/2006/main">
               <a:ext uri="{FF2B5EF4-FFF2-40B4-BE49-F238E27FC236}">
-                <a16:creationId xmlns:a16="http://schemas.microsoft.com/office/drawing/2014/main" id="{1D1E06C1-03CB-4B37-9F2F-5CAA95830850}"/>
+                <a16:creationId xmlns:a16="http://schemas.microsoft.com/office/drawing/2014/main" id="{7126C302-E5C8-45DC-8AA5-B774202D5DD1}"/>
               </a:ext>
             </a:extLst>
           </p:cNvPr>
@@ -6734,7 +8045,7 @@
           <p:cNvPr id="10" name="">
             <a:extLst xmlns:a="http://schemas.openxmlformats.org/drawingml/2006/main">
               <a:ext uri="{FF2B5EF4-FFF2-40B4-BE49-F238E27FC236}">
-                <a16:creationId xmlns:a16="http://schemas.microsoft.com/office/drawing/2014/main" id="{849D457E-EFA9-4130-948D-3085C9097232}"/>
+                <a16:creationId xmlns:a16="http://schemas.microsoft.com/office/drawing/2014/main" id="{B3E7E6A8-10F9-4402-A837-9C1C9285E442}"/>
               </a:ext>
             </a:extLst>
           </p:cNvPr>
@@ -6791,7 +8102,7 @@
           <p:cNvPr id="11" name="">
             <a:extLst xmlns:a="http://schemas.openxmlformats.org/drawingml/2006/main">
               <a:ext uri="{FF2B5EF4-FFF2-40B4-BE49-F238E27FC236}">
-                <a16:creationId xmlns:a16="http://schemas.microsoft.com/office/drawing/2014/main" id="{A3A9FEE6-0E91-47A7-814F-90EC93EC0BBA}"/>
+                <a16:creationId xmlns:a16="http://schemas.microsoft.com/office/drawing/2014/main" id="{99A822AA-EE4C-4B40-8065-48D6A4A57AE6}"/>
               </a:ext>
             </a:extLst>
           </p:cNvPr>
@@ -6848,7 +8159,7 @@
           <p:cNvPr id="12" name="">
             <a:extLst xmlns:a="http://schemas.openxmlformats.org/drawingml/2006/main">
               <a:ext uri="{FF2B5EF4-FFF2-40B4-BE49-F238E27FC236}">
-                <a16:creationId xmlns:a16="http://schemas.microsoft.com/office/drawing/2014/main" id="{4753562B-A03A-46E9-B923-337042AF737C}"/>
+                <a16:creationId xmlns:a16="http://schemas.microsoft.com/office/drawing/2014/main" id="{7ED77B2A-2B2A-4A92-AFF5-87325044B29B}"/>
               </a:ext>
             </a:extLst>
           </p:cNvPr>
@@ -6905,7 +8216,7 @@
           <p:cNvPr id="13" name="">
             <a:extLst xmlns:a="http://schemas.openxmlformats.org/drawingml/2006/main">
               <a:ext uri="{FF2B5EF4-FFF2-40B4-BE49-F238E27FC236}">
-                <a16:creationId xmlns:a16="http://schemas.microsoft.com/office/drawing/2014/main" id="{18A1057A-5B14-4498-814D-2F8857CDD9C3}"/>
+                <a16:creationId xmlns:a16="http://schemas.microsoft.com/office/drawing/2014/main" id="{D843BF82-9BAD-469F-A89C-9DD782C27F77}"/>
               </a:ext>
             </a:extLst>
           </p:cNvPr>
@@ -6935,7 +8246,7 @@
           <p:cNvPr id="14" name="">
             <a:extLst xmlns:a="http://schemas.openxmlformats.org/drawingml/2006/main">
               <a:ext uri="{FF2B5EF4-FFF2-40B4-BE49-F238E27FC236}">
-                <a16:creationId xmlns:a16="http://schemas.microsoft.com/office/drawing/2014/main" id="{A714A577-9894-4CE2-8DA0-8CE2F7CEC1C8}"/>
+                <a16:creationId xmlns:a16="http://schemas.microsoft.com/office/drawing/2014/main" id="{042620F2-275A-4E0E-9220-CAFA26CE8CB8}"/>
               </a:ext>
             </a:extLst>
           </p:cNvPr>
@@ -6992,7 +8303,7 @@
           <p:cNvPr id="15" name="">
             <a:extLst xmlns:a="http://schemas.openxmlformats.org/drawingml/2006/main">
               <a:ext uri="{FF2B5EF4-FFF2-40B4-BE49-F238E27FC236}">
-                <a16:creationId xmlns:a16="http://schemas.microsoft.com/office/drawing/2014/main" id="{A2A4FDFA-FA4E-4167-A6B0-B68EB3573BF3}"/>
+                <a16:creationId xmlns:a16="http://schemas.microsoft.com/office/drawing/2014/main" id="{8267C48D-0DAE-4C16-B2DF-5864E3CD9479}"/>
               </a:ext>
             </a:extLst>
           </p:cNvPr>
@@ -7049,7 +8360,7 @@
           <p:cNvPr id="16" name="">
             <a:extLst xmlns:a="http://schemas.openxmlformats.org/drawingml/2006/main">
               <a:ext uri="{FF2B5EF4-FFF2-40B4-BE49-F238E27FC236}">
-                <a16:creationId xmlns:a16="http://schemas.microsoft.com/office/drawing/2014/main" id="{E74636DE-B885-4C72-94E2-F1A3DB929588}"/>
+                <a16:creationId xmlns:a16="http://schemas.microsoft.com/office/drawing/2014/main" id="{227756CE-95EE-4948-BD50-D48AE1E54335}"/>
               </a:ext>
             </a:extLst>
           </p:cNvPr>
@@ -7104,7 +8415,7 @@
     </p:spTree>
     <p:extLst>
       <p:ext uri="{BB962C8B-B14F-4D97-AF65-F5344CB8AC3E}">
-        <p14:creationId xmlns:p14="http://schemas.microsoft.com/office/powerpoint/2010/main" val="104133457"/>
+        <p14:creationId xmlns:p14="http://schemas.microsoft.com/office/powerpoint/2010/main" val="89558498"/>
       </p:ext>
     </p:extLst>
   </p:cSld>
@@ -7132,24 +8443,24 @@
       </p:grpSpPr>
       <p:sp>
         <p:nvSpPr>
-          <p:cNvPr id="9" name="">
-            <a:extLst xmlns:a="http://schemas.openxmlformats.org/drawingml/2006/main">
-              <a:ext uri="{FF2B5EF4-FFF2-40B4-BE49-F238E27FC236}">
-                <a16:creationId xmlns:a16="http://schemas.microsoft.com/office/drawing/2014/main" id="{E079267D-53A2-47DF-9FCC-D6547C496553}"/>
-              </a:ext>
-            </a:extLst>
-          </p:cNvPr>
-          <p:cNvSpPr>
-            <a:spLocks xmlns:a="http://schemas.openxmlformats.org/drawingml/2006/main" noGrp="1"/>
-          </p:cNvSpPr>
-          <p:nvPr/>
-        </p:nvSpPr>
-        <p:spPr>
-          <a:xfrm xmlns:a="http://schemas.openxmlformats.org/drawingml/2006/main">
-            <a:off x="0" y="2013742"/>
-            <a:ext cx="12192000" cy="2493433"/>
-          </a:xfrm>
-          <a:prstGeom xmlns:a="http://schemas.openxmlformats.org/drawingml/2006/main" prst="rect">
+          <p:cNvPr id="17" name="">
+            <a:extLst xmlns:a="http://schemas.openxmlformats.org/drawingml/2006/main">
+              <a:ext uri="{FF2B5EF4-FFF2-40B4-BE49-F238E27FC236}">
+                <a16:creationId xmlns:a16="http://schemas.microsoft.com/office/drawing/2014/main" id="{611AC960-EB2C-4647-852D-BA7F471D37C1}"/>
+              </a:ext>
+            </a:extLst>
+          </p:cNvPr>
+          <p:cNvSpPr>
+            <a:spLocks xmlns:a="http://schemas.openxmlformats.org/drawingml/2006/main" noGrp="1"/>
+          </p:cNvSpPr>
+          <p:nvPr/>
+        </p:nvSpPr>
+        <p:spPr>
+          <a:xfrm xmlns:a="http://schemas.openxmlformats.org/drawingml/2006/main" rot="5400000">
+            <a:off x="533400" y="295275"/>
+            <a:ext cx="228600" cy="209550"/>
+          </a:xfrm>
+          <a:prstGeom xmlns:a="http://schemas.openxmlformats.org/drawingml/2006/main" prst="triangle">
             <a:avLst/>
           </a:prstGeom>
           <a:solidFill xmlns:a="http://schemas.openxmlformats.org/drawingml/2006/main">
@@ -7165,24 +8476,79 @@
           <p:cNvPr id="2" name="">
             <a:extLst xmlns:a="http://schemas.openxmlformats.org/drawingml/2006/main">
               <a:ext uri="{FF2B5EF4-FFF2-40B4-BE49-F238E27FC236}">
-                <a16:creationId xmlns:a16="http://schemas.microsoft.com/office/drawing/2014/main" id="{0AE22C66-0F1C-4C0F-815C-CA8C98CF04AA}"/>
-              </a:ext>
-            </a:extLst>
-          </p:cNvPr>
-          <p:cNvSpPr>
-            <a:spLocks xmlns:a="http://schemas.openxmlformats.org/drawingml/2006/main" noGrp="1"/>
-          </p:cNvSpPr>
-          <p:nvPr/>
-        </p:nvSpPr>
-        <p:spPr>
-          <a:xfrm xmlns:a="http://schemas.openxmlformats.org/drawingml/2006/main">
-            <a:off x="346377" y="262633"/>
-            <a:ext cx="596598" cy="60922"/>
-          </a:xfrm>
-          <a:prstGeom xmlns:a="http://schemas.openxmlformats.org/drawingml/2006/main" prst="roundRect">
-            <a:avLst>
-              <a:gd name="adj" fmla="val 50000"/>
-            </a:avLst>
+                <a16:creationId xmlns:a16="http://schemas.microsoft.com/office/drawing/2014/main" id="{35372B5C-8A4D-4E33-AE57-94ADB0AEAE1D}"/>
+              </a:ext>
+            </a:extLst>
+          </p:cNvPr>
+          <p:cNvSpPr>
+            <a:spLocks xmlns:a="http://schemas.openxmlformats.org/drawingml/2006/main" noGrp="1"/>
+          </p:cNvSpPr>
+          <p:nvPr/>
+        </p:nvSpPr>
+        <p:spPr>
+          <a:xfrm xmlns:a="http://schemas.openxmlformats.org/drawingml/2006/main">
+            <a:off x="857250" y="219075"/>
+            <a:ext cx="10715625" cy="409575"/>
+          </a:xfrm>
+          <a:prstGeom xmlns:a="http://schemas.openxmlformats.org/drawingml/2006/main" prst="rect">
+            <a:avLst/>
+          </a:prstGeom>
+          <a:noFill xmlns:a="http://schemas.openxmlformats.org/drawingml/2006/main"/>
+          <a:ln xmlns:a="http://schemas.openxmlformats.org/drawingml/2006/main" w="0">
+            <a:noFill/>
+          </a:ln>
+        </p:spPr>
+        <p:txBody>
+          <a:bodyPr xmlns:a="http://schemas.openxmlformats.org/drawingml/2006/main" wrap="square" lIns="0" tIns="0" rIns="0" bIns="0" anchor="t">
+            <a:noAutofit/>
+          </a:bodyPr>
+          <a:lstStyle xmlns:a="http://schemas.openxmlformats.org/drawingml/2006/main"/>
+          <a:p xmlns:a="http://schemas.openxmlformats.org/drawingml/2006/main">
+            <a:pPr algn="l">
+              <a:defRPr sz="2400" b="1">
+                <a:solidFill>
+                  <a:srgbClr val="32497B"/>
+                </a:solidFill>
+                <a:latin typeface="Source Han Sans CN"/>
+                <a:ea typeface="Source Han Sans CN"/>
+                <a:cs typeface="Source Han Sans CN"/>
+              </a:defRPr>
+            </a:pPr>
+            <a:r>
+              <a:rPr sz="2400" b="1">
+                <a:solidFill>
+                  <a:srgbClr val="32497B"/>
+                </a:solidFill>
+                <a:latin typeface="Source Han Sans CN"/>
+                <a:ea typeface="Source Han Sans CN"/>
+                <a:cs typeface="Source Han Sans CN"/>
+              </a:rPr>
+              <a:t>1.1 文献基本信息</a:t>
+            </a:r>
+          </a:p>
+        </p:txBody>
+      </p:sp>
+      <p:sp>
+        <p:nvSpPr>
+          <p:cNvPr id="3" name="">
+            <a:extLst xmlns:a="http://schemas.openxmlformats.org/drawingml/2006/main">
+              <a:ext uri="{FF2B5EF4-FFF2-40B4-BE49-F238E27FC236}">
+                <a16:creationId xmlns:a16="http://schemas.microsoft.com/office/drawing/2014/main" id="{9C55435A-A7CF-4D22-A3B9-06FBB8B31BEF}"/>
+              </a:ext>
+            </a:extLst>
+          </p:cNvPr>
+          <p:cNvSpPr>
+            <a:spLocks xmlns:a="http://schemas.openxmlformats.org/drawingml/2006/main" noGrp="1"/>
+          </p:cNvSpPr>
+          <p:nvPr/>
+        </p:nvSpPr>
+        <p:spPr>
+          <a:xfrm xmlns:a="http://schemas.openxmlformats.org/drawingml/2006/main">
+            <a:off x="533400" y="638175"/>
+            <a:ext cx="11125200" cy="9525"/>
+          </a:xfrm>
+          <a:prstGeom xmlns:a="http://schemas.openxmlformats.org/drawingml/2006/main" prst="rect">
+            <a:avLst/>
           </a:prstGeom>
           <a:solidFill xmlns:a="http://schemas.openxmlformats.org/drawingml/2006/main">
             <a:srgbClr val="32497B"/>
@@ -7194,27 +8560,25 @@
       </p:sp>
       <p:sp>
         <p:nvSpPr>
-          <p:cNvPr id="3" name="">
-            <a:extLst xmlns:a="http://schemas.openxmlformats.org/drawingml/2006/main">
-              <a:ext uri="{FF2B5EF4-FFF2-40B4-BE49-F238E27FC236}">
-                <a16:creationId xmlns:a16="http://schemas.microsoft.com/office/drawing/2014/main" id="{ABDC2C01-4214-49CD-8FDF-359D6B75E38C}"/>
-              </a:ext>
-            </a:extLst>
-          </p:cNvPr>
-          <p:cNvSpPr>
-            <a:spLocks xmlns:a="http://schemas.openxmlformats.org/drawingml/2006/main" noGrp="1"/>
-          </p:cNvSpPr>
-          <p:nvPr/>
-        </p:nvSpPr>
-        <p:spPr>
-          <a:xfrm xmlns:a="http://schemas.openxmlformats.org/drawingml/2006/main">
-            <a:off x="346377" y="363645"/>
-            <a:ext cx="432806" cy="60922"/>
-          </a:xfrm>
-          <a:prstGeom xmlns:a="http://schemas.openxmlformats.org/drawingml/2006/main" prst="roundRect">
-            <a:avLst>
-              <a:gd name="adj" fmla="val 50000"/>
-            </a:avLst>
+          <p:cNvPr id="4" name="">
+            <a:extLst xmlns:a="http://schemas.openxmlformats.org/drawingml/2006/main">
+              <a:ext uri="{FF2B5EF4-FFF2-40B4-BE49-F238E27FC236}">
+                <a16:creationId xmlns:a16="http://schemas.microsoft.com/office/drawing/2014/main" id="{7573A5C9-40AB-4483-B093-687AF54A9E75}"/>
+              </a:ext>
+            </a:extLst>
+          </p:cNvPr>
+          <p:cNvSpPr>
+            <a:spLocks xmlns:a="http://schemas.openxmlformats.org/drawingml/2006/main" noGrp="1"/>
+          </p:cNvSpPr>
+          <p:nvPr/>
+        </p:nvSpPr>
+        <p:spPr>
+          <a:xfrm xmlns:a="http://schemas.openxmlformats.org/drawingml/2006/main">
+            <a:off x="11782425" y="6438900"/>
+            <a:ext cx="409575" cy="419100"/>
+          </a:xfrm>
+          <a:prstGeom xmlns:a="http://schemas.openxmlformats.org/drawingml/2006/main" prst="rect">
+            <a:avLst/>
           </a:prstGeom>
           <a:solidFill xmlns:a="http://schemas.openxmlformats.org/drawingml/2006/main">
             <a:srgbClr val="32497B"/>
@@ -7226,150 +8590,22 @@
       </p:sp>
       <p:sp>
         <p:nvSpPr>
-          <p:cNvPr id="4" name="">
-            <a:extLst xmlns:a="http://schemas.openxmlformats.org/drawingml/2006/main">
-              <a:ext uri="{FF2B5EF4-FFF2-40B4-BE49-F238E27FC236}">
-                <a16:creationId xmlns:a16="http://schemas.microsoft.com/office/drawing/2014/main" id="{647550E2-52AF-4999-9CE8-03C6AB5417DB}"/>
-              </a:ext>
-            </a:extLst>
-          </p:cNvPr>
-          <p:cNvSpPr>
-            <a:spLocks xmlns:a="http://schemas.openxmlformats.org/drawingml/2006/main" noGrp="1"/>
-          </p:cNvSpPr>
-          <p:nvPr/>
-        </p:nvSpPr>
-        <p:spPr>
-          <a:xfrm xmlns:a="http://schemas.openxmlformats.org/drawingml/2006/main">
-            <a:off x="346377" y="464668"/>
-            <a:ext cx="291503" cy="60922"/>
-          </a:xfrm>
-          <a:prstGeom xmlns:a="http://schemas.openxmlformats.org/drawingml/2006/main" prst="roundRect">
-            <a:avLst>
-              <a:gd name="adj" fmla="val 50000"/>
-            </a:avLst>
-          </a:prstGeom>
-          <a:solidFill xmlns:a="http://schemas.openxmlformats.org/drawingml/2006/main">
-            <a:srgbClr val="32497B"/>
-          </a:solidFill>
-          <a:ln xmlns:a="http://schemas.openxmlformats.org/drawingml/2006/main" w="0">
-            <a:noFill/>
-          </a:ln>
-        </p:spPr>
-      </p:sp>
-      <p:sp>
-        <p:nvSpPr>
           <p:cNvPr id="5" name="">
             <a:extLst xmlns:a="http://schemas.openxmlformats.org/drawingml/2006/main">
               <a:ext uri="{FF2B5EF4-FFF2-40B4-BE49-F238E27FC236}">
-                <a16:creationId xmlns:a16="http://schemas.microsoft.com/office/drawing/2014/main" id="{8F477473-EF82-4DD0-85E8-C778CD3C67AA}"/>
-              </a:ext>
-            </a:extLst>
-          </p:cNvPr>
-          <p:cNvSpPr>
-            <a:spLocks xmlns:a="http://schemas.openxmlformats.org/drawingml/2006/main" noGrp="1"/>
-          </p:cNvSpPr>
-          <p:nvPr/>
-        </p:nvSpPr>
-        <p:spPr>
-          <a:xfrm xmlns:a="http://schemas.openxmlformats.org/drawingml/2006/main">
-            <a:off x="11249025" y="6537646"/>
-            <a:ext cx="596598" cy="60922"/>
-          </a:xfrm>
-          <a:prstGeom xmlns:a="http://schemas.openxmlformats.org/drawingml/2006/main" prst="roundRect">
-            <a:avLst>
-              <a:gd name="adj" fmla="val 50000"/>
-            </a:avLst>
-          </a:prstGeom>
-          <a:solidFill xmlns:a="http://schemas.openxmlformats.org/drawingml/2006/main">
-            <a:srgbClr val="32497B"/>
-          </a:solidFill>
-          <a:ln xmlns:a="http://schemas.openxmlformats.org/drawingml/2006/main" w="0">
-            <a:noFill/>
-          </a:ln>
-        </p:spPr>
-      </p:sp>
-      <p:sp>
-        <p:nvSpPr>
-          <p:cNvPr id="6" name="">
-            <a:extLst xmlns:a="http://schemas.openxmlformats.org/drawingml/2006/main">
-              <a:ext uri="{FF2B5EF4-FFF2-40B4-BE49-F238E27FC236}">
-                <a16:creationId xmlns:a16="http://schemas.microsoft.com/office/drawing/2014/main" id="{84386FD7-45C9-4374-BE3F-7F3D41C1E644}"/>
-              </a:ext>
-            </a:extLst>
-          </p:cNvPr>
-          <p:cNvSpPr>
-            <a:spLocks xmlns:a="http://schemas.openxmlformats.org/drawingml/2006/main" noGrp="1"/>
-          </p:cNvSpPr>
-          <p:nvPr/>
-        </p:nvSpPr>
-        <p:spPr>
-          <a:xfrm xmlns:a="http://schemas.openxmlformats.org/drawingml/2006/main">
-            <a:off x="11412817" y="6436624"/>
-            <a:ext cx="432806" cy="60922"/>
-          </a:xfrm>
-          <a:prstGeom xmlns:a="http://schemas.openxmlformats.org/drawingml/2006/main" prst="roundRect">
-            <a:avLst>
-              <a:gd name="adj" fmla="val 50000"/>
-            </a:avLst>
-          </a:prstGeom>
-          <a:solidFill xmlns:a="http://schemas.openxmlformats.org/drawingml/2006/main">
-            <a:srgbClr val="32497B"/>
-          </a:solidFill>
-          <a:ln xmlns:a="http://schemas.openxmlformats.org/drawingml/2006/main" w="0">
-            <a:noFill/>
-          </a:ln>
-        </p:spPr>
-      </p:sp>
-      <p:sp>
-        <p:nvSpPr>
-          <p:cNvPr id="7" name="">
-            <a:extLst xmlns:a="http://schemas.openxmlformats.org/drawingml/2006/main">
-              <a:ext uri="{FF2B5EF4-FFF2-40B4-BE49-F238E27FC236}">
-                <a16:creationId xmlns:a16="http://schemas.microsoft.com/office/drawing/2014/main" id="{DA1C7B65-F12F-4165-B104-4B4D6626D7FB}"/>
-              </a:ext>
-            </a:extLst>
-          </p:cNvPr>
-          <p:cNvSpPr>
-            <a:spLocks xmlns:a="http://schemas.openxmlformats.org/drawingml/2006/main" noGrp="1"/>
-          </p:cNvSpPr>
-          <p:nvPr/>
-        </p:nvSpPr>
-        <p:spPr>
-          <a:xfrm xmlns:a="http://schemas.openxmlformats.org/drawingml/2006/main">
-            <a:off x="11554111" y="6335611"/>
-            <a:ext cx="291503" cy="60922"/>
-          </a:xfrm>
-          <a:prstGeom xmlns:a="http://schemas.openxmlformats.org/drawingml/2006/main" prst="roundRect">
-            <a:avLst>
-              <a:gd name="adj" fmla="val 50000"/>
-            </a:avLst>
-          </a:prstGeom>
-          <a:solidFill xmlns:a="http://schemas.openxmlformats.org/drawingml/2006/main">
-            <a:srgbClr val="32497B"/>
-          </a:solidFill>
-          <a:ln xmlns:a="http://schemas.openxmlformats.org/drawingml/2006/main" w="0">
-            <a:noFill/>
-          </a:ln>
-        </p:spPr>
-      </p:sp>
-      <p:sp>
-        <p:nvSpPr>
-          <p:cNvPr id="8" name="">
-            <a:extLst xmlns:a="http://schemas.openxmlformats.org/drawingml/2006/main">
-              <a:ext uri="{FF2B5EF4-FFF2-40B4-BE49-F238E27FC236}">
-                <a16:creationId xmlns:a16="http://schemas.microsoft.com/office/drawing/2014/main" id="{1FE08006-E90D-45D5-A226-E931CF4F348A}"/>
-              </a:ext>
-            </a:extLst>
-          </p:cNvPr>
-          <p:cNvSpPr>
-            <a:spLocks xmlns:a="http://schemas.openxmlformats.org/drawingml/2006/main" noGrp="1"/>
-          </p:cNvSpPr>
-          <p:nvPr/>
-        </p:nvSpPr>
-        <p:spPr>
-          <a:xfrm xmlns:a="http://schemas.openxmlformats.org/drawingml/2006/main">
-            <a:off x="1284426" y="2875738"/>
-            <a:ext cx="9623148" cy="769441"/>
+                <a16:creationId xmlns:a16="http://schemas.microsoft.com/office/drawing/2014/main" id="{059086AA-16C3-441E-9E00-23EA052FEC9F}"/>
+              </a:ext>
+            </a:extLst>
+          </p:cNvPr>
+          <p:cNvSpPr>
+            <a:spLocks xmlns:a="http://schemas.openxmlformats.org/drawingml/2006/main" noGrp="1"/>
+          </p:cNvSpPr>
+          <p:nvPr/>
+        </p:nvSpPr>
+        <p:spPr>
+          <a:xfrm xmlns:a="http://schemas.openxmlformats.org/drawingml/2006/main">
+            <a:off x="11811000" y="6505575"/>
+            <a:ext cx="333375" cy="257175"/>
           </a:xfrm>
           <a:prstGeom xmlns:a="http://schemas.openxmlformats.org/drawingml/2006/main" prst="rect">
             <a:avLst/>
@@ -7386,7 +8622,7 @@
           <a:lstStyle xmlns:a="http://schemas.openxmlformats.org/drawingml/2006/main"/>
           <a:p xmlns:a="http://schemas.openxmlformats.org/drawingml/2006/main">
             <a:pPr algn="ctr">
-              <a:defRPr sz="4400" b="1">
+              <a:defRPr sz="1350" b="0">
                 <a:solidFill>
                   <a:srgbClr val="FFFFFF"/>
                 </a:solidFill>
@@ -7396,7 +8632,7 @@
               </a:defRPr>
             </a:pPr>
             <a:r>
-              <a:rPr sz="4400" b="1">
+              <a:rPr sz="1350" b="0">
                 <a:solidFill>
                   <a:srgbClr val="FFFFFF"/>
                 </a:solidFill>
@@ -7404,7 +8640,607 @@
                 <a:ea typeface="Source Han Sans CN"/>
                 <a:cs typeface="Source Han Sans CN"/>
               </a:rPr>
-              <a:t>汇报完毕，敬请老师同学批评指正！</a:t>
+              <a:t>9</a:t>
+            </a:r>
+          </a:p>
+        </p:txBody>
+      </p:sp>
+      <p:sp>
+        <p:nvSpPr>
+          <p:cNvPr id="6" name="">
+            <a:extLst xmlns:a="http://schemas.openxmlformats.org/drawingml/2006/main">
+              <a:ext uri="{FF2B5EF4-FFF2-40B4-BE49-F238E27FC236}">
+                <a16:creationId xmlns:a16="http://schemas.microsoft.com/office/drawing/2014/main" id="{E50C8990-8093-4FBC-9C78-72F04E88B58C}"/>
+              </a:ext>
+            </a:extLst>
+          </p:cNvPr>
+          <p:cNvSpPr>
+            <a:spLocks xmlns:a="http://schemas.openxmlformats.org/drawingml/2006/main" noGrp="1"/>
+          </p:cNvSpPr>
+          <p:nvPr/>
+        </p:nvSpPr>
+        <p:spPr>
+          <a:xfrm xmlns:a="http://schemas.openxmlformats.org/drawingml/2006/main">
+            <a:off x="609600" y="981075"/>
+            <a:ext cx="10953750" cy="414338"/>
+          </a:xfrm>
+          <a:prstGeom xmlns:a="http://schemas.openxmlformats.org/drawingml/2006/main" prst="rect">
+            <a:avLst/>
+          </a:prstGeom>
+          <a:noFill xmlns:a="http://schemas.openxmlformats.org/drawingml/2006/main"/>
+          <a:ln xmlns:a="http://schemas.openxmlformats.org/drawingml/2006/main" w="0">
+            <a:noFill/>
+          </a:ln>
+        </p:spPr>
+        <p:txBody>
+          <a:bodyPr xmlns:a="http://schemas.openxmlformats.org/drawingml/2006/main" wrap="square" lIns="0" tIns="0" rIns="0" bIns="0" anchor="t">
+            <a:noAutofit/>
+          </a:bodyPr>
+          <a:lstStyle xmlns:a="http://schemas.openxmlformats.org/drawingml/2006/main"/>
+          <a:p xmlns:a="http://schemas.openxmlformats.org/drawingml/2006/main">
+            <a:pPr algn="l">
+              <a:defRPr sz="2250" b="1">
+                <a:solidFill>
+                  <a:srgbClr val="252B35"/>
+                </a:solidFill>
+                <a:latin typeface="Source Han Sans CN"/>
+                <a:ea typeface="Source Han Sans CN"/>
+                <a:cs typeface="Source Han Sans CN"/>
+              </a:defRPr>
+            </a:pPr>
+            <a:r>
+              <a:rPr sz="2250" b="1">
+                <a:solidFill>
+                  <a:srgbClr val="252B35"/>
+                </a:solidFill>
+                <a:latin typeface="Source Han Sans CN"/>
+                <a:ea typeface="Source Han Sans CN"/>
+                <a:cs typeface="Source Han Sans CN"/>
+              </a:rPr>
+              <a:t>论文完整题名</a:t>
+            </a:r>
+          </a:p>
+        </p:txBody>
+      </p:sp>
+      <p:sp>
+        <p:nvSpPr>
+          <p:cNvPr id="7" name="">
+            <a:extLst xmlns:a="http://schemas.openxmlformats.org/drawingml/2006/main">
+              <a:ext uri="{FF2B5EF4-FFF2-40B4-BE49-F238E27FC236}">
+                <a16:creationId xmlns:a16="http://schemas.microsoft.com/office/drawing/2014/main" id="{4D317F96-D3CA-4ED2-A762-8D4823661286}"/>
+              </a:ext>
+            </a:extLst>
+          </p:cNvPr>
+          <p:cNvSpPr>
+            <a:spLocks xmlns:a="http://schemas.openxmlformats.org/drawingml/2006/main" noGrp="1"/>
+          </p:cNvSpPr>
+          <p:nvPr/>
+        </p:nvSpPr>
+        <p:spPr>
+          <a:xfrm xmlns:a="http://schemas.openxmlformats.org/drawingml/2006/main">
+            <a:off x="609600" y="1490663"/>
+            <a:ext cx="10953750" cy="327660"/>
+          </a:xfrm>
+          <a:prstGeom xmlns:a="http://schemas.openxmlformats.org/drawingml/2006/main" prst="rect">
+            <a:avLst/>
+          </a:prstGeom>
+          <a:noFill xmlns:a="http://schemas.openxmlformats.org/drawingml/2006/main"/>
+          <a:ln xmlns:a="http://schemas.openxmlformats.org/drawingml/2006/main" w="0">
+            <a:noFill/>
+          </a:ln>
+        </p:spPr>
+        <p:txBody>
+          <a:bodyPr xmlns:a="http://schemas.openxmlformats.org/drawingml/2006/main" wrap="square" lIns="0" tIns="0" rIns="0" bIns="0" anchor="t">
+            <a:noAutofit/>
+          </a:bodyPr>
+          <a:lstStyle xmlns:a="http://schemas.openxmlformats.org/drawingml/2006/main"/>
+          <a:p xmlns:a="http://schemas.openxmlformats.org/drawingml/2006/main">
+            <a:pPr algn="l">
+              <a:defRPr sz="1800" b="0">
+                <a:solidFill>
+                  <a:srgbClr val="626873"/>
+                </a:solidFill>
+                <a:latin typeface="Source Han Sans CN"/>
+                <a:ea typeface="Source Han Sans CN"/>
+                <a:cs typeface="Source Han Sans CN"/>
+              </a:defRPr>
+            </a:pPr>
+            <a:r>
+              <a:rPr sz="1800" b="0">
+                <a:solidFill>
+                  <a:srgbClr val="626873"/>
+                </a:solidFill>
+                <a:latin typeface="Source Han Sans CN"/>
+                <a:ea typeface="Source Han Sans CN"/>
+                <a:cs typeface="Source Han Sans CN"/>
+              </a:rPr>
+              <a:t>必要时可另列中文译名</a:t>
+            </a:r>
+          </a:p>
+        </p:txBody>
+      </p:sp>
+      <p:sp>
+        <p:nvSpPr>
+          <p:cNvPr id="8" name="">
+            <a:extLst xmlns:a="http://schemas.openxmlformats.org/drawingml/2006/main">
+              <a:ext uri="{FF2B5EF4-FFF2-40B4-BE49-F238E27FC236}">
+                <a16:creationId xmlns:a16="http://schemas.microsoft.com/office/drawing/2014/main" id="{EB7140BD-6313-4A91-86B5-0D94CAE2CC08}"/>
+              </a:ext>
+            </a:extLst>
+          </p:cNvPr>
+          <p:cNvSpPr>
+            <a:spLocks xmlns:a="http://schemas.openxmlformats.org/drawingml/2006/main" noGrp="1"/>
+          </p:cNvSpPr>
+          <p:nvPr/>
+        </p:nvSpPr>
+        <p:spPr>
+          <a:xfrm xmlns:a="http://schemas.openxmlformats.org/drawingml/2006/main">
+            <a:off x="609600" y="1980248"/>
+            <a:ext cx="10953750" cy="9525"/>
+          </a:xfrm>
+          <a:prstGeom xmlns:a="http://schemas.openxmlformats.org/drawingml/2006/main" prst="rect">
+            <a:avLst/>
+          </a:prstGeom>
+          <a:solidFill xmlns:a="http://schemas.openxmlformats.org/drawingml/2006/main">
+            <a:srgbClr val="A9B6D0"/>
+          </a:solidFill>
+          <a:ln xmlns:a="http://schemas.openxmlformats.org/drawingml/2006/main" w="0">
+            <a:noFill/>
+          </a:ln>
+        </p:spPr>
+      </p:sp>
+      <p:sp>
+        <p:nvSpPr>
+          <p:cNvPr id="9" name="">
+            <a:extLst xmlns:a="http://schemas.openxmlformats.org/drawingml/2006/main">
+              <a:ext uri="{FF2B5EF4-FFF2-40B4-BE49-F238E27FC236}">
+                <a16:creationId xmlns:a16="http://schemas.microsoft.com/office/drawing/2014/main" id="{CEEB9371-743E-4F36-AFAE-2B5B1AB68CC7}"/>
+              </a:ext>
+            </a:extLst>
+          </p:cNvPr>
+          <p:cNvSpPr>
+            <a:spLocks xmlns:a="http://schemas.openxmlformats.org/drawingml/2006/main" noGrp="1"/>
+          </p:cNvSpPr>
+          <p:nvPr/>
+        </p:nvSpPr>
+        <p:spPr>
+          <a:xfrm xmlns:a="http://schemas.openxmlformats.org/drawingml/2006/main">
+            <a:off x="609600" y="2208848"/>
+            <a:ext cx="5114925" cy="318135"/>
+          </a:xfrm>
+          <a:prstGeom xmlns:a="http://schemas.openxmlformats.org/drawingml/2006/main" prst="rect">
+            <a:avLst/>
+          </a:prstGeom>
+          <a:noFill xmlns:a="http://schemas.openxmlformats.org/drawingml/2006/main"/>
+          <a:ln xmlns:a="http://schemas.openxmlformats.org/drawingml/2006/main" w="0">
+            <a:noFill/>
+          </a:ln>
+        </p:spPr>
+        <p:txBody>
+          <a:bodyPr xmlns:a="http://schemas.openxmlformats.org/drawingml/2006/main" wrap="square" lIns="0" tIns="0" rIns="0" bIns="0" anchor="t">
+            <a:noAutofit/>
+          </a:bodyPr>
+          <a:lstStyle xmlns:a="http://schemas.openxmlformats.org/drawingml/2006/main"/>
+          <a:p xmlns:a="http://schemas.openxmlformats.org/drawingml/2006/main">
+            <a:pPr algn="l">
+              <a:defRPr sz="1800" b="0">
+                <a:solidFill>
+                  <a:srgbClr val="252B35"/>
+                </a:solidFill>
+                <a:latin typeface="Source Han Sans CN"/>
+                <a:ea typeface="Source Han Sans CN"/>
+                <a:cs typeface="Source Han Sans CN"/>
+              </a:defRPr>
+            </a:pPr>
+            <a:r>
+              <a:rPr sz="1800" b="0">
+                <a:solidFill>
+                  <a:srgbClr val="252B35"/>
+                </a:solidFill>
+                <a:latin typeface="Source Han Sans CN"/>
+                <a:ea typeface="Source Han Sans CN"/>
+                <a:cs typeface="Source Han Sans CN"/>
+              </a:rPr>
+              <a:t>作者：真实作者信息</a:t>
+            </a:r>
+          </a:p>
+        </p:txBody>
+      </p:sp>
+      <p:sp>
+        <p:nvSpPr>
+          <p:cNvPr id="10" name="">
+            <a:extLst xmlns:a="http://schemas.openxmlformats.org/drawingml/2006/main">
+              <a:ext uri="{FF2B5EF4-FFF2-40B4-BE49-F238E27FC236}">
+                <a16:creationId xmlns:a16="http://schemas.microsoft.com/office/drawing/2014/main" id="{F1A6FB9C-1327-43FE-B62D-E74B6E33A775}"/>
+              </a:ext>
+            </a:extLst>
+          </p:cNvPr>
+          <p:cNvSpPr>
+            <a:spLocks xmlns:a="http://schemas.openxmlformats.org/drawingml/2006/main" noGrp="1"/>
+          </p:cNvSpPr>
+          <p:nvPr/>
+        </p:nvSpPr>
+        <p:spPr>
+          <a:xfrm xmlns:a="http://schemas.openxmlformats.org/drawingml/2006/main">
+            <a:off x="609600" y="2669858"/>
+            <a:ext cx="5114925" cy="318135"/>
+          </a:xfrm>
+          <a:prstGeom xmlns:a="http://schemas.openxmlformats.org/drawingml/2006/main" prst="rect">
+            <a:avLst/>
+          </a:prstGeom>
+          <a:noFill xmlns:a="http://schemas.openxmlformats.org/drawingml/2006/main"/>
+          <a:ln xmlns:a="http://schemas.openxmlformats.org/drawingml/2006/main" w="0">
+            <a:noFill/>
+          </a:ln>
+        </p:spPr>
+        <p:txBody>
+          <a:bodyPr xmlns:a="http://schemas.openxmlformats.org/drawingml/2006/main" wrap="square" lIns="0" tIns="0" rIns="0" bIns="0" anchor="t">
+            <a:noAutofit/>
+          </a:bodyPr>
+          <a:lstStyle xmlns:a="http://schemas.openxmlformats.org/drawingml/2006/main"/>
+          <a:p xmlns:a="http://schemas.openxmlformats.org/drawingml/2006/main">
+            <a:pPr algn="l">
+              <a:defRPr sz="1800" b="0">
+                <a:solidFill>
+                  <a:srgbClr val="252B35"/>
+                </a:solidFill>
+                <a:latin typeface="Source Han Sans CN"/>
+                <a:ea typeface="Source Han Sans CN"/>
+                <a:cs typeface="Source Han Sans CN"/>
+              </a:defRPr>
+            </a:pPr>
+            <a:r>
+              <a:rPr sz="1800" b="0">
+                <a:solidFill>
+                  <a:srgbClr val="252B35"/>
+                </a:solidFill>
+                <a:latin typeface="Source Han Sans CN"/>
+                <a:ea typeface="Source Han Sans CN"/>
+                <a:cs typeface="Source Han Sans CN"/>
+              </a:rPr>
+              <a:t>来源：发表载体</a:t>
+            </a:r>
+          </a:p>
+        </p:txBody>
+      </p:sp>
+      <p:sp>
+        <p:nvSpPr>
+          <p:cNvPr id="11" name="">
+            <a:extLst xmlns:a="http://schemas.openxmlformats.org/drawingml/2006/main">
+              <a:ext uri="{FF2B5EF4-FFF2-40B4-BE49-F238E27FC236}">
+                <a16:creationId xmlns:a16="http://schemas.microsoft.com/office/drawing/2014/main" id="{410E746B-A285-4ADD-A5AD-3E0150D6E3BB}"/>
+              </a:ext>
+            </a:extLst>
+          </p:cNvPr>
+          <p:cNvSpPr>
+            <a:spLocks xmlns:a="http://schemas.openxmlformats.org/drawingml/2006/main" noGrp="1"/>
+          </p:cNvSpPr>
+          <p:nvPr/>
+        </p:nvSpPr>
+        <p:spPr>
+          <a:xfrm xmlns:a="http://schemas.openxmlformats.org/drawingml/2006/main">
+            <a:off x="609600" y="3130868"/>
+            <a:ext cx="5114925" cy="318135"/>
+          </a:xfrm>
+          <a:prstGeom xmlns:a="http://schemas.openxmlformats.org/drawingml/2006/main" prst="rect">
+            <a:avLst/>
+          </a:prstGeom>
+          <a:noFill xmlns:a="http://schemas.openxmlformats.org/drawingml/2006/main"/>
+          <a:ln xmlns:a="http://schemas.openxmlformats.org/drawingml/2006/main" w="0">
+            <a:noFill/>
+          </a:ln>
+        </p:spPr>
+        <p:txBody>
+          <a:bodyPr xmlns:a="http://schemas.openxmlformats.org/drawingml/2006/main" wrap="square" lIns="0" tIns="0" rIns="0" bIns="0" anchor="t">
+            <a:noAutofit/>
+          </a:bodyPr>
+          <a:lstStyle xmlns:a="http://schemas.openxmlformats.org/drawingml/2006/main"/>
+          <a:p xmlns:a="http://schemas.openxmlformats.org/drawingml/2006/main">
+            <a:pPr algn="l">
+              <a:defRPr sz="1800" b="0">
+                <a:solidFill>
+                  <a:srgbClr val="252B35"/>
+                </a:solidFill>
+                <a:latin typeface="Source Han Sans CN"/>
+                <a:ea typeface="Source Han Sans CN"/>
+                <a:cs typeface="Source Han Sans CN"/>
+              </a:defRPr>
+            </a:pPr>
+            <a:r>
+              <a:rPr sz="1800" b="0">
+                <a:solidFill>
+                  <a:srgbClr val="252B35"/>
+                </a:solidFill>
+                <a:latin typeface="Source Han Sans CN"/>
+                <a:ea typeface="Source Han Sans CN"/>
+                <a:cs typeface="Source Han Sans CN"/>
+              </a:rPr>
+              <a:t>发表：发表年份</a:t>
+            </a:r>
+          </a:p>
+        </p:txBody>
+      </p:sp>
+      <p:sp>
+        <p:nvSpPr>
+          <p:cNvPr id="12" name="">
+            <a:extLst xmlns:a="http://schemas.openxmlformats.org/drawingml/2006/main">
+              <a:ext uri="{FF2B5EF4-FFF2-40B4-BE49-F238E27FC236}">
+                <a16:creationId xmlns:a16="http://schemas.microsoft.com/office/drawing/2014/main" id="{F1A64F3C-3E29-431E-A1B3-702E4AD18422}"/>
+              </a:ext>
+            </a:extLst>
+          </p:cNvPr>
+          <p:cNvSpPr>
+            <a:spLocks xmlns:a="http://schemas.openxmlformats.org/drawingml/2006/main" noGrp="1"/>
+          </p:cNvSpPr>
+          <p:nvPr/>
+        </p:nvSpPr>
+        <p:spPr>
+          <a:xfrm xmlns:a="http://schemas.openxmlformats.org/drawingml/2006/main">
+            <a:off x="6296025" y="2208848"/>
+            <a:ext cx="5267325" cy="320040"/>
+          </a:xfrm>
+          <a:prstGeom xmlns:a="http://schemas.openxmlformats.org/drawingml/2006/main" prst="rect">
+            <a:avLst/>
+          </a:prstGeom>
+          <a:noFill xmlns:a="http://schemas.openxmlformats.org/drawingml/2006/main"/>
+          <a:ln xmlns:a="http://schemas.openxmlformats.org/drawingml/2006/main" w="0">
+            <a:noFill/>
+          </a:ln>
+        </p:spPr>
+        <p:txBody>
+          <a:bodyPr xmlns:a="http://schemas.openxmlformats.org/drawingml/2006/main" wrap="square" lIns="0" tIns="0" rIns="0" bIns="0" anchor="t">
+            <a:noAutofit/>
+          </a:bodyPr>
+          <a:lstStyle xmlns:a="http://schemas.openxmlformats.org/drawingml/2006/main"/>
+          <a:p xmlns:a="http://schemas.openxmlformats.org/drawingml/2006/main">
+            <a:pPr algn="l">
+              <a:defRPr sz="1800" b="1">
+                <a:solidFill>
+                  <a:srgbClr val="32497B"/>
+                </a:solidFill>
+                <a:latin typeface="Source Han Sans CN"/>
+                <a:ea typeface="Source Han Sans CN"/>
+                <a:cs typeface="Source Han Sans CN"/>
+              </a:defRPr>
+            </a:pPr>
+            <a:r>
+              <a:rPr sz="1800" b="1">
+                <a:solidFill>
+                  <a:srgbClr val="32497B"/>
+                </a:solidFill>
+                <a:latin typeface="Source Han Sans CN"/>
+                <a:ea typeface="Source Han Sans CN"/>
+                <a:cs typeface="Source Han Sans CN"/>
+              </a:rPr>
+              <a:t>主要研究内容</a:t>
+            </a:r>
+          </a:p>
+        </p:txBody>
+      </p:sp>
+      <p:sp>
+        <p:nvSpPr>
+          <p:cNvPr id="13" name="">
+            <a:extLst xmlns:a="http://schemas.openxmlformats.org/drawingml/2006/main">
+              <a:ext uri="{FF2B5EF4-FFF2-40B4-BE49-F238E27FC236}">
+                <a16:creationId xmlns:a16="http://schemas.microsoft.com/office/drawing/2014/main" id="{2C4BFA78-F173-4081-B19A-B138D2AAA3F3}"/>
+              </a:ext>
+            </a:extLst>
+          </p:cNvPr>
+          <p:cNvSpPr>
+            <a:spLocks xmlns:a="http://schemas.openxmlformats.org/drawingml/2006/main" noGrp="1"/>
+          </p:cNvSpPr>
+          <p:nvPr/>
+        </p:nvSpPr>
+        <p:spPr>
+          <a:xfrm xmlns:a="http://schemas.openxmlformats.org/drawingml/2006/main">
+            <a:off x="6296025" y="2608898"/>
+            <a:ext cx="5267325" cy="1022033"/>
+          </a:xfrm>
+          <a:prstGeom xmlns:a="http://schemas.openxmlformats.org/drawingml/2006/main" prst="rect">
+            <a:avLst/>
+          </a:prstGeom>
+          <a:noFill xmlns:a="http://schemas.openxmlformats.org/drawingml/2006/main"/>
+          <a:ln xmlns:a="http://schemas.openxmlformats.org/drawingml/2006/main" w="0">
+            <a:noFill/>
+          </a:ln>
+        </p:spPr>
+        <p:txBody>
+          <a:bodyPr xmlns:a="http://schemas.openxmlformats.org/drawingml/2006/main" wrap="square" lIns="0" tIns="0" rIns="0" bIns="0" anchor="t">
+            <a:noAutofit/>
+          </a:bodyPr>
+          <a:lstStyle xmlns:a="http://schemas.openxmlformats.org/drawingml/2006/main"/>
+          <a:p xmlns:a="http://schemas.openxmlformats.org/drawingml/2006/main">
+            <a:pPr algn="l">
+              <a:defRPr sz="1950" b="0">
+                <a:solidFill>
+                  <a:srgbClr val="252B35"/>
+                </a:solidFill>
+                <a:latin typeface="Source Han Sans CN"/>
+                <a:ea typeface="Source Han Sans CN"/>
+                <a:cs typeface="Source Han Sans CN"/>
+              </a:defRPr>
+            </a:pPr>
+            <a:r>
+              <a:rPr sz="1950" b="0">
+                <a:solidFill>
+                  <a:srgbClr val="252B35"/>
+                </a:solidFill>
+                <a:latin typeface="Source Han Sans CN"/>
+                <a:ea typeface="Source Han Sans CN"/>
+                <a:cs typeface="Source Han Sans CN"/>
+              </a:rPr>
+              <a:t>简要交代文献研究对象、核心问题与主要研究内容。正式汇报中据用户论文填写，不将本页标签作为事实。</a:t>
+            </a:r>
+          </a:p>
+        </p:txBody>
+      </p:sp>
+      <p:sp>
+        <p:nvSpPr>
+          <p:cNvPr id="14" name="">
+            <a:extLst xmlns:a="http://schemas.openxmlformats.org/drawingml/2006/main">
+              <a:ext uri="{FF2B5EF4-FFF2-40B4-BE49-F238E27FC236}">
+                <a16:creationId xmlns:a16="http://schemas.microsoft.com/office/drawing/2014/main" id="{EF9383F8-B4E0-43E0-A2E3-12D8F2559757}"/>
+              </a:ext>
+            </a:extLst>
+          </p:cNvPr>
+          <p:cNvSpPr>
+            <a:spLocks xmlns:a="http://schemas.openxmlformats.org/drawingml/2006/main" noGrp="1"/>
+          </p:cNvSpPr>
+          <p:nvPr/>
+        </p:nvSpPr>
+        <p:spPr>
+          <a:xfrm xmlns:a="http://schemas.openxmlformats.org/drawingml/2006/main">
+            <a:off x="6296025" y="3869055"/>
+            <a:ext cx="5267325" cy="320040"/>
+          </a:xfrm>
+          <a:prstGeom xmlns:a="http://schemas.openxmlformats.org/drawingml/2006/main" prst="rect">
+            <a:avLst/>
+          </a:prstGeom>
+          <a:noFill xmlns:a="http://schemas.openxmlformats.org/drawingml/2006/main"/>
+          <a:ln xmlns:a="http://schemas.openxmlformats.org/drawingml/2006/main" w="0">
+            <a:noFill/>
+          </a:ln>
+        </p:spPr>
+        <p:txBody>
+          <a:bodyPr xmlns:a="http://schemas.openxmlformats.org/drawingml/2006/main" wrap="square" lIns="0" tIns="0" rIns="0" bIns="0" anchor="t">
+            <a:noAutofit/>
+          </a:bodyPr>
+          <a:lstStyle xmlns:a="http://schemas.openxmlformats.org/drawingml/2006/main"/>
+          <a:p xmlns:a="http://schemas.openxmlformats.org/drawingml/2006/main">
+            <a:pPr algn="l">
+              <a:defRPr sz="1800" b="1">
+                <a:solidFill>
+                  <a:srgbClr val="32497B"/>
+                </a:solidFill>
+                <a:latin typeface="Source Han Sans CN"/>
+                <a:ea typeface="Source Han Sans CN"/>
+                <a:cs typeface="Source Han Sans CN"/>
+              </a:defRPr>
+            </a:pPr>
+            <a:r>
+              <a:rPr sz="1800" b="1">
+                <a:solidFill>
+                  <a:srgbClr val="32497B"/>
+                </a:solidFill>
+                <a:latin typeface="Source Han Sans CN"/>
+                <a:ea typeface="Source Han Sans CN"/>
+                <a:cs typeface="Source Han Sans CN"/>
+              </a:rPr>
+              <a:t>关键词</a:t>
+            </a:r>
+          </a:p>
+        </p:txBody>
+      </p:sp>
+      <p:sp>
+        <p:nvSpPr>
+          <p:cNvPr id="15" name="">
+            <a:extLst xmlns:a="http://schemas.openxmlformats.org/drawingml/2006/main">
+              <a:ext uri="{FF2B5EF4-FFF2-40B4-BE49-F238E27FC236}">
+                <a16:creationId xmlns:a16="http://schemas.microsoft.com/office/drawing/2014/main" id="{B2C28D91-A674-4760-8F2B-646FA1FE3732}"/>
+              </a:ext>
+            </a:extLst>
+          </p:cNvPr>
+          <p:cNvSpPr>
+            <a:spLocks xmlns:a="http://schemas.openxmlformats.org/drawingml/2006/main" noGrp="1"/>
+          </p:cNvSpPr>
+          <p:nvPr/>
+        </p:nvSpPr>
+        <p:spPr>
+          <a:xfrm xmlns:a="http://schemas.openxmlformats.org/drawingml/2006/main">
+            <a:off x="6296025" y="4269105"/>
+            <a:ext cx="5267325" cy="327660"/>
+          </a:xfrm>
+          <a:prstGeom xmlns:a="http://schemas.openxmlformats.org/drawingml/2006/main" prst="rect">
+            <a:avLst/>
+          </a:prstGeom>
+          <a:noFill xmlns:a="http://schemas.openxmlformats.org/drawingml/2006/main"/>
+          <a:ln xmlns:a="http://schemas.openxmlformats.org/drawingml/2006/main" w="0">
+            <a:noFill/>
+          </a:ln>
+        </p:spPr>
+        <p:txBody>
+          <a:bodyPr xmlns:a="http://schemas.openxmlformats.org/drawingml/2006/main" wrap="square" lIns="0" tIns="0" rIns="0" bIns="0" anchor="t">
+            <a:noAutofit/>
+          </a:bodyPr>
+          <a:lstStyle xmlns:a="http://schemas.openxmlformats.org/drawingml/2006/main"/>
+          <a:p xmlns:a="http://schemas.openxmlformats.org/drawingml/2006/main">
+            <a:pPr algn="l">
+              <a:defRPr sz="1800" b="0">
+                <a:solidFill>
+                  <a:srgbClr val="252B35"/>
+                </a:solidFill>
+                <a:latin typeface="Source Han Sans CN"/>
+                <a:ea typeface="Source Han Sans CN"/>
+                <a:cs typeface="Source Han Sans CN"/>
+              </a:defRPr>
+            </a:pPr>
+            <a:r>
+              <a:rPr sz="1800" b="0">
+                <a:solidFill>
+                  <a:srgbClr val="252B35"/>
+                </a:solidFill>
+                <a:latin typeface="Source Han Sans CN"/>
+                <a:ea typeface="Source Han Sans CN"/>
+                <a:cs typeface="Source Han Sans CN"/>
+              </a:rPr>
+              <a:t>据原文提炼的关键词</a:t>
+            </a:r>
+          </a:p>
+        </p:txBody>
+      </p:sp>
+      <p:sp>
+        <p:nvSpPr>
+          <p:cNvPr id="16" name="">
+            <a:extLst xmlns:a="http://schemas.openxmlformats.org/drawingml/2006/main">
+              <a:ext uri="{FF2B5EF4-FFF2-40B4-BE49-F238E27FC236}">
+                <a16:creationId xmlns:a16="http://schemas.microsoft.com/office/drawing/2014/main" id="{C77A2327-95E1-4CB9-9853-189ED53CDA6F}"/>
+              </a:ext>
+            </a:extLst>
+          </p:cNvPr>
+          <p:cNvSpPr>
+            <a:spLocks xmlns:a="http://schemas.openxmlformats.org/drawingml/2006/main" noGrp="1"/>
+          </p:cNvSpPr>
+          <p:nvPr/>
+        </p:nvSpPr>
+        <p:spPr>
+          <a:xfrm xmlns:a="http://schemas.openxmlformats.org/drawingml/2006/main">
+            <a:off x="542925" y="6429375"/>
+            <a:ext cx="10972800" cy="352425"/>
+          </a:xfrm>
+          <a:prstGeom xmlns:a="http://schemas.openxmlformats.org/drawingml/2006/main" prst="rect">
+            <a:avLst/>
+          </a:prstGeom>
+          <a:noFill xmlns:a="http://schemas.openxmlformats.org/drawingml/2006/main"/>
+          <a:ln xmlns:a="http://schemas.openxmlformats.org/drawingml/2006/main" w="0">
+            <a:noFill/>
+          </a:ln>
+        </p:spPr>
+        <p:txBody>
+          <a:bodyPr xmlns:a="http://schemas.openxmlformats.org/drawingml/2006/main" wrap="square" lIns="0" tIns="0" rIns="0" bIns="0" anchor="t">
+            <a:noAutofit/>
+          </a:bodyPr>
+          <a:lstStyle xmlns:a="http://schemas.openxmlformats.org/drawingml/2006/main"/>
+          <a:p xmlns:a="http://schemas.openxmlformats.org/drawingml/2006/main">
+            <a:pPr algn="l">
+              <a:defRPr sz="1050" b="0">
+                <a:solidFill>
+                  <a:srgbClr val="626873"/>
+                </a:solidFill>
+                <a:latin typeface="Source Han Sans CN"/>
+                <a:ea typeface="Source Han Sans CN"/>
+                <a:cs typeface="Source Han Sans CN"/>
+              </a:defRPr>
+            </a:pPr>
+            <a:r>
+              <a:rPr sz="1050" b="0">
+                <a:solidFill>
+                  <a:srgbClr val="626873"/>
+                </a:solidFill>
+                <a:latin typeface="Source Han Sans CN"/>
+                <a:ea typeface="Source Han Sans CN"/>
+                <a:cs typeface="Source Han Sans CN"/>
+              </a:rPr>
+              <a:t>论文出处与原文定位</a:t>
             </a:r>
           </a:p>
         </p:txBody>
@@ -7412,7 +9248,7 @@
     </p:spTree>
     <p:extLst>
       <p:ext uri="{BB962C8B-B14F-4D97-AF65-F5344CB8AC3E}">
-        <p14:creationId xmlns:p14="http://schemas.microsoft.com/office/powerpoint/2010/main" val="1332938250"/>
+        <p14:creationId xmlns:p14="http://schemas.microsoft.com/office/powerpoint/2010/main" val="751780968"/>
       </p:ext>
     </p:extLst>
   </p:cSld>

</xml_diff>

<commit_message>
chore: sync local skill assets and maintenance files
</commit_message>
<xml_diff>
--- a/assets/k105-blue/starter.pptx
+++ b/assets/k105-blue/starter.pptx
@@ -2,23 +2,23 @@
 <file path=ppt/presentation.xml><?xml version="1.0" encoding="utf-8"?>
 <p:presentation xmlns:p="http://schemas.openxmlformats.org/presentationml/2006/main">
   <p:sldMasterIdLst>
-    <p:sldMasterId xmlns:r="http://schemas.openxmlformats.org/officeDocument/2006/relationships" id="2147483648" r:id="R677e180bdaa84ecd"/>
+    <p:sldMasterId xmlns:r="http://schemas.openxmlformats.org/officeDocument/2006/relationships" id="2147483648" r:id="R0cd1e4226c654433"/>
   </p:sldMasterIdLst>
   <p:notesMasterIdLst>
-    <p:notesMasterId xmlns:r="http://schemas.openxmlformats.org/officeDocument/2006/relationships" r:id="Rbff4535b567040b6"/>
+    <p:notesMasterId xmlns:r="http://schemas.openxmlformats.org/officeDocument/2006/relationships" r:id="R3ef90075d4e2479c"/>
   </p:notesMasterIdLst>
   <p:sldIdLst>
-    <p:sldId xmlns:r="http://schemas.openxmlformats.org/officeDocument/2006/relationships" id="256" r:id="R66f76b3b981941ad"/>
-    <p:sldId xmlns:r="http://schemas.openxmlformats.org/officeDocument/2006/relationships" id="257" r:id="R0154c92990ee414b"/>
-    <p:sldId xmlns:r="http://schemas.openxmlformats.org/officeDocument/2006/relationships" id="258" r:id="Racfacc888410412f"/>
-    <p:sldId xmlns:r="http://schemas.openxmlformats.org/officeDocument/2006/relationships" id="259" r:id="Re3a6f6ce89584c5f"/>
-    <p:sldId xmlns:r="http://schemas.openxmlformats.org/officeDocument/2006/relationships" id="260" r:id="R2dfc3375341b4975"/>
-    <p:sldId xmlns:r="http://schemas.openxmlformats.org/officeDocument/2006/relationships" id="261" r:id="Rb8a80f5147354ab2"/>
-    <p:sldId xmlns:r="http://schemas.openxmlformats.org/officeDocument/2006/relationships" id="262" r:id="R49a9e4dfe454434d"/>
-    <p:sldId xmlns:r="http://schemas.openxmlformats.org/officeDocument/2006/relationships" id="263" r:id="R161d215a7ec44ed8"/>
-    <p:sldId xmlns:r="http://schemas.openxmlformats.org/officeDocument/2006/relationships" id="264" r:id="Rb6c161b49f604dec"/>
-    <p:sldId xmlns:r="http://schemas.openxmlformats.org/officeDocument/2006/relationships" id="265" r:id="R0752380716f24582"/>
-    <p:sldId xmlns:r="http://schemas.openxmlformats.org/officeDocument/2006/relationships" id="266" r:id="R96f5f5395e744eb7"/>
+    <p:sldId xmlns:r="http://schemas.openxmlformats.org/officeDocument/2006/relationships" id="256" r:id="Raf8b897aba7044ba"/>
+    <p:sldId xmlns:r="http://schemas.openxmlformats.org/officeDocument/2006/relationships" id="257" r:id="Rce3d1ac3092b46df"/>
+    <p:sldId xmlns:r="http://schemas.openxmlformats.org/officeDocument/2006/relationships" id="258" r:id="Rb081ab1a426e42bf"/>
+    <p:sldId xmlns:r="http://schemas.openxmlformats.org/officeDocument/2006/relationships" id="259" r:id="R38586a5c14324929"/>
+    <p:sldId xmlns:r="http://schemas.openxmlformats.org/officeDocument/2006/relationships" id="260" r:id="R3026a890138b4c8b"/>
+    <p:sldId xmlns:r="http://schemas.openxmlformats.org/officeDocument/2006/relationships" id="261" r:id="Rf90be533ce7f4d43"/>
+    <p:sldId xmlns:r="http://schemas.openxmlformats.org/officeDocument/2006/relationships" id="262" r:id="R7180feb0409b4ce5"/>
+    <p:sldId xmlns:r="http://schemas.openxmlformats.org/officeDocument/2006/relationships" id="263" r:id="R95afca282f3a4a23"/>
+    <p:sldId xmlns:r="http://schemas.openxmlformats.org/officeDocument/2006/relationships" id="264" r:id="Ra7432193b82f424a"/>
+    <p:sldId xmlns:r="http://schemas.openxmlformats.org/officeDocument/2006/relationships" id="265" r:id="Ra67bea7d82c649fe"/>
+    <p:sldId xmlns:r="http://schemas.openxmlformats.org/officeDocument/2006/relationships" id="266" r:id="Rf7f52fbe336e4b3d"/>
   </p:sldIdLst>
   <p:sldSz cx="12192000" cy="6858000"/>
   <p:notesSz cx="6858000" cy="9144000"/>
@@ -1220,7 +1220,7 @@
   </p:cSld>
   <p:clrMap bg1="lt1" tx1="dk1" bg2="lt2" tx2="dk2" accent1="accent1" accent2="accent2" accent3="accent3" accent4="accent4" accent5="accent5" accent6="accent6" hlink="hlink" folHlink="folHlink"/>
   <p:sldLayoutIdLst>
-    <p:sldLayoutId xmlns:r="http://schemas.openxmlformats.org/officeDocument/2006/relationships" id="2147483649" r:id="R683ef74864ec4db0"/>
+    <p:sldLayoutId xmlns:r="http://schemas.openxmlformats.org/officeDocument/2006/relationships" id="2147483649" r:id="Re0f20ccbcb124404"/>
   </p:sldLayoutIdLst>
   <p:txStyles>
     <p:titleStyle>
@@ -1771,7 +1771,7 @@
           <p:cNvPr id="13" name="">
             <a:extLst xmlns:a="http://schemas.openxmlformats.org/drawingml/2006/main">
               <a:ext uri="{FF2B5EF4-FFF2-40B4-BE49-F238E27FC236}">
-                <a16:creationId xmlns:a16="http://schemas.microsoft.com/office/drawing/2014/main" id="{17ADCACB-C64F-4A5D-B97B-1E8E28F7E436}"/>
+                <a16:creationId xmlns:a16="http://schemas.microsoft.com/office/drawing/2014/main" id="{166EE474-6119-4644-A02A-6FC0A9CA421E}"/>
               </a:ext>
             </a:extLst>
           </p:cNvPr>
@@ -1801,7 +1801,7 @@
           <p:cNvPr id="2" name="">
             <a:extLst xmlns:a="http://schemas.openxmlformats.org/drawingml/2006/main">
               <a:ext uri="{FF2B5EF4-FFF2-40B4-BE49-F238E27FC236}">
-                <a16:creationId xmlns:a16="http://schemas.microsoft.com/office/drawing/2014/main" id="{D6F0AFBC-C22C-40DD-8197-4909458AB077}"/>
+                <a16:creationId xmlns:a16="http://schemas.microsoft.com/office/drawing/2014/main" id="{37AC57D9-0CDD-4C96-9F19-835BB762A3A0}"/>
               </a:ext>
             </a:extLst>
           </p:cNvPr>
@@ -1833,7 +1833,7 @@
           <p:cNvPr id="3" name="">
             <a:extLst xmlns:a="http://schemas.openxmlformats.org/drawingml/2006/main">
               <a:ext uri="{FF2B5EF4-FFF2-40B4-BE49-F238E27FC236}">
-                <a16:creationId xmlns:a16="http://schemas.microsoft.com/office/drawing/2014/main" id="{96CE0632-A06C-4EFA-8B86-F7A9C739EC36}"/>
+                <a16:creationId xmlns:a16="http://schemas.microsoft.com/office/drawing/2014/main" id="{1CAD6338-657E-4610-B176-2FB15A09AF5D}"/>
               </a:ext>
             </a:extLst>
           </p:cNvPr>
@@ -1865,7 +1865,7 @@
           <p:cNvPr id="4" name="">
             <a:extLst xmlns:a="http://schemas.openxmlformats.org/drawingml/2006/main">
               <a:ext uri="{FF2B5EF4-FFF2-40B4-BE49-F238E27FC236}">
-                <a16:creationId xmlns:a16="http://schemas.microsoft.com/office/drawing/2014/main" id="{E6F77DE7-F195-4D09-84F3-55EFEFBC163F}"/>
+                <a16:creationId xmlns:a16="http://schemas.microsoft.com/office/drawing/2014/main" id="{19873B9E-DE0B-4234-B3EE-1C13B3190B95}"/>
               </a:ext>
             </a:extLst>
           </p:cNvPr>
@@ -1897,7 +1897,7 @@
           <p:cNvPr id="5" name="">
             <a:extLst xmlns:a="http://schemas.openxmlformats.org/drawingml/2006/main">
               <a:ext uri="{FF2B5EF4-FFF2-40B4-BE49-F238E27FC236}">
-                <a16:creationId xmlns:a16="http://schemas.microsoft.com/office/drawing/2014/main" id="{519819BF-9EFF-46DD-BB53-A0CD2646849B}"/>
+                <a16:creationId xmlns:a16="http://schemas.microsoft.com/office/drawing/2014/main" id="{699C1D3A-D0CB-48B1-84DC-C186A5D0EBF4}"/>
               </a:ext>
             </a:extLst>
           </p:cNvPr>
@@ -1929,7 +1929,7 @@
           <p:cNvPr id="6" name="">
             <a:extLst xmlns:a="http://schemas.openxmlformats.org/drawingml/2006/main">
               <a:ext uri="{FF2B5EF4-FFF2-40B4-BE49-F238E27FC236}">
-                <a16:creationId xmlns:a16="http://schemas.microsoft.com/office/drawing/2014/main" id="{812F2D24-E6E1-44A7-A1FC-08206FCDEDE8}"/>
+                <a16:creationId xmlns:a16="http://schemas.microsoft.com/office/drawing/2014/main" id="{A5EBC599-73A8-4946-9DA4-93D78B844FA6}"/>
               </a:ext>
             </a:extLst>
           </p:cNvPr>
@@ -1961,7 +1961,7 @@
           <p:cNvPr id="7" name="">
             <a:extLst xmlns:a="http://schemas.openxmlformats.org/drawingml/2006/main">
               <a:ext uri="{FF2B5EF4-FFF2-40B4-BE49-F238E27FC236}">
-                <a16:creationId xmlns:a16="http://schemas.microsoft.com/office/drawing/2014/main" id="{CD0FFB70-E648-490F-BF18-76DF1698A74B}"/>
+                <a16:creationId xmlns:a16="http://schemas.microsoft.com/office/drawing/2014/main" id="{02E41BCC-30A5-48EB-AD92-D77F3577B7D4}"/>
               </a:ext>
             </a:extLst>
           </p:cNvPr>
@@ -1993,7 +1993,7 @@
           <p:cNvPr id="8" name="">
             <a:extLst xmlns:a="http://schemas.openxmlformats.org/drawingml/2006/main">
               <a:ext uri="{FF2B5EF4-FFF2-40B4-BE49-F238E27FC236}">
-                <a16:creationId xmlns:a16="http://schemas.microsoft.com/office/drawing/2014/main" id="{07B61820-1126-4C07-973F-AE7693954581}"/>
+                <a16:creationId xmlns:a16="http://schemas.microsoft.com/office/drawing/2014/main" id="{7219BEBB-FEF4-47D4-855C-29C1659215A4}"/>
               </a:ext>
             </a:extLst>
           </p:cNvPr>
@@ -2054,10 +2054,10 @@
           <p:nvPr/>
         </p:nvPicPr>
         <p:blipFill>
-          <a:blip xmlns:r="http://schemas.openxmlformats.org/officeDocument/2006/relationships" xmlns:a="http://schemas.openxmlformats.org/drawingml/2006/main" r:embed="Rfdc9aae806bd4fe3">
+          <a:blip xmlns:r="http://schemas.openxmlformats.org/officeDocument/2006/relationships" xmlns:a="http://schemas.openxmlformats.org/drawingml/2006/main" r:embed="R4085866cc6394932">
             <a:extLst>
               <a:ext uri="{96DAC541-7B7A-43D3-8B79-37D633B846F1}">
-                <asvg:svgBlip xmlns:asvg="http://schemas.microsoft.com/office/drawing/2016/SVG/main" r:embed="Rddad0cdc9b094aec"/>
+                <asvg:svgBlip xmlns:asvg="http://schemas.microsoft.com/office/drawing/2016/SVG/main" r:embed="Rf7d09dcbd70848ea"/>
               </a:ext>
             </a:extLst>
           </a:blip>
@@ -2078,7 +2078,7 @@
           <p:cNvPr id="10" name="">
             <a:extLst xmlns:a="http://schemas.openxmlformats.org/drawingml/2006/main">
               <a:ext uri="{FF2B5EF4-FFF2-40B4-BE49-F238E27FC236}">
-                <a16:creationId xmlns:a16="http://schemas.microsoft.com/office/drawing/2014/main" id="{C4FF6878-A9A4-4A03-9E1D-4C10FC31C25B}"/>
+                <a16:creationId xmlns:a16="http://schemas.microsoft.com/office/drawing/2014/main" id="{C29769C2-3D61-453A-8BFA-D90ED20EA1CF}"/>
               </a:ext>
             </a:extLst>
           </p:cNvPr>
@@ -2139,10 +2139,10 @@
           <p:nvPr/>
         </p:nvPicPr>
         <p:blipFill>
-          <a:blip xmlns:r="http://schemas.openxmlformats.org/officeDocument/2006/relationships" xmlns:a="http://schemas.openxmlformats.org/drawingml/2006/main" r:embed="R5ca6705bbcc54b2b">
+          <a:blip xmlns:r="http://schemas.openxmlformats.org/officeDocument/2006/relationships" xmlns:a="http://schemas.openxmlformats.org/drawingml/2006/main" r:embed="R5183929d14624f4e">
             <a:extLst>
               <a:ext uri="{96DAC541-7B7A-43D3-8B79-37D633B846F1}">
-                <asvg:svgBlip xmlns:asvg="http://schemas.microsoft.com/office/drawing/2016/SVG/main" r:embed="R4dacd9282b4740ea"/>
+                <asvg:svgBlip xmlns:asvg="http://schemas.microsoft.com/office/drawing/2016/SVG/main" r:embed="Rae72bd700a90428a"/>
               </a:ext>
             </a:extLst>
           </a:blip>
@@ -2163,7 +2163,7 @@
           <p:cNvPr id="12" name="">
             <a:extLst xmlns:a="http://schemas.openxmlformats.org/drawingml/2006/main">
               <a:ext uri="{FF2B5EF4-FFF2-40B4-BE49-F238E27FC236}">
-                <a16:creationId xmlns:a16="http://schemas.microsoft.com/office/drawing/2014/main" id="{9983BA6D-FE4C-4CB2-820F-B99C0571F58E}"/>
+                <a16:creationId xmlns:a16="http://schemas.microsoft.com/office/drawing/2014/main" id="{3C0C0A31-FAA3-48D8-BD00-E044DF778829}"/>
               </a:ext>
             </a:extLst>
           </p:cNvPr>
@@ -2218,7 +2218,7 @@
     </p:spTree>
     <p:extLst>
       <p:ext uri="{BB962C8B-B14F-4D97-AF65-F5344CB8AC3E}">
-        <p14:creationId xmlns:p14="http://schemas.microsoft.com/office/powerpoint/2010/main" val="1546865354"/>
+        <p14:creationId xmlns:p14="http://schemas.microsoft.com/office/powerpoint/2010/main" val="1951787983"/>
       </p:ext>
     </p:extLst>
   </p:cSld>
@@ -2249,7 +2249,7 @@
           <p:cNvPr id="14" name="">
             <a:extLst xmlns:a="http://schemas.openxmlformats.org/drawingml/2006/main">
               <a:ext uri="{FF2B5EF4-FFF2-40B4-BE49-F238E27FC236}">
-                <a16:creationId xmlns:a16="http://schemas.microsoft.com/office/drawing/2014/main" id="{9D17FDE0-DE93-4B38-B1DD-1438F47F9CEC}"/>
+                <a16:creationId xmlns:a16="http://schemas.microsoft.com/office/drawing/2014/main" id="{4CE28580-55F0-4E86-8D32-0539EA6C71AE}"/>
               </a:ext>
             </a:extLst>
           </p:cNvPr>
@@ -2279,7 +2279,7 @@
           <p:cNvPr id="2" name="">
             <a:extLst xmlns:a="http://schemas.openxmlformats.org/drawingml/2006/main">
               <a:ext uri="{FF2B5EF4-FFF2-40B4-BE49-F238E27FC236}">
-                <a16:creationId xmlns:a16="http://schemas.microsoft.com/office/drawing/2014/main" id="{1DB7CFE1-9420-4AAA-8B6C-314AAEDD222D}"/>
+                <a16:creationId xmlns:a16="http://schemas.microsoft.com/office/drawing/2014/main" id="{710177CE-6D62-4588-A18A-908A62A54B8E}"/>
               </a:ext>
             </a:extLst>
           </p:cNvPr>
@@ -2309,7 +2309,7 @@
           <p:cNvPr id="3" name="">
             <a:extLst xmlns:a="http://schemas.openxmlformats.org/drawingml/2006/main">
               <a:ext uri="{FF2B5EF4-FFF2-40B4-BE49-F238E27FC236}">
-                <a16:creationId xmlns:a16="http://schemas.microsoft.com/office/drawing/2014/main" id="{AC41EE28-ED68-4685-A6DA-E2D885C44B8D}"/>
+                <a16:creationId xmlns:a16="http://schemas.microsoft.com/office/drawing/2014/main" id="{2D0EC8CF-6AA3-4976-A070-15ACA464C183}"/>
               </a:ext>
             </a:extLst>
           </p:cNvPr>
@@ -2366,7 +2366,7 @@
           <p:cNvPr id="4" name="">
             <a:extLst xmlns:a="http://schemas.openxmlformats.org/drawingml/2006/main">
               <a:ext uri="{FF2B5EF4-FFF2-40B4-BE49-F238E27FC236}">
-                <a16:creationId xmlns:a16="http://schemas.microsoft.com/office/drawing/2014/main" id="{5934E892-828D-4889-ABA6-0EBBD475FCEF}"/>
+                <a16:creationId xmlns:a16="http://schemas.microsoft.com/office/drawing/2014/main" id="{A3CB1191-62DB-4540-8E96-9E71C15641E6}"/>
               </a:ext>
             </a:extLst>
           </p:cNvPr>
@@ -2423,7 +2423,7 @@
           <p:cNvPr id="5" name="">
             <a:extLst xmlns:a="http://schemas.openxmlformats.org/drawingml/2006/main">
               <a:ext uri="{FF2B5EF4-FFF2-40B4-BE49-F238E27FC236}">
-                <a16:creationId xmlns:a16="http://schemas.microsoft.com/office/drawing/2014/main" id="{89C5C6E0-4AB8-49DA-95A6-6C6BEA247BFB}"/>
+                <a16:creationId xmlns:a16="http://schemas.microsoft.com/office/drawing/2014/main" id="{8651A99C-C8EF-41B9-ACE2-8556088234A3}"/>
               </a:ext>
             </a:extLst>
           </p:cNvPr>
@@ -2453,7 +2453,7 @@
           <p:cNvPr id="6" name="">
             <a:extLst xmlns:a="http://schemas.openxmlformats.org/drawingml/2006/main">
               <a:ext uri="{FF2B5EF4-FFF2-40B4-BE49-F238E27FC236}">
-                <a16:creationId xmlns:a16="http://schemas.microsoft.com/office/drawing/2014/main" id="{5067A5BA-2C74-4489-85C1-CEB8443A2059}"/>
+                <a16:creationId xmlns:a16="http://schemas.microsoft.com/office/drawing/2014/main" id="{DF21E0C5-9B37-40F0-9D95-87C7F4488F07}"/>
               </a:ext>
             </a:extLst>
           </p:cNvPr>
@@ -2510,7 +2510,7 @@
           <p:cNvPr id="7" name="">
             <a:extLst xmlns:a="http://schemas.openxmlformats.org/drawingml/2006/main">
               <a:ext uri="{FF2B5EF4-FFF2-40B4-BE49-F238E27FC236}">
-                <a16:creationId xmlns:a16="http://schemas.microsoft.com/office/drawing/2014/main" id="{0B97E78B-831A-4D94-952C-2234D8B3D4BF}"/>
+                <a16:creationId xmlns:a16="http://schemas.microsoft.com/office/drawing/2014/main" id="{A42E56B1-AF3D-4FD3-B93D-F89992305FA6}"/>
               </a:ext>
             </a:extLst>
           </p:cNvPr>
@@ -2567,7 +2567,7 @@
           <p:cNvPr id="8" name="">
             <a:extLst xmlns:a="http://schemas.openxmlformats.org/drawingml/2006/main">
               <a:ext uri="{FF2B5EF4-FFF2-40B4-BE49-F238E27FC236}">
-                <a16:creationId xmlns:a16="http://schemas.microsoft.com/office/drawing/2014/main" id="{150F5ADE-C44F-44FE-AC51-499A0BD5C798}"/>
+                <a16:creationId xmlns:a16="http://schemas.microsoft.com/office/drawing/2014/main" id="{E53B1680-9DA3-4E0D-B369-164AF2046E1D}"/>
               </a:ext>
             </a:extLst>
           </p:cNvPr>
@@ -2597,7 +2597,7 @@
           <p:cNvPr id="9" name="">
             <a:extLst xmlns:a="http://schemas.openxmlformats.org/drawingml/2006/main">
               <a:ext uri="{FF2B5EF4-FFF2-40B4-BE49-F238E27FC236}">
-                <a16:creationId xmlns:a16="http://schemas.microsoft.com/office/drawing/2014/main" id="{20745556-7260-44FA-9E0F-A0175E394708}"/>
+                <a16:creationId xmlns:a16="http://schemas.microsoft.com/office/drawing/2014/main" id="{14EB610A-268D-44A7-9344-E0D7621E8F47}"/>
               </a:ext>
             </a:extLst>
           </p:cNvPr>
@@ -2654,7 +2654,7 @@
           <p:cNvPr id="10" name="">
             <a:extLst xmlns:a="http://schemas.openxmlformats.org/drawingml/2006/main">
               <a:ext uri="{FF2B5EF4-FFF2-40B4-BE49-F238E27FC236}">
-                <a16:creationId xmlns:a16="http://schemas.microsoft.com/office/drawing/2014/main" id="{DA919A34-9F5E-4BB7-AF68-0FB8AC370F74}"/>
+                <a16:creationId xmlns:a16="http://schemas.microsoft.com/office/drawing/2014/main" id="{52853883-959D-4D49-B9C6-9B1C89103130}"/>
               </a:ext>
             </a:extLst>
           </p:cNvPr>
@@ -2711,7 +2711,7 @@
           <p:cNvPr id="11" name="">
             <a:extLst xmlns:a="http://schemas.openxmlformats.org/drawingml/2006/main">
               <a:ext uri="{FF2B5EF4-FFF2-40B4-BE49-F238E27FC236}">
-                <a16:creationId xmlns:a16="http://schemas.microsoft.com/office/drawing/2014/main" id="{30857C27-8A6F-4F81-8DB5-F96E6A317200}"/>
+                <a16:creationId xmlns:a16="http://schemas.microsoft.com/office/drawing/2014/main" id="{5E0D0DC6-3AE4-44C2-B896-5CC325785649}"/>
               </a:ext>
             </a:extLst>
           </p:cNvPr>
@@ -2741,7 +2741,7 @@
           <p:cNvPr id="12" name="">
             <a:extLst xmlns:a="http://schemas.openxmlformats.org/drawingml/2006/main">
               <a:ext uri="{FF2B5EF4-FFF2-40B4-BE49-F238E27FC236}">
-                <a16:creationId xmlns:a16="http://schemas.microsoft.com/office/drawing/2014/main" id="{7336E57D-F7A2-49E9-8E8C-7EC2AE51C6B8}"/>
+                <a16:creationId xmlns:a16="http://schemas.microsoft.com/office/drawing/2014/main" id="{575F035D-3108-4025-9D80-1686C4C84F42}"/>
               </a:ext>
             </a:extLst>
           </p:cNvPr>
@@ -2798,7 +2798,7 @@
           <p:cNvPr id="13" name="">
             <a:extLst xmlns:a="http://schemas.openxmlformats.org/drawingml/2006/main">
               <a:ext uri="{FF2B5EF4-FFF2-40B4-BE49-F238E27FC236}">
-                <a16:creationId xmlns:a16="http://schemas.microsoft.com/office/drawing/2014/main" id="{E5D2ED97-7855-4F77-9401-891C939910FF}"/>
+                <a16:creationId xmlns:a16="http://schemas.microsoft.com/office/drawing/2014/main" id="{1E453731-7537-414D-89B1-79422F46EC79}"/>
               </a:ext>
             </a:extLst>
           </p:cNvPr>
@@ -2853,7 +2853,7 @@
     </p:spTree>
     <p:extLst>
       <p:ext uri="{BB962C8B-B14F-4D97-AF65-F5344CB8AC3E}">
-        <p14:creationId xmlns:p14="http://schemas.microsoft.com/office/powerpoint/2010/main" val="1448974078"/>
+        <p14:creationId xmlns:p14="http://schemas.microsoft.com/office/powerpoint/2010/main" val="1603232118"/>
       </p:ext>
     </p:extLst>
   </p:cSld>
@@ -2884,7 +2884,7 @@
           <p:cNvPr id="13" name="">
             <a:extLst xmlns:a="http://schemas.openxmlformats.org/drawingml/2006/main">
               <a:ext uri="{FF2B5EF4-FFF2-40B4-BE49-F238E27FC236}">
-                <a16:creationId xmlns:a16="http://schemas.microsoft.com/office/drawing/2014/main" id="{994D5E81-C0DE-4027-82D2-EE5450D82620}"/>
+                <a16:creationId xmlns:a16="http://schemas.microsoft.com/office/drawing/2014/main" id="{F518C648-380A-456B-9402-232EAD8B1038}"/>
               </a:ext>
             </a:extLst>
           </p:cNvPr>
@@ -2914,7 +2914,7 @@
           <p:cNvPr id="2" name="">
             <a:extLst xmlns:a="http://schemas.openxmlformats.org/drawingml/2006/main">
               <a:ext uri="{FF2B5EF4-FFF2-40B4-BE49-F238E27FC236}">
-                <a16:creationId xmlns:a16="http://schemas.microsoft.com/office/drawing/2014/main" id="{D937CD2A-6A5C-4AF4-86BE-357C36879D85}"/>
+                <a16:creationId xmlns:a16="http://schemas.microsoft.com/office/drawing/2014/main" id="{308C63F1-24B9-4A9B-AA86-22BF25CC369C}"/>
               </a:ext>
             </a:extLst>
           </p:cNvPr>
@@ -2946,7 +2946,7 @@
           <p:cNvPr id="3" name="">
             <a:extLst xmlns:a="http://schemas.openxmlformats.org/drawingml/2006/main">
               <a:ext uri="{FF2B5EF4-FFF2-40B4-BE49-F238E27FC236}">
-                <a16:creationId xmlns:a16="http://schemas.microsoft.com/office/drawing/2014/main" id="{F484B090-EC82-4E34-824B-6FF099DA40EB}"/>
+                <a16:creationId xmlns:a16="http://schemas.microsoft.com/office/drawing/2014/main" id="{8E2AB6ED-1625-4DE1-8BC0-DC13A1648093}"/>
               </a:ext>
             </a:extLst>
           </p:cNvPr>
@@ -2978,7 +2978,7 @@
           <p:cNvPr id="4" name="">
             <a:extLst xmlns:a="http://schemas.openxmlformats.org/drawingml/2006/main">
               <a:ext uri="{FF2B5EF4-FFF2-40B4-BE49-F238E27FC236}">
-                <a16:creationId xmlns:a16="http://schemas.microsoft.com/office/drawing/2014/main" id="{67530C3E-C18A-4DF2-946C-F6860C9E6E72}"/>
+                <a16:creationId xmlns:a16="http://schemas.microsoft.com/office/drawing/2014/main" id="{1D7C477C-5E89-4E9E-8F91-06B6130C1EA5}"/>
               </a:ext>
             </a:extLst>
           </p:cNvPr>
@@ -3010,7 +3010,7 @@
           <p:cNvPr id="5" name="">
             <a:extLst xmlns:a="http://schemas.openxmlformats.org/drawingml/2006/main">
               <a:ext uri="{FF2B5EF4-FFF2-40B4-BE49-F238E27FC236}">
-                <a16:creationId xmlns:a16="http://schemas.microsoft.com/office/drawing/2014/main" id="{2916447C-ADED-4D78-8A10-FE10B9A87DAF}"/>
+                <a16:creationId xmlns:a16="http://schemas.microsoft.com/office/drawing/2014/main" id="{D36F2A7C-AFFC-4013-9E9B-060D23069E5F}"/>
               </a:ext>
             </a:extLst>
           </p:cNvPr>
@@ -3042,7 +3042,7 @@
           <p:cNvPr id="6" name="">
             <a:extLst xmlns:a="http://schemas.openxmlformats.org/drawingml/2006/main">
               <a:ext uri="{FF2B5EF4-FFF2-40B4-BE49-F238E27FC236}">
-                <a16:creationId xmlns:a16="http://schemas.microsoft.com/office/drawing/2014/main" id="{EEEAFC96-98DB-40B4-8600-84FEBFB4F50D}"/>
+                <a16:creationId xmlns:a16="http://schemas.microsoft.com/office/drawing/2014/main" id="{42CF526B-563D-4926-9E8D-257D16049A47}"/>
               </a:ext>
             </a:extLst>
           </p:cNvPr>
@@ -3074,7 +3074,7 @@
           <p:cNvPr id="7" name="">
             <a:extLst xmlns:a="http://schemas.openxmlformats.org/drawingml/2006/main">
               <a:ext uri="{FF2B5EF4-FFF2-40B4-BE49-F238E27FC236}">
-                <a16:creationId xmlns:a16="http://schemas.microsoft.com/office/drawing/2014/main" id="{E314FD08-E4FC-4A12-A3C2-171DE145E04B}"/>
+                <a16:creationId xmlns:a16="http://schemas.microsoft.com/office/drawing/2014/main" id="{4DB56FAF-9252-4DFD-8B11-485D272FBC39}"/>
               </a:ext>
             </a:extLst>
           </p:cNvPr>
@@ -3106,7 +3106,7 @@
           <p:cNvPr id="8" name="">
             <a:extLst xmlns:a="http://schemas.openxmlformats.org/drawingml/2006/main">
               <a:ext uri="{FF2B5EF4-FFF2-40B4-BE49-F238E27FC236}">
-                <a16:creationId xmlns:a16="http://schemas.microsoft.com/office/drawing/2014/main" id="{5FDF7C22-E335-423D-AA87-22B63BC73792}"/>
+                <a16:creationId xmlns:a16="http://schemas.microsoft.com/office/drawing/2014/main" id="{5FF6DB32-FB21-441B-AC01-BAC35CF8DB95}"/>
               </a:ext>
             </a:extLst>
           </p:cNvPr>
@@ -3167,10 +3167,10 @@
           <p:nvPr/>
         </p:nvPicPr>
         <p:blipFill>
-          <a:blip xmlns:r="http://schemas.openxmlformats.org/officeDocument/2006/relationships" xmlns:a="http://schemas.openxmlformats.org/drawingml/2006/main" r:embed="R9ee00347852749d1">
+          <a:blip xmlns:r="http://schemas.openxmlformats.org/officeDocument/2006/relationships" xmlns:a="http://schemas.openxmlformats.org/drawingml/2006/main" r:embed="Rde4072d19595413b">
             <a:extLst>
               <a:ext uri="{96DAC541-7B7A-43D3-8B79-37D633B846F1}">
-                <asvg:svgBlip xmlns:asvg="http://schemas.microsoft.com/office/drawing/2016/SVG/main" r:embed="R29d12d91d3c64edc"/>
+                <asvg:svgBlip xmlns:asvg="http://schemas.microsoft.com/office/drawing/2016/SVG/main" r:embed="R05bfff9ca2d94e49"/>
               </a:ext>
             </a:extLst>
           </a:blip>
@@ -3191,7 +3191,7 @@
           <p:cNvPr id="10" name="">
             <a:extLst xmlns:a="http://schemas.openxmlformats.org/drawingml/2006/main">
               <a:ext uri="{FF2B5EF4-FFF2-40B4-BE49-F238E27FC236}">
-                <a16:creationId xmlns:a16="http://schemas.microsoft.com/office/drawing/2014/main" id="{A35A2715-E84F-42AD-A2BF-68E66FC5C6B9}"/>
+                <a16:creationId xmlns:a16="http://schemas.microsoft.com/office/drawing/2014/main" id="{87066154-D158-4B97-B1A7-C0ECD0566A57}"/>
               </a:ext>
             </a:extLst>
           </p:cNvPr>
@@ -3252,10 +3252,10 @@
           <p:nvPr/>
         </p:nvPicPr>
         <p:blipFill>
-          <a:blip xmlns:r="http://schemas.openxmlformats.org/officeDocument/2006/relationships" xmlns:a="http://schemas.openxmlformats.org/drawingml/2006/main" r:embed="R5c2601538f4942be">
+          <a:blip xmlns:r="http://schemas.openxmlformats.org/officeDocument/2006/relationships" xmlns:a="http://schemas.openxmlformats.org/drawingml/2006/main" r:embed="R08e0a8f4b18e40aa">
             <a:extLst>
               <a:ext uri="{96DAC541-7B7A-43D3-8B79-37D633B846F1}">
-                <asvg:svgBlip xmlns:asvg="http://schemas.microsoft.com/office/drawing/2016/SVG/main" r:embed="R9474024c5fa046e8"/>
+                <asvg:svgBlip xmlns:asvg="http://schemas.microsoft.com/office/drawing/2016/SVG/main" r:embed="R2d24a3aee0ad44bd"/>
               </a:ext>
             </a:extLst>
           </a:blip>
@@ -3276,7 +3276,7 @@
           <p:cNvPr id="12" name="">
             <a:extLst xmlns:a="http://schemas.openxmlformats.org/drawingml/2006/main">
               <a:ext uri="{FF2B5EF4-FFF2-40B4-BE49-F238E27FC236}">
-                <a16:creationId xmlns:a16="http://schemas.microsoft.com/office/drawing/2014/main" id="{346BD9D8-5C66-4C4D-A998-7701DDCDA05B}"/>
+                <a16:creationId xmlns:a16="http://schemas.microsoft.com/office/drawing/2014/main" id="{49936FED-8C68-4D9F-B700-3ECE233F6C08}"/>
               </a:ext>
             </a:extLst>
           </p:cNvPr>
@@ -3331,7 +3331,7 @@
     </p:spTree>
     <p:extLst>
       <p:ext uri="{BB962C8B-B14F-4D97-AF65-F5344CB8AC3E}">
-        <p14:creationId xmlns:p14="http://schemas.microsoft.com/office/powerpoint/2010/main" val="184421856"/>
+        <p14:creationId xmlns:p14="http://schemas.microsoft.com/office/powerpoint/2010/main" val="245796545"/>
       </p:ext>
     </p:extLst>
   </p:cSld>
@@ -3362,7 +3362,7 @@
           <p:cNvPr id="12" name="">
             <a:extLst xmlns:a="http://schemas.openxmlformats.org/drawingml/2006/main">
               <a:ext uri="{FF2B5EF4-FFF2-40B4-BE49-F238E27FC236}">
-                <a16:creationId xmlns:a16="http://schemas.microsoft.com/office/drawing/2014/main" id="{AA7EF225-F3C0-4F07-A74D-586E165B96B5}"/>
+                <a16:creationId xmlns:a16="http://schemas.microsoft.com/office/drawing/2014/main" id="{B244C56A-BCDA-4A54-AD57-EEB6A1749DEA}"/>
               </a:ext>
             </a:extLst>
           </p:cNvPr>
@@ -3392,7 +3392,7 @@
           <p:cNvPr id="2" name="">
             <a:extLst xmlns:a="http://schemas.openxmlformats.org/drawingml/2006/main">
               <a:ext uri="{FF2B5EF4-FFF2-40B4-BE49-F238E27FC236}">
-                <a16:creationId xmlns:a16="http://schemas.microsoft.com/office/drawing/2014/main" id="{25FAA2EF-643A-4FF4-82DA-3C715E1FA13E}"/>
+                <a16:creationId xmlns:a16="http://schemas.microsoft.com/office/drawing/2014/main" id="{E086B023-EF2D-4602-9BC0-021C0F0F66FA}"/>
               </a:ext>
             </a:extLst>
           </p:cNvPr>
@@ -3449,7 +3449,7 @@
           <p:cNvPr id="3" name="">
             <a:extLst xmlns:a="http://schemas.openxmlformats.org/drawingml/2006/main">
               <a:ext uri="{FF2B5EF4-FFF2-40B4-BE49-F238E27FC236}">
-                <a16:creationId xmlns:a16="http://schemas.microsoft.com/office/drawing/2014/main" id="{C2BABE0F-B79C-4F02-AA6D-0104CADAD362}"/>
+                <a16:creationId xmlns:a16="http://schemas.microsoft.com/office/drawing/2014/main" id="{D2F8F6DF-00AF-4274-99BA-E19418FA4595}"/>
               </a:ext>
             </a:extLst>
           </p:cNvPr>
@@ -3479,7 +3479,7 @@
           <p:cNvPr id="4" name="">
             <a:extLst xmlns:a="http://schemas.openxmlformats.org/drawingml/2006/main">
               <a:ext uri="{FF2B5EF4-FFF2-40B4-BE49-F238E27FC236}">
-                <a16:creationId xmlns:a16="http://schemas.microsoft.com/office/drawing/2014/main" id="{16B45270-405D-4BE5-B540-E05860119904}"/>
+                <a16:creationId xmlns:a16="http://schemas.microsoft.com/office/drawing/2014/main" id="{DE79D4D7-8A46-49CA-BF60-AF25DD52E9E5}"/>
               </a:ext>
             </a:extLst>
           </p:cNvPr>
@@ -3509,7 +3509,7 @@
           <p:cNvPr id="5" name="">
             <a:extLst xmlns:a="http://schemas.openxmlformats.org/drawingml/2006/main">
               <a:ext uri="{FF2B5EF4-FFF2-40B4-BE49-F238E27FC236}">
-                <a16:creationId xmlns:a16="http://schemas.microsoft.com/office/drawing/2014/main" id="{F08D2999-EFD5-429D-8EA3-CC8F42A5E089}"/>
+                <a16:creationId xmlns:a16="http://schemas.microsoft.com/office/drawing/2014/main" id="{E5DCFBE9-93D7-408B-BC4B-4CBB7F010BD1}"/>
               </a:ext>
             </a:extLst>
           </p:cNvPr>
@@ -3566,7 +3566,7 @@
           <p:cNvPr id="6" name="">
             <a:extLst xmlns:a="http://schemas.openxmlformats.org/drawingml/2006/main">
               <a:ext uri="{FF2B5EF4-FFF2-40B4-BE49-F238E27FC236}">
-                <a16:creationId xmlns:a16="http://schemas.microsoft.com/office/drawing/2014/main" id="{CA020110-ECCD-4E51-87AC-A141AAB30468}"/>
+                <a16:creationId xmlns:a16="http://schemas.microsoft.com/office/drawing/2014/main" id="{A0D7576E-E807-4499-9950-AB761013747B}"/>
               </a:ext>
             </a:extLst>
           </p:cNvPr>
@@ -3623,7 +3623,7 @@
           <p:cNvPr id="7" name="">
             <a:extLst xmlns:a="http://schemas.openxmlformats.org/drawingml/2006/main">
               <a:ext uri="{FF2B5EF4-FFF2-40B4-BE49-F238E27FC236}">
-                <a16:creationId xmlns:a16="http://schemas.microsoft.com/office/drawing/2014/main" id="{C671558C-3A3A-48AE-A292-0A5073247F52}"/>
+                <a16:creationId xmlns:a16="http://schemas.microsoft.com/office/drawing/2014/main" id="{44439932-FF4F-428B-8E32-1CADE2B2DFF2}"/>
               </a:ext>
             </a:extLst>
           </p:cNvPr>
@@ -3680,7 +3680,7 @@
           <p:cNvPr id="8" name="">
             <a:extLst xmlns:a="http://schemas.openxmlformats.org/drawingml/2006/main">
               <a:ext uri="{FF2B5EF4-FFF2-40B4-BE49-F238E27FC236}">
-                <a16:creationId xmlns:a16="http://schemas.microsoft.com/office/drawing/2014/main" id="{8EF6658B-54B2-4C77-A4DB-98A0B4B4C32F}"/>
+                <a16:creationId xmlns:a16="http://schemas.microsoft.com/office/drawing/2014/main" id="{0F7A1118-2DF9-4576-B641-6D3021800BCA}"/>
               </a:ext>
             </a:extLst>
           </p:cNvPr>
@@ -3737,7 +3737,7 @@
           <p:cNvPr id="9" name="">
             <a:extLst xmlns:a="http://schemas.openxmlformats.org/drawingml/2006/main">
               <a:ext uri="{FF2B5EF4-FFF2-40B4-BE49-F238E27FC236}">
-                <a16:creationId xmlns:a16="http://schemas.microsoft.com/office/drawing/2014/main" id="{ACE8D104-ABE9-4FF4-B2A7-8C789E96E561}"/>
+                <a16:creationId xmlns:a16="http://schemas.microsoft.com/office/drawing/2014/main" id="{FA5AD089-84F3-4525-9FC1-9CDC22C3D0EB}"/>
               </a:ext>
             </a:extLst>
           </p:cNvPr>
@@ -3767,7 +3767,7 @@
           <p:cNvPr id="10" name="">
             <a:extLst xmlns:a="http://schemas.openxmlformats.org/drawingml/2006/main">
               <a:ext uri="{FF2B5EF4-FFF2-40B4-BE49-F238E27FC236}">
-                <a16:creationId xmlns:a16="http://schemas.microsoft.com/office/drawing/2014/main" id="{8097D2FF-5758-4608-A8DC-6D5E3A8C04A3}"/>
+                <a16:creationId xmlns:a16="http://schemas.microsoft.com/office/drawing/2014/main" id="{5302CB5A-361A-47BC-B0D4-D4A1210A0BFD}"/>
               </a:ext>
             </a:extLst>
           </p:cNvPr>
@@ -3824,7 +3824,7 @@
           <p:cNvPr id="11" name="">
             <a:extLst xmlns:a="http://schemas.openxmlformats.org/drawingml/2006/main">
               <a:ext uri="{FF2B5EF4-FFF2-40B4-BE49-F238E27FC236}">
-                <a16:creationId xmlns:a16="http://schemas.microsoft.com/office/drawing/2014/main" id="{5B15479E-A96E-4B9D-88F8-B4310F32C301}"/>
+                <a16:creationId xmlns:a16="http://schemas.microsoft.com/office/drawing/2014/main" id="{F4BA769B-0C43-40EA-909F-B4997F426731}"/>
               </a:ext>
             </a:extLst>
           </p:cNvPr>
@@ -3879,7 +3879,7 @@
     </p:spTree>
     <p:extLst>
       <p:ext uri="{BB962C8B-B14F-4D97-AF65-F5344CB8AC3E}">
-        <p14:creationId xmlns:p14="http://schemas.microsoft.com/office/powerpoint/2010/main" val="1888624232"/>
+        <p14:creationId xmlns:p14="http://schemas.microsoft.com/office/powerpoint/2010/main" val="581602899"/>
       </p:ext>
     </p:extLst>
   </p:cSld>
@@ -3910,7 +3910,7 @@
           <p:cNvPr id="14" name="">
             <a:extLst xmlns:a="http://schemas.openxmlformats.org/drawingml/2006/main">
               <a:ext uri="{FF2B5EF4-FFF2-40B4-BE49-F238E27FC236}">
-                <a16:creationId xmlns:a16="http://schemas.microsoft.com/office/drawing/2014/main" id="{8FFC9BE1-FCE7-490A-A7FA-7C48BE85E104}"/>
+                <a16:creationId xmlns:a16="http://schemas.microsoft.com/office/drawing/2014/main" id="{9EBE5FB4-B0D0-4FBC-AB2B-EF94BDAE2391}"/>
               </a:ext>
             </a:extLst>
           </p:cNvPr>
@@ -3940,7 +3940,7 @@
           <p:cNvPr id="2" name="">
             <a:extLst xmlns:a="http://schemas.openxmlformats.org/drawingml/2006/main">
               <a:ext uri="{FF2B5EF4-FFF2-40B4-BE49-F238E27FC236}">
-                <a16:creationId xmlns:a16="http://schemas.microsoft.com/office/drawing/2014/main" id="{3DF4E84F-2802-4949-8D05-07548DCA7773}"/>
+                <a16:creationId xmlns:a16="http://schemas.microsoft.com/office/drawing/2014/main" id="{E468C9C1-22D7-4AC6-855A-6BA4A4EB1D14}"/>
               </a:ext>
             </a:extLst>
           </p:cNvPr>
@@ -3997,7 +3997,7 @@
           <p:cNvPr id="3" name="">
             <a:extLst xmlns:a="http://schemas.openxmlformats.org/drawingml/2006/main">
               <a:ext uri="{FF2B5EF4-FFF2-40B4-BE49-F238E27FC236}">
-                <a16:creationId xmlns:a16="http://schemas.microsoft.com/office/drawing/2014/main" id="{F3EEADC2-4813-4468-86CD-18AA9E2AC67F}"/>
+                <a16:creationId xmlns:a16="http://schemas.microsoft.com/office/drawing/2014/main" id="{B6ED0B84-B2D6-4ACD-89C5-4B252D8C89A9}"/>
               </a:ext>
             </a:extLst>
           </p:cNvPr>
@@ -4027,7 +4027,7 @@
           <p:cNvPr id="4" name="">
             <a:extLst xmlns:a="http://schemas.openxmlformats.org/drawingml/2006/main">
               <a:ext uri="{FF2B5EF4-FFF2-40B4-BE49-F238E27FC236}">
-                <a16:creationId xmlns:a16="http://schemas.microsoft.com/office/drawing/2014/main" id="{9486458A-A60C-489F-B928-6C4F81D3DDAE}"/>
+                <a16:creationId xmlns:a16="http://schemas.microsoft.com/office/drawing/2014/main" id="{F40F9326-F4D2-40E2-ADF1-9636948E7DC6}"/>
               </a:ext>
             </a:extLst>
           </p:cNvPr>
@@ -4057,7 +4057,7 @@
           <p:cNvPr id="5" name="">
             <a:extLst xmlns:a="http://schemas.openxmlformats.org/drawingml/2006/main">
               <a:ext uri="{FF2B5EF4-FFF2-40B4-BE49-F238E27FC236}">
-                <a16:creationId xmlns:a16="http://schemas.microsoft.com/office/drawing/2014/main" id="{48D0B65E-B09F-45D5-B040-30A3E3FEEF80}"/>
+                <a16:creationId xmlns:a16="http://schemas.microsoft.com/office/drawing/2014/main" id="{D718BBE7-B71C-4D42-A7BC-52CC5D7AE4B0}"/>
               </a:ext>
             </a:extLst>
           </p:cNvPr>
@@ -4114,7 +4114,7 @@
           <p:cNvPr id="6" name="">
             <a:extLst xmlns:a="http://schemas.openxmlformats.org/drawingml/2006/main">
               <a:ext uri="{FF2B5EF4-FFF2-40B4-BE49-F238E27FC236}">
-                <a16:creationId xmlns:a16="http://schemas.microsoft.com/office/drawing/2014/main" id="{4CE0719B-8133-44F2-B852-F928C1C81A3C}"/>
+                <a16:creationId xmlns:a16="http://schemas.microsoft.com/office/drawing/2014/main" id="{AB38A1E6-2B9E-4849-819B-BAE3FD67C2CC}"/>
               </a:ext>
             </a:extLst>
           </p:cNvPr>
@@ -4146,7 +4146,7 @@
           <p:cNvPr id="7" name="">
             <a:extLst xmlns:a="http://schemas.openxmlformats.org/drawingml/2006/main">
               <a:ext uri="{FF2B5EF4-FFF2-40B4-BE49-F238E27FC236}">
-                <a16:creationId xmlns:a16="http://schemas.microsoft.com/office/drawing/2014/main" id="{2430DF6C-6DE5-4A97-B347-BC76129F133C}"/>
+                <a16:creationId xmlns:a16="http://schemas.microsoft.com/office/drawing/2014/main" id="{E6FA7809-BF85-4D0F-AA8A-21A0F1F1113E}"/>
               </a:ext>
             </a:extLst>
           </p:cNvPr>
@@ -4203,7 +4203,7 @@
           <p:cNvPr id="8" name="">
             <a:extLst xmlns:a="http://schemas.openxmlformats.org/drawingml/2006/main">
               <a:ext uri="{FF2B5EF4-FFF2-40B4-BE49-F238E27FC236}">
-                <a16:creationId xmlns:a16="http://schemas.microsoft.com/office/drawing/2014/main" id="{34FD10DA-73F8-46F7-A38F-A8F75D931D89}"/>
+                <a16:creationId xmlns:a16="http://schemas.microsoft.com/office/drawing/2014/main" id="{F3AA1430-C68F-4E22-9D8D-9E7DD4346E9D}"/>
               </a:ext>
             </a:extLst>
           </p:cNvPr>
@@ -4260,7 +4260,7 @@
           <p:cNvPr id="9" name="">
             <a:extLst xmlns:a="http://schemas.openxmlformats.org/drawingml/2006/main">
               <a:ext uri="{FF2B5EF4-FFF2-40B4-BE49-F238E27FC236}">
-                <a16:creationId xmlns:a16="http://schemas.microsoft.com/office/drawing/2014/main" id="{2796583A-A6FD-469B-B60E-8A3E7D9F9241}"/>
+                <a16:creationId xmlns:a16="http://schemas.microsoft.com/office/drawing/2014/main" id="{45FC3845-77CC-46EB-9CB0-A7620A27F382}"/>
               </a:ext>
             </a:extLst>
           </p:cNvPr>
@@ -4317,7 +4317,7 @@
           <p:cNvPr id="10" name="">
             <a:extLst xmlns:a="http://schemas.openxmlformats.org/drawingml/2006/main">
               <a:ext uri="{FF2B5EF4-FFF2-40B4-BE49-F238E27FC236}">
-                <a16:creationId xmlns:a16="http://schemas.microsoft.com/office/drawing/2014/main" id="{28A2D5A9-3027-4670-BB90-79698F9EC7A7}"/>
+                <a16:creationId xmlns:a16="http://schemas.microsoft.com/office/drawing/2014/main" id="{1B1CC3DD-AF00-4303-B5E6-062E54A390AF}"/>
               </a:ext>
             </a:extLst>
           </p:cNvPr>
@@ -4374,7 +4374,7 @@
           <p:cNvPr id="11" name="">
             <a:extLst xmlns:a="http://schemas.openxmlformats.org/drawingml/2006/main">
               <a:ext uri="{FF2B5EF4-FFF2-40B4-BE49-F238E27FC236}">
-                <a16:creationId xmlns:a16="http://schemas.microsoft.com/office/drawing/2014/main" id="{76643914-BF3C-4F9B-B5B8-D09D6AA70FC5}"/>
+                <a16:creationId xmlns:a16="http://schemas.microsoft.com/office/drawing/2014/main" id="{1EF47356-C180-4F21-8341-4C79EF37E267}"/>
               </a:ext>
             </a:extLst>
           </p:cNvPr>
@@ -4404,7 +4404,7 @@
           <p:cNvPr id="12" name="">
             <a:extLst xmlns:a="http://schemas.openxmlformats.org/drawingml/2006/main">
               <a:ext uri="{FF2B5EF4-FFF2-40B4-BE49-F238E27FC236}">
-                <a16:creationId xmlns:a16="http://schemas.microsoft.com/office/drawing/2014/main" id="{08936366-A58C-4855-853A-20E84C06859A}"/>
+                <a16:creationId xmlns:a16="http://schemas.microsoft.com/office/drawing/2014/main" id="{8F3F29FF-4A4F-4D18-AF1F-83B041769063}"/>
               </a:ext>
             </a:extLst>
           </p:cNvPr>
@@ -4461,7 +4461,7 @@
           <p:cNvPr id="13" name="">
             <a:extLst xmlns:a="http://schemas.openxmlformats.org/drawingml/2006/main">
               <a:ext uri="{FF2B5EF4-FFF2-40B4-BE49-F238E27FC236}">
-                <a16:creationId xmlns:a16="http://schemas.microsoft.com/office/drawing/2014/main" id="{33D85E1F-3D4B-45EA-9D69-8DB0829BDFF2}"/>
+                <a16:creationId xmlns:a16="http://schemas.microsoft.com/office/drawing/2014/main" id="{ED585119-8B43-4CF7-A8C2-843085E86B53}"/>
               </a:ext>
             </a:extLst>
           </p:cNvPr>
@@ -4516,7 +4516,7 @@
     </p:spTree>
     <p:extLst>
       <p:ext uri="{BB962C8B-B14F-4D97-AF65-F5344CB8AC3E}">
-        <p14:creationId xmlns:p14="http://schemas.microsoft.com/office/powerpoint/2010/main" val="177693260"/>
+        <p14:creationId xmlns:p14="http://schemas.microsoft.com/office/powerpoint/2010/main" val="1133284138"/>
       </p:ext>
     </p:extLst>
   </p:cSld>
@@ -4547,7 +4547,7 @@
           <p:cNvPr id="15" name="">
             <a:extLst xmlns:a="http://schemas.openxmlformats.org/drawingml/2006/main">
               <a:ext uri="{FF2B5EF4-FFF2-40B4-BE49-F238E27FC236}">
-                <a16:creationId xmlns:a16="http://schemas.microsoft.com/office/drawing/2014/main" id="{567898E2-47CD-4CA4-90B7-637F1ED1D5B5}"/>
+                <a16:creationId xmlns:a16="http://schemas.microsoft.com/office/drawing/2014/main" id="{A4256AE5-2E4A-4D14-877C-155CEA4C4568}"/>
               </a:ext>
             </a:extLst>
           </p:cNvPr>
@@ -4577,7 +4577,7 @@
           <p:cNvPr id="2" name="">
             <a:extLst xmlns:a="http://schemas.openxmlformats.org/drawingml/2006/main">
               <a:ext uri="{FF2B5EF4-FFF2-40B4-BE49-F238E27FC236}">
-                <a16:creationId xmlns:a16="http://schemas.microsoft.com/office/drawing/2014/main" id="{6D099AD1-F6C8-4287-B36F-1EC3029118C2}"/>
+                <a16:creationId xmlns:a16="http://schemas.microsoft.com/office/drawing/2014/main" id="{FEEFB7E4-F4EA-4ED6-9087-82F36E225B7E}"/>
               </a:ext>
             </a:extLst>
           </p:cNvPr>
@@ -4634,7 +4634,7 @@
           <p:cNvPr id="3" name="">
             <a:extLst xmlns:a="http://schemas.openxmlformats.org/drawingml/2006/main">
               <a:ext uri="{FF2B5EF4-FFF2-40B4-BE49-F238E27FC236}">
-                <a16:creationId xmlns:a16="http://schemas.microsoft.com/office/drawing/2014/main" id="{928A9C81-D4E9-402C-A16F-7930D70380C9}"/>
+                <a16:creationId xmlns:a16="http://schemas.microsoft.com/office/drawing/2014/main" id="{83D0AA04-62AE-4E48-A84A-FCF69524442E}"/>
               </a:ext>
             </a:extLst>
           </p:cNvPr>
@@ -4664,7 +4664,7 @@
           <p:cNvPr id="4" name="">
             <a:extLst xmlns:a="http://schemas.openxmlformats.org/drawingml/2006/main">
               <a:ext uri="{FF2B5EF4-FFF2-40B4-BE49-F238E27FC236}">
-                <a16:creationId xmlns:a16="http://schemas.microsoft.com/office/drawing/2014/main" id="{0D0D7504-4B55-43C9-B9E1-A4CC89DAF716}"/>
+                <a16:creationId xmlns:a16="http://schemas.microsoft.com/office/drawing/2014/main" id="{7AADDC3D-C565-4538-87C1-93065BF2D972}"/>
               </a:ext>
             </a:extLst>
           </p:cNvPr>
@@ -4694,7 +4694,7 @@
           <p:cNvPr id="5" name="">
             <a:extLst xmlns:a="http://schemas.openxmlformats.org/drawingml/2006/main">
               <a:ext uri="{FF2B5EF4-FFF2-40B4-BE49-F238E27FC236}">
-                <a16:creationId xmlns:a16="http://schemas.microsoft.com/office/drawing/2014/main" id="{62EA545B-1936-44EE-89F3-E1AB2C597D0B}"/>
+                <a16:creationId xmlns:a16="http://schemas.microsoft.com/office/drawing/2014/main" id="{4444F018-F648-44FB-B081-7F8E04A4C086}"/>
               </a:ext>
             </a:extLst>
           </p:cNvPr>
@@ -4751,7 +4751,7 @@
           <p:cNvPr id="6" name="">
             <a:extLst xmlns:a="http://schemas.openxmlformats.org/drawingml/2006/main">
               <a:ext uri="{FF2B5EF4-FFF2-40B4-BE49-F238E27FC236}">
-                <a16:creationId xmlns:a16="http://schemas.microsoft.com/office/drawing/2014/main" id="{0DD1FBD5-A169-4F35-A0A9-8333DC367DAE}"/>
+                <a16:creationId xmlns:a16="http://schemas.microsoft.com/office/drawing/2014/main" id="{206392A7-C160-4A87-8203-509DD2403157}"/>
               </a:ext>
             </a:extLst>
           </p:cNvPr>
@@ -4783,7 +4783,7 @@
           <p:cNvPr id="7" name="">
             <a:extLst xmlns:a="http://schemas.openxmlformats.org/drawingml/2006/main">
               <a:ext uri="{FF2B5EF4-FFF2-40B4-BE49-F238E27FC236}">
-                <a16:creationId xmlns:a16="http://schemas.microsoft.com/office/drawing/2014/main" id="{6DD8DD0B-67F4-4AD5-BE54-A67B8BB541DC}"/>
+                <a16:creationId xmlns:a16="http://schemas.microsoft.com/office/drawing/2014/main" id="{64B84D6B-AA8E-4D2F-9D5A-25393F5E621D}"/>
               </a:ext>
             </a:extLst>
           </p:cNvPr>
@@ -4840,7 +4840,7 @@
           <p:cNvPr id="8" name="">
             <a:extLst xmlns:a="http://schemas.openxmlformats.org/drawingml/2006/main">
               <a:ext uri="{FF2B5EF4-FFF2-40B4-BE49-F238E27FC236}">
-                <a16:creationId xmlns:a16="http://schemas.microsoft.com/office/drawing/2014/main" id="{79B4DD37-A073-41F7-A629-F7223B7F44EE}"/>
+                <a16:creationId xmlns:a16="http://schemas.microsoft.com/office/drawing/2014/main" id="{EC0A6AA6-F2C3-4D4A-A161-CA9CD51F0774}"/>
               </a:ext>
             </a:extLst>
           </p:cNvPr>
@@ -4872,7 +4872,7 @@
           <p:cNvPr id="9" name="">
             <a:extLst xmlns:a="http://schemas.openxmlformats.org/drawingml/2006/main">
               <a:ext uri="{FF2B5EF4-FFF2-40B4-BE49-F238E27FC236}">
-                <a16:creationId xmlns:a16="http://schemas.microsoft.com/office/drawing/2014/main" id="{596DB2F7-DB69-4D26-8E48-6ABF4BA517D9}"/>
+                <a16:creationId xmlns:a16="http://schemas.microsoft.com/office/drawing/2014/main" id="{AF201F01-3572-40BB-A6EB-389CB8CC8714}"/>
               </a:ext>
             </a:extLst>
           </p:cNvPr>
@@ -4929,7 +4929,7 @@
           <p:cNvPr id="10" name="">
             <a:extLst xmlns:a="http://schemas.openxmlformats.org/drawingml/2006/main">
               <a:ext uri="{FF2B5EF4-FFF2-40B4-BE49-F238E27FC236}">
-                <a16:creationId xmlns:a16="http://schemas.microsoft.com/office/drawing/2014/main" id="{C8A07254-A4B8-4D16-B570-74399EF117E7}"/>
+                <a16:creationId xmlns:a16="http://schemas.microsoft.com/office/drawing/2014/main" id="{DB1F77DB-1B90-47C4-BDEF-E04379DAB05D}"/>
               </a:ext>
             </a:extLst>
           </p:cNvPr>
@@ -4986,7 +4986,7 @@
           <p:cNvPr id="11" name="">
             <a:extLst xmlns:a="http://schemas.openxmlformats.org/drawingml/2006/main">
               <a:ext uri="{FF2B5EF4-FFF2-40B4-BE49-F238E27FC236}">
-                <a16:creationId xmlns:a16="http://schemas.microsoft.com/office/drawing/2014/main" id="{60A366FF-7F45-4874-B4E3-30402E1F1E80}"/>
+                <a16:creationId xmlns:a16="http://schemas.microsoft.com/office/drawing/2014/main" id="{634C0794-ACDF-4640-8FE6-0884711D9E2A}"/>
               </a:ext>
             </a:extLst>
           </p:cNvPr>
@@ -5043,7 +5043,7 @@
           <p:cNvPr id="12" name="">
             <a:extLst xmlns:a="http://schemas.openxmlformats.org/drawingml/2006/main">
               <a:ext uri="{FF2B5EF4-FFF2-40B4-BE49-F238E27FC236}">
-                <a16:creationId xmlns:a16="http://schemas.microsoft.com/office/drawing/2014/main" id="{74A404AF-F199-4B3E-A801-3F489C85B49C}"/>
+                <a16:creationId xmlns:a16="http://schemas.microsoft.com/office/drawing/2014/main" id="{BCB56914-4B91-4967-9D90-4C981ECB442F}"/>
               </a:ext>
             </a:extLst>
           </p:cNvPr>
@@ -5073,7 +5073,7 @@
           <p:cNvPr id="13" name="">
             <a:extLst xmlns:a="http://schemas.openxmlformats.org/drawingml/2006/main">
               <a:ext uri="{FF2B5EF4-FFF2-40B4-BE49-F238E27FC236}">
-                <a16:creationId xmlns:a16="http://schemas.microsoft.com/office/drawing/2014/main" id="{C66BE2FD-D409-4D30-AB23-0285A187A40A}"/>
+                <a16:creationId xmlns:a16="http://schemas.microsoft.com/office/drawing/2014/main" id="{BC83283A-9AFB-46AD-B12D-9B8C6A679A32}"/>
               </a:ext>
             </a:extLst>
           </p:cNvPr>
@@ -5130,7 +5130,7 @@
           <p:cNvPr id="14" name="">
             <a:extLst xmlns:a="http://schemas.openxmlformats.org/drawingml/2006/main">
               <a:ext uri="{FF2B5EF4-FFF2-40B4-BE49-F238E27FC236}">
-                <a16:creationId xmlns:a16="http://schemas.microsoft.com/office/drawing/2014/main" id="{6C09471C-E704-4CC7-9346-25BA3B81AE50}"/>
+                <a16:creationId xmlns:a16="http://schemas.microsoft.com/office/drawing/2014/main" id="{6B32FBD0-88AC-435F-9955-43ED2DBBCB8C}"/>
               </a:ext>
             </a:extLst>
           </p:cNvPr>
@@ -5185,7 +5185,7 @@
     </p:spTree>
     <p:extLst>
       <p:ext uri="{BB962C8B-B14F-4D97-AF65-F5344CB8AC3E}">
-        <p14:creationId xmlns:p14="http://schemas.microsoft.com/office/powerpoint/2010/main" val="277050836"/>
+        <p14:creationId xmlns:p14="http://schemas.microsoft.com/office/powerpoint/2010/main" val="455655411"/>
       </p:ext>
     </p:extLst>
   </p:cSld>
@@ -5216,7 +5216,7 @@
           <p:cNvPr id="10" name="">
             <a:extLst xmlns:a="http://schemas.openxmlformats.org/drawingml/2006/main">
               <a:ext uri="{FF2B5EF4-FFF2-40B4-BE49-F238E27FC236}">
-                <a16:creationId xmlns:a16="http://schemas.microsoft.com/office/drawing/2014/main" id="{FB79D7B7-F9D6-491E-B6C0-729200146E0C}"/>
+                <a16:creationId xmlns:a16="http://schemas.microsoft.com/office/drawing/2014/main" id="{43649CA5-3B18-49FC-817F-E2CAD11CB15F}"/>
               </a:ext>
             </a:extLst>
           </p:cNvPr>
@@ -5246,7 +5246,7 @@
           <p:cNvPr id="2" name="">
             <a:extLst xmlns:a="http://schemas.openxmlformats.org/drawingml/2006/main">
               <a:ext uri="{FF2B5EF4-FFF2-40B4-BE49-F238E27FC236}">
-                <a16:creationId xmlns:a16="http://schemas.microsoft.com/office/drawing/2014/main" id="{A60A89A9-1527-438D-855B-FF7319C621A6}"/>
+                <a16:creationId xmlns:a16="http://schemas.microsoft.com/office/drawing/2014/main" id="{154422AA-FF5E-4B79-A47D-58EEE4F330DF}"/>
               </a:ext>
             </a:extLst>
           </p:cNvPr>
@@ -5303,7 +5303,7 @@
           <p:cNvPr id="3" name="">
             <a:extLst xmlns:a="http://schemas.openxmlformats.org/drawingml/2006/main">
               <a:ext uri="{FF2B5EF4-FFF2-40B4-BE49-F238E27FC236}">
-                <a16:creationId xmlns:a16="http://schemas.microsoft.com/office/drawing/2014/main" id="{C31C53F3-1431-4CE0-9DE0-40306D088105}"/>
+                <a16:creationId xmlns:a16="http://schemas.microsoft.com/office/drawing/2014/main" id="{FA4B8715-CCF2-44A2-9DC7-8A3321250F81}"/>
               </a:ext>
             </a:extLst>
           </p:cNvPr>
@@ -5333,7 +5333,7 @@
           <p:cNvPr id="4" name="">
             <a:extLst xmlns:a="http://schemas.openxmlformats.org/drawingml/2006/main">
               <a:ext uri="{FF2B5EF4-FFF2-40B4-BE49-F238E27FC236}">
-                <a16:creationId xmlns:a16="http://schemas.microsoft.com/office/drawing/2014/main" id="{7B04F532-FA4E-4B9A-B466-4F786287891F}"/>
+                <a16:creationId xmlns:a16="http://schemas.microsoft.com/office/drawing/2014/main" id="{93DB291A-206C-4872-BE38-1C3DEA00719A}"/>
               </a:ext>
             </a:extLst>
           </p:cNvPr>
@@ -5363,7 +5363,7 @@
           <p:cNvPr id="5" name="">
             <a:extLst xmlns:a="http://schemas.openxmlformats.org/drawingml/2006/main">
               <a:ext uri="{FF2B5EF4-FFF2-40B4-BE49-F238E27FC236}">
-                <a16:creationId xmlns:a16="http://schemas.microsoft.com/office/drawing/2014/main" id="{6F6AAB8B-2F44-447D-9E91-79A937F94D31}"/>
+                <a16:creationId xmlns:a16="http://schemas.microsoft.com/office/drawing/2014/main" id="{DEA2B895-F3A7-4ED6-B1E0-2D3B6A4DB1DF}"/>
               </a:ext>
             </a:extLst>
           </p:cNvPr>
@@ -5739,7 +5739,7 @@
           <p:cNvPr id="7" name="">
             <a:extLst xmlns:a="http://schemas.openxmlformats.org/drawingml/2006/main">
               <a:ext uri="{FF2B5EF4-FFF2-40B4-BE49-F238E27FC236}">
-                <a16:creationId xmlns:a16="http://schemas.microsoft.com/office/drawing/2014/main" id="{96CA9C4C-D951-42F7-953E-7EFE934B5445}"/>
+                <a16:creationId xmlns:a16="http://schemas.microsoft.com/office/drawing/2014/main" id="{F5174629-0463-42EE-ACDF-E422EC31D5E3}"/>
               </a:ext>
             </a:extLst>
           </p:cNvPr>
@@ -5769,7 +5769,7 @@
           <p:cNvPr id="8" name="">
             <a:extLst xmlns:a="http://schemas.openxmlformats.org/drawingml/2006/main">
               <a:ext uri="{FF2B5EF4-FFF2-40B4-BE49-F238E27FC236}">
-                <a16:creationId xmlns:a16="http://schemas.microsoft.com/office/drawing/2014/main" id="{AA0A5610-12BC-4865-B60E-47A4A8B1FC23}"/>
+                <a16:creationId xmlns:a16="http://schemas.microsoft.com/office/drawing/2014/main" id="{600B3555-4725-4ADA-B32D-8D2CA0078B6D}"/>
               </a:ext>
             </a:extLst>
           </p:cNvPr>
@@ -5826,7 +5826,7 @@
           <p:cNvPr id="9" name="">
             <a:extLst xmlns:a="http://schemas.openxmlformats.org/drawingml/2006/main">
               <a:ext uri="{FF2B5EF4-FFF2-40B4-BE49-F238E27FC236}">
-                <a16:creationId xmlns:a16="http://schemas.microsoft.com/office/drawing/2014/main" id="{693297D0-93C1-4E2A-B8B8-3052697E5D96}"/>
+                <a16:creationId xmlns:a16="http://schemas.microsoft.com/office/drawing/2014/main" id="{6D769EB3-8471-43C6-BF67-62139787752C}"/>
               </a:ext>
             </a:extLst>
           </p:cNvPr>
@@ -5881,7 +5881,7 @@
     </p:spTree>
     <p:extLst>
       <p:ext uri="{BB962C8B-B14F-4D97-AF65-F5344CB8AC3E}">
-        <p14:creationId xmlns:p14="http://schemas.microsoft.com/office/powerpoint/2010/main" val="1276044715"/>
+        <p14:creationId xmlns:p14="http://schemas.microsoft.com/office/powerpoint/2010/main" val="1299317291"/>
       </p:ext>
     </p:extLst>
   </p:cSld>
@@ -5912,7 +5912,7 @@
           <p:cNvPr id="27" name="">
             <a:extLst xmlns:a="http://schemas.openxmlformats.org/drawingml/2006/main">
               <a:ext uri="{FF2B5EF4-FFF2-40B4-BE49-F238E27FC236}">
-                <a16:creationId xmlns:a16="http://schemas.microsoft.com/office/drawing/2014/main" id="{741E3778-7369-4CE4-A805-3521D0BA5CE0}"/>
+                <a16:creationId xmlns:a16="http://schemas.microsoft.com/office/drawing/2014/main" id="{EEBCC0CF-BD7B-4A9E-8A4B-56C1E5C79EBC}"/>
               </a:ext>
             </a:extLst>
           </p:cNvPr>
@@ -5942,7 +5942,7 @@
           <p:cNvPr id="2" name="">
             <a:extLst xmlns:a="http://schemas.openxmlformats.org/drawingml/2006/main">
               <a:ext uri="{FF2B5EF4-FFF2-40B4-BE49-F238E27FC236}">
-                <a16:creationId xmlns:a16="http://schemas.microsoft.com/office/drawing/2014/main" id="{EB9E95B9-024D-4B0D-BAC9-A66EBF0972C5}"/>
+                <a16:creationId xmlns:a16="http://schemas.microsoft.com/office/drawing/2014/main" id="{632A4676-6CE3-4D99-972A-EA4CDB45C928}"/>
               </a:ext>
             </a:extLst>
           </p:cNvPr>
@@ -5999,7 +5999,7 @@
           <p:cNvPr id="3" name="">
             <a:extLst xmlns:a="http://schemas.openxmlformats.org/drawingml/2006/main">
               <a:ext uri="{FF2B5EF4-FFF2-40B4-BE49-F238E27FC236}">
-                <a16:creationId xmlns:a16="http://schemas.microsoft.com/office/drawing/2014/main" id="{68435D1F-E34D-4F01-97A4-45A13A17AC1B}"/>
+                <a16:creationId xmlns:a16="http://schemas.microsoft.com/office/drawing/2014/main" id="{78B059E0-93C0-4EAD-805E-9DD6C8E0B0E3}"/>
               </a:ext>
             </a:extLst>
           </p:cNvPr>
@@ -6029,7 +6029,7 @@
           <p:cNvPr id="4" name="">
             <a:extLst xmlns:a="http://schemas.openxmlformats.org/drawingml/2006/main">
               <a:ext uri="{FF2B5EF4-FFF2-40B4-BE49-F238E27FC236}">
-                <a16:creationId xmlns:a16="http://schemas.microsoft.com/office/drawing/2014/main" id="{AAC8CAD1-75D3-4383-939C-870E7EEE1587}"/>
+                <a16:creationId xmlns:a16="http://schemas.microsoft.com/office/drawing/2014/main" id="{4893B3E8-2A59-48C0-A388-E58020F8E096}"/>
               </a:ext>
             </a:extLst>
           </p:cNvPr>
@@ -6059,7 +6059,7 @@
           <p:cNvPr id="5" name="">
             <a:extLst xmlns:a="http://schemas.openxmlformats.org/drawingml/2006/main">
               <a:ext uri="{FF2B5EF4-FFF2-40B4-BE49-F238E27FC236}">
-                <a16:creationId xmlns:a16="http://schemas.microsoft.com/office/drawing/2014/main" id="{566F4BA7-EAED-4A72-AB14-2621A86CC012}"/>
+                <a16:creationId xmlns:a16="http://schemas.microsoft.com/office/drawing/2014/main" id="{EEFCEE26-91EC-472D-A38F-FE63F37AD696}"/>
               </a:ext>
             </a:extLst>
           </p:cNvPr>
@@ -6116,7 +6116,7 @@
           <p:cNvPr id="6" name="">
             <a:extLst xmlns:a="http://schemas.openxmlformats.org/drawingml/2006/main">
               <a:ext uri="{FF2B5EF4-FFF2-40B4-BE49-F238E27FC236}">
-                <a16:creationId xmlns:a16="http://schemas.microsoft.com/office/drawing/2014/main" id="{C66BA6E0-2579-4CC9-8F6D-8CA359FE780E}"/>
+                <a16:creationId xmlns:a16="http://schemas.microsoft.com/office/drawing/2014/main" id="{7D5E2E33-B168-4DB4-AA66-8893EF2D6E06}"/>
               </a:ext>
             </a:extLst>
           </p:cNvPr>
@@ -6173,7 +6173,7 @@
           <p:cNvPr id="7" name="">
             <a:extLst xmlns:a="http://schemas.openxmlformats.org/drawingml/2006/main">
               <a:ext uri="{FF2B5EF4-FFF2-40B4-BE49-F238E27FC236}">
-                <a16:creationId xmlns:a16="http://schemas.microsoft.com/office/drawing/2014/main" id="{2F2393A3-BD66-46F0-BD08-5F6B9CBDDF01}"/>
+                <a16:creationId xmlns:a16="http://schemas.microsoft.com/office/drawing/2014/main" id="{CD3C6CC1-39D0-405F-BA61-3B8DF486D37C}"/>
               </a:ext>
             </a:extLst>
           </p:cNvPr>
@@ -6205,7 +6205,7 @@
           <p:cNvPr id="8" name="">
             <a:extLst xmlns:a="http://schemas.openxmlformats.org/drawingml/2006/main">
               <a:ext uri="{FF2B5EF4-FFF2-40B4-BE49-F238E27FC236}">
-                <a16:creationId xmlns:a16="http://schemas.microsoft.com/office/drawing/2014/main" id="{E9477291-921D-45CA-8D40-A790B8F4CDF3}"/>
+                <a16:creationId xmlns:a16="http://schemas.microsoft.com/office/drawing/2014/main" id="{8CF7F74A-686E-46E1-8BBC-7B35FD8F3319}"/>
               </a:ext>
             </a:extLst>
           </p:cNvPr>
@@ -6262,7 +6262,7 @@
           <p:cNvPr id="9" name="">
             <a:extLst xmlns:a="http://schemas.openxmlformats.org/drawingml/2006/main">
               <a:ext uri="{FF2B5EF4-FFF2-40B4-BE49-F238E27FC236}">
-                <a16:creationId xmlns:a16="http://schemas.microsoft.com/office/drawing/2014/main" id="{E47F9AE4-B44A-429A-984A-0AEFD051A836}"/>
+                <a16:creationId xmlns:a16="http://schemas.microsoft.com/office/drawing/2014/main" id="{377D32AB-6A10-401D-8ED4-CD2C83B7BE7C}"/>
               </a:ext>
             </a:extLst>
           </p:cNvPr>
@@ -6319,7 +6319,7 @@
           <p:cNvPr id="10" name="">
             <a:extLst xmlns:a="http://schemas.openxmlformats.org/drawingml/2006/main">
               <a:ext uri="{FF2B5EF4-FFF2-40B4-BE49-F238E27FC236}">
-                <a16:creationId xmlns:a16="http://schemas.microsoft.com/office/drawing/2014/main" id="{8C127795-165D-4CDE-826B-672B6809FCE3}"/>
+                <a16:creationId xmlns:a16="http://schemas.microsoft.com/office/drawing/2014/main" id="{8ECC109A-269B-458E-AE02-E1641A9E94EB}"/>
               </a:ext>
             </a:extLst>
           </p:cNvPr>
@@ -6351,7 +6351,7 @@
           <p:cNvPr id="11" name="">
             <a:extLst xmlns:a="http://schemas.openxmlformats.org/drawingml/2006/main">
               <a:ext uri="{FF2B5EF4-FFF2-40B4-BE49-F238E27FC236}">
-                <a16:creationId xmlns:a16="http://schemas.microsoft.com/office/drawing/2014/main" id="{341AABF1-66A7-4258-BAF6-B93F15007A97}"/>
+                <a16:creationId xmlns:a16="http://schemas.microsoft.com/office/drawing/2014/main" id="{95945CE7-C577-4BAF-B2FA-CAFD679F2626}"/>
               </a:ext>
             </a:extLst>
           </p:cNvPr>
@@ -6408,7 +6408,7 @@
           <p:cNvPr id="12" name="">
             <a:extLst xmlns:a="http://schemas.openxmlformats.org/drawingml/2006/main">
               <a:ext uri="{FF2B5EF4-FFF2-40B4-BE49-F238E27FC236}">
-                <a16:creationId xmlns:a16="http://schemas.microsoft.com/office/drawing/2014/main" id="{64F40134-33DA-4BFA-A4F3-D85F990B7E10}"/>
+                <a16:creationId xmlns:a16="http://schemas.microsoft.com/office/drawing/2014/main" id="{39474E67-1C5A-4399-B7D3-EC9DCDEC88B6}"/>
               </a:ext>
             </a:extLst>
           </p:cNvPr>
@@ -6465,7 +6465,7 @@
           <p:cNvPr id="13" name="">
             <a:extLst xmlns:a="http://schemas.openxmlformats.org/drawingml/2006/main">
               <a:ext uri="{FF2B5EF4-FFF2-40B4-BE49-F238E27FC236}">
-                <a16:creationId xmlns:a16="http://schemas.microsoft.com/office/drawing/2014/main" id="{3B536103-B520-462D-9979-3297EA68BE31}"/>
+                <a16:creationId xmlns:a16="http://schemas.microsoft.com/office/drawing/2014/main" id="{6DCFB886-FDD1-4BC8-AEC8-3A6DCDA8D774}"/>
               </a:ext>
             </a:extLst>
           </p:cNvPr>
@@ -6497,7 +6497,7 @@
           <p:cNvPr id="14" name="">
             <a:extLst xmlns:a="http://schemas.openxmlformats.org/drawingml/2006/main">
               <a:ext uri="{FF2B5EF4-FFF2-40B4-BE49-F238E27FC236}">
-                <a16:creationId xmlns:a16="http://schemas.microsoft.com/office/drawing/2014/main" id="{BFE1BF96-2DAF-4A1A-A8C1-F02BF33B1CCA}"/>
+                <a16:creationId xmlns:a16="http://schemas.microsoft.com/office/drawing/2014/main" id="{59C6E914-9430-4237-A464-876445F15CEC}"/>
               </a:ext>
             </a:extLst>
           </p:cNvPr>
@@ -6554,7 +6554,7 @@
           <p:cNvPr id="15" name="">
             <a:extLst xmlns:a="http://schemas.openxmlformats.org/drawingml/2006/main">
               <a:ext uri="{FF2B5EF4-FFF2-40B4-BE49-F238E27FC236}">
-                <a16:creationId xmlns:a16="http://schemas.microsoft.com/office/drawing/2014/main" id="{98048CD5-DE87-4121-8117-9B5BB13690CD}"/>
+                <a16:creationId xmlns:a16="http://schemas.microsoft.com/office/drawing/2014/main" id="{A4A465B5-C7C1-46A9-BBB2-F0016ECB2F3C}"/>
               </a:ext>
             </a:extLst>
           </p:cNvPr>
@@ -6611,7 +6611,7 @@
           <p:cNvPr id="16" name="">
             <a:extLst xmlns:a="http://schemas.openxmlformats.org/drawingml/2006/main">
               <a:ext uri="{FF2B5EF4-FFF2-40B4-BE49-F238E27FC236}">
-                <a16:creationId xmlns:a16="http://schemas.microsoft.com/office/drawing/2014/main" id="{6426508E-8B41-422E-AF12-9F9EC27E1E71}"/>
+                <a16:creationId xmlns:a16="http://schemas.microsoft.com/office/drawing/2014/main" id="{EC4B7327-EEA4-4791-A509-2563B48A8708}"/>
               </a:ext>
             </a:extLst>
           </p:cNvPr>
@@ -6643,7 +6643,7 @@
           <p:cNvPr id="17" name="">
             <a:extLst xmlns:a="http://schemas.openxmlformats.org/drawingml/2006/main">
               <a:ext uri="{FF2B5EF4-FFF2-40B4-BE49-F238E27FC236}">
-                <a16:creationId xmlns:a16="http://schemas.microsoft.com/office/drawing/2014/main" id="{86B6DA4D-2623-4F02-9A44-8E7AEB4DBBAC}"/>
+                <a16:creationId xmlns:a16="http://schemas.microsoft.com/office/drawing/2014/main" id="{A4294194-CCC7-4A2F-A8E1-9C59819AA95E}"/>
               </a:ext>
             </a:extLst>
           </p:cNvPr>
@@ -6700,7 +6700,7 @@
           <p:cNvPr id="18" name="">
             <a:extLst xmlns:a="http://schemas.openxmlformats.org/drawingml/2006/main">
               <a:ext uri="{FF2B5EF4-FFF2-40B4-BE49-F238E27FC236}">
-                <a16:creationId xmlns:a16="http://schemas.microsoft.com/office/drawing/2014/main" id="{30C2319C-1B90-4229-B87D-B92B26017CD4}"/>
+                <a16:creationId xmlns:a16="http://schemas.microsoft.com/office/drawing/2014/main" id="{872975EC-00B0-4ECE-BA44-A3234953A9D9}"/>
               </a:ext>
             </a:extLst>
           </p:cNvPr>
@@ -6832,7 +6832,7 @@
           <p:cNvPr id="22" name="">
             <a:extLst xmlns:a="http://schemas.openxmlformats.org/drawingml/2006/main">
               <a:ext uri="{FF2B5EF4-FFF2-40B4-BE49-F238E27FC236}">
-                <a16:creationId xmlns:a16="http://schemas.microsoft.com/office/drawing/2014/main" id="{30F92B52-F097-41E7-8370-FE0314CB2278}"/>
+                <a16:creationId xmlns:a16="http://schemas.microsoft.com/office/drawing/2014/main" id="{902B3CA2-1288-4913-B9EF-3836DD043F6F}"/>
               </a:ext>
             </a:extLst>
           </p:cNvPr>
@@ -6862,7 +6862,7 @@
           <p:cNvPr id="23" name="">
             <a:extLst xmlns:a="http://schemas.openxmlformats.org/drawingml/2006/main">
               <a:ext uri="{FF2B5EF4-FFF2-40B4-BE49-F238E27FC236}">
-                <a16:creationId xmlns:a16="http://schemas.microsoft.com/office/drawing/2014/main" id="{93723859-4B21-440A-9854-261F8AFC90F3}"/>
+                <a16:creationId xmlns:a16="http://schemas.microsoft.com/office/drawing/2014/main" id="{38BB0E1F-1C09-486A-B0FA-D395A8A765D9}"/>
               </a:ext>
             </a:extLst>
           </p:cNvPr>
@@ -6919,7 +6919,7 @@
           <p:cNvPr id="24" name="">
             <a:extLst xmlns:a="http://schemas.openxmlformats.org/drawingml/2006/main">
               <a:ext uri="{FF2B5EF4-FFF2-40B4-BE49-F238E27FC236}">
-                <a16:creationId xmlns:a16="http://schemas.microsoft.com/office/drawing/2014/main" id="{928123A1-701A-48B2-8502-6DCE391D795E}"/>
+                <a16:creationId xmlns:a16="http://schemas.microsoft.com/office/drawing/2014/main" id="{C890225A-2C52-4BCB-985A-BE0A1E5965B4}"/>
               </a:ext>
             </a:extLst>
           </p:cNvPr>
@@ -6949,7 +6949,7 @@
           <p:cNvPr id="25" name="">
             <a:extLst xmlns:a="http://schemas.openxmlformats.org/drawingml/2006/main">
               <a:ext uri="{FF2B5EF4-FFF2-40B4-BE49-F238E27FC236}">
-                <a16:creationId xmlns:a16="http://schemas.microsoft.com/office/drawing/2014/main" id="{84E93326-29C1-42E3-AF11-C8E2869A38C9}"/>
+                <a16:creationId xmlns:a16="http://schemas.microsoft.com/office/drawing/2014/main" id="{32C5EA53-7C57-4F99-B23D-AF8FB740C92E}"/>
               </a:ext>
             </a:extLst>
           </p:cNvPr>
@@ -7006,7 +7006,7 @@
           <p:cNvPr id="26" name="">
             <a:extLst xmlns:a="http://schemas.openxmlformats.org/drawingml/2006/main">
               <a:ext uri="{FF2B5EF4-FFF2-40B4-BE49-F238E27FC236}">
-                <a16:creationId xmlns:a16="http://schemas.microsoft.com/office/drawing/2014/main" id="{D54896B1-1AC6-47B1-AC6D-463408728837}"/>
+                <a16:creationId xmlns:a16="http://schemas.microsoft.com/office/drawing/2014/main" id="{859D8B97-37B5-4CE8-BA12-24E6696F9BBE}"/>
               </a:ext>
             </a:extLst>
           </p:cNvPr>
@@ -7061,7 +7061,7 @@
     </p:spTree>
     <p:extLst>
       <p:ext uri="{BB962C8B-B14F-4D97-AF65-F5344CB8AC3E}">
-        <p14:creationId xmlns:p14="http://schemas.microsoft.com/office/powerpoint/2010/main" val="1776583273"/>
+        <p14:creationId xmlns:p14="http://schemas.microsoft.com/office/powerpoint/2010/main" val="1730076257"/>
       </p:ext>
     </p:extLst>
   </p:cSld>
@@ -7092,7 +7092,7 @@
           <p:cNvPr id="12" name="">
             <a:extLst xmlns:a="http://schemas.openxmlformats.org/drawingml/2006/main">
               <a:ext uri="{FF2B5EF4-FFF2-40B4-BE49-F238E27FC236}">
-                <a16:creationId xmlns:a16="http://schemas.microsoft.com/office/drawing/2014/main" id="{A03187BF-FF09-44F0-A8EE-A66166C2A50D}"/>
+                <a16:creationId xmlns:a16="http://schemas.microsoft.com/office/drawing/2014/main" id="{07F56EAA-FCF1-4680-A200-FE571429B132}"/>
               </a:ext>
             </a:extLst>
           </p:cNvPr>
@@ -7122,7 +7122,7 @@
           <p:cNvPr id="2" name="">
             <a:extLst xmlns:a="http://schemas.openxmlformats.org/drawingml/2006/main">
               <a:ext uri="{FF2B5EF4-FFF2-40B4-BE49-F238E27FC236}">
-                <a16:creationId xmlns:a16="http://schemas.microsoft.com/office/drawing/2014/main" id="{1A482E36-C4A7-48B8-9FF3-AA412A695098}"/>
+                <a16:creationId xmlns:a16="http://schemas.microsoft.com/office/drawing/2014/main" id="{265F9944-28CD-4079-8259-60CF93C110DE}"/>
               </a:ext>
             </a:extLst>
           </p:cNvPr>
@@ -7179,7 +7179,7 @@
           <p:cNvPr id="3" name="">
             <a:extLst xmlns:a="http://schemas.openxmlformats.org/drawingml/2006/main">
               <a:ext uri="{FF2B5EF4-FFF2-40B4-BE49-F238E27FC236}">
-                <a16:creationId xmlns:a16="http://schemas.microsoft.com/office/drawing/2014/main" id="{A420DFB9-DFD9-4AF5-803A-492436BBF0B4}"/>
+                <a16:creationId xmlns:a16="http://schemas.microsoft.com/office/drawing/2014/main" id="{E5A1E82A-DF99-4E2F-93E9-43367FA6C631}"/>
               </a:ext>
             </a:extLst>
           </p:cNvPr>
@@ -7209,7 +7209,7 @@
           <p:cNvPr id="4" name="">
             <a:extLst xmlns:a="http://schemas.openxmlformats.org/drawingml/2006/main">
               <a:ext uri="{FF2B5EF4-FFF2-40B4-BE49-F238E27FC236}">
-                <a16:creationId xmlns:a16="http://schemas.microsoft.com/office/drawing/2014/main" id="{0D93870D-19EA-465E-A0FE-5D0D6B920F57}"/>
+                <a16:creationId xmlns:a16="http://schemas.microsoft.com/office/drawing/2014/main" id="{F14AFCB8-850D-4CEA-A1DF-B7127C6964AC}"/>
               </a:ext>
             </a:extLst>
           </p:cNvPr>
@@ -7239,7 +7239,7 @@
           <p:cNvPr id="5" name="">
             <a:extLst xmlns:a="http://schemas.openxmlformats.org/drawingml/2006/main">
               <a:ext uri="{FF2B5EF4-FFF2-40B4-BE49-F238E27FC236}">
-                <a16:creationId xmlns:a16="http://schemas.microsoft.com/office/drawing/2014/main" id="{317F6DD3-A873-4649-B5C6-A09A93E03EB2}"/>
+                <a16:creationId xmlns:a16="http://schemas.microsoft.com/office/drawing/2014/main" id="{4B684C45-6D74-4754-828C-8ED4DA6C2A25}"/>
               </a:ext>
             </a:extLst>
           </p:cNvPr>
@@ -7296,7 +7296,7 @@
           <p:cNvPr id="6" name="">
             <a:extLst xmlns:a="http://schemas.openxmlformats.org/drawingml/2006/main">
               <a:ext uri="{FF2B5EF4-FFF2-40B4-BE49-F238E27FC236}">
-                <a16:creationId xmlns:a16="http://schemas.microsoft.com/office/drawing/2014/main" id="{9F1ED9D9-2C4F-472D-9BE9-039BDC77DC47}"/>
+                <a16:creationId xmlns:a16="http://schemas.microsoft.com/office/drawing/2014/main" id="{516BE608-E2DF-42F3-B398-6B4C1581E7D0}"/>
               </a:ext>
             </a:extLst>
           </p:cNvPr>
@@ -7353,7 +7353,7 @@
           <p:cNvPr id="7" name="">
             <a:extLst xmlns:a="http://schemas.openxmlformats.org/drawingml/2006/main">
               <a:ext uri="{FF2B5EF4-FFF2-40B4-BE49-F238E27FC236}">
-                <a16:creationId xmlns:a16="http://schemas.microsoft.com/office/drawing/2014/main" id="{2B8E9FAB-DFE7-4C4F-85C3-FC6744192CCE}"/>
+                <a16:creationId xmlns:a16="http://schemas.microsoft.com/office/drawing/2014/main" id="{D9EA1B44-C3D3-48E8-A4D8-070D0B64A878}"/>
               </a:ext>
             </a:extLst>
           </p:cNvPr>
@@ -7410,7 +7410,7 @@
           <p:cNvPr id="8" name="">
             <a:extLst xmlns:a="http://schemas.openxmlformats.org/drawingml/2006/main">
               <a:ext uri="{FF2B5EF4-FFF2-40B4-BE49-F238E27FC236}">
-                <a16:creationId xmlns:a16="http://schemas.microsoft.com/office/drawing/2014/main" id="{917C7478-C287-4601-9847-EEDA99960686}"/>
+                <a16:creationId xmlns:a16="http://schemas.microsoft.com/office/drawing/2014/main" id="{080F97F9-1503-4A01-84A3-405F66B5EC97}"/>
               </a:ext>
             </a:extLst>
           </p:cNvPr>
@@ -7467,7 +7467,7 @@
           <p:cNvPr id="9" name="">
             <a:extLst xmlns:a="http://schemas.openxmlformats.org/drawingml/2006/main">
               <a:ext uri="{FF2B5EF4-FFF2-40B4-BE49-F238E27FC236}">
-                <a16:creationId xmlns:a16="http://schemas.microsoft.com/office/drawing/2014/main" id="{8968EAEA-49C6-44A0-AB85-82EBF219549C}"/>
+                <a16:creationId xmlns:a16="http://schemas.microsoft.com/office/drawing/2014/main" id="{748FBA28-19B5-45D2-BB5B-638452DB04EF}"/>
               </a:ext>
             </a:extLst>
           </p:cNvPr>
@@ -7497,7 +7497,7 @@
           <p:cNvPr id="10" name="">
             <a:extLst xmlns:a="http://schemas.openxmlformats.org/drawingml/2006/main">
               <a:ext uri="{FF2B5EF4-FFF2-40B4-BE49-F238E27FC236}">
-                <a16:creationId xmlns:a16="http://schemas.microsoft.com/office/drawing/2014/main" id="{854677D4-88D7-4A6B-AFBD-29A04095B871}"/>
+                <a16:creationId xmlns:a16="http://schemas.microsoft.com/office/drawing/2014/main" id="{FF841CA3-5E3A-453E-B6F4-50F9B95EFFBE}"/>
               </a:ext>
             </a:extLst>
           </p:cNvPr>
@@ -7554,7 +7554,7 @@
           <p:cNvPr id="11" name="">
             <a:extLst xmlns:a="http://schemas.openxmlformats.org/drawingml/2006/main">
               <a:ext uri="{FF2B5EF4-FFF2-40B4-BE49-F238E27FC236}">
-                <a16:creationId xmlns:a16="http://schemas.microsoft.com/office/drawing/2014/main" id="{90E2C2B9-EA45-43A7-909B-D0763FFF939E}"/>
+                <a16:creationId xmlns:a16="http://schemas.microsoft.com/office/drawing/2014/main" id="{A5BE76EB-DEE8-475B-BAC4-9F9F74879225}"/>
               </a:ext>
             </a:extLst>
           </p:cNvPr>
@@ -7609,7 +7609,7 @@
     </p:spTree>
     <p:extLst>
       <p:ext uri="{BB962C8B-B14F-4D97-AF65-F5344CB8AC3E}">
-        <p14:creationId xmlns:p14="http://schemas.microsoft.com/office/powerpoint/2010/main" val="498371696"/>
+        <p14:creationId xmlns:p14="http://schemas.microsoft.com/office/powerpoint/2010/main" val="1051515177"/>
       </p:ext>
     </p:extLst>
   </p:cSld>
@@ -7640,7 +7640,7 @@
           <p:cNvPr id="17" name="">
             <a:extLst xmlns:a="http://schemas.openxmlformats.org/drawingml/2006/main">
               <a:ext uri="{FF2B5EF4-FFF2-40B4-BE49-F238E27FC236}">
-                <a16:creationId xmlns:a16="http://schemas.microsoft.com/office/drawing/2014/main" id="{81BEFAEA-9AF1-4099-9A1F-68358D4D8B76}"/>
+                <a16:creationId xmlns:a16="http://schemas.microsoft.com/office/drawing/2014/main" id="{9B9BA317-C062-4D17-94E5-8BF0DD97C0AB}"/>
               </a:ext>
             </a:extLst>
           </p:cNvPr>
@@ -7670,7 +7670,7 @@
           <p:cNvPr id="2" name="">
             <a:extLst xmlns:a="http://schemas.openxmlformats.org/drawingml/2006/main">
               <a:ext uri="{FF2B5EF4-FFF2-40B4-BE49-F238E27FC236}">
-                <a16:creationId xmlns:a16="http://schemas.microsoft.com/office/drawing/2014/main" id="{883169EA-3E27-4B35-AF1A-23BA2F37974E}"/>
+                <a16:creationId xmlns:a16="http://schemas.microsoft.com/office/drawing/2014/main" id="{527A3F5D-9516-4EB2-9450-419517632081}"/>
               </a:ext>
             </a:extLst>
           </p:cNvPr>
@@ -7700,7 +7700,7 @@
           <p:cNvPr id="3" name="">
             <a:extLst xmlns:a="http://schemas.openxmlformats.org/drawingml/2006/main">
               <a:ext uri="{FF2B5EF4-FFF2-40B4-BE49-F238E27FC236}">
-                <a16:creationId xmlns:a16="http://schemas.microsoft.com/office/drawing/2014/main" id="{83F2DE6E-32BD-4310-872D-1BCA9A5DE4D8}"/>
+                <a16:creationId xmlns:a16="http://schemas.microsoft.com/office/drawing/2014/main" id="{35667422-3020-4665-80D8-101AEC01EDD8}"/>
               </a:ext>
             </a:extLst>
           </p:cNvPr>
@@ -7757,7 +7757,7 @@
           <p:cNvPr id="4" name="">
             <a:extLst xmlns:a="http://schemas.openxmlformats.org/drawingml/2006/main">
               <a:ext uri="{FF2B5EF4-FFF2-40B4-BE49-F238E27FC236}">
-                <a16:creationId xmlns:a16="http://schemas.microsoft.com/office/drawing/2014/main" id="{A3DAE35C-5335-40EB-9BDD-CB60A8C45B49}"/>
+                <a16:creationId xmlns:a16="http://schemas.microsoft.com/office/drawing/2014/main" id="{8A88ECF0-0FA3-43F2-A0BB-7CA38B7ACE5B}"/>
               </a:ext>
             </a:extLst>
           </p:cNvPr>
@@ -7814,7 +7814,7 @@
           <p:cNvPr id="5" name="">
             <a:extLst xmlns:a="http://schemas.openxmlformats.org/drawingml/2006/main">
               <a:ext uri="{FF2B5EF4-FFF2-40B4-BE49-F238E27FC236}">
-                <a16:creationId xmlns:a16="http://schemas.microsoft.com/office/drawing/2014/main" id="{C3CC11A4-5012-45C4-8E41-F4AFA6946623}"/>
+                <a16:creationId xmlns:a16="http://schemas.microsoft.com/office/drawing/2014/main" id="{8123CC3F-4016-41B3-A147-1A6BFDFE9063}"/>
               </a:ext>
             </a:extLst>
           </p:cNvPr>
@@ -7844,7 +7844,7 @@
           <p:cNvPr id="6" name="">
             <a:extLst xmlns:a="http://schemas.openxmlformats.org/drawingml/2006/main">
               <a:ext uri="{FF2B5EF4-FFF2-40B4-BE49-F238E27FC236}">
-                <a16:creationId xmlns:a16="http://schemas.microsoft.com/office/drawing/2014/main" id="{29B158C3-91E4-49DD-9AB5-4BF081DC70B2}"/>
+                <a16:creationId xmlns:a16="http://schemas.microsoft.com/office/drawing/2014/main" id="{5F616E04-CD8E-4F8A-88C1-BCB5E3142AFC}"/>
               </a:ext>
             </a:extLst>
           </p:cNvPr>
@@ -7901,7 +7901,7 @@
           <p:cNvPr id="7" name="">
             <a:extLst xmlns:a="http://schemas.openxmlformats.org/drawingml/2006/main">
               <a:ext uri="{FF2B5EF4-FFF2-40B4-BE49-F238E27FC236}">
-                <a16:creationId xmlns:a16="http://schemas.microsoft.com/office/drawing/2014/main" id="{55A7771D-4B08-4595-8FD9-1AB743DAF14C}"/>
+                <a16:creationId xmlns:a16="http://schemas.microsoft.com/office/drawing/2014/main" id="{F32702CC-F0C8-4A31-81F4-74CA1130F991}"/>
               </a:ext>
             </a:extLst>
           </p:cNvPr>
@@ -7958,7 +7958,7 @@
           <p:cNvPr id="8" name="">
             <a:extLst xmlns:a="http://schemas.openxmlformats.org/drawingml/2006/main">
               <a:ext uri="{FF2B5EF4-FFF2-40B4-BE49-F238E27FC236}">
-                <a16:creationId xmlns:a16="http://schemas.microsoft.com/office/drawing/2014/main" id="{663B018B-4323-43C3-8103-2CDEB471034A}"/>
+                <a16:creationId xmlns:a16="http://schemas.microsoft.com/office/drawing/2014/main" id="{531E003F-E065-434E-B6A8-59CAF9B00B06}"/>
               </a:ext>
             </a:extLst>
           </p:cNvPr>
@@ -8015,7 +8015,7 @@
           <p:cNvPr id="9" name="">
             <a:extLst xmlns:a="http://schemas.openxmlformats.org/drawingml/2006/main">
               <a:ext uri="{FF2B5EF4-FFF2-40B4-BE49-F238E27FC236}">
-                <a16:creationId xmlns:a16="http://schemas.microsoft.com/office/drawing/2014/main" id="{7126C302-E5C8-45DC-8AA5-B774202D5DD1}"/>
+                <a16:creationId xmlns:a16="http://schemas.microsoft.com/office/drawing/2014/main" id="{63F63A29-1CDD-4E57-9A01-330C14211E68}"/>
               </a:ext>
             </a:extLst>
           </p:cNvPr>
@@ -8045,7 +8045,7 @@
           <p:cNvPr id="10" name="">
             <a:extLst xmlns:a="http://schemas.openxmlformats.org/drawingml/2006/main">
               <a:ext uri="{FF2B5EF4-FFF2-40B4-BE49-F238E27FC236}">
-                <a16:creationId xmlns:a16="http://schemas.microsoft.com/office/drawing/2014/main" id="{B3E7E6A8-10F9-4402-A837-9C1C9285E442}"/>
+                <a16:creationId xmlns:a16="http://schemas.microsoft.com/office/drawing/2014/main" id="{70732FAF-0546-4052-88AD-65E4AB3A00D5}"/>
               </a:ext>
             </a:extLst>
           </p:cNvPr>
@@ -8102,7 +8102,7 @@
           <p:cNvPr id="11" name="">
             <a:extLst xmlns:a="http://schemas.openxmlformats.org/drawingml/2006/main">
               <a:ext uri="{FF2B5EF4-FFF2-40B4-BE49-F238E27FC236}">
-                <a16:creationId xmlns:a16="http://schemas.microsoft.com/office/drawing/2014/main" id="{99A822AA-EE4C-4B40-8065-48D6A4A57AE6}"/>
+                <a16:creationId xmlns:a16="http://schemas.microsoft.com/office/drawing/2014/main" id="{A639C8DA-707E-467C-9157-ACB11F1A306F}"/>
               </a:ext>
             </a:extLst>
           </p:cNvPr>
@@ -8159,7 +8159,7 @@
           <p:cNvPr id="12" name="">
             <a:extLst xmlns:a="http://schemas.openxmlformats.org/drawingml/2006/main">
               <a:ext uri="{FF2B5EF4-FFF2-40B4-BE49-F238E27FC236}">
-                <a16:creationId xmlns:a16="http://schemas.microsoft.com/office/drawing/2014/main" id="{7ED77B2A-2B2A-4A92-AFF5-87325044B29B}"/>
+                <a16:creationId xmlns:a16="http://schemas.microsoft.com/office/drawing/2014/main" id="{E1963C49-5FBA-44C9-AE80-9B995FFA645A}"/>
               </a:ext>
             </a:extLst>
           </p:cNvPr>
@@ -8216,7 +8216,7 @@
           <p:cNvPr id="13" name="">
             <a:extLst xmlns:a="http://schemas.openxmlformats.org/drawingml/2006/main">
               <a:ext uri="{FF2B5EF4-FFF2-40B4-BE49-F238E27FC236}">
-                <a16:creationId xmlns:a16="http://schemas.microsoft.com/office/drawing/2014/main" id="{D843BF82-9BAD-469F-A89C-9DD782C27F77}"/>
+                <a16:creationId xmlns:a16="http://schemas.microsoft.com/office/drawing/2014/main" id="{0853E034-03F4-4311-B1DD-C21E4CE6FB70}"/>
               </a:ext>
             </a:extLst>
           </p:cNvPr>
@@ -8246,7 +8246,7 @@
           <p:cNvPr id="14" name="">
             <a:extLst xmlns:a="http://schemas.openxmlformats.org/drawingml/2006/main">
               <a:ext uri="{FF2B5EF4-FFF2-40B4-BE49-F238E27FC236}">
-                <a16:creationId xmlns:a16="http://schemas.microsoft.com/office/drawing/2014/main" id="{042620F2-275A-4E0E-9220-CAFA26CE8CB8}"/>
+                <a16:creationId xmlns:a16="http://schemas.microsoft.com/office/drawing/2014/main" id="{8F99C3C3-C636-43BD-A33B-7CDEED166AB6}"/>
               </a:ext>
             </a:extLst>
           </p:cNvPr>
@@ -8303,7 +8303,7 @@
           <p:cNvPr id="15" name="">
             <a:extLst xmlns:a="http://schemas.openxmlformats.org/drawingml/2006/main">
               <a:ext uri="{FF2B5EF4-FFF2-40B4-BE49-F238E27FC236}">
-                <a16:creationId xmlns:a16="http://schemas.microsoft.com/office/drawing/2014/main" id="{8267C48D-0DAE-4C16-B2DF-5864E3CD9479}"/>
+                <a16:creationId xmlns:a16="http://schemas.microsoft.com/office/drawing/2014/main" id="{D498376D-6967-4EFF-A1F5-5B33A88AB3F8}"/>
               </a:ext>
             </a:extLst>
           </p:cNvPr>
@@ -8360,7 +8360,7 @@
           <p:cNvPr id="16" name="">
             <a:extLst xmlns:a="http://schemas.openxmlformats.org/drawingml/2006/main">
               <a:ext uri="{FF2B5EF4-FFF2-40B4-BE49-F238E27FC236}">
-                <a16:creationId xmlns:a16="http://schemas.microsoft.com/office/drawing/2014/main" id="{227756CE-95EE-4948-BD50-D48AE1E54335}"/>
+                <a16:creationId xmlns:a16="http://schemas.microsoft.com/office/drawing/2014/main" id="{9E22FC35-A1BC-45EE-9DC5-7208EBFD8634}"/>
               </a:ext>
             </a:extLst>
           </p:cNvPr>
@@ -8415,7 +8415,7 @@
     </p:spTree>
     <p:extLst>
       <p:ext uri="{BB962C8B-B14F-4D97-AF65-F5344CB8AC3E}">
-        <p14:creationId xmlns:p14="http://schemas.microsoft.com/office/powerpoint/2010/main" val="89558498"/>
+        <p14:creationId xmlns:p14="http://schemas.microsoft.com/office/powerpoint/2010/main" val="1428999960"/>
       </p:ext>
     </p:extLst>
   </p:cSld>
@@ -8446,7 +8446,7 @@
           <p:cNvPr id="17" name="">
             <a:extLst xmlns:a="http://schemas.openxmlformats.org/drawingml/2006/main">
               <a:ext uri="{FF2B5EF4-FFF2-40B4-BE49-F238E27FC236}">
-                <a16:creationId xmlns:a16="http://schemas.microsoft.com/office/drawing/2014/main" id="{611AC960-EB2C-4647-852D-BA7F471D37C1}"/>
+                <a16:creationId xmlns:a16="http://schemas.microsoft.com/office/drawing/2014/main" id="{D526B51A-854E-48F7-802E-E1422494A278}"/>
               </a:ext>
             </a:extLst>
           </p:cNvPr>
@@ -8476,7 +8476,7 @@
           <p:cNvPr id="2" name="">
             <a:extLst xmlns:a="http://schemas.openxmlformats.org/drawingml/2006/main">
               <a:ext uri="{FF2B5EF4-FFF2-40B4-BE49-F238E27FC236}">
-                <a16:creationId xmlns:a16="http://schemas.microsoft.com/office/drawing/2014/main" id="{35372B5C-8A4D-4E33-AE57-94ADB0AEAE1D}"/>
+                <a16:creationId xmlns:a16="http://schemas.microsoft.com/office/drawing/2014/main" id="{C567A58D-1379-46A1-B1B7-392C0615A289}"/>
               </a:ext>
             </a:extLst>
           </p:cNvPr>
@@ -8533,7 +8533,7 @@
           <p:cNvPr id="3" name="">
             <a:extLst xmlns:a="http://schemas.openxmlformats.org/drawingml/2006/main">
               <a:ext uri="{FF2B5EF4-FFF2-40B4-BE49-F238E27FC236}">
-                <a16:creationId xmlns:a16="http://schemas.microsoft.com/office/drawing/2014/main" id="{9C55435A-A7CF-4D22-A3B9-06FBB8B31BEF}"/>
+                <a16:creationId xmlns:a16="http://schemas.microsoft.com/office/drawing/2014/main" id="{0EF2282A-7E27-40B4-84B8-5C190F466F30}"/>
               </a:ext>
             </a:extLst>
           </p:cNvPr>
@@ -8563,7 +8563,7 @@
           <p:cNvPr id="4" name="">
             <a:extLst xmlns:a="http://schemas.openxmlformats.org/drawingml/2006/main">
               <a:ext uri="{FF2B5EF4-FFF2-40B4-BE49-F238E27FC236}">
-                <a16:creationId xmlns:a16="http://schemas.microsoft.com/office/drawing/2014/main" id="{7573A5C9-40AB-4483-B093-687AF54A9E75}"/>
+                <a16:creationId xmlns:a16="http://schemas.microsoft.com/office/drawing/2014/main" id="{E26DD9F8-2717-4748-9953-43B6556E8E60}"/>
               </a:ext>
             </a:extLst>
           </p:cNvPr>
@@ -8593,7 +8593,7 @@
           <p:cNvPr id="5" name="">
             <a:extLst xmlns:a="http://schemas.openxmlformats.org/drawingml/2006/main">
               <a:ext uri="{FF2B5EF4-FFF2-40B4-BE49-F238E27FC236}">
-                <a16:creationId xmlns:a16="http://schemas.microsoft.com/office/drawing/2014/main" id="{059086AA-16C3-441E-9E00-23EA052FEC9F}"/>
+                <a16:creationId xmlns:a16="http://schemas.microsoft.com/office/drawing/2014/main" id="{59CBC30C-C570-4D15-8F4F-6CC64FFC5298}"/>
               </a:ext>
             </a:extLst>
           </p:cNvPr>
@@ -8650,7 +8650,7 @@
           <p:cNvPr id="6" name="">
             <a:extLst xmlns:a="http://schemas.openxmlformats.org/drawingml/2006/main">
               <a:ext uri="{FF2B5EF4-FFF2-40B4-BE49-F238E27FC236}">
-                <a16:creationId xmlns:a16="http://schemas.microsoft.com/office/drawing/2014/main" id="{E50C8990-8093-4FBC-9C78-72F04E88B58C}"/>
+                <a16:creationId xmlns:a16="http://schemas.microsoft.com/office/drawing/2014/main" id="{B1F1AA3E-169B-48F9-8A36-1D9240456E2B}"/>
               </a:ext>
             </a:extLst>
           </p:cNvPr>
@@ -8707,7 +8707,7 @@
           <p:cNvPr id="7" name="">
             <a:extLst xmlns:a="http://schemas.openxmlformats.org/drawingml/2006/main">
               <a:ext uri="{FF2B5EF4-FFF2-40B4-BE49-F238E27FC236}">
-                <a16:creationId xmlns:a16="http://schemas.microsoft.com/office/drawing/2014/main" id="{4D317F96-D3CA-4ED2-A762-8D4823661286}"/>
+                <a16:creationId xmlns:a16="http://schemas.microsoft.com/office/drawing/2014/main" id="{0A2BB944-82E2-401B-8D27-9DD716421A52}"/>
               </a:ext>
             </a:extLst>
           </p:cNvPr>
@@ -8764,7 +8764,7 @@
           <p:cNvPr id="8" name="">
             <a:extLst xmlns:a="http://schemas.openxmlformats.org/drawingml/2006/main">
               <a:ext uri="{FF2B5EF4-FFF2-40B4-BE49-F238E27FC236}">
-                <a16:creationId xmlns:a16="http://schemas.microsoft.com/office/drawing/2014/main" id="{EB7140BD-6313-4A91-86B5-0D94CAE2CC08}"/>
+                <a16:creationId xmlns:a16="http://schemas.microsoft.com/office/drawing/2014/main" id="{0F18F2A6-D156-474E-8054-9F05E3E8F3ED}"/>
               </a:ext>
             </a:extLst>
           </p:cNvPr>
@@ -8794,7 +8794,7 @@
           <p:cNvPr id="9" name="">
             <a:extLst xmlns:a="http://schemas.openxmlformats.org/drawingml/2006/main">
               <a:ext uri="{FF2B5EF4-FFF2-40B4-BE49-F238E27FC236}">
-                <a16:creationId xmlns:a16="http://schemas.microsoft.com/office/drawing/2014/main" id="{CEEB9371-743E-4F36-AFAE-2B5B1AB68CC7}"/>
+                <a16:creationId xmlns:a16="http://schemas.microsoft.com/office/drawing/2014/main" id="{EBF98FDB-C1F3-446B-9630-388015326A81}"/>
               </a:ext>
             </a:extLst>
           </p:cNvPr>
@@ -8851,7 +8851,7 @@
           <p:cNvPr id="10" name="">
             <a:extLst xmlns:a="http://schemas.openxmlformats.org/drawingml/2006/main">
               <a:ext uri="{FF2B5EF4-FFF2-40B4-BE49-F238E27FC236}">
-                <a16:creationId xmlns:a16="http://schemas.microsoft.com/office/drawing/2014/main" id="{F1A6FB9C-1327-43FE-B62D-E74B6E33A775}"/>
+                <a16:creationId xmlns:a16="http://schemas.microsoft.com/office/drawing/2014/main" id="{56424652-5956-4AA1-84D9-AF0E906F7832}"/>
               </a:ext>
             </a:extLst>
           </p:cNvPr>
@@ -8908,7 +8908,7 @@
           <p:cNvPr id="11" name="">
             <a:extLst xmlns:a="http://schemas.openxmlformats.org/drawingml/2006/main">
               <a:ext uri="{FF2B5EF4-FFF2-40B4-BE49-F238E27FC236}">
-                <a16:creationId xmlns:a16="http://schemas.microsoft.com/office/drawing/2014/main" id="{410E746B-A285-4ADD-A5AD-3E0150D6E3BB}"/>
+                <a16:creationId xmlns:a16="http://schemas.microsoft.com/office/drawing/2014/main" id="{2EFBFE79-8D67-4E0E-BEBA-14437E0A71F4}"/>
               </a:ext>
             </a:extLst>
           </p:cNvPr>
@@ -8965,7 +8965,7 @@
           <p:cNvPr id="12" name="">
             <a:extLst xmlns:a="http://schemas.openxmlformats.org/drawingml/2006/main">
               <a:ext uri="{FF2B5EF4-FFF2-40B4-BE49-F238E27FC236}">
-                <a16:creationId xmlns:a16="http://schemas.microsoft.com/office/drawing/2014/main" id="{F1A64F3C-3E29-431E-A1B3-702E4AD18422}"/>
+                <a16:creationId xmlns:a16="http://schemas.microsoft.com/office/drawing/2014/main" id="{24E620F2-B959-42F1-BD4F-39F685B88F1D}"/>
               </a:ext>
             </a:extLst>
           </p:cNvPr>
@@ -9022,7 +9022,7 @@
           <p:cNvPr id="13" name="">
             <a:extLst xmlns:a="http://schemas.openxmlformats.org/drawingml/2006/main">
               <a:ext uri="{FF2B5EF4-FFF2-40B4-BE49-F238E27FC236}">
-                <a16:creationId xmlns:a16="http://schemas.microsoft.com/office/drawing/2014/main" id="{2C4BFA78-F173-4081-B19A-B138D2AAA3F3}"/>
+                <a16:creationId xmlns:a16="http://schemas.microsoft.com/office/drawing/2014/main" id="{06FCD2B8-097A-46A3-8EB2-ABDCCCA634DB}"/>
               </a:ext>
             </a:extLst>
           </p:cNvPr>
@@ -9079,7 +9079,7 @@
           <p:cNvPr id="14" name="">
             <a:extLst xmlns:a="http://schemas.openxmlformats.org/drawingml/2006/main">
               <a:ext uri="{FF2B5EF4-FFF2-40B4-BE49-F238E27FC236}">
-                <a16:creationId xmlns:a16="http://schemas.microsoft.com/office/drawing/2014/main" id="{EF9383F8-B4E0-43E0-A2E3-12D8F2559757}"/>
+                <a16:creationId xmlns:a16="http://schemas.microsoft.com/office/drawing/2014/main" id="{5F2FFFE6-516F-40D8-A8C5-4AB411D05963}"/>
               </a:ext>
             </a:extLst>
           </p:cNvPr>
@@ -9136,7 +9136,7 @@
           <p:cNvPr id="15" name="">
             <a:extLst xmlns:a="http://schemas.openxmlformats.org/drawingml/2006/main">
               <a:ext uri="{FF2B5EF4-FFF2-40B4-BE49-F238E27FC236}">
-                <a16:creationId xmlns:a16="http://schemas.microsoft.com/office/drawing/2014/main" id="{B2C28D91-A674-4760-8F2B-646FA1FE3732}"/>
+                <a16:creationId xmlns:a16="http://schemas.microsoft.com/office/drawing/2014/main" id="{4AF88EC5-92BB-4D86-8896-C2AE4CF275D5}"/>
               </a:ext>
             </a:extLst>
           </p:cNvPr>
@@ -9193,7 +9193,7 @@
           <p:cNvPr id="16" name="">
             <a:extLst xmlns:a="http://schemas.openxmlformats.org/drawingml/2006/main">
               <a:ext uri="{FF2B5EF4-FFF2-40B4-BE49-F238E27FC236}">
-                <a16:creationId xmlns:a16="http://schemas.microsoft.com/office/drawing/2014/main" id="{C77A2327-95E1-4CB9-9853-189ED53CDA6F}"/>
+                <a16:creationId xmlns:a16="http://schemas.microsoft.com/office/drawing/2014/main" id="{8747F1A2-17FA-41C6-8CCE-8715A96C3235}"/>
               </a:ext>
             </a:extLst>
           </p:cNvPr>
@@ -9248,7 +9248,7 @@
     </p:spTree>
     <p:extLst>
       <p:ext uri="{BB962C8B-B14F-4D97-AF65-F5344CB8AC3E}">
-        <p14:creationId xmlns:p14="http://schemas.microsoft.com/office/powerpoint/2010/main" val="751780968"/>
+        <p14:creationId xmlns:p14="http://schemas.microsoft.com/office/powerpoint/2010/main" val="834893748"/>
       </p:ext>
     </p:extLst>
   </p:cSld>

</xml_diff>

<commit_message>
chore: sync local skill assets and maintenance files (#19)
Co-authored-by: tutuhu <tutuhu@tutuhudeMac-mini-5.local>
</commit_message>
<xml_diff>
--- a/assets/k105-blue/starter.pptx
+++ b/assets/k105-blue/starter.pptx
@@ -2,23 +2,23 @@
 <file path=ppt/presentation.xml><?xml version="1.0" encoding="utf-8"?>
 <p:presentation xmlns:p="http://schemas.openxmlformats.org/presentationml/2006/main">
   <p:sldMasterIdLst>
-    <p:sldMasterId xmlns:r="http://schemas.openxmlformats.org/officeDocument/2006/relationships" id="2147483648" r:id="R677e180bdaa84ecd"/>
+    <p:sldMasterId xmlns:r="http://schemas.openxmlformats.org/officeDocument/2006/relationships" id="2147483648" r:id="R0cd1e4226c654433"/>
   </p:sldMasterIdLst>
   <p:notesMasterIdLst>
-    <p:notesMasterId xmlns:r="http://schemas.openxmlformats.org/officeDocument/2006/relationships" r:id="Rbff4535b567040b6"/>
+    <p:notesMasterId xmlns:r="http://schemas.openxmlformats.org/officeDocument/2006/relationships" r:id="R3ef90075d4e2479c"/>
   </p:notesMasterIdLst>
   <p:sldIdLst>
-    <p:sldId xmlns:r="http://schemas.openxmlformats.org/officeDocument/2006/relationships" id="256" r:id="R66f76b3b981941ad"/>
-    <p:sldId xmlns:r="http://schemas.openxmlformats.org/officeDocument/2006/relationships" id="257" r:id="R0154c92990ee414b"/>
-    <p:sldId xmlns:r="http://schemas.openxmlformats.org/officeDocument/2006/relationships" id="258" r:id="Racfacc888410412f"/>
-    <p:sldId xmlns:r="http://schemas.openxmlformats.org/officeDocument/2006/relationships" id="259" r:id="Re3a6f6ce89584c5f"/>
-    <p:sldId xmlns:r="http://schemas.openxmlformats.org/officeDocument/2006/relationships" id="260" r:id="R2dfc3375341b4975"/>
-    <p:sldId xmlns:r="http://schemas.openxmlformats.org/officeDocument/2006/relationships" id="261" r:id="Rb8a80f5147354ab2"/>
-    <p:sldId xmlns:r="http://schemas.openxmlformats.org/officeDocument/2006/relationships" id="262" r:id="R49a9e4dfe454434d"/>
-    <p:sldId xmlns:r="http://schemas.openxmlformats.org/officeDocument/2006/relationships" id="263" r:id="R161d215a7ec44ed8"/>
-    <p:sldId xmlns:r="http://schemas.openxmlformats.org/officeDocument/2006/relationships" id="264" r:id="Rb6c161b49f604dec"/>
-    <p:sldId xmlns:r="http://schemas.openxmlformats.org/officeDocument/2006/relationships" id="265" r:id="R0752380716f24582"/>
-    <p:sldId xmlns:r="http://schemas.openxmlformats.org/officeDocument/2006/relationships" id="266" r:id="R96f5f5395e744eb7"/>
+    <p:sldId xmlns:r="http://schemas.openxmlformats.org/officeDocument/2006/relationships" id="256" r:id="Raf8b897aba7044ba"/>
+    <p:sldId xmlns:r="http://schemas.openxmlformats.org/officeDocument/2006/relationships" id="257" r:id="Rce3d1ac3092b46df"/>
+    <p:sldId xmlns:r="http://schemas.openxmlformats.org/officeDocument/2006/relationships" id="258" r:id="Rb081ab1a426e42bf"/>
+    <p:sldId xmlns:r="http://schemas.openxmlformats.org/officeDocument/2006/relationships" id="259" r:id="R38586a5c14324929"/>
+    <p:sldId xmlns:r="http://schemas.openxmlformats.org/officeDocument/2006/relationships" id="260" r:id="R3026a890138b4c8b"/>
+    <p:sldId xmlns:r="http://schemas.openxmlformats.org/officeDocument/2006/relationships" id="261" r:id="Rf90be533ce7f4d43"/>
+    <p:sldId xmlns:r="http://schemas.openxmlformats.org/officeDocument/2006/relationships" id="262" r:id="R7180feb0409b4ce5"/>
+    <p:sldId xmlns:r="http://schemas.openxmlformats.org/officeDocument/2006/relationships" id="263" r:id="R95afca282f3a4a23"/>
+    <p:sldId xmlns:r="http://schemas.openxmlformats.org/officeDocument/2006/relationships" id="264" r:id="Ra7432193b82f424a"/>
+    <p:sldId xmlns:r="http://schemas.openxmlformats.org/officeDocument/2006/relationships" id="265" r:id="Ra67bea7d82c649fe"/>
+    <p:sldId xmlns:r="http://schemas.openxmlformats.org/officeDocument/2006/relationships" id="266" r:id="Rf7f52fbe336e4b3d"/>
   </p:sldIdLst>
   <p:sldSz cx="12192000" cy="6858000"/>
   <p:notesSz cx="6858000" cy="9144000"/>
@@ -1220,7 +1220,7 @@
   </p:cSld>
   <p:clrMap bg1="lt1" tx1="dk1" bg2="lt2" tx2="dk2" accent1="accent1" accent2="accent2" accent3="accent3" accent4="accent4" accent5="accent5" accent6="accent6" hlink="hlink" folHlink="folHlink"/>
   <p:sldLayoutIdLst>
-    <p:sldLayoutId xmlns:r="http://schemas.openxmlformats.org/officeDocument/2006/relationships" id="2147483649" r:id="R683ef74864ec4db0"/>
+    <p:sldLayoutId xmlns:r="http://schemas.openxmlformats.org/officeDocument/2006/relationships" id="2147483649" r:id="Re0f20ccbcb124404"/>
   </p:sldLayoutIdLst>
   <p:txStyles>
     <p:titleStyle>
@@ -1771,7 +1771,7 @@
           <p:cNvPr id="13" name="">
             <a:extLst xmlns:a="http://schemas.openxmlformats.org/drawingml/2006/main">
               <a:ext uri="{FF2B5EF4-FFF2-40B4-BE49-F238E27FC236}">
-                <a16:creationId xmlns:a16="http://schemas.microsoft.com/office/drawing/2014/main" id="{17ADCACB-C64F-4A5D-B97B-1E8E28F7E436}"/>
+                <a16:creationId xmlns:a16="http://schemas.microsoft.com/office/drawing/2014/main" id="{166EE474-6119-4644-A02A-6FC0A9CA421E}"/>
               </a:ext>
             </a:extLst>
           </p:cNvPr>
@@ -1801,7 +1801,7 @@
           <p:cNvPr id="2" name="">
             <a:extLst xmlns:a="http://schemas.openxmlformats.org/drawingml/2006/main">
               <a:ext uri="{FF2B5EF4-FFF2-40B4-BE49-F238E27FC236}">
-                <a16:creationId xmlns:a16="http://schemas.microsoft.com/office/drawing/2014/main" id="{D6F0AFBC-C22C-40DD-8197-4909458AB077}"/>
+                <a16:creationId xmlns:a16="http://schemas.microsoft.com/office/drawing/2014/main" id="{37AC57D9-0CDD-4C96-9F19-835BB762A3A0}"/>
               </a:ext>
             </a:extLst>
           </p:cNvPr>
@@ -1833,7 +1833,7 @@
           <p:cNvPr id="3" name="">
             <a:extLst xmlns:a="http://schemas.openxmlformats.org/drawingml/2006/main">
               <a:ext uri="{FF2B5EF4-FFF2-40B4-BE49-F238E27FC236}">
-                <a16:creationId xmlns:a16="http://schemas.microsoft.com/office/drawing/2014/main" id="{96CE0632-A06C-4EFA-8B86-F7A9C739EC36}"/>
+                <a16:creationId xmlns:a16="http://schemas.microsoft.com/office/drawing/2014/main" id="{1CAD6338-657E-4610-B176-2FB15A09AF5D}"/>
               </a:ext>
             </a:extLst>
           </p:cNvPr>
@@ -1865,7 +1865,7 @@
           <p:cNvPr id="4" name="">
             <a:extLst xmlns:a="http://schemas.openxmlformats.org/drawingml/2006/main">
               <a:ext uri="{FF2B5EF4-FFF2-40B4-BE49-F238E27FC236}">
-                <a16:creationId xmlns:a16="http://schemas.microsoft.com/office/drawing/2014/main" id="{E6F77DE7-F195-4D09-84F3-55EFEFBC163F}"/>
+                <a16:creationId xmlns:a16="http://schemas.microsoft.com/office/drawing/2014/main" id="{19873B9E-DE0B-4234-B3EE-1C13B3190B95}"/>
               </a:ext>
             </a:extLst>
           </p:cNvPr>
@@ -1897,7 +1897,7 @@
           <p:cNvPr id="5" name="">
             <a:extLst xmlns:a="http://schemas.openxmlformats.org/drawingml/2006/main">
               <a:ext uri="{FF2B5EF4-FFF2-40B4-BE49-F238E27FC236}">
-                <a16:creationId xmlns:a16="http://schemas.microsoft.com/office/drawing/2014/main" id="{519819BF-9EFF-46DD-BB53-A0CD2646849B}"/>
+                <a16:creationId xmlns:a16="http://schemas.microsoft.com/office/drawing/2014/main" id="{699C1D3A-D0CB-48B1-84DC-C186A5D0EBF4}"/>
               </a:ext>
             </a:extLst>
           </p:cNvPr>
@@ -1929,7 +1929,7 @@
           <p:cNvPr id="6" name="">
             <a:extLst xmlns:a="http://schemas.openxmlformats.org/drawingml/2006/main">
               <a:ext uri="{FF2B5EF4-FFF2-40B4-BE49-F238E27FC236}">
-                <a16:creationId xmlns:a16="http://schemas.microsoft.com/office/drawing/2014/main" id="{812F2D24-E6E1-44A7-A1FC-08206FCDEDE8}"/>
+                <a16:creationId xmlns:a16="http://schemas.microsoft.com/office/drawing/2014/main" id="{A5EBC599-73A8-4946-9DA4-93D78B844FA6}"/>
               </a:ext>
             </a:extLst>
           </p:cNvPr>
@@ -1961,7 +1961,7 @@
           <p:cNvPr id="7" name="">
             <a:extLst xmlns:a="http://schemas.openxmlformats.org/drawingml/2006/main">
               <a:ext uri="{FF2B5EF4-FFF2-40B4-BE49-F238E27FC236}">
-                <a16:creationId xmlns:a16="http://schemas.microsoft.com/office/drawing/2014/main" id="{CD0FFB70-E648-490F-BF18-76DF1698A74B}"/>
+                <a16:creationId xmlns:a16="http://schemas.microsoft.com/office/drawing/2014/main" id="{02E41BCC-30A5-48EB-AD92-D77F3577B7D4}"/>
               </a:ext>
             </a:extLst>
           </p:cNvPr>
@@ -1993,7 +1993,7 @@
           <p:cNvPr id="8" name="">
             <a:extLst xmlns:a="http://schemas.openxmlformats.org/drawingml/2006/main">
               <a:ext uri="{FF2B5EF4-FFF2-40B4-BE49-F238E27FC236}">
-                <a16:creationId xmlns:a16="http://schemas.microsoft.com/office/drawing/2014/main" id="{07B61820-1126-4C07-973F-AE7693954581}"/>
+                <a16:creationId xmlns:a16="http://schemas.microsoft.com/office/drawing/2014/main" id="{7219BEBB-FEF4-47D4-855C-29C1659215A4}"/>
               </a:ext>
             </a:extLst>
           </p:cNvPr>
@@ -2054,10 +2054,10 @@
           <p:nvPr/>
         </p:nvPicPr>
         <p:blipFill>
-          <a:blip xmlns:r="http://schemas.openxmlformats.org/officeDocument/2006/relationships" xmlns:a="http://schemas.openxmlformats.org/drawingml/2006/main" r:embed="Rfdc9aae806bd4fe3">
+          <a:blip xmlns:r="http://schemas.openxmlformats.org/officeDocument/2006/relationships" xmlns:a="http://schemas.openxmlformats.org/drawingml/2006/main" r:embed="R4085866cc6394932">
             <a:extLst>
               <a:ext uri="{96DAC541-7B7A-43D3-8B79-37D633B846F1}">
-                <asvg:svgBlip xmlns:asvg="http://schemas.microsoft.com/office/drawing/2016/SVG/main" r:embed="Rddad0cdc9b094aec"/>
+                <asvg:svgBlip xmlns:asvg="http://schemas.microsoft.com/office/drawing/2016/SVG/main" r:embed="Rf7d09dcbd70848ea"/>
               </a:ext>
             </a:extLst>
           </a:blip>
@@ -2078,7 +2078,7 @@
           <p:cNvPr id="10" name="">
             <a:extLst xmlns:a="http://schemas.openxmlformats.org/drawingml/2006/main">
               <a:ext uri="{FF2B5EF4-FFF2-40B4-BE49-F238E27FC236}">
-                <a16:creationId xmlns:a16="http://schemas.microsoft.com/office/drawing/2014/main" id="{C4FF6878-A9A4-4A03-9E1D-4C10FC31C25B}"/>
+                <a16:creationId xmlns:a16="http://schemas.microsoft.com/office/drawing/2014/main" id="{C29769C2-3D61-453A-8BFA-D90ED20EA1CF}"/>
               </a:ext>
             </a:extLst>
           </p:cNvPr>
@@ -2139,10 +2139,10 @@
           <p:nvPr/>
         </p:nvPicPr>
         <p:blipFill>
-          <a:blip xmlns:r="http://schemas.openxmlformats.org/officeDocument/2006/relationships" xmlns:a="http://schemas.openxmlformats.org/drawingml/2006/main" r:embed="R5ca6705bbcc54b2b">
+          <a:blip xmlns:r="http://schemas.openxmlformats.org/officeDocument/2006/relationships" xmlns:a="http://schemas.openxmlformats.org/drawingml/2006/main" r:embed="R5183929d14624f4e">
             <a:extLst>
               <a:ext uri="{96DAC541-7B7A-43D3-8B79-37D633B846F1}">
-                <asvg:svgBlip xmlns:asvg="http://schemas.microsoft.com/office/drawing/2016/SVG/main" r:embed="R4dacd9282b4740ea"/>
+                <asvg:svgBlip xmlns:asvg="http://schemas.microsoft.com/office/drawing/2016/SVG/main" r:embed="Rae72bd700a90428a"/>
               </a:ext>
             </a:extLst>
           </a:blip>
@@ -2163,7 +2163,7 @@
           <p:cNvPr id="12" name="">
             <a:extLst xmlns:a="http://schemas.openxmlformats.org/drawingml/2006/main">
               <a:ext uri="{FF2B5EF4-FFF2-40B4-BE49-F238E27FC236}">
-                <a16:creationId xmlns:a16="http://schemas.microsoft.com/office/drawing/2014/main" id="{9983BA6D-FE4C-4CB2-820F-B99C0571F58E}"/>
+                <a16:creationId xmlns:a16="http://schemas.microsoft.com/office/drawing/2014/main" id="{3C0C0A31-FAA3-48D8-BD00-E044DF778829}"/>
               </a:ext>
             </a:extLst>
           </p:cNvPr>
@@ -2218,7 +2218,7 @@
     </p:spTree>
     <p:extLst>
       <p:ext uri="{BB962C8B-B14F-4D97-AF65-F5344CB8AC3E}">
-        <p14:creationId xmlns:p14="http://schemas.microsoft.com/office/powerpoint/2010/main" val="1546865354"/>
+        <p14:creationId xmlns:p14="http://schemas.microsoft.com/office/powerpoint/2010/main" val="1951787983"/>
       </p:ext>
     </p:extLst>
   </p:cSld>
@@ -2249,7 +2249,7 @@
           <p:cNvPr id="14" name="">
             <a:extLst xmlns:a="http://schemas.openxmlformats.org/drawingml/2006/main">
               <a:ext uri="{FF2B5EF4-FFF2-40B4-BE49-F238E27FC236}">
-                <a16:creationId xmlns:a16="http://schemas.microsoft.com/office/drawing/2014/main" id="{9D17FDE0-DE93-4B38-B1DD-1438F47F9CEC}"/>
+                <a16:creationId xmlns:a16="http://schemas.microsoft.com/office/drawing/2014/main" id="{4CE28580-55F0-4E86-8D32-0539EA6C71AE}"/>
               </a:ext>
             </a:extLst>
           </p:cNvPr>
@@ -2279,7 +2279,7 @@
           <p:cNvPr id="2" name="">
             <a:extLst xmlns:a="http://schemas.openxmlformats.org/drawingml/2006/main">
               <a:ext uri="{FF2B5EF4-FFF2-40B4-BE49-F238E27FC236}">
-                <a16:creationId xmlns:a16="http://schemas.microsoft.com/office/drawing/2014/main" id="{1DB7CFE1-9420-4AAA-8B6C-314AAEDD222D}"/>
+                <a16:creationId xmlns:a16="http://schemas.microsoft.com/office/drawing/2014/main" id="{710177CE-6D62-4588-A18A-908A62A54B8E}"/>
               </a:ext>
             </a:extLst>
           </p:cNvPr>
@@ -2309,7 +2309,7 @@
           <p:cNvPr id="3" name="">
             <a:extLst xmlns:a="http://schemas.openxmlformats.org/drawingml/2006/main">
               <a:ext uri="{FF2B5EF4-FFF2-40B4-BE49-F238E27FC236}">
-                <a16:creationId xmlns:a16="http://schemas.microsoft.com/office/drawing/2014/main" id="{AC41EE28-ED68-4685-A6DA-E2D885C44B8D}"/>
+                <a16:creationId xmlns:a16="http://schemas.microsoft.com/office/drawing/2014/main" id="{2D0EC8CF-6AA3-4976-A070-15ACA464C183}"/>
               </a:ext>
             </a:extLst>
           </p:cNvPr>
@@ -2366,7 +2366,7 @@
           <p:cNvPr id="4" name="">
             <a:extLst xmlns:a="http://schemas.openxmlformats.org/drawingml/2006/main">
               <a:ext uri="{FF2B5EF4-FFF2-40B4-BE49-F238E27FC236}">
-                <a16:creationId xmlns:a16="http://schemas.microsoft.com/office/drawing/2014/main" id="{5934E892-828D-4889-ABA6-0EBBD475FCEF}"/>
+                <a16:creationId xmlns:a16="http://schemas.microsoft.com/office/drawing/2014/main" id="{A3CB1191-62DB-4540-8E96-9E71C15641E6}"/>
               </a:ext>
             </a:extLst>
           </p:cNvPr>
@@ -2423,7 +2423,7 @@
           <p:cNvPr id="5" name="">
             <a:extLst xmlns:a="http://schemas.openxmlformats.org/drawingml/2006/main">
               <a:ext uri="{FF2B5EF4-FFF2-40B4-BE49-F238E27FC236}">
-                <a16:creationId xmlns:a16="http://schemas.microsoft.com/office/drawing/2014/main" id="{89C5C6E0-4AB8-49DA-95A6-6C6BEA247BFB}"/>
+                <a16:creationId xmlns:a16="http://schemas.microsoft.com/office/drawing/2014/main" id="{8651A99C-C8EF-41B9-ACE2-8556088234A3}"/>
               </a:ext>
             </a:extLst>
           </p:cNvPr>
@@ -2453,7 +2453,7 @@
           <p:cNvPr id="6" name="">
             <a:extLst xmlns:a="http://schemas.openxmlformats.org/drawingml/2006/main">
               <a:ext uri="{FF2B5EF4-FFF2-40B4-BE49-F238E27FC236}">
-                <a16:creationId xmlns:a16="http://schemas.microsoft.com/office/drawing/2014/main" id="{5067A5BA-2C74-4489-85C1-CEB8443A2059}"/>
+                <a16:creationId xmlns:a16="http://schemas.microsoft.com/office/drawing/2014/main" id="{DF21E0C5-9B37-40F0-9D95-87C7F4488F07}"/>
               </a:ext>
             </a:extLst>
           </p:cNvPr>
@@ -2510,7 +2510,7 @@
           <p:cNvPr id="7" name="">
             <a:extLst xmlns:a="http://schemas.openxmlformats.org/drawingml/2006/main">
               <a:ext uri="{FF2B5EF4-FFF2-40B4-BE49-F238E27FC236}">
-                <a16:creationId xmlns:a16="http://schemas.microsoft.com/office/drawing/2014/main" id="{0B97E78B-831A-4D94-952C-2234D8B3D4BF}"/>
+                <a16:creationId xmlns:a16="http://schemas.microsoft.com/office/drawing/2014/main" id="{A42E56B1-AF3D-4FD3-B93D-F89992305FA6}"/>
               </a:ext>
             </a:extLst>
           </p:cNvPr>
@@ -2567,7 +2567,7 @@
           <p:cNvPr id="8" name="">
             <a:extLst xmlns:a="http://schemas.openxmlformats.org/drawingml/2006/main">
               <a:ext uri="{FF2B5EF4-FFF2-40B4-BE49-F238E27FC236}">
-                <a16:creationId xmlns:a16="http://schemas.microsoft.com/office/drawing/2014/main" id="{150F5ADE-C44F-44FE-AC51-499A0BD5C798}"/>
+                <a16:creationId xmlns:a16="http://schemas.microsoft.com/office/drawing/2014/main" id="{E53B1680-9DA3-4E0D-B369-164AF2046E1D}"/>
               </a:ext>
             </a:extLst>
           </p:cNvPr>
@@ -2597,7 +2597,7 @@
           <p:cNvPr id="9" name="">
             <a:extLst xmlns:a="http://schemas.openxmlformats.org/drawingml/2006/main">
               <a:ext uri="{FF2B5EF4-FFF2-40B4-BE49-F238E27FC236}">
-                <a16:creationId xmlns:a16="http://schemas.microsoft.com/office/drawing/2014/main" id="{20745556-7260-44FA-9E0F-A0175E394708}"/>
+                <a16:creationId xmlns:a16="http://schemas.microsoft.com/office/drawing/2014/main" id="{14EB610A-268D-44A7-9344-E0D7621E8F47}"/>
               </a:ext>
             </a:extLst>
           </p:cNvPr>
@@ -2654,7 +2654,7 @@
           <p:cNvPr id="10" name="">
             <a:extLst xmlns:a="http://schemas.openxmlformats.org/drawingml/2006/main">
               <a:ext uri="{FF2B5EF4-FFF2-40B4-BE49-F238E27FC236}">
-                <a16:creationId xmlns:a16="http://schemas.microsoft.com/office/drawing/2014/main" id="{DA919A34-9F5E-4BB7-AF68-0FB8AC370F74}"/>
+                <a16:creationId xmlns:a16="http://schemas.microsoft.com/office/drawing/2014/main" id="{52853883-959D-4D49-B9C6-9B1C89103130}"/>
               </a:ext>
             </a:extLst>
           </p:cNvPr>
@@ -2711,7 +2711,7 @@
           <p:cNvPr id="11" name="">
             <a:extLst xmlns:a="http://schemas.openxmlformats.org/drawingml/2006/main">
               <a:ext uri="{FF2B5EF4-FFF2-40B4-BE49-F238E27FC236}">
-                <a16:creationId xmlns:a16="http://schemas.microsoft.com/office/drawing/2014/main" id="{30857C27-8A6F-4F81-8DB5-F96E6A317200}"/>
+                <a16:creationId xmlns:a16="http://schemas.microsoft.com/office/drawing/2014/main" id="{5E0D0DC6-3AE4-44C2-B896-5CC325785649}"/>
               </a:ext>
             </a:extLst>
           </p:cNvPr>
@@ -2741,7 +2741,7 @@
           <p:cNvPr id="12" name="">
             <a:extLst xmlns:a="http://schemas.openxmlformats.org/drawingml/2006/main">
               <a:ext uri="{FF2B5EF4-FFF2-40B4-BE49-F238E27FC236}">
-                <a16:creationId xmlns:a16="http://schemas.microsoft.com/office/drawing/2014/main" id="{7336E57D-F7A2-49E9-8E8C-7EC2AE51C6B8}"/>
+                <a16:creationId xmlns:a16="http://schemas.microsoft.com/office/drawing/2014/main" id="{575F035D-3108-4025-9D80-1686C4C84F42}"/>
               </a:ext>
             </a:extLst>
           </p:cNvPr>
@@ -2798,7 +2798,7 @@
           <p:cNvPr id="13" name="">
             <a:extLst xmlns:a="http://schemas.openxmlformats.org/drawingml/2006/main">
               <a:ext uri="{FF2B5EF4-FFF2-40B4-BE49-F238E27FC236}">
-                <a16:creationId xmlns:a16="http://schemas.microsoft.com/office/drawing/2014/main" id="{E5D2ED97-7855-4F77-9401-891C939910FF}"/>
+                <a16:creationId xmlns:a16="http://schemas.microsoft.com/office/drawing/2014/main" id="{1E453731-7537-414D-89B1-79422F46EC79}"/>
               </a:ext>
             </a:extLst>
           </p:cNvPr>
@@ -2853,7 +2853,7 @@
     </p:spTree>
     <p:extLst>
       <p:ext uri="{BB962C8B-B14F-4D97-AF65-F5344CB8AC3E}">
-        <p14:creationId xmlns:p14="http://schemas.microsoft.com/office/powerpoint/2010/main" val="1448974078"/>
+        <p14:creationId xmlns:p14="http://schemas.microsoft.com/office/powerpoint/2010/main" val="1603232118"/>
       </p:ext>
     </p:extLst>
   </p:cSld>
@@ -2884,7 +2884,7 @@
           <p:cNvPr id="13" name="">
             <a:extLst xmlns:a="http://schemas.openxmlformats.org/drawingml/2006/main">
               <a:ext uri="{FF2B5EF4-FFF2-40B4-BE49-F238E27FC236}">
-                <a16:creationId xmlns:a16="http://schemas.microsoft.com/office/drawing/2014/main" id="{994D5E81-C0DE-4027-82D2-EE5450D82620}"/>
+                <a16:creationId xmlns:a16="http://schemas.microsoft.com/office/drawing/2014/main" id="{F518C648-380A-456B-9402-232EAD8B1038}"/>
               </a:ext>
             </a:extLst>
           </p:cNvPr>
@@ -2914,7 +2914,7 @@
           <p:cNvPr id="2" name="">
             <a:extLst xmlns:a="http://schemas.openxmlformats.org/drawingml/2006/main">
               <a:ext uri="{FF2B5EF4-FFF2-40B4-BE49-F238E27FC236}">
-                <a16:creationId xmlns:a16="http://schemas.microsoft.com/office/drawing/2014/main" id="{D937CD2A-6A5C-4AF4-86BE-357C36879D85}"/>
+                <a16:creationId xmlns:a16="http://schemas.microsoft.com/office/drawing/2014/main" id="{308C63F1-24B9-4A9B-AA86-22BF25CC369C}"/>
               </a:ext>
             </a:extLst>
           </p:cNvPr>
@@ -2946,7 +2946,7 @@
           <p:cNvPr id="3" name="">
             <a:extLst xmlns:a="http://schemas.openxmlformats.org/drawingml/2006/main">
               <a:ext uri="{FF2B5EF4-FFF2-40B4-BE49-F238E27FC236}">
-                <a16:creationId xmlns:a16="http://schemas.microsoft.com/office/drawing/2014/main" id="{F484B090-EC82-4E34-824B-6FF099DA40EB}"/>
+                <a16:creationId xmlns:a16="http://schemas.microsoft.com/office/drawing/2014/main" id="{8E2AB6ED-1625-4DE1-8BC0-DC13A1648093}"/>
               </a:ext>
             </a:extLst>
           </p:cNvPr>
@@ -2978,7 +2978,7 @@
           <p:cNvPr id="4" name="">
             <a:extLst xmlns:a="http://schemas.openxmlformats.org/drawingml/2006/main">
               <a:ext uri="{FF2B5EF4-FFF2-40B4-BE49-F238E27FC236}">
-                <a16:creationId xmlns:a16="http://schemas.microsoft.com/office/drawing/2014/main" id="{67530C3E-C18A-4DF2-946C-F6860C9E6E72}"/>
+                <a16:creationId xmlns:a16="http://schemas.microsoft.com/office/drawing/2014/main" id="{1D7C477C-5E89-4E9E-8F91-06B6130C1EA5}"/>
               </a:ext>
             </a:extLst>
           </p:cNvPr>
@@ -3010,7 +3010,7 @@
           <p:cNvPr id="5" name="">
             <a:extLst xmlns:a="http://schemas.openxmlformats.org/drawingml/2006/main">
               <a:ext uri="{FF2B5EF4-FFF2-40B4-BE49-F238E27FC236}">
-                <a16:creationId xmlns:a16="http://schemas.microsoft.com/office/drawing/2014/main" id="{2916447C-ADED-4D78-8A10-FE10B9A87DAF}"/>
+                <a16:creationId xmlns:a16="http://schemas.microsoft.com/office/drawing/2014/main" id="{D36F2A7C-AFFC-4013-9E9B-060D23069E5F}"/>
               </a:ext>
             </a:extLst>
           </p:cNvPr>
@@ -3042,7 +3042,7 @@
           <p:cNvPr id="6" name="">
             <a:extLst xmlns:a="http://schemas.openxmlformats.org/drawingml/2006/main">
               <a:ext uri="{FF2B5EF4-FFF2-40B4-BE49-F238E27FC236}">
-                <a16:creationId xmlns:a16="http://schemas.microsoft.com/office/drawing/2014/main" id="{EEEAFC96-98DB-40B4-8600-84FEBFB4F50D}"/>
+                <a16:creationId xmlns:a16="http://schemas.microsoft.com/office/drawing/2014/main" id="{42CF526B-563D-4926-9E8D-257D16049A47}"/>
               </a:ext>
             </a:extLst>
           </p:cNvPr>
@@ -3074,7 +3074,7 @@
           <p:cNvPr id="7" name="">
             <a:extLst xmlns:a="http://schemas.openxmlformats.org/drawingml/2006/main">
               <a:ext uri="{FF2B5EF4-FFF2-40B4-BE49-F238E27FC236}">
-                <a16:creationId xmlns:a16="http://schemas.microsoft.com/office/drawing/2014/main" id="{E314FD08-E4FC-4A12-A3C2-171DE145E04B}"/>
+                <a16:creationId xmlns:a16="http://schemas.microsoft.com/office/drawing/2014/main" id="{4DB56FAF-9252-4DFD-8B11-485D272FBC39}"/>
               </a:ext>
             </a:extLst>
           </p:cNvPr>
@@ -3106,7 +3106,7 @@
           <p:cNvPr id="8" name="">
             <a:extLst xmlns:a="http://schemas.openxmlformats.org/drawingml/2006/main">
               <a:ext uri="{FF2B5EF4-FFF2-40B4-BE49-F238E27FC236}">
-                <a16:creationId xmlns:a16="http://schemas.microsoft.com/office/drawing/2014/main" id="{5FDF7C22-E335-423D-AA87-22B63BC73792}"/>
+                <a16:creationId xmlns:a16="http://schemas.microsoft.com/office/drawing/2014/main" id="{5FF6DB32-FB21-441B-AC01-BAC35CF8DB95}"/>
               </a:ext>
             </a:extLst>
           </p:cNvPr>
@@ -3167,10 +3167,10 @@
           <p:nvPr/>
         </p:nvPicPr>
         <p:blipFill>
-          <a:blip xmlns:r="http://schemas.openxmlformats.org/officeDocument/2006/relationships" xmlns:a="http://schemas.openxmlformats.org/drawingml/2006/main" r:embed="R9ee00347852749d1">
+          <a:blip xmlns:r="http://schemas.openxmlformats.org/officeDocument/2006/relationships" xmlns:a="http://schemas.openxmlformats.org/drawingml/2006/main" r:embed="Rde4072d19595413b">
             <a:extLst>
               <a:ext uri="{96DAC541-7B7A-43D3-8B79-37D633B846F1}">
-                <asvg:svgBlip xmlns:asvg="http://schemas.microsoft.com/office/drawing/2016/SVG/main" r:embed="R29d12d91d3c64edc"/>
+                <asvg:svgBlip xmlns:asvg="http://schemas.microsoft.com/office/drawing/2016/SVG/main" r:embed="R05bfff9ca2d94e49"/>
               </a:ext>
             </a:extLst>
           </a:blip>
@@ -3191,7 +3191,7 @@
           <p:cNvPr id="10" name="">
             <a:extLst xmlns:a="http://schemas.openxmlformats.org/drawingml/2006/main">
               <a:ext uri="{FF2B5EF4-FFF2-40B4-BE49-F238E27FC236}">
-                <a16:creationId xmlns:a16="http://schemas.microsoft.com/office/drawing/2014/main" id="{A35A2715-E84F-42AD-A2BF-68E66FC5C6B9}"/>
+                <a16:creationId xmlns:a16="http://schemas.microsoft.com/office/drawing/2014/main" id="{87066154-D158-4B97-B1A7-C0ECD0566A57}"/>
               </a:ext>
             </a:extLst>
           </p:cNvPr>
@@ -3252,10 +3252,10 @@
           <p:nvPr/>
         </p:nvPicPr>
         <p:blipFill>
-          <a:blip xmlns:r="http://schemas.openxmlformats.org/officeDocument/2006/relationships" xmlns:a="http://schemas.openxmlformats.org/drawingml/2006/main" r:embed="R5c2601538f4942be">
+          <a:blip xmlns:r="http://schemas.openxmlformats.org/officeDocument/2006/relationships" xmlns:a="http://schemas.openxmlformats.org/drawingml/2006/main" r:embed="R08e0a8f4b18e40aa">
             <a:extLst>
               <a:ext uri="{96DAC541-7B7A-43D3-8B79-37D633B846F1}">
-                <asvg:svgBlip xmlns:asvg="http://schemas.microsoft.com/office/drawing/2016/SVG/main" r:embed="R9474024c5fa046e8"/>
+                <asvg:svgBlip xmlns:asvg="http://schemas.microsoft.com/office/drawing/2016/SVG/main" r:embed="R2d24a3aee0ad44bd"/>
               </a:ext>
             </a:extLst>
           </a:blip>
@@ -3276,7 +3276,7 @@
           <p:cNvPr id="12" name="">
             <a:extLst xmlns:a="http://schemas.openxmlformats.org/drawingml/2006/main">
               <a:ext uri="{FF2B5EF4-FFF2-40B4-BE49-F238E27FC236}">
-                <a16:creationId xmlns:a16="http://schemas.microsoft.com/office/drawing/2014/main" id="{346BD9D8-5C66-4C4D-A998-7701DDCDA05B}"/>
+                <a16:creationId xmlns:a16="http://schemas.microsoft.com/office/drawing/2014/main" id="{49936FED-8C68-4D9F-B700-3ECE233F6C08}"/>
               </a:ext>
             </a:extLst>
           </p:cNvPr>
@@ -3331,7 +3331,7 @@
     </p:spTree>
     <p:extLst>
       <p:ext uri="{BB962C8B-B14F-4D97-AF65-F5344CB8AC3E}">
-        <p14:creationId xmlns:p14="http://schemas.microsoft.com/office/powerpoint/2010/main" val="184421856"/>
+        <p14:creationId xmlns:p14="http://schemas.microsoft.com/office/powerpoint/2010/main" val="245796545"/>
       </p:ext>
     </p:extLst>
   </p:cSld>
@@ -3362,7 +3362,7 @@
           <p:cNvPr id="12" name="">
             <a:extLst xmlns:a="http://schemas.openxmlformats.org/drawingml/2006/main">
               <a:ext uri="{FF2B5EF4-FFF2-40B4-BE49-F238E27FC236}">
-                <a16:creationId xmlns:a16="http://schemas.microsoft.com/office/drawing/2014/main" id="{AA7EF225-F3C0-4F07-A74D-586E165B96B5}"/>
+                <a16:creationId xmlns:a16="http://schemas.microsoft.com/office/drawing/2014/main" id="{B244C56A-BCDA-4A54-AD57-EEB6A1749DEA}"/>
               </a:ext>
             </a:extLst>
           </p:cNvPr>
@@ -3392,7 +3392,7 @@
           <p:cNvPr id="2" name="">
             <a:extLst xmlns:a="http://schemas.openxmlformats.org/drawingml/2006/main">
               <a:ext uri="{FF2B5EF4-FFF2-40B4-BE49-F238E27FC236}">
-                <a16:creationId xmlns:a16="http://schemas.microsoft.com/office/drawing/2014/main" id="{25FAA2EF-643A-4FF4-82DA-3C715E1FA13E}"/>
+                <a16:creationId xmlns:a16="http://schemas.microsoft.com/office/drawing/2014/main" id="{E086B023-EF2D-4602-9BC0-021C0F0F66FA}"/>
               </a:ext>
             </a:extLst>
           </p:cNvPr>
@@ -3449,7 +3449,7 @@
           <p:cNvPr id="3" name="">
             <a:extLst xmlns:a="http://schemas.openxmlformats.org/drawingml/2006/main">
               <a:ext uri="{FF2B5EF4-FFF2-40B4-BE49-F238E27FC236}">
-                <a16:creationId xmlns:a16="http://schemas.microsoft.com/office/drawing/2014/main" id="{C2BABE0F-B79C-4F02-AA6D-0104CADAD362}"/>
+                <a16:creationId xmlns:a16="http://schemas.microsoft.com/office/drawing/2014/main" id="{D2F8F6DF-00AF-4274-99BA-E19418FA4595}"/>
               </a:ext>
             </a:extLst>
           </p:cNvPr>
@@ -3479,7 +3479,7 @@
           <p:cNvPr id="4" name="">
             <a:extLst xmlns:a="http://schemas.openxmlformats.org/drawingml/2006/main">
               <a:ext uri="{FF2B5EF4-FFF2-40B4-BE49-F238E27FC236}">
-                <a16:creationId xmlns:a16="http://schemas.microsoft.com/office/drawing/2014/main" id="{16B45270-405D-4BE5-B540-E05860119904}"/>
+                <a16:creationId xmlns:a16="http://schemas.microsoft.com/office/drawing/2014/main" id="{DE79D4D7-8A46-49CA-BF60-AF25DD52E9E5}"/>
               </a:ext>
             </a:extLst>
           </p:cNvPr>
@@ -3509,7 +3509,7 @@
           <p:cNvPr id="5" name="">
             <a:extLst xmlns:a="http://schemas.openxmlformats.org/drawingml/2006/main">
               <a:ext uri="{FF2B5EF4-FFF2-40B4-BE49-F238E27FC236}">
-                <a16:creationId xmlns:a16="http://schemas.microsoft.com/office/drawing/2014/main" id="{F08D2999-EFD5-429D-8EA3-CC8F42A5E089}"/>
+                <a16:creationId xmlns:a16="http://schemas.microsoft.com/office/drawing/2014/main" id="{E5DCFBE9-93D7-408B-BC4B-4CBB7F010BD1}"/>
               </a:ext>
             </a:extLst>
           </p:cNvPr>
@@ -3566,7 +3566,7 @@
           <p:cNvPr id="6" name="">
             <a:extLst xmlns:a="http://schemas.openxmlformats.org/drawingml/2006/main">
               <a:ext uri="{FF2B5EF4-FFF2-40B4-BE49-F238E27FC236}">
-                <a16:creationId xmlns:a16="http://schemas.microsoft.com/office/drawing/2014/main" id="{CA020110-ECCD-4E51-87AC-A141AAB30468}"/>
+                <a16:creationId xmlns:a16="http://schemas.microsoft.com/office/drawing/2014/main" id="{A0D7576E-E807-4499-9950-AB761013747B}"/>
               </a:ext>
             </a:extLst>
           </p:cNvPr>
@@ -3623,7 +3623,7 @@
           <p:cNvPr id="7" name="">
             <a:extLst xmlns:a="http://schemas.openxmlformats.org/drawingml/2006/main">
               <a:ext uri="{FF2B5EF4-FFF2-40B4-BE49-F238E27FC236}">
-                <a16:creationId xmlns:a16="http://schemas.microsoft.com/office/drawing/2014/main" id="{C671558C-3A3A-48AE-A292-0A5073247F52}"/>
+                <a16:creationId xmlns:a16="http://schemas.microsoft.com/office/drawing/2014/main" id="{44439932-FF4F-428B-8E32-1CADE2B2DFF2}"/>
               </a:ext>
             </a:extLst>
           </p:cNvPr>
@@ -3680,7 +3680,7 @@
           <p:cNvPr id="8" name="">
             <a:extLst xmlns:a="http://schemas.openxmlformats.org/drawingml/2006/main">
               <a:ext uri="{FF2B5EF4-FFF2-40B4-BE49-F238E27FC236}">
-                <a16:creationId xmlns:a16="http://schemas.microsoft.com/office/drawing/2014/main" id="{8EF6658B-54B2-4C77-A4DB-98A0B4B4C32F}"/>
+                <a16:creationId xmlns:a16="http://schemas.microsoft.com/office/drawing/2014/main" id="{0F7A1118-2DF9-4576-B641-6D3021800BCA}"/>
               </a:ext>
             </a:extLst>
           </p:cNvPr>
@@ -3737,7 +3737,7 @@
           <p:cNvPr id="9" name="">
             <a:extLst xmlns:a="http://schemas.openxmlformats.org/drawingml/2006/main">
               <a:ext uri="{FF2B5EF4-FFF2-40B4-BE49-F238E27FC236}">
-                <a16:creationId xmlns:a16="http://schemas.microsoft.com/office/drawing/2014/main" id="{ACE8D104-ABE9-4FF4-B2A7-8C789E96E561}"/>
+                <a16:creationId xmlns:a16="http://schemas.microsoft.com/office/drawing/2014/main" id="{FA5AD089-84F3-4525-9FC1-9CDC22C3D0EB}"/>
               </a:ext>
             </a:extLst>
           </p:cNvPr>
@@ -3767,7 +3767,7 @@
           <p:cNvPr id="10" name="">
             <a:extLst xmlns:a="http://schemas.openxmlformats.org/drawingml/2006/main">
               <a:ext uri="{FF2B5EF4-FFF2-40B4-BE49-F238E27FC236}">
-                <a16:creationId xmlns:a16="http://schemas.microsoft.com/office/drawing/2014/main" id="{8097D2FF-5758-4608-A8DC-6D5E3A8C04A3}"/>
+                <a16:creationId xmlns:a16="http://schemas.microsoft.com/office/drawing/2014/main" id="{5302CB5A-361A-47BC-B0D4-D4A1210A0BFD}"/>
               </a:ext>
             </a:extLst>
           </p:cNvPr>
@@ -3824,7 +3824,7 @@
           <p:cNvPr id="11" name="">
             <a:extLst xmlns:a="http://schemas.openxmlformats.org/drawingml/2006/main">
               <a:ext uri="{FF2B5EF4-FFF2-40B4-BE49-F238E27FC236}">
-                <a16:creationId xmlns:a16="http://schemas.microsoft.com/office/drawing/2014/main" id="{5B15479E-A96E-4B9D-88F8-B4310F32C301}"/>
+                <a16:creationId xmlns:a16="http://schemas.microsoft.com/office/drawing/2014/main" id="{F4BA769B-0C43-40EA-909F-B4997F426731}"/>
               </a:ext>
             </a:extLst>
           </p:cNvPr>
@@ -3879,7 +3879,7 @@
     </p:spTree>
     <p:extLst>
       <p:ext uri="{BB962C8B-B14F-4D97-AF65-F5344CB8AC3E}">
-        <p14:creationId xmlns:p14="http://schemas.microsoft.com/office/powerpoint/2010/main" val="1888624232"/>
+        <p14:creationId xmlns:p14="http://schemas.microsoft.com/office/powerpoint/2010/main" val="581602899"/>
       </p:ext>
     </p:extLst>
   </p:cSld>
@@ -3910,7 +3910,7 @@
           <p:cNvPr id="14" name="">
             <a:extLst xmlns:a="http://schemas.openxmlformats.org/drawingml/2006/main">
               <a:ext uri="{FF2B5EF4-FFF2-40B4-BE49-F238E27FC236}">
-                <a16:creationId xmlns:a16="http://schemas.microsoft.com/office/drawing/2014/main" id="{8FFC9BE1-FCE7-490A-A7FA-7C48BE85E104}"/>
+                <a16:creationId xmlns:a16="http://schemas.microsoft.com/office/drawing/2014/main" id="{9EBE5FB4-B0D0-4FBC-AB2B-EF94BDAE2391}"/>
               </a:ext>
             </a:extLst>
           </p:cNvPr>
@@ -3940,7 +3940,7 @@
           <p:cNvPr id="2" name="">
             <a:extLst xmlns:a="http://schemas.openxmlformats.org/drawingml/2006/main">
               <a:ext uri="{FF2B5EF4-FFF2-40B4-BE49-F238E27FC236}">
-                <a16:creationId xmlns:a16="http://schemas.microsoft.com/office/drawing/2014/main" id="{3DF4E84F-2802-4949-8D05-07548DCA7773}"/>
+                <a16:creationId xmlns:a16="http://schemas.microsoft.com/office/drawing/2014/main" id="{E468C9C1-22D7-4AC6-855A-6BA4A4EB1D14}"/>
               </a:ext>
             </a:extLst>
           </p:cNvPr>
@@ -3997,7 +3997,7 @@
           <p:cNvPr id="3" name="">
             <a:extLst xmlns:a="http://schemas.openxmlformats.org/drawingml/2006/main">
               <a:ext uri="{FF2B5EF4-FFF2-40B4-BE49-F238E27FC236}">
-                <a16:creationId xmlns:a16="http://schemas.microsoft.com/office/drawing/2014/main" id="{F3EEADC2-4813-4468-86CD-18AA9E2AC67F}"/>
+                <a16:creationId xmlns:a16="http://schemas.microsoft.com/office/drawing/2014/main" id="{B6ED0B84-B2D6-4ACD-89C5-4B252D8C89A9}"/>
               </a:ext>
             </a:extLst>
           </p:cNvPr>
@@ -4027,7 +4027,7 @@
           <p:cNvPr id="4" name="">
             <a:extLst xmlns:a="http://schemas.openxmlformats.org/drawingml/2006/main">
               <a:ext uri="{FF2B5EF4-FFF2-40B4-BE49-F238E27FC236}">
-                <a16:creationId xmlns:a16="http://schemas.microsoft.com/office/drawing/2014/main" id="{9486458A-A60C-489F-B928-6C4F81D3DDAE}"/>
+                <a16:creationId xmlns:a16="http://schemas.microsoft.com/office/drawing/2014/main" id="{F40F9326-F4D2-40E2-ADF1-9636948E7DC6}"/>
               </a:ext>
             </a:extLst>
           </p:cNvPr>
@@ -4057,7 +4057,7 @@
           <p:cNvPr id="5" name="">
             <a:extLst xmlns:a="http://schemas.openxmlformats.org/drawingml/2006/main">
               <a:ext uri="{FF2B5EF4-FFF2-40B4-BE49-F238E27FC236}">
-                <a16:creationId xmlns:a16="http://schemas.microsoft.com/office/drawing/2014/main" id="{48D0B65E-B09F-45D5-B040-30A3E3FEEF80}"/>
+                <a16:creationId xmlns:a16="http://schemas.microsoft.com/office/drawing/2014/main" id="{D718BBE7-B71C-4D42-A7BC-52CC5D7AE4B0}"/>
               </a:ext>
             </a:extLst>
           </p:cNvPr>
@@ -4114,7 +4114,7 @@
           <p:cNvPr id="6" name="">
             <a:extLst xmlns:a="http://schemas.openxmlformats.org/drawingml/2006/main">
               <a:ext uri="{FF2B5EF4-FFF2-40B4-BE49-F238E27FC236}">
-                <a16:creationId xmlns:a16="http://schemas.microsoft.com/office/drawing/2014/main" id="{4CE0719B-8133-44F2-B852-F928C1C81A3C}"/>
+                <a16:creationId xmlns:a16="http://schemas.microsoft.com/office/drawing/2014/main" id="{AB38A1E6-2B9E-4849-819B-BAE3FD67C2CC}"/>
               </a:ext>
             </a:extLst>
           </p:cNvPr>
@@ -4146,7 +4146,7 @@
           <p:cNvPr id="7" name="">
             <a:extLst xmlns:a="http://schemas.openxmlformats.org/drawingml/2006/main">
               <a:ext uri="{FF2B5EF4-FFF2-40B4-BE49-F238E27FC236}">
-                <a16:creationId xmlns:a16="http://schemas.microsoft.com/office/drawing/2014/main" id="{2430DF6C-6DE5-4A97-B347-BC76129F133C}"/>
+                <a16:creationId xmlns:a16="http://schemas.microsoft.com/office/drawing/2014/main" id="{E6FA7809-BF85-4D0F-AA8A-21A0F1F1113E}"/>
               </a:ext>
             </a:extLst>
           </p:cNvPr>
@@ -4203,7 +4203,7 @@
           <p:cNvPr id="8" name="">
             <a:extLst xmlns:a="http://schemas.openxmlformats.org/drawingml/2006/main">
               <a:ext uri="{FF2B5EF4-FFF2-40B4-BE49-F238E27FC236}">
-                <a16:creationId xmlns:a16="http://schemas.microsoft.com/office/drawing/2014/main" id="{34FD10DA-73F8-46F7-A38F-A8F75D931D89}"/>
+                <a16:creationId xmlns:a16="http://schemas.microsoft.com/office/drawing/2014/main" id="{F3AA1430-C68F-4E22-9D8D-9E7DD4346E9D}"/>
               </a:ext>
             </a:extLst>
           </p:cNvPr>
@@ -4260,7 +4260,7 @@
           <p:cNvPr id="9" name="">
             <a:extLst xmlns:a="http://schemas.openxmlformats.org/drawingml/2006/main">
               <a:ext uri="{FF2B5EF4-FFF2-40B4-BE49-F238E27FC236}">
-                <a16:creationId xmlns:a16="http://schemas.microsoft.com/office/drawing/2014/main" id="{2796583A-A6FD-469B-B60E-8A3E7D9F9241}"/>
+                <a16:creationId xmlns:a16="http://schemas.microsoft.com/office/drawing/2014/main" id="{45FC3845-77CC-46EB-9CB0-A7620A27F382}"/>
               </a:ext>
             </a:extLst>
           </p:cNvPr>
@@ -4317,7 +4317,7 @@
           <p:cNvPr id="10" name="">
             <a:extLst xmlns:a="http://schemas.openxmlformats.org/drawingml/2006/main">
               <a:ext uri="{FF2B5EF4-FFF2-40B4-BE49-F238E27FC236}">
-                <a16:creationId xmlns:a16="http://schemas.microsoft.com/office/drawing/2014/main" id="{28A2D5A9-3027-4670-BB90-79698F9EC7A7}"/>
+                <a16:creationId xmlns:a16="http://schemas.microsoft.com/office/drawing/2014/main" id="{1B1CC3DD-AF00-4303-B5E6-062E54A390AF}"/>
               </a:ext>
             </a:extLst>
           </p:cNvPr>
@@ -4374,7 +4374,7 @@
           <p:cNvPr id="11" name="">
             <a:extLst xmlns:a="http://schemas.openxmlformats.org/drawingml/2006/main">
               <a:ext uri="{FF2B5EF4-FFF2-40B4-BE49-F238E27FC236}">
-                <a16:creationId xmlns:a16="http://schemas.microsoft.com/office/drawing/2014/main" id="{76643914-BF3C-4F9B-B5B8-D09D6AA70FC5}"/>
+                <a16:creationId xmlns:a16="http://schemas.microsoft.com/office/drawing/2014/main" id="{1EF47356-C180-4F21-8341-4C79EF37E267}"/>
               </a:ext>
             </a:extLst>
           </p:cNvPr>
@@ -4404,7 +4404,7 @@
           <p:cNvPr id="12" name="">
             <a:extLst xmlns:a="http://schemas.openxmlformats.org/drawingml/2006/main">
               <a:ext uri="{FF2B5EF4-FFF2-40B4-BE49-F238E27FC236}">
-                <a16:creationId xmlns:a16="http://schemas.microsoft.com/office/drawing/2014/main" id="{08936366-A58C-4855-853A-20E84C06859A}"/>
+                <a16:creationId xmlns:a16="http://schemas.microsoft.com/office/drawing/2014/main" id="{8F3F29FF-4A4F-4D18-AF1F-83B041769063}"/>
               </a:ext>
             </a:extLst>
           </p:cNvPr>
@@ -4461,7 +4461,7 @@
           <p:cNvPr id="13" name="">
             <a:extLst xmlns:a="http://schemas.openxmlformats.org/drawingml/2006/main">
               <a:ext uri="{FF2B5EF4-FFF2-40B4-BE49-F238E27FC236}">
-                <a16:creationId xmlns:a16="http://schemas.microsoft.com/office/drawing/2014/main" id="{33D85E1F-3D4B-45EA-9D69-8DB0829BDFF2}"/>
+                <a16:creationId xmlns:a16="http://schemas.microsoft.com/office/drawing/2014/main" id="{ED585119-8B43-4CF7-A8C2-843085E86B53}"/>
               </a:ext>
             </a:extLst>
           </p:cNvPr>
@@ -4516,7 +4516,7 @@
     </p:spTree>
     <p:extLst>
       <p:ext uri="{BB962C8B-B14F-4D97-AF65-F5344CB8AC3E}">
-        <p14:creationId xmlns:p14="http://schemas.microsoft.com/office/powerpoint/2010/main" val="177693260"/>
+        <p14:creationId xmlns:p14="http://schemas.microsoft.com/office/powerpoint/2010/main" val="1133284138"/>
       </p:ext>
     </p:extLst>
   </p:cSld>
@@ -4547,7 +4547,7 @@
           <p:cNvPr id="15" name="">
             <a:extLst xmlns:a="http://schemas.openxmlformats.org/drawingml/2006/main">
               <a:ext uri="{FF2B5EF4-FFF2-40B4-BE49-F238E27FC236}">
-                <a16:creationId xmlns:a16="http://schemas.microsoft.com/office/drawing/2014/main" id="{567898E2-47CD-4CA4-90B7-637F1ED1D5B5}"/>
+                <a16:creationId xmlns:a16="http://schemas.microsoft.com/office/drawing/2014/main" id="{A4256AE5-2E4A-4D14-877C-155CEA4C4568}"/>
               </a:ext>
             </a:extLst>
           </p:cNvPr>
@@ -4577,7 +4577,7 @@
           <p:cNvPr id="2" name="">
             <a:extLst xmlns:a="http://schemas.openxmlformats.org/drawingml/2006/main">
               <a:ext uri="{FF2B5EF4-FFF2-40B4-BE49-F238E27FC236}">
-                <a16:creationId xmlns:a16="http://schemas.microsoft.com/office/drawing/2014/main" id="{6D099AD1-F6C8-4287-B36F-1EC3029118C2}"/>
+                <a16:creationId xmlns:a16="http://schemas.microsoft.com/office/drawing/2014/main" id="{FEEFB7E4-F4EA-4ED6-9087-82F36E225B7E}"/>
               </a:ext>
             </a:extLst>
           </p:cNvPr>
@@ -4634,7 +4634,7 @@
           <p:cNvPr id="3" name="">
             <a:extLst xmlns:a="http://schemas.openxmlformats.org/drawingml/2006/main">
               <a:ext uri="{FF2B5EF4-FFF2-40B4-BE49-F238E27FC236}">
-                <a16:creationId xmlns:a16="http://schemas.microsoft.com/office/drawing/2014/main" id="{928A9C81-D4E9-402C-A16F-7930D70380C9}"/>
+                <a16:creationId xmlns:a16="http://schemas.microsoft.com/office/drawing/2014/main" id="{83D0AA04-62AE-4E48-A84A-FCF69524442E}"/>
               </a:ext>
             </a:extLst>
           </p:cNvPr>
@@ -4664,7 +4664,7 @@
           <p:cNvPr id="4" name="">
             <a:extLst xmlns:a="http://schemas.openxmlformats.org/drawingml/2006/main">
               <a:ext uri="{FF2B5EF4-FFF2-40B4-BE49-F238E27FC236}">
-                <a16:creationId xmlns:a16="http://schemas.microsoft.com/office/drawing/2014/main" id="{0D0D7504-4B55-43C9-B9E1-A4CC89DAF716}"/>
+                <a16:creationId xmlns:a16="http://schemas.microsoft.com/office/drawing/2014/main" id="{7AADDC3D-C565-4538-87C1-93065BF2D972}"/>
               </a:ext>
             </a:extLst>
           </p:cNvPr>
@@ -4694,7 +4694,7 @@
           <p:cNvPr id="5" name="">
             <a:extLst xmlns:a="http://schemas.openxmlformats.org/drawingml/2006/main">
               <a:ext uri="{FF2B5EF4-FFF2-40B4-BE49-F238E27FC236}">
-                <a16:creationId xmlns:a16="http://schemas.microsoft.com/office/drawing/2014/main" id="{62EA545B-1936-44EE-89F3-E1AB2C597D0B}"/>
+                <a16:creationId xmlns:a16="http://schemas.microsoft.com/office/drawing/2014/main" id="{4444F018-F648-44FB-B081-7F8E04A4C086}"/>
               </a:ext>
             </a:extLst>
           </p:cNvPr>
@@ -4751,7 +4751,7 @@
           <p:cNvPr id="6" name="">
             <a:extLst xmlns:a="http://schemas.openxmlformats.org/drawingml/2006/main">
               <a:ext uri="{FF2B5EF4-FFF2-40B4-BE49-F238E27FC236}">
-                <a16:creationId xmlns:a16="http://schemas.microsoft.com/office/drawing/2014/main" id="{0DD1FBD5-A169-4F35-A0A9-8333DC367DAE}"/>
+                <a16:creationId xmlns:a16="http://schemas.microsoft.com/office/drawing/2014/main" id="{206392A7-C160-4A87-8203-509DD2403157}"/>
               </a:ext>
             </a:extLst>
           </p:cNvPr>
@@ -4783,7 +4783,7 @@
           <p:cNvPr id="7" name="">
             <a:extLst xmlns:a="http://schemas.openxmlformats.org/drawingml/2006/main">
               <a:ext uri="{FF2B5EF4-FFF2-40B4-BE49-F238E27FC236}">
-                <a16:creationId xmlns:a16="http://schemas.microsoft.com/office/drawing/2014/main" id="{6DD8DD0B-67F4-4AD5-BE54-A67B8BB541DC}"/>
+                <a16:creationId xmlns:a16="http://schemas.microsoft.com/office/drawing/2014/main" id="{64B84D6B-AA8E-4D2F-9D5A-25393F5E621D}"/>
               </a:ext>
             </a:extLst>
           </p:cNvPr>
@@ -4840,7 +4840,7 @@
           <p:cNvPr id="8" name="">
             <a:extLst xmlns:a="http://schemas.openxmlformats.org/drawingml/2006/main">
               <a:ext uri="{FF2B5EF4-FFF2-40B4-BE49-F238E27FC236}">
-                <a16:creationId xmlns:a16="http://schemas.microsoft.com/office/drawing/2014/main" id="{79B4DD37-A073-41F7-A629-F7223B7F44EE}"/>
+                <a16:creationId xmlns:a16="http://schemas.microsoft.com/office/drawing/2014/main" id="{EC0A6AA6-F2C3-4D4A-A161-CA9CD51F0774}"/>
               </a:ext>
             </a:extLst>
           </p:cNvPr>
@@ -4872,7 +4872,7 @@
           <p:cNvPr id="9" name="">
             <a:extLst xmlns:a="http://schemas.openxmlformats.org/drawingml/2006/main">
               <a:ext uri="{FF2B5EF4-FFF2-40B4-BE49-F238E27FC236}">
-                <a16:creationId xmlns:a16="http://schemas.microsoft.com/office/drawing/2014/main" id="{596DB2F7-DB69-4D26-8E48-6ABF4BA517D9}"/>
+                <a16:creationId xmlns:a16="http://schemas.microsoft.com/office/drawing/2014/main" id="{AF201F01-3572-40BB-A6EB-389CB8CC8714}"/>
               </a:ext>
             </a:extLst>
           </p:cNvPr>
@@ -4929,7 +4929,7 @@
           <p:cNvPr id="10" name="">
             <a:extLst xmlns:a="http://schemas.openxmlformats.org/drawingml/2006/main">
               <a:ext uri="{FF2B5EF4-FFF2-40B4-BE49-F238E27FC236}">
-                <a16:creationId xmlns:a16="http://schemas.microsoft.com/office/drawing/2014/main" id="{C8A07254-A4B8-4D16-B570-74399EF117E7}"/>
+                <a16:creationId xmlns:a16="http://schemas.microsoft.com/office/drawing/2014/main" id="{DB1F77DB-1B90-47C4-BDEF-E04379DAB05D}"/>
               </a:ext>
             </a:extLst>
           </p:cNvPr>
@@ -4986,7 +4986,7 @@
           <p:cNvPr id="11" name="">
             <a:extLst xmlns:a="http://schemas.openxmlformats.org/drawingml/2006/main">
               <a:ext uri="{FF2B5EF4-FFF2-40B4-BE49-F238E27FC236}">
-                <a16:creationId xmlns:a16="http://schemas.microsoft.com/office/drawing/2014/main" id="{60A366FF-7F45-4874-B4E3-30402E1F1E80}"/>
+                <a16:creationId xmlns:a16="http://schemas.microsoft.com/office/drawing/2014/main" id="{634C0794-ACDF-4640-8FE6-0884711D9E2A}"/>
               </a:ext>
             </a:extLst>
           </p:cNvPr>
@@ -5043,7 +5043,7 @@
           <p:cNvPr id="12" name="">
             <a:extLst xmlns:a="http://schemas.openxmlformats.org/drawingml/2006/main">
               <a:ext uri="{FF2B5EF4-FFF2-40B4-BE49-F238E27FC236}">
-                <a16:creationId xmlns:a16="http://schemas.microsoft.com/office/drawing/2014/main" id="{74A404AF-F199-4B3E-A801-3F489C85B49C}"/>
+                <a16:creationId xmlns:a16="http://schemas.microsoft.com/office/drawing/2014/main" id="{BCB56914-4B91-4967-9D90-4C981ECB442F}"/>
               </a:ext>
             </a:extLst>
           </p:cNvPr>
@@ -5073,7 +5073,7 @@
           <p:cNvPr id="13" name="">
             <a:extLst xmlns:a="http://schemas.openxmlformats.org/drawingml/2006/main">
               <a:ext uri="{FF2B5EF4-FFF2-40B4-BE49-F238E27FC236}">
-                <a16:creationId xmlns:a16="http://schemas.microsoft.com/office/drawing/2014/main" id="{C66BE2FD-D409-4D30-AB23-0285A187A40A}"/>
+                <a16:creationId xmlns:a16="http://schemas.microsoft.com/office/drawing/2014/main" id="{BC83283A-9AFB-46AD-B12D-9B8C6A679A32}"/>
               </a:ext>
             </a:extLst>
           </p:cNvPr>
@@ -5130,7 +5130,7 @@
           <p:cNvPr id="14" name="">
             <a:extLst xmlns:a="http://schemas.openxmlformats.org/drawingml/2006/main">
               <a:ext uri="{FF2B5EF4-FFF2-40B4-BE49-F238E27FC236}">
-                <a16:creationId xmlns:a16="http://schemas.microsoft.com/office/drawing/2014/main" id="{6C09471C-E704-4CC7-9346-25BA3B81AE50}"/>
+                <a16:creationId xmlns:a16="http://schemas.microsoft.com/office/drawing/2014/main" id="{6B32FBD0-88AC-435F-9955-43ED2DBBCB8C}"/>
               </a:ext>
             </a:extLst>
           </p:cNvPr>
@@ -5185,7 +5185,7 @@
     </p:spTree>
     <p:extLst>
       <p:ext uri="{BB962C8B-B14F-4D97-AF65-F5344CB8AC3E}">
-        <p14:creationId xmlns:p14="http://schemas.microsoft.com/office/powerpoint/2010/main" val="277050836"/>
+        <p14:creationId xmlns:p14="http://schemas.microsoft.com/office/powerpoint/2010/main" val="455655411"/>
       </p:ext>
     </p:extLst>
   </p:cSld>
@@ -5216,7 +5216,7 @@
           <p:cNvPr id="10" name="">
             <a:extLst xmlns:a="http://schemas.openxmlformats.org/drawingml/2006/main">
               <a:ext uri="{FF2B5EF4-FFF2-40B4-BE49-F238E27FC236}">
-                <a16:creationId xmlns:a16="http://schemas.microsoft.com/office/drawing/2014/main" id="{FB79D7B7-F9D6-491E-B6C0-729200146E0C}"/>
+                <a16:creationId xmlns:a16="http://schemas.microsoft.com/office/drawing/2014/main" id="{43649CA5-3B18-49FC-817F-E2CAD11CB15F}"/>
               </a:ext>
             </a:extLst>
           </p:cNvPr>
@@ -5246,7 +5246,7 @@
           <p:cNvPr id="2" name="">
             <a:extLst xmlns:a="http://schemas.openxmlformats.org/drawingml/2006/main">
               <a:ext uri="{FF2B5EF4-FFF2-40B4-BE49-F238E27FC236}">
-                <a16:creationId xmlns:a16="http://schemas.microsoft.com/office/drawing/2014/main" id="{A60A89A9-1527-438D-855B-FF7319C621A6}"/>
+                <a16:creationId xmlns:a16="http://schemas.microsoft.com/office/drawing/2014/main" id="{154422AA-FF5E-4B79-A47D-58EEE4F330DF}"/>
               </a:ext>
             </a:extLst>
           </p:cNvPr>
@@ -5303,7 +5303,7 @@
           <p:cNvPr id="3" name="">
             <a:extLst xmlns:a="http://schemas.openxmlformats.org/drawingml/2006/main">
               <a:ext uri="{FF2B5EF4-FFF2-40B4-BE49-F238E27FC236}">
-                <a16:creationId xmlns:a16="http://schemas.microsoft.com/office/drawing/2014/main" id="{C31C53F3-1431-4CE0-9DE0-40306D088105}"/>
+                <a16:creationId xmlns:a16="http://schemas.microsoft.com/office/drawing/2014/main" id="{FA4B8715-CCF2-44A2-9DC7-8A3321250F81}"/>
               </a:ext>
             </a:extLst>
           </p:cNvPr>
@@ -5333,7 +5333,7 @@
           <p:cNvPr id="4" name="">
             <a:extLst xmlns:a="http://schemas.openxmlformats.org/drawingml/2006/main">
               <a:ext uri="{FF2B5EF4-FFF2-40B4-BE49-F238E27FC236}">
-                <a16:creationId xmlns:a16="http://schemas.microsoft.com/office/drawing/2014/main" id="{7B04F532-FA4E-4B9A-B466-4F786287891F}"/>
+                <a16:creationId xmlns:a16="http://schemas.microsoft.com/office/drawing/2014/main" id="{93DB291A-206C-4872-BE38-1C3DEA00719A}"/>
               </a:ext>
             </a:extLst>
           </p:cNvPr>
@@ -5363,7 +5363,7 @@
           <p:cNvPr id="5" name="">
             <a:extLst xmlns:a="http://schemas.openxmlformats.org/drawingml/2006/main">
               <a:ext uri="{FF2B5EF4-FFF2-40B4-BE49-F238E27FC236}">
-                <a16:creationId xmlns:a16="http://schemas.microsoft.com/office/drawing/2014/main" id="{6F6AAB8B-2F44-447D-9E91-79A937F94D31}"/>
+                <a16:creationId xmlns:a16="http://schemas.microsoft.com/office/drawing/2014/main" id="{DEA2B895-F3A7-4ED6-B1E0-2D3B6A4DB1DF}"/>
               </a:ext>
             </a:extLst>
           </p:cNvPr>
@@ -5739,7 +5739,7 @@
           <p:cNvPr id="7" name="">
             <a:extLst xmlns:a="http://schemas.openxmlformats.org/drawingml/2006/main">
               <a:ext uri="{FF2B5EF4-FFF2-40B4-BE49-F238E27FC236}">
-                <a16:creationId xmlns:a16="http://schemas.microsoft.com/office/drawing/2014/main" id="{96CA9C4C-D951-42F7-953E-7EFE934B5445}"/>
+                <a16:creationId xmlns:a16="http://schemas.microsoft.com/office/drawing/2014/main" id="{F5174629-0463-42EE-ACDF-E422EC31D5E3}"/>
               </a:ext>
             </a:extLst>
           </p:cNvPr>
@@ -5769,7 +5769,7 @@
           <p:cNvPr id="8" name="">
             <a:extLst xmlns:a="http://schemas.openxmlformats.org/drawingml/2006/main">
               <a:ext uri="{FF2B5EF4-FFF2-40B4-BE49-F238E27FC236}">
-                <a16:creationId xmlns:a16="http://schemas.microsoft.com/office/drawing/2014/main" id="{AA0A5610-12BC-4865-B60E-47A4A8B1FC23}"/>
+                <a16:creationId xmlns:a16="http://schemas.microsoft.com/office/drawing/2014/main" id="{600B3555-4725-4ADA-B32D-8D2CA0078B6D}"/>
               </a:ext>
             </a:extLst>
           </p:cNvPr>
@@ -5826,7 +5826,7 @@
           <p:cNvPr id="9" name="">
             <a:extLst xmlns:a="http://schemas.openxmlformats.org/drawingml/2006/main">
               <a:ext uri="{FF2B5EF4-FFF2-40B4-BE49-F238E27FC236}">
-                <a16:creationId xmlns:a16="http://schemas.microsoft.com/office/drawing/2014/main" id="{693297D0-93C1-4E2A-B8B8-3052697E5D96}"/>
+                <a16:creationId xmlns:a16="http://schemas.microsoft.com/office/drawing/2014/main" id="{6D769EB3-8471-43C6-BF67-62139787752C}"/>
               </a:ext>
             </a:extLst>
           </p:cNvPr>
@@ -5881,7 +5881,7 @@
     </p:spTree>
     <p:extLst>
       <p:ext uri="{BB962C8B-B14F-4D97-AF65-F5344CB8AC3E}">
-        <p14:creationId xmlns:p14="http://schemas.microsoft.com/office/powerpoint/2010/main" val="1276044715"/>
+        <p14:creationId xmlns:p14="http://schemas.microsoft.com/office/powerpoint/2010/main" val="1299317291"/>
       </p:ext>
     </p:extLst>
   </p:cSld>
@@ -5912,7 +5912,7 @@
           <p:cNvPr id="27" name="">
             <a:extLst xmlns:a="http://schemas.openxmlformats.org/drawingml/2006/main">
               <a:ext uri="{FF2B5EF4-FFF2-40B4-BE49-F238E27FC236}">
-                <a16:creationId xmlns:a16="http://schemas.microsoft.com/office/drawing/2014/main" id="{741E3778-7369-4CE4-A805-3521D0BA5CE0}"/>
+                <a16:creationId xmlns:a16="http://schemas.microsoft.com/office/drawing/2014/main" id="{EEBCC0CF-BD7B-4A9E-8A4B-56C1E5C79EBC}"/>
               </a:ext>
             </a:extLst>
           </p:cNvPr>
@@ -5942,7 +5942,7 @@
           <p:cNvPr id="2" name="">
             <a:extLst xmlns:a="http://schemas.openxmlformats.org/drawingml/2006/main">
               <a:ext uri="{FF2B5EF4-FFF2-40B4-BE49-F238E27FC236}">
-                <a16:creationId xmlns:a16="http://schemas.microsoft.com/office/drawing/2014/main" id="{EB9E95B9-024D-4B0D-BAC9-A66EBF0972C5}"/>
+                <a16:creationId xmlns:a16="http://schemas.microsoft.com/office/drawing/2014/main" id="{632A4676-6CE3-4D99-972A-EA4CDB45C928}"/>
               </a:ext>
             </a:extLst>
           </p:cNvPr>
@@ -5999,7 +5999,7 @@
           <p:cNvPr id="3" name="">
             <a:extLst xmlns:a="http://schemas.openxmlformats.org/drawingml/2006/main">
               <a:ext uri="{FF2B5EF4-FFF2-40B4-BE49-F238E27FC236}">
-                <a16:creationId xmlns:a16="http://schemas.microsoft.com/office/drawing/2014/main" id="{68435D1F-E34D-4F01-97A4-45A13A17AC1B}"/>
+                <a16:creationId xmlns:a16="http://schemas.microsoft.com/office/drawing/2014/main" id="{78B059E0-93C0-4EAD-805E-9DD6C8E0B0E3}"/>
               </a:ext>
             </a:extLst>
           </p:cNvPr>
@@ -6029,7 +6029,7 @@
           <p:cNvPr id="4" name="">
             <a:extLst xmlns:a="http://schemas.openxmlformats.org/drawingml/2006/main">
               <a:ext uri="{FF2B5EF4-FFF2-40B4-BE49-F238E27FC236}">
-                <a16:creationId xmlns:a16="http://schemas.microsoft.com/office/drawing/2014/main" id="{AAC8CAD1-75D3-4383-939C-870E7EEE1587}"/>
+                <a16:creationId xmlns:a16="http://schemas.microsoft.com/office/drawing/2014/main" id="{4893B3E8-2A59-48C0-A388-E58020F8E096}"/>
               </a:ext>
             </a:extLst>
           </p:cNvPr>
@@ -6059,7 +6059,7 @@
           <p:cNvPr id="5" name="">
             <a:extLst xmlns:a="http://schemas.openxmlformats.org/drawingml/2006/main">
               <a:ext uri="{FF2B5EF4-FFF2-40B4-BE49-F238E27FC236}">
-                <a16:creationId xmlns:a16="http://schemas.microsoft.com/office/drawing/2014/main" id="{566F4BA7-EAED-4A72-AB14-2621A86CC012}"/>
+                <a16:creationId xmlns:a16="http://schemas.microsoft.com/office/drawing/2014/main" id="{EEFCEE26-91EC-472D-A38F-FE63F37AD696}"/>
               </a:ext>
             </a:extLst>
           </p:cNvPr>
@@ -6116,7 +6116,7 @@
           <p:cNvPr id="6" name="">
             <a:extLst xmlns:a="http://schemas.openxmlformats.org/drawingml/2006/main">
               <a:ext uri="{FF2B5EF4-FFF2-40B4-BE49-F238E27FC236}">
-                <a16:creationId xmlns:a16="http://schemas.microsoft.com/office/drawing/2014/main" id="{C66BA6E0-2579-4CC9-8F6D-8CA359FE780E}"/>
+                <a16:creationId xmlns:a16="http://schemas.microsoft.com/office/drawing/2014/main" id="{7D5E2E33-B168-4DB4-AA66-8893EF2D6E06}"/>
               </a:ext>
             </a:extLst>
           </p:cNvPr>
@@ -6173,7 +6173,7 @@
           <p:cNvPr id="7" name="">
             <a:extLst xmlns:a="http://schemas.openxmlformats.org/drawingml/2006/main">
               <a:ext uri="{FF2B5EF4-FFF2-40B4-BE49-F238E27FC236}">
-                <a16:creationId xmlns:a16="http://schemas.microsoft.com/office/drawing/2014/main" id="{2F2393A3-BD66-46F0-BD08-5F6B9CBDDF01}"/>
+                <a16:creationId xmlns:a16="http://schemas.microsoft.com/office/drawing/2014/main" id="{CD3C6CC1-39D0-405F-BA61-3B8DF486D37C}"/>
               </a:ext>
             </a:extLst>
           </p:cNvPr>
@@ -6205,7 +6205,7 @@
           <p:cNvPr id="8" name="">
             <a:extLst xmlns:a="http://schemas.openxmlformats.org/drawingml/2006/main">
               <a:ext uri="{FF2B5EF4-FFF2-40B4-BE49-F238E27FC236}">
-                <a16:creationId xmlns:a16="http://schemas.microsoft.com/office/drawing/2014/main" id="{E9477291-921D-45CA-8D40-A790B8F4CDF3}"/>
+                <a16:creationId xmlns:a16="http://schemas.microsoft.com/office/drawing/2014/main" id="{8CF7F74A-686E-46E1-8BBC-7B35FD8F3319}"/>
               </a:ext>
             </a:extLst>
           </p:cNvPr>
@@ -6262,7 +6262,7 @@
           <p:cNvPr id="9" name="">
             <a:extLst xmlns:a="http://schemas.openxmlformats.org/drawingml/2006/main">
               <a:ext uri="{FF2B5EF4-FFF2-40B4-BE49-F238E27FC236}">
-                <a16:creationId xmlns:a16="http://schemas.microsoft.com/office/drawing/2014/main" id="{E47F9AE4-B44A-429A-984A-0AEFD051A836}"/>
+                <a16:creationId xmlns:a16="http://schemas.microsoft.com/office/drawing/2014/main" id="{377D32AB-6A10-401D-8ED4-CD2C83B7BE7C}"/>
               </a:ext>
             </a:extLst>
           </p:cNvPr>
@@ -6319,7 +6319,7 @@
           <p:cNvPr id="10" name="">
             <a:extLst xmlns:a="http://schemas.openxmlformats.org/drawingml/2006/main">
               <a:ext uri="{FF2B5EF4-FFF2-40B4-BE49-F238E27FC236}">
-                <a16:creationId xmlns:a16="http://schemas.microsoft.com/office/drawing/2014/main" id="{8C127795-165D-4CDE-826B-672B6809FCE3}"/>
+                <a16:creationId xmlns:a16="http://schemas.microsoft.com/office/drawing/2014/main" id="{8ECC109A-269B-458E-AE02-E1641A9E94EB}"/>
               </a:ext>
             </a:extLst>
           </p:cNvPr>
@@ -6351,7 +6351,7 @@
           <p:cNvPr id="11" name="">
             <a:extLst xmlns:a="http://schemas.openxmlformats.org/drawingml/2006/main">
               <a:ext uri="{FF2B5EF4-FFF2-40B4-BE49-F238E27FC236}">
-                <a16:creationId xmlns:a16="http://schemas.microsoft.com/office/drawing/2014/main" id="{341AABF1-66A7-4258-BAF6-B93F15007A97}"/>
+                <a16:creationId xmlns:a16="http://schemas.microsoft.com/office/drawing/2014/main" id="{95945CE7-C577-4BAF-B2FA-CAFD679F2626}"/>
               </a:ext>
             </a:extLst>
           </p:cNvPr>
@@ -6408,7 +6408,7 @@
           <p:cNvPr id="12" name="">
             <a:extLst xmlns:a="http://schemas.openxmlformats.org/drawingml/2006/main">
               <a:ext uri="{FF2B5EF4-FFF2-40B4-BE49-F238E27FC236}">
-                <a16:creationId xmlns:a16="http://schemas.microsoft.com/office/drawing/2014/main" id="{64F40134-33DA-4BFA-A4F3-D85F990B7E10}"/>
+                <a16:creationId xmlns:a16="http://schemas.microsoft.com/office/drawing/2014/main" id="{39474E67-1C5A-4399-B7D3-EC9DCDEC88B6}"/>
               </a:ext>
             </a:extLst>
           </p:cNvPr>
@@ -6465,7 +6465,7 @@
           <p:cNvPr id="13" name="">
             <a:extLst xmlns:a="http://schemas.openxmlformats.org/drawingml/2006/main">
               <a:ext uri="{FF2B5EF4-FFF2-40B4-BE49-F238E27FC236}">
-                <a16:creationId xmlns:a16="http://schemas.microsoft.com/office/drawing/2014/main" id="{3B536103-B520-462D-9979-3297EA68BE31}"/>
+                <a16:creationId xmlns:a16="http://schemas.microsoft.com/office/drawing/2014/main" id="{6DCFB886-FDD1-4BC8-AEC8-3A6DCDA8D774}"/>
               </a:ext>
             </a:extLst>
           </p:cNvPr>
@@ -6497,7 +6497,7 @@
           <p:cNvPr id="14" name="">
             <a:extLst xmlns:a="http://schemas.openxmlformats.org/drawingml/2006/main">
               <a:ext uri="{FF2B5EF4-FFF2-40B4-BE49-F238E27FC236}">
-                <a16:creationId xmlns:a16="http://schemas.microsoft.com/office/drawing/2014/main" id="{BFE1BF96-2DAF-4A1A-A8C1-F02BF33B1CCA}"/>
+                <a16:creationId xmlns:a16="http://schemas.microsoft.com/office/drawing/2014/main" id="{59C6E914-9430-4237-A464-876445F15CEC}"/>
               </a:ext>
             </a:extLst>
           </p:cNvPr>
@@ -6554,7 +6554,7 @@
           <p:cNvPr id="15" name="">
             <a:extLst xmlns:a="http://schemas.openxmlformats.org/drawingml/2006/main">
               <a:ext uri="{FF2B5EF4-FFF2-40B4-BE49-F238E27FC236}">
-                <a16:creationId xmlns:a16="http://schemas.microsoft.com/office/drawing/2014/main" id="{98048CD5-DE87-4121-8117-9B5BB13690CD}"/>
+                <a16:creationId xmlns:a16="http://schemas.microsoft.com/office/drawing/2014/main" id="{A4A465B5-C7C1-46A9-BBB2-F0016ECB2F3C}"/>
               </a:ext>
             </a:extLst>
           </p:cNvPr>
@@ -6611,7 +6611,7 @@
           <p:cNvPr id="16" name="">
             <a:extLst xmlns:a="http://schemas.openxmlformats.org/drawingml/2006/main">
               <a:ext uri="{FF2B5EF4-FFF2-40B4-BE49-F238E27FC236}">
-                <a16:creationId xmlns:a16="http://schemas.microsoft.com/office/drawing/2014/main" id="{6426508E-8B41-422E-AF12-9F9EC27E1E71}"/>
+                <a16:creationId xmlns:a16="http://schemas.microsoft.com/office/drawing/2014/main" id="{EC4B7327-EEA4-4791-A509-2563B48A8708}"/>
               </a:ext>
             </a:extLst>
           </p:cNvPr>
@@ -6643,7 +6643,7 @@
           <p:cNvPr id="17" name="">
             <a:extLst xmlns:a="http://schemas.openxmlformats.org/drawingml/2006/main">
               <a:ext uri="{FF2B5EF4-FFF2-40B4-BE49-F238E27FC236}">
-                <a16:creationId xmlns:a16="http://schemas.microsoft.com/office/drawing/2014/main" id="{86B6DA4D-2623-4F02-9A44-8E7AEB4DBBAC}"/>
+                <a16:creationId xmlns:a16="http://schemas.microsoft.com/office/drawing/2014/main" id="{A4294194-CCC7-4A2F-A8E1-9C59819AA95E}"/>
               </a:ext>
             </a:extLst>
           </p:cNvPr>
@@ -6700,7 +6700,7 @@
           <p:cNvPr id="18" name="">
             <a:extLst xmlns:a="http://schemas.openxmlformats.org/drawingml/2006/main">
               <a:ext uri="{FF2B5EF4-FFF2-40B4-BE49-F238E27FC236}">
-                <a16:creationId xmlns:a16="http://schemas.microsoft.com/office/drawing/2014/main" id="{30C2319C-1B90-4229-B87D-B92B26017CD4}"/>
+                <a16:creationId xmlns:a16="http://schemas.microsoft.com/office/drawing/2014/main" id="{872975EC-00B0-4ECE-BA44-A3234953A9D9}"/>
               </a:ext>
             </a:extLst>
           </p:cNvPr>
@@ -6832,7 +6832,7 @@
           <p:cNvPr id="22" name="">
             <a:extLst xmlns:a="http://schemas.openxmlformats.org/drawingml/2006/main">
               <a:ext uri="{FF2B5EF4-FFF2-40B4-BE49-F238E27FC236}">
-                <a16:creationId xmlns:a16="http://schemas.microsoft.com/office/drawing/2014/main" id="{30F92B52-F097-41E7-8370-FE0314CB2278}"/>
+                <a16:creationId xmlns:a16="http://schemas.microsoft.com/office/drawing/2014/main" id="{902B3CA2-1288-4913-B9EF-3836DD043F6F}"/>
               </a:ext>
             </a:extLst>
           </p:cNvPr>
@@ -6862,7 +6862,7 @@
           <p:cNvPr id="23" name="">
             <a:extLst xmlns:a="http://schemas.openxmlformats.org/drawingml/2006/main">
               <a:ext uri="{FF2B5EF4-FFF2-40B4-BE49-F238E27FC236}">
-                <a16:creationId xmlns:a16="http://schemas.microsoft.com/office/drawing/2014/main" id="{93723859-4B21-440A-9854-261F8AFC90F3}"/>
+                <a16:creationId xmlns:a16="http://schemas.microsoft.com/office/drawing/2014/main" id="{38BB0E1F-1C09-486A-B0FA-D395A8A765D9}"/>
               </a:ext>
             </a:extLst>
           </p:cNvPr>
@@ -6919,7 +6919,7 @@
           <p:cNvPr id="24" name="">
             <a:extLst xmlns:a="http://schemas.openxmlformats.org/drawingml/2006/main">
               <a:ext uri="{FF2B5EF4-FFF2-40B4-BE49-F238E27FC236}">
-                <a16:creationId xmlns:a16="http://schemas.microsoft.com/office/drawing/2014/main" id="{928123A1-701A-48B2-8502-6DCE391D795E}"/>
+                <a16:creationId xmlns:a16="http://schemas.microsoft.com/office/drawing/2014/main" id="{C890225A-2C52-4BCB-985A-BE0A1E5965B4}"/>
               </a:ext>
             </a:extLst>
           </p:cNvPr>
@@ -6949,7 +6949,7 @@
           <p:cNvPr id="25" name="">
             <a:extLst xmlns:a="http://schemas.openxmlformats.org/drawingml/2006/main">
               <a:ext uri="{FF2B5EF4-FFF2-40B4-BE49-F238E27FC236}">
-                <a16:creationId xmlns:a16="http://schemas.microsoft.com/office/drawing/2014/main" id="{84E93326-29C1-42E3-AF11-C8E2869A38C9}"/>
+                <a16:creationId xmlns:a16="http://schemas.microsoft.com/office/drawing/2014/main" id="{32C5EA53-7C57-4F99-B23D-AF8FB740C92E}"/>
               </a:ext>
             </a:extLst>
           </p:cNvPr>
@@ -7006,7 +7006,7 @@
           <p:cNvPr id="26" name="">
             <a:extLst xmlns:a="http://schemas.openxmlformats.org/drawingml/2006/main">
               <a:ext uri="{FF2B5EF4-FFF2-40B4-BE49-F238E27FC236}">
-                <a16:creationId xmlns:a16="http://schemas.microsoft.com/office/drawing/2014/main" id="{D54896B1-1AC6-47B1-AC6D-463408728837}"/>
+                <a16:creationId xmlns:a16="http://schemas.microsoft.com/office/drawing/2014/main" id="{859D8B97-37B5-4CE8-BA12-24E6696F9BBE}"/>
               </a:ext>
             </a:extLst>
           </p:cNvPr>
@@ -7061,7 +7061,7 @@
     </p:spTree>
     <p:extLst>
       <p:ext uri="{BB962C8B-B14F-4D97-AF65-F5344CB8AC3E}">
-        <p14:creationId xmlns:p14="http://schemas.microsoft.com/office/powerpoint/2010/main" val="1776583273"/>
+        <p14:creationId xmlns:p14="http://schemas.microsoft.com/office/powerpoint/2010/main" val="1730076257"/>
       </p:ext>
     </p:extLst>
   </p:cSld>
@@ -7092,7 +7092,7 @@
           <p:cNvPr id="12" name="">
             <a:extLst xmlns:a="http://schemas.openxmlformats.org/drawingml/2006/main">
               <a:ext uri="{FF2B5EF4-FFF2-40B4-BE49-F238E27FC236}">
-                <a16:creationId xmlns:a16="http://schemas.microsoft.com/office/drawing/2014/main" id="{A03187BF-FF09-44F0-A8EE-A66166C2A50D}"/>
+                <a16:creationId xmlns:a16="http://schemas.microsoft.com/office/drawing/2014/main" id="{07F56EAA-FCF1-4680-A200-FE571429B132}"/>
               </a:ext>
             </a:extLst>
           </p:cNvPr>
@@ -7122,7 +7122,7 @@
           <p:cNvPr id="2" name="">
             <a:extLst xmlns:a="http://schemas.openxmlformats.org/drawingml/2006/main">
               <a:ext uri="{FF2B5EF4-FFF2-40B4-BE49-F238E27FC236}">
-                <a16:creationId xmlns:a16="http://schemas.microsoft.com/office/drawing/2014/main" id="{1A482E36-C4A7-48B8-9FF3-AA412A695098}"/>
+                <a16:creationId xmlns:a16="http://schemas.microsoft.com/office/drawing/2014/main" id="{265F9944-28CD-4079-8259-60CF93C110DE}"/>
               </a:ext>
             </a:extLst>
           </p:cNvPr>
@@ -7179,7 +7179,7 @@
           <p:cNvPr id="3" name="">
             <a:extLst xmlns:a="http://schemas.openxmlformats.org/drawingml/2006/main">
               <a:ext uri="{FF2B5EF4-FFF2-40B4-BE49-F238E27FC236}">
-                <a16:creationId xmlns:a16="http://schemas.microsoft.com/office/drawing/2014/main" id="{A420DFB9-DFD9-4AF5-803A-492436BBF0B4}"/>
+                <a16:creationId xmlns:a16="http://schemas.microsoft.com/office/drawing/2014/main" id="{E5A1E82A-DF99-4E2F-93E9-43367FA6C631}"/>
               </a:ext>
             </a:extLst>
           </p:cNvPr>
@@ -7209,7 +7209,7 @@
           <p:cNvPr id="4" name="">
             <a:extLst xmlns:a="http://schemas.openxmlformats.org/drawingml/2006/main">
               <a:ext uri="{FF2B5EF4-FFF2-40B4-BE49-F238E27FC236}">
-                <a16:creationId xmlns:a16="http://schemas.microsoft.com/office/drawing/2014/main" id="{0D93870D-19EA-465E-A0FE-5D0D6B920F57}"/>
+                <a16:creationId xmlns:a16="http://schemas.microsoft.com/office/drawing/2014/main" id="{F14AFCB8-850D-4CEA-A1DF-B7127C6964AC}"/>
               </a:ext>
             </a:extLst>
           </p:cNvPr>
@@ -7239,7 +7239,7 @@
           <p:cNvPr id="5" name="">
             <a:extLst xmlns:a="http://schemas.openxmlformats.org/drawingml/2006/main">
               <a:ext uri="{FF2B5EF4-FFF2-40B4-BE49-F238E27FC236}">
-                <a16:creationId xmlns:a16="http://schemas.microsoft.com/office/drawing/2014/main" id="{317F6DD3-A873-4649-B5C6-A09A93E03EB2}"/>
+                <a16:creationId xmlns:a16="http://schemas.microsoft.com/office/drawing/2014/main" id="{4B684C45-6D74-4754-828C-8ED4DA6C2A25}"/>
               </a:ext>
             </a:extLst>
           </p:cNvPr>
@@ -7296,7 +7296,7 @@
           <p:cNvPr id="6" name="">
             <a:extLst xmlns:a="http://schemas.openxmlformats.org/drawingml/2006/main">
               <a:ext uri="{FF2B5EF4-FFF2-40B4-BE49-F238E27FC236}">
-                <a16:creationId xmlns:a16="http://schemas.microsoft.com/office/drawing/2014/main" id="{9F1ED9D9-2C4F-472D-9BE9-039BDC77DC47}"/>
+                <a16:creationId xmlns:a16="http://schemas.microsoft.com/office/drawing/2014/main" id="{516BE608-E2DF-42F3-B398-6B4C1581E7D0}"/>
               </a:ext>
             </a:extLst>
           </p:cNvPr>
@@ -7353,7 +7353,7 @@
           <p:cNvPr id="7" name="">
             <a:extLst xmlns:a="http://schemas.openxmlformats.org/drawingml/2006/main">
               <a:ext uri="{FF2B5EF4-FFF2-40B4-BE49-F238E27FC236}">
-                <a16:creationId xmlns:a16="http://schemas.microsoft.com/office/drawing/2014/main" id="{2B8E9FAB-DFE7-4C4F-85C3-FC6744192CCE}"/>
+                <a16:creationId xmlns:a16="http://schemas.microsoft.com/office/drawing/2014/main" id="{D9EA1B44-C3D3-48E8-A4D8-070D0B64A878}"/>
               </a:ext>
             </a:extLst>
           </p:cNvPr>
@@ -7410,7 +7410,7 @@
           <p:cNvPr id="8" name="">
             <a:extLst xmlns:a="http://schemas.openxmlformats.org/drawingml/2006/main">
               <a:ext uri="{FF2B5EF4-FFF2-40B4-BE49-F238E27FC236}">
-                <a16:creationId xmlns:a16="http://schemas.microsoft.com/office/drawing/2014/main" id="{917C7478-C287-4601-9847-EEDA99960686}"/>
+                <a16:creationId xmlns:a16="http://schemas.microsoft.com/office/drawing/2014/main" id="{080F97F9-1503-4A01-84A3-405F66B5EC97}"/>
               </a:ext>
             </a:extLst>
           </p:cNvPr>
@@ -7467,7 +7467,7 @@
           <p:cNvPr id="9" name="">
             <a:extLst xmlns:a="http://schemas.openxmlformats.org/drawingml/2006/main">
               <a:ext uri="{FF2B5EF4-FFF2-40B4-BE49-F238E27FC236}">
-                <a16:creationId xmlns:a16="http://schemas.microsoft.com/office/drawing/2014/main" id="{8968EAEA-49C6-44A0-AB85-82EBF219549C}"/>
+                <a16:creationId xmlns:a16="http://schemas.microsoft.com/office/drawing/2014/main" id="{748FBA28-19B5-45D2-BB5B-638452DB04EF}"/>
               </a:ext>
             </a:extLst>
           </p:cNvPr>
@@ -7497,7 +7497,7 @@
           <p:cNvPr id="10" name="">
             <a:extLst xmlns:a="http://schemas.openxmlformats.org/drawingml/2006/main">
               <a:ext uri="{FF2B5EF4-FFF2-40B4-BE49-F238E27FC236}">
-                <a16:creationId xmlns:a16="http://schemas.microsoft.com/office/drawing/2014/main" id="{854677D4-88D7-4A6B-AFBD-29A04095B871}"/>
+                <a16:creationId xmlns:a16="http://schemas.microsoft.com/office/drawing/2014/main" id="{FF841CA3-5E3A-453E-B6F4-50F9B95EFFBE}"/>
               </a:ext>
             </a:extLst>
           </p:cNvPr>
@@ -7554,7 +7554,7 @@
           <p:cNvPr id="11" name="">
             <a:extLst xmlns:a="http://schemas.openxmlformats.org/drawingml/2006/main">
               <a:ext uri="{FF2B5EF4-FFF2-40B4-BE49-F238E27FC236}">
-                <a16:creationId xmlns:a16="http://schemas.microsoft.com/office/drawing/2014/main" id="{90E2C2B9-EA45-43A7-909B-D0763FFF939E}"/>
+                <a16:creationId xmlns:a16="http://schemas.microsoft.com/office/drawing/2014/main" id="{A5BE76EB-DEE8-475B-BAC4-9F9F74879225}"/>
               </a:ext>
             </a:extLst>
           </p:cNvPr>
@@ -7609,7 +7609,7 @@
     </p:spTree>
     <p:extLst>
       <p:ext uri="{BB962C8B-B14F-4D97-AF65-F5344CB8AC3E}">
-        <p14:creationId xmlns:p14="http://schemas.microsoft.com/office/powerpoint/2010/main" val="498371696"/>
+        <p14:creationId xmlns:p14="http://schemas.microsoft.com/office/powerpoint/2010/main" val="1051515177"/>
       </p:ext>
     </p:extLst>
   </p:cSld>
@@ -7640,7 +7640,7 @@
           <p:cNvPr id="17" name="">
             <a:extLst xmlns:a="http://schemas.openxmlformats.org/drawingml/2006/main">
               <a:ext uri="{FF2B5EF4-FFF2-40B4-BE49-F238E27FC236}">
-                <a16:creationId xmlns:a16="http://schemas.microsoft.com/office/drawing/2014/main" id="{81BEFAEA-9AF1-4099-9A1F-68358D4D8B76}"/>
+                <a16:creationId xmlns:a16="http://schemas.microsoft.com/office/drawing/2014/main" id="{9B9BA317-C062-4D17-94E5-8BF0DD97C0AB}"/>
               </a:ext>
             </a:extLst>
           </p:cNvPr>
@@ -7670,7 +7670,7 @@
           <p:cNvPr id="2" name="">
             <a:extLst xmlns:a="http://schemas.openxmlformats.org/drawingml/2006/main">
               <a:ext uri="{FF2B5EF4-FFF2-40B4-BE49-F238E27FC236}">
-                <a16:creationId xmlns:a16="http://schemas.microsoft.com/office/drawing/2014/main" id="{883169EA-3E27-4B35-AF1A-23BA2F37974E}"/>
+                <a16:creationId xmlns:a16="http://schemas.microsoft.com/office/drawing/2014/main" id="{527A3F5D-9516-4EB2-9450-419517632081}"/>
               </a:ext>
             </a:extLst>
           </p:cNvPr>
@@ -7700,7 +7700,7 @@
           <p:cNvPr id="3" name="">
             <a:extLst xmlns:a="http://schemas.openxmlformats.org/drawingml/2006/main">
               <a:ext uri="{FF2B5EF4-FFF2-40B4-BE49-F238E27FC236}">
-                <a16:creationId xmlns:a16="http://schemas.microsoft.com/office/drawing/2014/main" id="{83F2DE6E-32BD-4310-872D-1BCA9A5DE4D8}"/>
+                <a16:creationId xmlns:a16="http://schemas.microsoft.com/office/drawing/2014/main" id="{35667422-3020-4665-80D8-101AEC01EDD8}"/>
               </a:ext>
             </a:extLst>
           </p:cNvPr>
@@ -7757,7 +7757,7 @@
           <p:cNvPr id="4" name="">
             <a:extLst xmlns:a="http://schemas.openxmlformats.org/drawingml/2006/main">
               <a:ext uri="{FF2B5EF4-FFF2-40B4-BE49-F238E27FC236}">
-                <a16:creationId xmlns:a16="http://schemas.microsoft.com/office/drawing/2014/main" id="{A3DAE35C-5335-40EB-9BDD-CB60A8C45B49}"/>
+                <a16:creationId xmlns:a16="http://schemas.microsoft.com/office/drawing/2014/main" id="{8A88ECF0-0FA3-43F2-A0BB-7CA38B7ACE5B}"/>
               </a:ext>
             </a:extLst>
           </p:cNvPr>
@@ -7814,7 +7814,7 @@
           <p:cNvPr id="5" name="">
             <a:extLst xmlns:a="http://schemas.openxmlformats.org/drawingml/2006/main">
               <a:ext uri="{FF2B5EF4-FFF2-40B4-BE49-F238E27FC236}">
-                <a16:creationId xmlns:a16="http://schemas.microsoft.com/office/drawing/2014/main" id="{C3CC11A4-5012-45C4-8E41-F4AFA6946623}"/>
+                <a16:creationId xmlns:a16="http://schemas.microsoft.com/office/drawing/2014/main" id="{8123CC3F-4016-41B3-A147-1A6BFDFE9063}"/>
               </a:ext>
             </a:extLst>
           </p:cNvPr>
@@ -7844,7 +7844,7 @@
           <p:cNvPr id="6" name="">
             <a:extLst xmlns:a="http://schemas.openxmlformats.org/drawingml/2006/main">
               <a:ext uri="{FF2B5EF4-FFF2-40B4-BE49-F238E27FC236}">
-                <a16:creationId xmlns:a16="http://schemas.microsoft.com/office/drawing/2014/main" id="{29B158C3-91E4-49DD-9AB5-4BF081DC70B2}"/>
+                <a16:creationId xmlns:a16="http://schemas.microsoft.com/office/drawing/2014/main" id="{5F616E04-CD8E-4F8A-88C1-BCB5E3142AFC}"/>
               </a:ext>
             </a:extLst>
           </p:cNvPr>
@@ -7901,7 +7901,7 @@
           <p:cNvPr id="7" name="">
             <a:extLst xmlns:a="http://schemas.openxmlformats.org/drawingml/2006/main">
               <a:ext uri="{FF2B5EF4-FFF2-40B4-BE49-F238E27FC236}">
-                <a16:creationId xmlns:a16="http://schemas.microsoft.com/office/drawing/2014/main" id="{55A7771D-4B08-4595-8FD9-1AB743DAF14C}"/>
+                <a16:creationId xmlns:a16="http://schemas.microsoft.com/office/drawing/2014/main" id="{F32702CC-F0C8-4A31-81F4-74CA1130F991}"/>
               </a:ext>
             </a:extLst>
           </p:cNvPr>
@@ -7958,7 +7958,7 @@
           <p:cNvPr id="8" name="">
             <a:extLst xmlns:a="http://schemas.openxmlformats.org/drawingml/2006/main">
               <a:ext uri="{FF2B5EF4-FFF2-40B4-BE49-F238E27FC236}">
-                <a16:creationId xmlns:a16="http://schemas.microsoft.com/office/drawing/2014/main" id="{663B018B-4323-43C3-8103-2CDEB471034A}"/>
+                <a16:creationId xmlns:a16="http://schemas.microsoft.com/office/drawing/2014/main" id="{531E003F-E065-434E-B6A8-59CAF9B00B06}"/>
               </a:ext>
             </a:extLst>
           </p:cNvPr>
@@ -8015,7 +8015,7 @@
           <p:cNvPr id="9" name="">
             <a:extLst xmlns:a="http://schemas.openxmlformats.org/drawingml/2006/main">
               <a:ext uri="{FF2B5EF4-FFF2-40B4-BE49-F238E27FC236}">
-                <a16:creationId xmlns:a16="http://schemas.microsoft.com/office/drawing/2014/main" id="{7126C302-E5C8-45DC-8AA5-B774202D5DD1}"/>
+                <a16:creationId xmlns:a16="http://schemas.microsoft.com/office/drawing/2014/main" id="{63F63A29-1CDD-4E57-9A01-330C14211E68}"/>
               </a:ext>
             </a:extLst>
           </p:cNvPr>
@@ -8045,7 +8045,7 @@
           <p:cNvPr id="10" name="">
             <a:extLst xmlns:a="http://schemas.openxmlformats.org/drawingml/2006/main">
               <a:ext uri="{FF2B5EF4-FFF2-40B4-BE49-F238E27FC236}">
-                <a16:creationId xmlns:a16="http://schemas.microsoft.com/office/drawing/2014/main" id="{B3E7E6A8-10F9-4402-A837-9C1C9285E442}"/>
+                <a16:creationId xmlns:a16="http://schemas.microsoft.com/office/drawing/2014/main" id="{70732FAF-0546-4052-88AD-65E4AB3A00D5}"/>
               </a:ext>
             </a:extLst>
           </p:cNvPr>
@@ -8102,7 +8102,7 @@
           <p:cNvPr id="11" name="">
             <a:extLst xmlns:a="http://schemas.openxmlformats.org/drawingml/2006/main">
               <a:ext uri="{FF2B5EF4-FFF2-40B4-BE49-F238E27FC236}">
-                <a16:creationId xmlns:a16="http://schemas.microsoft.com/office/drawing/2014/main" id="{99A822AA-EE4C-4B40-8065-48D6A4A57AE6}"/>
+                <a16:creationId xmlns:a16="http://schemas.microsoft.com/office/drawing/2014/main" id="{A639C8DA-707E-467C-9157-ACB11F1A306F}"/>
               </a:ext>
             </a:extLst>
           </p:cNvPr>
@@ -8159,7 +8159,7 @@
           <p:cNvPr id="12" name="">
             <a:extLst xmlns:a="http://schemas.openxmlformats.org/drawingml/2006/main">
               <a:ext uri="{FF2B5EF4-FFF2-40B4-BE49-F238E27FC236}">
-                <a16:creationId xmlns:a16="http://schemas.microsoft.com/office/drawing/2014/main" id="{7ED77B2A-2B2A-4A92-AFF5-87325044B29B}"/>
+                <a16:creationId xmlns:a16="http://schemas.microsoft.com/office/drawing/2014/main" id="{E1963C49-5FBA-44C9-AE80-9B995FFA645A}"/>
               </a:ext>
             </a:extLst>
           </p:cNvPr>
@@ -8216,7 +8216,7 @@
           <p:cNvPr id="13" name="">
             <a:extLst xmlns:a="http://schemas.openxmlformats.org/drawingml/2006/main">
               <a:ext uri="{FF2B5EF4-FFF2-40B4-BE49-F238E27FC236}">
-                <a16:creationId xmlns:a16="http://schemas.microsoft.com/office/drawing/2014/main" id="{D843BF82-9BAD-469F-A89C-9DD782C27F77}"/>
+                <a16:creationId xmlns:a16="http://schemas.microsoft.com/office/drawing/2014/main" id="{0853E034-03F4-4311-B1DD-C21E4CE6FB70}"/>
               </a:ext>
             </a:extLst>
           </p:cNvPr>
@@ -8246,7 +8246,7 @@
           <p:cNvPr id="14" name="">
             <a:extLst xmlns:a="http://schemas.openxmlformats.org/drawingml/2006/main">
               <a:ext uri="{FF2B5EF4-FFF2-40B4-BE49-F238E27FC236}">
-                <a16:creationId xmlns:a16="http://schemas.microsoft.com/office/drawing/2014/main" id="{042620F2-275A-4E0E-9220-CAFA26CE8CB8}"/>
+                <a16:creationId xmlns:a16="http://schemas.microsoft.com/office/drawing/2014/main" id="{8F99C3C3-C636-43BD-A33B-7CDEED166AB6}"/>
               </a:ext>
             </a:extLst>
           </p:cNvPr>
@@ -8303,7 +8303,7 @@
           <p:cNvPr id="15" name="">
             <a:extLst xmlns:a="http://schemas.openxmlformats.org/drawingml/2006/main">
               <a:ext uri="{FF2B5EF4-FFF2-40B4-BE49-F238E27FC236}">
-                <a16:creationId xmlns:a16="http://schemas.microsoft.com/office/drawing/2014/main" id="{8267C48D-0DAE-4C16-B2DF-5864E3CD9479}"/>
+                <a16:creationId xmlns:a16="http://schemas.microsoft.com/office/drawing/2014/main" id="{D498376D-6967-4EFF-A1F5-5B33A88AB3F8}"/>
               </a:ext>
             </a:extLst>
           </p:cNvPr>
@@ -8360,7 +8360,7 @@
           <p:cNvPr id="16" name="">
             <a:extLst xmlns:a="http://schemas.openxmlformats.org/drawingml/2006/main">
               <a:ext uri="{FF2B5EF4-FFF2-40B4-BE49-F238E27FC236}">
-                <a16:creationId xmlns:a16="http://schemas.microsoft.com/office/drawing/2014/main" id="{227756CE-95EE-4948-BD50-D48AE1E54335}"/>
+                <a16:creationId xmlns:a16="http://schemas.microsoft.com/office/drawing/2014/main" id="{9E22FC35-A1BC-45EE-9DC5-7208EBFD8634}"/>
               </a:ext>
             </a:extLst>
           </p:cNvPr>
@@ -8415,7 +8415,7 @@
     </p:spTree>
     <p:extLst>
       <p:ext uri="{BB962C8B-B14F-4D97-AF65-F5344CB8AC3E}">
-        <p14:creationId xmlns:p14="http://schemas.microsoft.com/office/powerpoint/2010/main" val="89558498"/>
+        <p14:creationId xmlns:p14="http://schemas.microsoft.com/office/powerpoint/2010/main" val="1428999960"/>
       </p:ext>
     </p:extLst>
   </p:cSld>
@@ -8446,7 +8446,7 @@
           <p:cNvPr id="17" name="">
             <a:extLst xmlns:a="http://schemas.openxmlformats.org/drawingml/2006/main">
               <a:ext uri="{FF2B5EF4-FFF2-40B4-BE49-F238E27FC236}">
-                <a16:creationId xmlns:a16="http://schemas.microsoft.com/office/drawing/2014/main" id="{611AC960-EB2C-4647-852D-BA7F471D37C1}"/>
+                <a16:creationId xmlns:a16="http://schemas.microsoft.com/office/drawing/2014/main" id="{D526B51A-854E-48F7-802E-E1422494A278}"/>
               </a:ext>
             </a:extLst>
           </p:cNvPr>
@@ -8476,7 +8476,7 @@
           <p:cNvPr id="2" name="">
             <a:extLst xmlns:a="http://schemas.openxmlformats.org/drawingml/2006/main">
               <a:ext uri="{FF2B5EF4-FFF2-40B4-BE49-F238E27FC236}">
-                <a16:creationId xmlns:a16="http://schemas.microsoft.com/office/drawing/2014/main" id="{35372B5C-8A4D-4E33-AE57-94ADB0AEAE1D}"/>
+                <a16:creationId xmlns:a16="http://schemas.microsoft.com/office/drawing/2014/main" id="{C567A58D-1379-46A1-B1B7-392C0615A289}"/>
               </a:ext>
             </a:extLst>
           </p:cNvPr>
@@ -8533,7 +8533,7 @@
           <p:cNvPr id="3" name="">
             <a:extLst xmlns:a="http://schemas.openxmlformats.org/drawingml/2006/main">
               <a:ext uri="{FF2B5EF4-FFF2-40B4-BE49-F238E27FC236}">
-                <a16:creationId xmlns:a16="http://schemas.microsoft.com/office/drawing/2014/main" id="{9C55435A-A7CF-4D22-A3B9-06FBB8B31BEF}"/>
+                <a16:creationId xmlns:a16="http://schemas.microsoft.com/office/drawing/2014/main" id="{0EF2282A-7E27-40B4-84B8-5C190F466F30}"/>
               </a:ext>
             </a:extLst>
           </p:cNvPr>
@@ -8563,7 +8563,7 @@
           <p:cNvPr id="4" name="">
             <a:extLst xmlns:a="http://schemas.openxmlformats.org/drawingml/2006/main">
               <a:ext uri="{FF2B5EF4-FFF2-40B4-BE49-F238E27FC236}">
-                <a16:creationId xmlns:a16="http://schemas.microsoft.com/office/drawing/2014/main" id="{7573A5C9-40AB-4483-B093-687AF54A9E75}"/>
+                <a16:creationId xmlns:a16="http://schemas.microsoft.com/office/drawing/2014/main" id="{E26DD9F8-2717-4748-9953-43B6556E8E60}"/>
               </a:ext>
             </a:extLst>
           </p:cNvPr>
@@ -8593,7 +8593,7 @@
           <p:cNvPr id="5" name="">
             <a:extLst xmlns:a="http://schemas.openxmlformats.org/drawingml/2006/main">
               <a:ext uri="{FF2B5EF4-FFF2-40B4-BE49-F238E27FC236}">
-                <a16:creationId xmlns:a16="http://schemas.microsoft.com/office/drawing/2014/main" id="{059086AA-16C3-441E-9E00-23EA052FEC9F}"/>
+                <a16:creationId xmlns:a16="http://schemas.microsoft.com/office/drawing/2014/main" id="{59CBC30C-C570-4D15-8F4F-6CC64FFC5298}"/>
               </a:ext>
             </a:extLst>
           </p:cNvPr>
@@ -8650,7 +8650,7 @@
           <p:cNvPr id="6" name="">
             <a:extLst xmlns:a="http://schemas.openxmlformats.org/drawingml/2006/main">
               <a:ext uri="{FF2B5EF4-FFF2-40B4-BE49-F238E27FC236}">
-                <a16:creationId xmlns:a16="http://schemas.microsoft.com/office/drawing/2014/main" id="{E50C8990-8093-4FBC-9C78-72F04E88B58C}"/>
+                <a16:creationId xmlns:a16="http://schemas.microsoft.com/office/drawing/2014/main" id="{B1F1AA3E-169B-48F9-8A36-1D9240456E2B}"/>
               </a:ext>
             </a:extLst>
           </p:cNvPr>
@@ -8707,7 +8707,7 @@
           <p:cNvPr id="7" name="">
             <a:extLst xmlns:a="http://schemas.openxmlformats.org/drawingml/2006/main">
               <a:ext uri="{FF2B5EF4-FFF2-40B4-BE49-F238E27FC236}">
-                <a16:creationId xmlns:a16="http://schemas.microsoft.com/office/drawing/2014/main" id="{4D317F96-D3CA-4ED2-A762-8D4823661286}"/>
+                <a16:creationId xmlns:a16="http://schemas.microsoft.com/office/drawing/2014/main" id="{0A2BB944-82E2-401B-8D27-9DD716421A52}"/>
               </a:ext>
             </a:extLst>
           </p:cNvPr>
@@ -8764,7 +8764,7 @@
           <p:cNvPr id="8" name="">
             <a:extLst xmlns:a="http://schemas.openxmlformats.org/drawingml/2006/main">
               <a:ext uri="{FF2B5EF4-FFF2-40B4-BE49-F238E27FC236}">
-                <a16:creationId xmlns:a16="http://schemas.microsoft.com/office/drawing/2014/main" id="{EB7140BD-6313-4A91-86B5-0D94CAE2CC08}"/>
+                <a16:creationId xmlns:a16="http://schemas.microsoft.com/office/drawing/2014/main" id="{0F18F2A6-D156-474E-8054-9F05E3E8F3ED}"/>
               </a:ext>
             </a:extLst>
           </p:cNvPr>
@@ -8794,7 +8794,7 @@
           <p:cNvPr id="9" name="">
             <a:extLst xmlns:a="http://schemas.openxmlformats.org/drawingml/2006/main">
               <a:ext uri="{FF2B5EF4-FFF2-40B4-BE49-F238E27FC236}">
-                <a16:creationId xmlns:a16="http://schemas.microsoft.com/office/drawing/2014/main" id="{CEEB9371-743E-4F36-AFAE-2B5B1AB68CC7}"/>
+                <a16:creationId xmlns:a16="http://schemas.microsoft.com/office/drawing/2014/main" id="{EBF98FDB-C1F3-446B-9630-388015326A81}"/>
               </a:ext>
             </a:extLst>
           </p:cNvPr>
@@ -8851,7 +8851,7 @@
           <p:cNvPr id="10" name="">
             <a:extLst xmlns:a="http://schemas.openxmlformats.org/drawingml/2006/main">
               <a:ext uri="{FF2B5EF4-FFF2-40B4-BE49-F238E27FC236}">
-                <a16:creationId xmlns:a16="http://schemas.microsoft.com/office/drawing/2014/main" id="{F1A6FB9C-1327-43FE-B62D-E74B6E33A775}"/>
+                <a16:creationId xmlns:a16="http://schemas.microsoft.com/office/drawing/2014/main" id="{56424652-5956-4AA1-84D9-AF0E906F7832}"/>
               </a:ext>
             </a:extLst>
           </p:cNvPr>
@@ -8908,7 +8908,7 @@
           <p:cNvPr id="11" name="">
             <a:extLst xmlns:a="http://schemas.openxmlformats.org/drawingml/2006/main">
               <a:ext uri="{FF2B5EF4-FFF2-40B4-BE49-F238E27FC236}">
-                <a16:creationId xmlns:a16="http://schemas.microsoft.com/office/drawing/2014/main" id="{410E746B-A285-4ADD-A5AD-3E0150D6E3BB}"/>
+                <a16:creationId xmlns:a16="http://schemas.microsoft.com/office/drawing/2014/main" id="{2EFBFE79-8D67-4E0E-BEBA-14437E0A71F4}"/>
               </a:ext>
             </a:extLst>
           </p:cNvPr>
@@ -8965,7 +8965,7 @@
           <p:cNvPr id="12" name="">
             <a:extLst xmlns:a="http://schemas.openxmlformats.org/drawingml/2006/main">
               <a:ext uri="{FF2B5EF4-FFF2-40B4-BE49-F238E27FC236}">
-                <a16:creationId xmlns:a16="http://schemas.microsoft.com/office/drawing/2014/main" id="{F1A64F3C-3E29-431E-A1B3-702E4AD18422}"/>
+                <a16:creationId xmlns:a16="http://schemas.microsoft.com/office/drawing/2014/main" id="{24E620F2-B959-42F1-BD4F-39F685B88F1D}"/>
               </a:ext>
             </a:extLst>
           </p:cNvPr>
@@ -9022,7 +9022,7 @@
           <p:cNvPr id="13" name="">
             <a:extLst xmlns:a="http://schemas.openxmlformats.org/drawingml/2006/main">
               <a:ext uri="{FF2B5EF4-FFF2-40B4-BE49-F238E27FC236}">
-                <a16:creationId xmlns:a16="http://schemas.microsoft.com/office/drawing/2014/main" id="{2C4BFA78-F173-4081-B19A-B138D2AAA3F3}"/>
+                <a16:creationId xmlns:a16="http://schemas.microsoft.com/office/drawing/2014/main" id="{06FCD2B8-097A-46A3-8EB2-ABDCCCA634DB}"/>
               </a:ext>
             </a:extLst>
           </p:cNvPr>
@@ -9079,7 +9079,7 @@
           <p:cNvPr id="14" name="">
             <a:extLst xmlns:a="http://schemas.openxmlformats.org/drawingml/2006/main">
               <a:ext uri="{FF2B5EF4-FFF2-40B4-BE49-F238E27FC236}">
-                <a16:creationId xmlns:a16="http://schemas.microsoft.com/office/drawing/2014/main" id="{EF9383F8-B4E0-43E0-A2E3-12D8F2559757}"/>
+                <a16:creationId xmlns:a16="http://schemas.microsoft.com/office/drawing/2014/main" id="{5F2FFFE6-516F-40D8-A8C5-4AB411D05963}"/>
               </a:ext>
             </a:extLst>
           </p:cNvPr>
@@ -9136,7 +9136,7 @@
           <p:cNvPr id="15" name="">
             <a:extLst xmlns:a="http://schemas.openxmlformats.org/drawingml/2006/main">
               <a:ext uri="{FF2B5EF4-FFF2-40B4-BE49-F238E27FC236}">
-                <a16:creationId xmlns:a16="http://schemas.microsoft.com/office/drawing/2014/main" id="{B2C28D91-A674-4760-8F2B-646FA1FE3732}"/>
+                <a16:creationId xmlns:a16="http://schemas.microsoft.com/office/drawing/2014/main" id="{4AF88EC5-92BB-4D86-8896-C2AE4CF275D5}"/>
               </a:ext>
             </a:extLst>
           </p:cNvPr>
@@ -9193,7 +9193,7 @@
           <p:cNvPr id="16" name="">
             <a:extLst xmlns:a="http://schemas.openxmlformats.org/drawingml/2006/main">
               <a:ext uri="{FF2B5EF4-FFF2-40B4-BE49-F238E27FC236}">
-                <a16:creationId xmlns:a16="http://schemas.microsoft.com/office/drawing/2014/main" id="{C77A2327-95E1-4CB9-9853-189ED53CDA6F}"/>
+                <a16:creationId xmlns:a16="http://schemas.microsoft.com/office/drawing/2014/main" id="{8747F1A2-17FA-41C6-8CCE-8715A96C3235}"/>
               </a:ext>
             </a:extLst>
           </p:cNvPr>
@@ -9248,7 +9248,7 @@
     </p:spTree>
     <p:extLst>
       <p:ext uri="{BB962C8B-B14F-4D97-AF65-F5344CB8AC3E}">
-        <p14:creationId xmlns:p14="http://schemas.microsoft.com/office/powerpoint/2010/main" val="751780968"/>
+        <p14:creationId xmlns:p14="http://schemas.microsoft.com/office/powerpoint/2010/main" val="834893748"/>
       </p:ext>
     </p:extLst>
   </p:cSld>

</xml_diff>